<commit_message>
Correct and refresh challenge report
Correct stale report figures and dashboard wording, then apply a clearer blue, teal, and orange visual palette while preserving all ten slides and embedded charts.
</commit_message>
<xml_diff>
--- a/rapport/Rapport_Defi1_Acces_numerique_Togo.pptx
+++ b/rapport/Rapport_Defi1_Acces_numerique_Togo.pptx
@@ -173,7 +173,7 @@
           </c:tx>
           <c:spPr>
             <a:solidFill>
-              <a:srgbClr val="1C7C54"/>
+              <a:srgbClr val="2A78D6"/>
             </a:solidFill>
             <a:effectLst/>
           </c:spPr>
@@ -454,7 +454,7 @@
           </c:tx>
           <c:spPr>
             <a:solidFill>
-              <a:srgbClr val="C8102E"/>
+              <a:srgbClr val="2A78D6"/>
             </a:solidFill>
             <a:effectLst/>
           </c:spPr>
@@ -777,7 +777,7 @@
           </c:tx>
           <c:spPr>
             <a:solidFill>
-              <a:srgbClr val="EB6834"/>
+              <a:srgbClr val="2A78D6"/>
             </a:solidFill>
             <a:effectLst/>
           </c:spPr>
@@ -1070,7 +1070,7 @@
           </c:tx>
           <c:spPr>
             <a:solidFill>
-              <a:srgbClr val="1C7C54"/>
+              <a:srgbClr val="2A78D6"/>
             </a:solidFill>
             <a:effectLst/>
           </c:spPr>
@@ -2854,7 +2854,7 @@
     <p:bg>
       <p:bgPr>
         <a:solidFill>
-          <a:srgbClr val="07341F"/>
+          <a:srgbClr val="FCFCFB"/>
         </a:solidFill>
       </p:bgPr>
     </p:bg>
@@ -2899,9 +2899,9 @@
             <a:r>
               <a:rPr lang="en-US" sz="1200" b="1" spc="200" kern="0" dirty="0">
                 <a:solidFill>
-                  <a:srgbClr val="4FA47C"/>
-                </a:solidFill>
-                <a:latin typeface="Calibri" pitchFamily="34" charset="0"/>
+                  <a:srgbClr val="12345F"/>
+                </a:solidFill>
+                <a:latin typeface="Aptos" pitchFamily="34" charset="0"/>
                 <a:ea typeface="Calibri" pitchFamily="34" charset="-122"/>
                 <a:cs typeface="Calibri" pitchFamily="34" charset="-120"/>
               </a:rPr>
@@ -2938,9 +2938,9 @@
             <a:r>
               <a:rPr lang="en-US" sz="4200" b="1" dirty="0">
                 <a:solidFill>
-                  <a:srgbClr val="FFFFFF"/>
-                </a:solidFill>
-                <a:latin typeface="Cambria" pitchFamily="34" charset="0"/>
+                  <a:srgbClr val="12345F"/>
+                </a:solidFill>
+                <a:latin typeface="Aptos" pitchFamily="34" charset="0"/>
                 <a:ea typeface="Cambria" pitchFamily="34" charset="-122"/>
                 <a:cs typeface="Cambria" pitchFamily="34" charset="-120"/>
               </a:rPr>
@@ -2977,9 +2977,9 @@
             <a:r>
               <a:rPr lang="en-US" sz="1700" dirty="0">
                 <a:solidFill>
-                  <a:srgbClr val="BFDDCB"/>
-                </a:solidFill>
-                <a:latin typeface="Calibri" pitchFamily="34" charset="0"/>
+                  <a:srgbClr val="12345F"/>
+                </a:solidFill>
+                <a:latin typeface="Aptos" pitchFamily="34" charset="0"/>
                 <a:ea typeface="Calibri" pitchFamily="34" charset="-122"/>
                 <a:cs typeface="Calibri" pitchFamily="34" charset="-120"/>
               </a:rPr>
@@ -3011,6 +3011,10 @@
             <a:prstDash val="solid"/>
           </a:ln>
         </p:spPr>
+        <p:txBody>
+          <a:bodyPr/>
+          <a:p/>
+        </p:txBody>
       </p:sp>
       <p:sp>
         <p:nvSpPr>
@@ -3039,9 +3043,9 @@
             <a:r>
               <a:rPr lang="en-US" sz="1900" i="1" dirty="0">
                 <a:solidFill>
-                  <a:srgbClr val="F2C230"/>
-                </a:solidFill>
-                <a:latin typeface="Cambria" pitchFamily="34" charset="0"/>
+                  <a:srgbClr val="12345F"/>
+                </a:solidFill>
+                <a:latin typeface="Aptos" pitchFamily="34" charset="0"/>
                 <a:ea typeface="Cambria" pitchFamily="34" charset="-122"/>
                 <a:cs typeface="Cambria" pitchFamily="34" charset="-120"/>
               </a:rPr>
@@ -3056,9 +3060,9 @@
             <a:r>
               <a:rPr lang="en-US" sz="1900" i="1" dirty="0">
                 <a:solidFill>
-                  <a:srgbClr val="F2C230"/>
-                </a:solidFill>
-                <a:latin typeface="Cambria" pitchFamily="34" charset="0"/>
+                  <a:srgbClr val="0B0B0B"/>
+                </a:solidFill>
+                <a:latin typeface="Aptos" pitchFamily="34" charset="0"/>
                 <a:ea typeface="Cambria" pitchFamily="34" charset="-122"/>
                 <a:cs typeface="Cambria" pitchFamily="34" charset="-120"/>
               </a:rPr>
@@ -3095,9 +3099,9 @@
             <a:r>
               <a:rPr lang="en-US" sz="1100" dirty="0">
                 <a:solidFill>
-                  <a:srgbClr val="8CC4A5"/>
-                </a:solidFill>
-                <a:latin typeface="Calibri" pitchFamily="34" charset="0"/>
+                  <a:srgbClr val="12345F"/>
+                </a:solidFill>
+                <a:latin typeface="Aptos" pitchFamily="34" charset="0"/>
                 <a:ea typeface="Calibri" pitchFamily="34" charset="-122"/>
                 <a:cs typeface="Calibri" pitchFamily="34" charset="-120"/>
               </a:rPr>
@@ -3121,7 +3125,7 @@
     <p:bg>
       <p:bgPr>
         <a:solidFill>
-          <a:srgbClr val="07341F"/>
+          <a:srgbClr val="FCFCFB"/>
         </a:solidFill>
       </p:bgPr>
     </p:bg>
@@ -3166,9 +3170,9 @@
             <a:r>
               <a:rPr lang="en-US" sz="1200" b="1" spc="200" kern="0" dirty="0">
                 <a:solidFill>
-                  <a:srgbClr val="4FA47C"/>
-                </a:solidFill>
-                <a:latin typeface="Calibri" pitchFamily="34" charset="0"/>
+                  <a:srgbClr val="12345F"/>
+                </a:solidFill>
+                <a:latin typeface="Aptos" pitchFamily="34" charset="0"/>
                 <a:ea typeface="Calibri" pitchFamily="34" charset="-122"/>
                 <a:cs typeface="Calibri" pitchFamily="34" charset="-120"/>
               </a:rPr>
@@ -3205,9 +3209,9 @@
             <a:r>
               <a:rPr lang="en-US" sz="3000" b="1" dirty="0">
                 <a:solidFill>
-                  <a:srgbClr val="FFFFFF"/>
-                </a:solidFill>
-                <a:latin typeface="Cambria" pitchFamily="34" charset="0"/>
+                  <a:srgbClr val="12345F"/>
+                </a:solidFill>
+                <a:latin typeface="Aptos" pitchFamily="34" charset="0"/>
                 <a:ea typeface="Cambria" pitchFamily="34" charset="-122"/>
                 <a:cs typeface="Cambria" pitchFamily="34" charset="-120"/>
               </a:rPr>
@@ -3244,9 +3248,9 @@
             <a:r>
               <a:rPr lang="en-US" sz="1300" b="1" dirty="0">
                 <a:solidFill>
-                  <a:srgbClr val="F2C230"/>
-                </a:solidFill>
-                <a:latin typeface="Cambria" pitchFamily="34" charset="0"/>
+                  <a:srgbClr val="12345F"/>
+                </a:solidFill>
+                <a:latin typeface="Aptos" pitchFamily="34" charset="0"/>
                 <a:ea typeface="Cambria" pitchFamily="34" charset="-122"/>
                 <a:cs typeface="Cambria" pitchFamily="34" charset="-120"/>
               </a:rPr>
@@ -3283,9 +3287,9 @@
             <a:r>
               <a:rPr lang="en-US" sz="1050" dirty="0">
                 <a:solidFill>
-                  <a:srgbClr val="CFE3D7"/>
-                </a:solidFill>
-                <a:latin typeface="Calibri" pitchFamily="34" charset="0"/>
+                  <a:srgbClr val="0B0B0B"/>
+                </a:solidFill>
+                <a:latin typeface="Aptos" pitchFamily="34" charset="0"/>
                 <a:ea typeface="Calibri" pitchFamily="34" charset="-122"/>
                 <a:cs typeface="Calibri" pitchFamily="34" charset="-120"/>
               </a:rPr>
@@ -3322,9 +3326,9 @@
             <a:r>
               <a:rPr lang="en-US" sz="1300" b="1" dirty="0">
                 <a:solidFill>
-                  <a:srgbClr val="F2C230"/>
-                </a:solidFill>
-                <a:latin typeface="Cambria" pitchFamily="34" charset="0"/>
+                  <a:srgbClr val="12345F"/>
+                </a:solidFill>
+                <a:latin typeface="Aptos" pitchFamily="34" charset="0"/>
                 <a:ea typeface="Cambria" pitchFamily="34" charset="-122"/>
                 <a:cs typeface="Cambria" pitchFamily="34" charset="-120"/>
               </a:rPr>
@@ -3361,9 +3365,9 @@
             <a:r>
               <a:rPr lang="en-US" sz="1050" dirty="0">
                 <a:solidFill>
-                  <a:srgbClr val="CFE3D7"/>
-                </a:solidFill>
-                <a:latin typeface="Calibri" pitchFamily="34" charset="0"/>
+                  <a:srgbClr val="0B0B0B"/>
+                </a:solidFill>
+                <a:latin typeface="Aptos" pitchFamily="34" charset="0"/>
                 <a:ea typeface="Calibri" pitchFamily="34" charset="-122"/>
                 <a:cs typeface="Calibri" pitchFamily="34" charset="-120"/>
               </a:rPr>
@@ -3400,9 +3404,9 @@
             <a:r>
               <a:rPr lang="en-US" sz="1300" b="1" dirty="0">
                 <a:solidFill>
-                  <a:srgbClr val="F2C230"/>
-                </a:solidFill>
-                <a:latin typeface="Cambria" pitchFamily="34" charset="0"/>
+                  <a:srgbClr val="12345F"/>
+                </a:solidFill>
+                <a:latin typeface="Aptos" pitchFamily="34" charset="0"/>
                 <a:ea typeface="Cambria" pitchFamily="34" charset="-122"/>
                 <a:cs typeface="Cambria" pitchFamily="34" charset="-120"/>
               </a:rPr>
@@ -3439,9 +3443,9 @@
             <a:r>
               <a:rPr lang="en-US" sz="1050" dirty="0">
                 <a:solidFill>
-                  <a:srgbClr val="CFE3D7"/>
-                </a:solidFill>
-                <a:latin typeface="Calibri" pitchFamily="34" charset="0"/>
+                  <a:srgbClr val="0B0B0B"/>
+                </a:solidFill>
+                <a:latin typeface="Aptos" pitchFamily="34" charset="0"/>
                 <a:ea typeface="Calibri" pitchFamily="34" charset="-122"/>
                 <a:cs typeface="Calibri" pitchFamily="34" charset="-120"/>
               </a:rPr>
@@ -3478,9 +3482,9 @@
             <a:r>
               <a:rPr lang="en-US" sz="1300" b="1" dirty="0">
                 <a:solidFill>
-                  <a:srgbClr val="F2C230"/>
-                </a:solidFill>
-                <a:latin typeface="Cambria" pitchFamily="34" charset="0"/>
+                  <a:srgbClr val="12345F"/>
+                </a:solidFill>
+                <a:latin typeface="Aptos" pitchFamily="34" charset="0"/>
                 <a:ea typeface="Cambria" pitchFamily="34" charset="-122"/>
                 <a:cs typeface="Cambria" pitchFamily="34" charset="-120"/>
               </a:rPr>
@@ -3517,9 +3521,9 @@
             <a:r>
               <a:rPr lang="en-US" sz="1050" dirty="0">
                 <a:solidFill>
-                  <a:srgbClr val="CFE3D7"/>
-                </a:solidFill>
-                <a:latin typeface="Calibri" pitchFamily="34" charset="0"/>
+                  <a:srgbClr val="0B0B0B"/>
+                </a:solidFill>
+                <a:latin typeface="Aptos" pitchFamily="34" charset="0"/>
                 <a:ea typeface="Calibri" pitchFamily="34" charset="-122"/>
                 <a:cs typeface="Calibri" pitchFamily="34" charset="-120"/>
               </a:rPr>
@@ -3556,9 +3560,9 @@
             <a:r>
               <a:rPr lang="en-US" sz="1300" b="1" dirty="0">
                 <a:solidFill>
-                  <a:srgbClr val="F2C230"/>
-                </a:solidFill>
-                <a:latin typeface="Cambria" pitchFamily="34" charset="0"/>
+                  <a:srgbClr val="12345F"/>
+                </a:solidFill>
+                <a:latin typeface="Aptos" pitchFamily="34" charset="0"/>
                 <a:ea typeface="Cambria" pitchFamily="34" charset="-122"/>
                 <a:cs typeface="Cambria" pitchFamily="34" charset="-120"/>
               </a:rPr>
@@ -3595,9 +3599,9 @@
             <a:r>
               <a:rPr lang="en-US" sz="1050" dirty="0">
                 <a:solidFill>
-                  <a:srgbClr val="CFE3D7"/>
-                </a:solidFill>
-                <a:latin typeface="Calibri" pitchFamily="34" charset="0"/>
+                  <a:srgbClr val="0B0B0B"/>
+                </a:solidFill>
+                <a:latin typeface="Aptos" pitchFamily="34" charset="0"/>
                 <a:ea typeface="Calibri" pitchFamily="34" charset="-122"/>
                 <a:cs typeface="Calibri" pitchFamily="34" charset="-120"/>
               </a:rPr>
@@ -3634,9 +3638,9 @@
             <a:r>
               <a:rPr lang="en-US" sz="1300" b="1" dirty="0">
                 <a:solidFill>
-                  <a:srgbClr val="F2C230"/>
-                </a:solidFill>
-                <a:latin typeface="Cambria" pitchFamily="34" charset="0"/>
+                  <a:srgbClr val="12345F"/>
+                </a:solidFill>
+                <a:latin typeface="Aptos" pitchFamily="34" charset="0"/>
                 <a:ea typeface="Cambria" pitchFamily="34" charset="-122"/>
                 <a:cs typeface="Cambria" pitchFamily="34" charset="-120"/>
               </a:rPr>
@@ -3673,9 +3677,9 @@
             <a:r>
               <a:rPr lang="en-US" sz="1050" dirty="0">
                 <a:solidFill>
-                  <a:srgbClr val="CFE3D7"/>
-                </a:solidFill>
-                <a:latin typeface="Calibri" pitchFamily="34" charset="0"/>
+                  <a:srgbClr val="0B0B0B"/>
+                </a:solidFill>
+                <a:latin typeface="Aptos" pitchFamily="34" charset="0"/>
                 <a:ea typeface="Calibri" pitchFamily="34" charset="-122"/>
                 <a:cs typeface="Calibri" pitchFamily="34" charset="-120"/>
               </a:rPr>
@@ -3707,6 +3711,10 @@
             <a:prstDash val="solid"/>
           </a:ln>
         </p:spPr>
+        <p:txBody>
+          <a:bodyPr/>
+          <a:p/>
+        </p:txBody>
       </p:sp>
       <p:sp>
         <p:nvSpPr>
@@ -3735,9 +3743,9 @@
             <a:r>
               <a:rPr lang="en-US" sz="1400" b="1" dirty="0">
                 <a:solidFill>
-                  <a:srgbClr val="FFFFFF"/>
-                </a:solidFill>
-                <a:latin typeface="Cambria" pitchFamily="34" charset="0"/>
+                  <a:srgbClr val="12345F"/>
+                </a:solidFill>
+                <a:latin typeface="Aptos" pitchFamily="34" charset="0"/>
                 <a:ea typeface="Cambria" pitchFamily="34" charset="-122"/>
                 <a:cs typeface="Cambria" pitchFamily="34" charset="-120"/>
               </a:rPr>
@@ -3774,13 +3782,13 @@
             <a:r>
               <a:rPr lang="en-US" sz="1100" dirty="0">
                 <a:solidFill>
-                  <a:srgbClr val="8CC4A5"/>
-                </a:solidFill>
-                <a:latin typeface="Calibri" pitchFamily="34" charset="0"/>
+                  <a:srgbClr val="0B0B0B"/>
+                </a:solidFill>
+                <a:latin typeface="Aptos" pitchFamily="34" charset="0"/>
                 <a:ea typeface="Calibri" pitchFamily="34" charset="-122"/>
                 <a:cs typeface="Calibri" pitchFamily="34" charset="-120"/>
               </a:rPr>
-              <a:t>8 vues, filtrables par région et par échelle · lecture automatique recalculée à chaque filtre · export CSV de toutes les tables · 3 scripts Python des sources brutes au rendu</a:t>
+              <a:t>8 vues, filtrables par région, avec une analyse cantonale dédiée dans Accès local · lecture automatique recalculée à chaque filtre · export CSV de toutes les tables · 3 scripts Python des sources brutes au rendu</a:t>
             </a:r>
             <a:endParaRPr lang="en-US" sz="1100" dirty="0"/>
           </a:p>
@@ -3797,6 +3805,14 @@
 <file path=ppt/slides/slide2.xml><?xml version="1.0" encoding="utf-8"?>
 <p:sld xmlns:a="http://schemas.openxmlformats.org/drawingml/2006/main" xmlns:r="http://schemas.openxmlformats.org/officeDocument/2006/relationships" xmlns:p="http://schemas.openxmlformats.org/presentationml/2006/main">
   <p:cSld name="Slide 2">
+    <p:bg>
+      <p:bgPr>
+        <a:solidFill>
+          <a:srgbClr val="FCFCFB"/>
+        </a:solidFill>
+        <a:effectLst/>
+      </p:bgPr>
+    </p:bg>
     <p:spTree>
       <p:nvGrpSpPr>
         <p:cNvPr id="1" name=""/>
@@ -3838,9 +3854,9 @@
             <a:r>
               <a:rPr lang="en-US" sz="1100" b="1" spc="200" kern="0" dirty="0">
                 <a:solidFill>
-                  <a:srgbClr val="4FA47C"/>
-                </a:solidFill>
-                <a:latin typeface="Calibri" pitchFamily="34" charset="0"/>
+                  <a:srgbClr val="12345F"/>
+                </a:solidFill>
+                <a:latin typeface="Aptos" pitchFamily="34" charset="0"/>
                 <a:ea typeface="Calibri" pitchFamily="34" charset="-122"/>
                 <a:cs typeface="Calibri" pitchFamily="34" charset="-120"/>
               </a:rPr>
@@ -3877,9 +3893,9 @@
             <a:r>
               <a:rPr lang="en-US" sz="3000" b="1" dirty="0">
                 <a:solidFill>
-                  <a:srgbClr val="0B0B0B"/>
-                </a:solidFill>
-                <a:latin typeface="Cambria" pitchFamily="34" charset="0"/>
+                  <a:srgbClr val="12345F"/>
+                </a:solidFill>
+                <a:latin typeface="Aptos" pitchFamily="34" charset="0"/>
                 <a:ea typeface="Cambria" pitchFamily="34" charset="-122"/>
                 <a:cs typeface="Cambria" pitchFamily="34" charset="-120"/>
               </a:rPr>
@@ -3904,15 +3920,19 @@
             <a:avLst/>
           </a:prstGeom>
           <a:solidFill>
-            <a:srgbClr val="0E5236"/>
+            <a:srgbClr val="12345F"/>
           </a:solidFill>
           <a:ln w="12700">
             <a:solidFill>
-              <a:srgbClr val="0E5236"/>
+              <a:srgbClr val="12345F"/>
             </a:solidFill>
             <a:prstDash val="solid"/>
           </a:ln>
         </p:spPr>
+        <p:txBody>
+          <a:bodyPr/>
+          <a:p/>
+        </p:txBody>
       </p:sp>
       <p:sp>
         <p:nvSpPr>
@@ -3943,7 +3963,7 @@
                 <a:solidFill>
                   <a:srgbClr val="FFFFFF"/>
                 </a:solidFill>
-                <a:latin typeface="Cambria" pitchFamily="34" charset="0"/>
+                <a:latin typeface="Aptos" pitchFamily="34" charset="0"/>
                 <a:ea typeface="Cambria" pitchFamily="34" charset="-122"/>
                 <a:cs typeface="Cambria" pitchFamily="34" charset="-120"/>
               </a:rPr>
@@ -3980,9 +4000,9 @@
             <a:r>
               <a:rPr lang="en-US" sz="2300" b="1" dirty="0">
                 <a:solidFill>
-                  <a:srgbClr val="0E5236"/>
-                </a:solidFill>
-                <a:latin typeface="Cambria" pitchFamily="34" charset="0"/>
+                  <a:srgbClr val="12345F"/>
+                </a:solidFill>
+                <a:latin typeface="Aptos" pitchFamily="34" charset="0"/>
                 <a:ea typeface="Cambria" pitchFamily="34" charset="-122"/>
                 <a:cs typeface="Cambria" pitchFamily="34" charset="-120"/>
               </a:rPr>
@@ -4019,9 +4039,9 @@
             <a:r>
               <a:rPr lang="en-US" sz="1400" b="1" dirty="0">
                 <a:solidFill>
-                  <a:srgbClr val="0B0B0B"/>
-                </a:solidFill>
-                <a:latin typeface="Calibri" pitchFamily="34" charset="0"/>
+                  <a:srgbClr val="12345F"/>
+                </a:solidFill>
+                <a:latin typeface="Aptos" pitchFamily="34" charset="0"/>
                 <a:ea typeface="Calibri" pitchFamily="34" charset="-122"/>
                 <a:cs typeface="Calibri" pitchFamily="34" charset="-120"/>
               </a:rPr>
@@ -4058,9 +4078,9 @@
             <a:r>
               <a:rPr lang="en-US" sz="1100" dirty="0">
                 <a:solidFill>
-                  <a:srgbClr val="5A6B62"/>
-                </a:solidFill>
-                <a:latin typeface="Calibri" pitchFamily="34" charset="0"/>
+                  <a:srgbClr val="12345F"/>
+                </a:solidFill>
+                <a:latin typeface="Aptos" pitchFamily="34" charset="0"/>
                 <a:ea typeface="Calibri" pitchFamily="34" charset="-122"/>
                 <a:cs typeface="Calibri" pitchFamily="34" charset="-120"/>
               </a:rPr>
@@ -4085,15 +4105,19 @@
             <a:avLst/>
           </a:prstGeom>
           <a:solidFill>
-            <a:srgbClr val="0E5236"/>
+            <a:srgbClr val="12345F"/>
           </a:solidFill>
           <a:ln w="12700">
             <a:solidFill>
-              <a:srgbClr val="0E5236"/>
+              <a:srgbClr val="12345F"/>
             </a:solidFill>
             <a:prstDash val="solid"/>
           </a:ln>
         </p:spPr>
+        <p:txBody>
+          <a:bodyPr/>
+          <a:p/>
+        </p:txBody>
       </p:sp>
       <p:sp>
         <p:nvSpPr>
@@ -4124,7 +4148,7 @@
                 <a:solidFill>
                   <a:srgbClr val="FFFFFF"/>
                 </a:solidFill>
-                <a:latin typeface="Cambria" pitchFamily="34" charset="0"/>
+                <a:latin typeface="Aptos" pitchFamily="34" charset="0"/>
                 <a:ea typeface="Cambria" pitchFamily="34" charset="-122"/>
                 <a:cs typeface="Cambria" pitchFamily="34" charset="-120"/>
               </a:rPr>
@@ -4161,9 +4185,9 @@
             <a:r>
               <a:rPr lang="en-US" sz="2300" b="1" dirty="0">
                 <a:solidFill>
-                  <a:srgbClr val="0E5236"/>
-                </a:solidFill>
-                <a:latin typeface="Cambria" pitchFamily="34" charset="0"/>
+                  <a:srgbClr val="12345F"/>
+                </a:solidFill>
+                <a:latin typeface="Aptos" pitchFamily="34" charset="0"/>
                 <a:ea typeface="Cambria" pitchFamily="34" charset="-122"/>
                 <a:cs typeface="Cambria" pitchFamily="34" charset="-120"/>
               </a:rPr>
@@ -4200,9 +4224,9 @@
             <a:r>
               <a:rPr lang="en-US" sz="1400" b="1" dirty="0">
                 <a:solidFill>
-                  <a:srgbClr val="0B0B0B"/>
-                </a:solidFill>
-                <a:latin typeface="Calibri" pitchFamily="34" charset="0"/>
+                  <a:srgbClr val="12345F"/>
+                </a:solidFill>
+                <a:latin typeface="Aptos" pitchFamily="34" charset="0"/>
                 <a:ea typeface="Calibri" pitchFamily="34" charset="-122"/>
                 <a:cs typeface="Calibri" pitchFamily="34" charset="-120"/>
               </a:rPr>
@@ -4239,13 +4263,13 @@
             <a:r>
               <a:rPr lang="en-US" sz="1100" dirty="0">
                 <a:solidFill>
-                  <a:srgbClr val="5A6B62"/>
-                </a:solidFill>
-                <a:latin typeface="Calibri" pitchFamily="34" charset="0"/>
+                  <a:srgbClr val="12345F"/>
+                </a:solidFill>
+                <a:latin typeface="Aptos" pitchFamily="34" charset="0"/>
                 <a:ea typeface="Calibri" pitchFamily="34" charset="-122"/>
                 <a:cs typeface="Calibri" pitchFamily="34" charset="-120"/>
               </a:rPr>
-              <a:t>dont 7 boutiques CANAL+ retrouvées hors Géodata</a:t>
+              <a:t>7 boutiques CANAL+ retrouvées hors Géodata</a:t>
             </a:r>
             <a:endParaRPr lang="en-US" sz="1100" dirty="0"/>
           </a:p>
@@ -4266,15 +4290,19 @@
             <a:avLst/>
           </a:prstGeom>
           <a:solidFill>
-            <a:srgbClr val="0E5236"/>
+            <a:srgbClr val="12345F"/>
           </a:solidFill>
           <a:ln w="12700">
             <a:solidFill>
-              <a:srgbClr val="0E5236"/>
+              <a:srgbClr val="12345F"/>
             </a:solidFill>
             <a:prstDash val="solid"/>
           </a:ln>
         </p:spPr>
+        <p:txBody>
+          <a:bodyPr/>
+          <a:p/>
+        </p:txBody>
       </p:sp>
       <p:sp>
         <p:nvSpPr>
@@ -4305,7 +4333,7 @@
                 <a:solidFill>
                   <a:srgbClr val="FFFFFF"/>
                 </a:solidFill>
-                <a:latin typeface="Cambria" pitchFamily="34" charset="0"/>
+                <a:latin typeface="Aptos" pitchFamily="34" charset="0"/>
                 <a:ea typeface="Cambria" pitchFamily="34" charset="-122"/>
                 <a:cs typeface="Cambria" pitchFamily="34" charset="-120"/>
               </a:rPr>
@@ -4342,9 +4370,9 @@
             <a:r>
               <a:rPr lang="en-US" sz="2300" b="1" dirty="0">
                 <a:solidFill>
-                  <a:srgbClr val="0E5236"/>
-                </a:solidFill>
-                <a:latin typeface="Cambria" pitchFamily="34" charset="0"/>
+                  <a:srgbClr val="12345F"/>
+                </a:solidFill>
+                <a:latin typeface="Aptos" pitchFamily="34" charset="0"/>
                 <a:ea typeface="Cambria" pitchFamily="34" charset="-122"/>
                 <a:cs typeface="Cambria" pitchFamily="34" charset="-120"/>
               </a:rPr>
@@ -4381,9 +4409,9 @@
             <a:r>
               <a:rPr lang="en-US" sz="1400" b="1" dirty="0">
                 <a:solidFill>
-                  <a:srgbClr val="0B0B0B"/>
-                </a:solidFill>
-                <a:latin typeface="Calibri" pitchFamily="34" charset="0"/>
+                  <a:srgbClr val="12345F"/>
+                </a:solidFill>
+                <a:latin typeface="Aptos" pitchFamily="34" charset="0"/>
                 <a:ea typeface="Calibri" pitchFamily="34" charset="-122"/>
                 <a:cs typeface="Calibri" pitchFamily="34" charset="-120"/>
               </a:rPr>
@@ -4420,9 +4448,9 @@
             <a:r>
               <a:rPr lang="en-US" sz="1100" dirty="0">
                 <a:solidFill>
-                  <a:srgbClr val="5A6B62"/>
-                </a:solidFill>
-                <a:latin typeface="Calibri" pitchFamily="34" charset="0"/>
+                  <a:srgbClr val="12345F"/>
+                </a:solidFill>
+                <a:latin typeface="Aptos" pitchFamily="34" charset="0"/>
                 <a:ea typeface="Calibri" pitchFamily="34" charset="-122"/>
                 <a:cs typeface="Calibri" pitchFamily="34" charset="-120"/>
               </a:rPr>
@@ -4447,15 +4475,19 @@
             <a:avLst/>
           </a:prstGeom>
           <a:solidFill>
-            <a:srgbClr val="0E5236"/>
+            <a:srgbClr val="12345F"/>
           </a:solidFill>
           <a:ln w="12700">
             <a:solidFill>
-              <a:srgbClr val="0E5236"/>
+              <a:srgbClr val="12345F"/>
             </a:solidFill>
             <a:prstDash val="solid"/>
           </a:ln>
         </p:spPr>
+        <p:txBody>
+          <a:bodyPr/>
+          <a:p/>
+        </p:txBody>
       </p:sp>
       <p:sp>
         <p:nvSpPr>
@@ -4486,7 +4518,7 @@
                 <a:solidFill>
                   <a:srgbClr val="FFFFFF"/>
                 </a:solidFill>
-                <a:latin typeface="Cambria" pitchFamily="34" charset="0"/>
+                <a:latin typeface="Aptos" pitchFamily="34" charset="0"/>
                 <a:ea typeface="Cambria" pitchFamily="34" charset="-122"/>
                 <a:cs typeface="Cambria" pitchFamily="34" charset="-120"/>
               </a:rPr>
@@ -4523,9 +4555,9 @@
             <a:r>
               <a:rPr lang="en-US" sz="2300" b="1" dirty="0">
                 <a:solidFill>
-                  <a:srgbClr val="0E5236"/>
-                </a:solidFill>
-                <a:latin typeface="Cambria" pitchFamily="34" charset="0"/>
+                  <a:srgbClr val="12345F"/>
+                </a:solidFill>
+                <a:latin typeface="Aptos" pitchFamily="34" charset="0"/>
                 <a:ea typeface="Cambria" pitchFamily="34" charset="-122"/>
                 <a:cs typeface="Cambria" pitchFamily="34" charset="-120"/>
               </a:rPr>
@@ -4562,9 +4594,9 @@
             <a:r>
               <a:rPr lang="en-US" sz="1400" b="1" dirty="0">
                 <a:solidFill>
-                  <a:srgbClr val="0B0B0B"/>
-                </a:solidFill>
-                <a:latin typeface="Calibri" pitchFamily="34" charset="0"/>
+                  <a:srgbClr val="12345F"/>
+                </a:solidFill>
+                <a:latin typeface="Aptos" pitchFamily="34" charset="0"/>
                 <a:ea typeface="Calibri" pitchFamily="34" charset="-122"/>
                 <a:cs typeface="Calibri" pitchFamily="34" charset="-120"/>
               </a:rPr>
@@ -4601,9 +4633,9 @@
             <a:r>
               <a:rPr lang="en-US" sz="1100" dirty="0">
                 <a:solidFill>
-                  <a:srgbClr val="5A6B62"/>
-                </a:solidFill>
-                <a:latin typeface="Calibri" pitchFamily="34" charset="0"/>
+                  <a:srgbClr val="12345F"/>
+                </a:solidFill>
+                <a:latin typeface="Aptos" pitchFamily="34" charset="0"/>
                 <a:ea typeface="Calibri" pitchFamily="34" charset="-122"/>
                 <a:cs typeface="Calibri" pitchFamily="34" charset="-120"/>
               </a:rPr>
@@ -4630,15 +4662,19 @@
             </a:avLst>
           </a:prstGeom>
           <a:solidFill>
-            <a:srgbClr val="EAF3EE"/>
+            <a:srgbClr val="EAF1FB"/>
           </a:solidFill>
           <a:ln w="12700">
             <a:solidFill>
-              <a:srgbClr val="EAF3EE"/>
+              <a:srgbClr val="EAF1FB"/>
             </a:solidFill>
             <a:prstDash val="solid"/>
           </a:ln>
         </p:spPr>
+        <p:txBody>
+          <a:bodyPr/>
+          <a:p/>
+        </p:txBody>
       </p:sp>
       <p:sp>
         <p:nvSpPr>
@@ -4667,9 +4703,9 @@
             <a:r>
               <a:rPr lang="en-US" sz="1600" b="1" dirty="0">
                 <a:solidFill>
-                  <a:srgbClr val="0E5236"/>
-                </a:solidFill>
-                <a:latin typeface="Cambria" pitchFamily="34" charset="0"/>
+                  <a:srgbClr val="12345F"/>
+                </a:solidFill>
+                <a:latin typeface="Aptos" pitchFamily="34" charset="0"/>
                 <a:ea typeface="Cambria" pitchFamily="34" charset="-122"/>
                 <a:cs typeface="Cambria" pitchFamily="34" charset="-120"/>
               </a:rPr>
@@ -4711,7 +4747,7 @@
                 <a:solidFill>
                   <a:srgbClr val="0B0B0B"/>
                 </a:solidFill>
-                <a:latin typeface="Calibri" pitchFamily="34" charset="0"/>
+                <a:latin typeface="Aptos" pitchFamily="34" charset="0"/>
                 <a:ea typeface="Calibri" pitchFamily="34" charset="-122"/>
                 <a:cs typeface="Calibri" pitchFamily="34" charset="-120"/>
               </a:rPr>
@@ -4728,7 +4764,7 @@
                 <a:solidFill>
                   <a:srgbClr val="0B0B0B"/>
                 </a:solidFill>
-                <a:latin typeface="Calibri" pitchFamily="34" charset="0"/>
+                <a:latin typeface="Aptos" pitchFamily="34" charset="0"/>
                 <a:ea typeface="Calibri" pitchFamily="34" charset="-122"/>
                 <a:cs typeface="Calibri" pitchFamily="34" charset="-120"/>
               </a:rPr>
@@ -4757,7 +4793,7 @@
                 <a:solidFill>
                   <a:srgbClr val="0B0B0B"/>
                 </a:solidFill>
-                <a:latin typeface="Calibri" pitchFamily="34" charset="0"/>
+                <a:latin typeface="Aptos" pitchFamily="34" charset="0"/>
                 <a:ea typeface="Calibri" pitchFamily="34" charset="-122"/>
                 <a:cs typeface="Calibri" pitchFamily="34" charset="-120"/>
               </a:rPr>
@@ -4777,7 +4813,7 @@
                 <a:solidFill>
                   <a:srgbClr val="0B0B0B"/>
                 </a:solidFill>
-                <a:latin typeface="Calibri" pitchFamily="34" charset="0"/>
+                <a:latin typeface="Aptos" pitchFamily="34" charset="0"/>
                 <a:ea typeface="Calibri" pitchFamily="34" charset="-122"/>
                 <a:cs typeface="Calibri" pitchFamily="34" charset="-120"/>
               </a:rPr>
@@ -4806,7 +4842,7 @@
                 <a:solidFill>
                   <a:srgbClr val="0B0B0B"/>
                 </a:solidFill>
-                <a:latin typeface="Calibri" pitchFamily="34" charset="0"/>
+                <a:latin typeface="Aptos" pitchFamily="34" charset="0"/>
                 <a:ea typeface="Calibri" pitchFamily="34" charset="-122"/>
                 <a:cs typeface="Calibri" pitchFamily="34" charset="-120"/>
               </a:rPr>
@@ -4826,7 +4862,7 @@
                 <a:solidFill>
                   <a:srgbClr val="0B0B0B"/>
                 </a:solidFill>
-                <a:latin typeface="Calibri" pitchFamily="34" charset="0"/>
+                <a:latin typeface="Aptos" pitchFamily="34" charset="0"/>
                 <a:ea typeface="Calibri" pitchFamily="34" charset="-122"/>
                 <a:cs typeface="Calibri" pitchFamily="34" charset="-120"/>
               </a:rPr>
@@ -4863,9 +4899,9 @@
             <a:r>
               <a:rPr lang="en-US" sz="1000" dirty="0">
                 <a:solidFill>
-                  <a:srgbClr val="5A6B62"/>
-                </a:solidFill>
-                <a:latin typeface="Calibri" pitchFamily="34" charset="0"/>
+                  <a:srgbClr val="0B0B0B"/>
+                </a:solidFill>
+                <a:latin typeface="Aptos" pitchFamily="34" charset="0"/>
                 <a:ea typeface="Calibri" pitchFamily="34" charset="-122"/>
                 <a:cs typeface="Calibri" pitchFamily="34" charset="-120"/>
               </a:rPr>
@@ -4886,6 +4922,14 @@
 <file path=ppt/slides/slide3.xml><?xml version="1.0" encoding="utf-8"?>
 <p:sld xmlns:a="http://schemas.openxmlformats.org/drawingml/2006/main" xmlns:r="http://schemas.openxmlformats.org/officeDocument/2006/relationships" xmlns:p="http://schemas.openxmlformats.org/presentationml/2006/main">
   <p:cSld name="Slide 3">
+    <p:bg>
+      <p:bgPr>
+        <a:solidFill>
+          <a:srgbClr val="FCFCFB"/>
+        </a:solidFill>
+        <a:effectLst/>
+      </p:bgPr>
+    </p:bg>
     <p:spTree>
       <p:nvGrpSpPr>
         <p:cNvPr id="1" name=""/>
@@ -4927,9 +4971,9 @@
             <a:r>
               <a:rPr lang="en-US" sz="1100" b="1" spc="200" kern="0" dirty="0">
                 <a:solidFill>
-                  <a:srgbClr val="4FA47C"/>
-                </a:solidFill>
-                <a:latin typeface="Calibri" pitchFamily="34" charset="0"/>
+                  <a:srgbClr val="12345F"/>
+                </a:solidFill>
+                <a:latin typeface="Aptos" pitchFamily="34" charset="0"/>
                 <a:ea typeface="Calibri" pitchFamily="34" charset="-122"/>
                 <a:cs typeface="Calibri" pitchFamily="34" charset="-120"/>
               </a:rPr>
@@ -4966,9 +5010,9 @@
             <a:r>
               <a:rPr lang="en-US" sz="3000" b="1" dirty="0">
                 <a:solidFill>
-                  <a:srgbClr val="0B0B0B"/>
-                </a:solidFill>
-                <a:latin typeface="Cambria" pitchFamily="34" charset="0"/>
+                  <a:srgbClr val="12345F"/>
+                </a:solidFill>
+                <a:latin typeface="Aptos" pitchFamily="34" charset="0"/>
                 <a:ea typeface="Cambria" pitchFamily="34" charset="-122"/>
                 <a:cs typeface="Cambria" pitchFamily="34" charset="-120"/>
               </a:rPr>
@@ -5047,7 +5091,7 @@
                 <a:solidFill>
                   <a:srgbClr val="0B0B0B"/>
                 </a:solidFill>
-                <a:latin typeface="Calibri" pitchFamily="34" charset="0"/>
+                <a:latin typeface="Aptos" pitchFamily="34" charset="0"/>
                 <a:ea typeface="Calibri" pitchFamily="34" charset="-122"/>
                 <a:cs typeface="Calibri" pitchFamily="34" charset="-120"/>
               </a:rPr>
@@ -5074,15 +5118,19 @@
             </a:avLst>
           </a:prstGeom>
           <a:solidFill>
-            <a:srgbClr val="EAF3EE"/>
+            <a:srgbClr val="EAF1FB"/>
           </a:solidFill>
           <a:ln w="12700">
             <a:solidFill>
-              <a:srgbClr val="EAF3EE"/>
+              <a:srgbClr val="EAF1FB"/>
             </a:solidFill>
             <a:prstDash val="solid"/>
           </a:ln>
         </p:spPr>
+        <p:txBody>
+          <a:bodyPr/>
+          <a:p/>
+        </p:txBody>
       </p:sp>
       <p:sp>
         <p:nvSpPr>
@@ -5111,9 +5159,9 @@
             <a:r>
               <a:rPr lang="en-US" sz="3400" b="1" dirty="0">
                 <a:solidFill>
-                  <a:srgbClr val="0E5236"/>
-                </a:solidFill>
-                <a:latin typeface="Cambria" pitchFamily="34" charset="0"/>
+                  <a:srgbClr val="12345F"/>
+                </a:solidFill>
+                <a:latin typeface="Aptos" pitchFamily="34" charset="0"/>
                 <a:ea typeface="Cambria" pitchFamily="34" charset="-122"/>
                 <a:cs typeface="Cambria" pitchFamily="34" charset="-120"/>
               </a:rPr>
@@ -5150,9 +5198,9 @@
             <a:r>
               <a:rPr lang="en-US" sz="1200" b="1" dirty="0">
                 <a:solidFill>
-                  <a:srgbClr val="0B0B0B"/>
-                </a:solidFill>
-                <a:latin typeface="Calibri" pitchFamily="34" charset="0"/>
+                  <a:srgbClr val="12345F"/>
+                </a:solidFill>
+                <a:latin typeface="Aptos" pitchFamily="34" charset="0"/>
                 <a:ea typeface="Calibri" pitchFamily="34" charset="-122"/>
                 <a:cs typeface="Calibri" pitchFamily="34" charset="-120"/>
               </a:rPr>
@@ -5189,9 +5237,9 @@
             <a:r>
               <a:rPr lang="en-US" sz="1000" dirty="0">
                 <a:solidFill>
-                  <a:srgbClr val="5A6B62"/>
-                </a:solidFill>
-                <a:latin typeface="Calibri" pitchFamily="34" charset="0"/>
+                  <a:srgbClr val="12345F"/>
+                </a:solidFill>
+                <a:latin typeface="Aptos" pitchFamily="34" charset="0"/>
                 <a:ea typeface="Calibri" pitchFamily="34" charset="-122"/>
                 <a:cs typeface="Calibri" pitchFamily="34" charset="-120"/>
               </a:rPr>
@@ -5218,15 +5266,19 @@
             </a:avLst>
           </a:prstGeom>
           <a:solidFill>
-            <a:srgbClr val="EAF3EE"/>
+            <a:srgbClr val="EAF1FB"/>
           </a:solidFill>
           <a:ln w="12700">
             <a:solidFill>
-              <a:srgbClr val="EAF3EE"/>
+              <a:srgbClr val="EAF1FB"/>
             </a:solidFill>
             <a:prstDash val="solid"/>
           </a:ln>
         </p:spPr>
+        <p:txBody>
+          <a:bodyPr/>
+          <a:p/>
+        </p:txBody>
       </p:sp>
       <p:sp>
         <p:nvSpPr>
@@ -5255,9 +5307,9 @@
             <a:r>
               <a:rPr lang="en-US" sz="3400" b="1" dirty="0">
                 <a:solidFill>
-                  <a:srgbClr val="EB6834"/>
-                </a:solidFill>
-                <a:latin typeface="Cambria" pitchFamily="34" charset="0"/>
+                  <a:srgbClr val="12345F"/>
+                </a:solidFill>
+                <a:latin typeface="Aptos" pitchFamily="34" charset="0"/>
                 <a:ea typeface="Cambria" pitchFamily="34" charset="-122"/>
                 <a:cs typeface="Cambria" pitchFamily="34" charset="-120"/>
               </a:rPr>
@@ -5294,9 +5346,9 @@
             <a:r>
               <a:rPr lang="en-US" sz="1200" b="1" dirty="0">
                 <a:solidFill>
-                  <a:srgbClr val="0B0B0B"/>
-                </a:solidFill>
-                <a:latin typeface="Calibri" pitchFamily="34" charset="0"/>
+                  <a:srgbClr val="12345F"/>
+                </a:solidFill>
+                <a:latin typeface="Aptos" pitchFamily="34" charset="0"/>
                 <a:ea typeface="Calibri" pitchFamily="34" charset="-122"/>
                 <a:cs typeface="Calibri" pitchFamily="34" charset="-120"/>
               </a:rPr>
@@ -5333,9 +5385,9 @@
             <a:r>
               <a:rPr lang="en-US" sz="1000" dirty="0">
                 <a:solidFill>
-                  <a:srgbClr val="5A6B62"/>
-                </a:solidFill>
-                <a:latin typeface="Calibri" pitchFamily="34" charset="0"/>
+                  <a:srgbClr val="12345F"/>
+                </a:solidFill>
+                <a:latin typeface="Aptos" pitchFamily="34" charset="0"/>
                 <a:ea typeface="Calibri" pitchFamily="34" charset="-122"/>
                 <a:cs typeface="Calibri" pitchFamily="34" charset="-120"/>
               </a:rPr>
@@ -5372,9 +5424,9 @@
             <a:r>
               <a:rPr lang="en-US" sz="1200" i="1" dirty="0">
                 <a:solidFill>
-                  <a:srgbClr val="0E5236"/>
-                </a:solidFill>
-                <a:latin typeface="Cambria" pitchFamily="34" charset="0"/>
+                  <a:srgbClr val="12345F"/>
+                </a:solidFill>
+                <a:latin typeface="Aptos" pitchFamily="34" charset="0"/>
                 <a:ea typeface="Cambria" pitchFamily="34" charset="-122"/>
                 <a:cs typeface="Cambria" pitchFamily="34" charset="-120"/>
               </a:rPr>
@@ -5411,9 +5463,9 @@
             <a:r>
               <a:rPr lang="en-US" sz="1000" dirty="0">
                 <a:solidFill>
-                  <a:srgbClr val="5A6B62"/>
-                </a:solidFill>
-                <a:latin typeface="Calibri" pitchFamily="34" charset="0"/>
+                  <a:srgbClr val="12345F"/>
+                </a:solidFill>
+                <a:latin typeface="Aptos" pitchFamily="34" charset="0"/>
                 <a:ea typeface="Calibri" pitchFamily="34" charset="-122"/>
                 <a:cs typeface="Calibri" pitchFamily="34" charset="-120"/>
               </a:rPr>
@@ -5434,6 +5486,14 @@
 <file path=ppt/slides/slide4.xml><?xml version="1.0" encoding="utf-8"?>
 <p:sld xmlns:a="http://schemas.openxmlformats.org/drawingml/2006/main" xmlns:r="http://schemas.openxmlformats.org/officeDocument/2006/relationships" xmlns:p="http://schemas.openxmlformats.org/presentationml/2006/main">
   <p:cSld name="Slide 4">
+    <p:bg>
+      <p:bgPr>
+        <a:solidFill>
+          <a:srgbClr val="FCFCFB"/>
+        </a:solidFill>
+        <a:effectLst/>
+      </p:bgPr>
+    </p:bg>
     <p:spTree>
       <p:nvGrpSpPr>
         <p:cNvPr id="1" name=""/>
@@ -5475,9 +5535,9 @@
             <a:r>
               <a:rPr lang="en-US" sz="1100" b="1" spc="200" kern="0" dirty="0">
                 <a:solidFill>
-                  <a:srgbClr val="4FA47C"/>
-                </a:solidFill>
-                <a:latin typeface="Calibri" pitchFamily="34" charset="0"/>
+                  <a:srgbClr val="12345F"/>
+                </a:solidFill>
+                <a:latin typeface="Aptos" pitchFamily="34" charset="0"/>
                 <a:ea typeface="Calibri" pitchFamily="34" charset="-122"/>
                 <a:cs typeface="Calibri" pitchFamily="34" charset="-120"/>
               </a:rPr>
@@ -5514,9 +5574,9 @@
             <a:r>
               <a:rPr lang="en-US" sz="3000" b="1" dirty="0">
                 <a:solidFill>
-                  <a:srgbClr val="0B0B0B"/>
-                </a:solidFill>
-                <a:latin typeface="Cambria" pitchFamily="34" charset="0"/>
+                  <a:srgbClr val="12345F"/>
+                </a:solidFill>
+                <a:latin typeface="Aptos" pitchFamily="34" charset="0"/>
                 <a:ea typeface="Cambria" pitchFamily="34" charset="-122"/>
                 <a:cs typeface="Cambria" pitchFamily="34" charset="-120"/>
               </a:rPr>
@@ -5543,15 +5603,19 @@
             </a:avLst>
           </a:prstGeom>
           <a:solidFill>
-            <a:srgbClr val="EAF3EE"/>
+            <a:srgbClr val="EAF1FB"/>
           </a:solidFill>
           <a:ln w="12700">
             <a:solidFill>
-              <a:srgbClr val="EAF3EE"/>
+              <a:srgbClr val="EAF1FB"/>
             </a:solidFill>
             <a:prstDash val="solid"/>
           </a:ln>
         </p:spPr>
+        <p:txBody>
+          <a:bodyPr/>
+          <a:p/>
+        </p:txBody>
       </p:sp>
       <p:sp>
         <p:nvSpPr>
@@ -5580,9 +5644,9 @@
             <a:r>
               <a:rPr lang="en-US" sz="3400" b="1" dirty="0">
                 <a:solidFill>
-                  <a:srgbClr val="C8102E"/>
-                </a:solidFill>
-                <a:latin typeface="Cambria" pitchFamily="34" charset="0"/>
+                  <a:srgbClr val="12345F"/>
+                </a:solidFill>
+                <a:latin typeface="Aptos" pitchFamily="34" charset="0"/>
                 <a:ea typeface="Cambria" pitchFamily="34" charset="-122"/>
                 <a:cs typeface="Cambria" pitchFamily="34" charset="-120"/>
               </a:rPr>
@@ -5619,9 +5683,9 @@
             <a:r>
               <a:rPr lang="en-US" sz="1200" b="1" dirty="0">
                 <a:solidFill>
-                  <a:srgbClr val="0B0B0B"/>
-                </a:solidFill>
-                <a:latin typeface="Calibri" pitchFamily="34" charset="0"/>
+                  <a:srgbClr val="12345F"/>
+                </a:solidFill>
+                <a:latin typeface="Aptos" pitchFamily="34" charset="0"/>
                 <a:ea typeface="Calibri" pitchFamily="34" charset="-122"/>
                 <a:cs typeface="Calibri" pitchFamily="34" charset="-120"/>
               </a:rPr>
@@ -5658,9 +5722,9 @@
             <a:r>
               <a:rPr lang="en-US" sz="1000" dirty="0">
                 <a:solidFill>
-                  <a:srgbClr val="5A6B62"/>
-                </a:solidFill>
-                <a:latin typeface="Calibri" pitchFamily="34" charset="0"/>
+                  <a:srgbClr val="12345F"/>
+                </a:solidFill>
+                <a:latin typeface="Aptos" pitchFamily="34" charset="0"/>
                 <a:ea typeface="Calibri" pitchFamily="34" charset="-122"/>
                 <a:cs typeface="Calibri" pitchFamily="34" charset="-120"/>
               </a:rPr>
@@ -5687,15 +5751,19 @@
             </a:avLst>
           </a:prstGeom>
           <a:solidFill>
-            <a:srgbClr val="EAF3EE"/>
+            <a:srgbClr val="EAF1FB"/>
           </a:solidFill>
           <a:ln w="12700">
             <a:solidFill>
-              <a:srgbClr val="EAF3EE"/>
+              <a:srgbClr val="EAF1FB"/>
             </a:solidFill>
             <a:prstDash val="solid"/>
           </a:ln>
         </p:spPr>
+        <p:txBody>
+          <a:bodyPr/>
+          <a:p/>
+        </p:txBody>
       </p:sp>
       <p:sp>
         <p:nvSpPr>
@@ -5724,9 +5792,9 @@
             <a:r>
               <a:rPr lang="en-US" sz="3400" b="1" dirty="0">
                 <a:solidFill>
-                  <a:srgbClr val="0E5236"/>
-                </a:solidFill>
-                <a:latin typeface="Cambria" pitchFamily="34" charset="0"/>
+                  <a:srgbClr val="12345F"/>
+                </a:solidFill>
+                <a:latin typeface="Aptos" pitchFamily="34" charset="0"/>
                 <a:ea typeface="Cambria" pitchFamily="34" charset="-122"/>
                 <a:cs typeface="Cambria" pitchFamily="34" charset="-120"/>
               </a:rPr>
@@ -5763,9 +5831,9 @@
             <a:r>
               <a:rPr lang="en-US" sz="1200" b="1" dirty="0">
                 <a:solidFill>
-                  <a:srgbClr val="0B0B0B"/>
-                </a:solidFill>
-                <a:latin typeface="Calibri" pitchFamily="34" charset="0"/>
+                  <a:srgbClr val="12345F"/>
+                </a:solidFill>
+                <a:latin typeface="Aptos" pitchFamily="34" charset="0"/>
                 <a:ea typeface="Calibri" pitchFamily="34" charset="-122"/>
                 <a:cs typeface="Calibri" pitchFamily="34" charset="-120"/>
               </a:rPr>
@@ -5802,13 +5870,13 @@
             <a:r>
               <a:rPr lang="en-US" sz="1000" dirty="0">
                 <a:solidFill>
-                  <a:srgbClr val="5A6B62"/>
-                </a:solidFill>
-                <a:latin typeface="Calibri" pitchFamily="34" charset="0"/>
+                  <a:srgbClr val="12345F"/>
+                </a:solidFill>
+                <a:latin typeface="Aptos" pitchFamily="34" charset="0"/>
                 <a:ea typeface="Calibri" pitchFamily="34" charset="-122"/>
                 <a:cs typeface="Calibri" pitchFamily="34" charset="-120"/>
               </a:rPr>
-              <a:t>aucun opérateur, aucun point de souscription</a:t>
+              <a:t>aucun guichet opérateur ni point physique de souscription</a:t>
             </a:r>
             <a:endParaRPr lang="en-US" sz="1000" dirty="0"/>
           </a:p>
@@ -5843,7 +5911,7 @@
                 <a:solidFill>
                   <a:srgbClr val="0B0B0B"/>
                 </a:solidFill>
-                <a:latin typeface="Calibri" pitchFamily="34" charset="0"/>
+                <a:latin typeface="Aptos" pitchFamily="34" charset="0"/>
                 <a:ea typeface="Calibri" pitchFamily="34" charset="-122"/>
                 <a:cs typeface="Calibri" pitchFamily="34" charset="-120"/>
               </a:rPr>
@@ -5896,9 +5964,9 @@
             <a:r>
               <a:rPr lang="en-US" sz="1000" dirty="0">
                 <a:solidFill>
-                  <a:srgbClr val="5A6B62"/>
-                </a:solidFill>
-                <a:latin typeface="Calibri" pitchFamily="34" charset="0"/>
+                  <a:srgbClr val="0B0B0B"/>
+                </a:solidFill>
+                <a:latin typeface="Aptos" pitchFamily="34" charset="0"/>
                 <a:ea typeface="Calibri" pitchFamily="34" charset="-122"/>
                 <a:cs typeface="Calibri" pitchFamily="34" charset="-120"/>
               </a:rPr>
@@ -5919,6 +5987,14 @@
 <file path=ppt/slides/slide5.xml><?xml version="1.0" encoding="utf-8"?>
 <p:sld xmlns:a="http://schemas.openxmlformats.org/drawingml/2006/main" xmlns:r="http://schemas.openxmlformats.org/officeDocument/2006/relationships" xmlns:p="http://schemas.openxmlformats.org/presentationml/2006/main">
   <p:cSld name="Slide 5">
+    <p:bg>
+      <p:bgPr>
+        <a:solidFill>
+          <a:srgbClr val="FCFCFB"/>
+        </a:solidFill>
+        <a:effectLst/>
+      </p:bgPr>
+    </p:bg>
     <p:spTree>
       <p:nvGrpSpPr>
         <p:cNvPr id="1" name=""/>
@@ -5960,9 +6036,9 @@
             <a:r>
               <a:rPr lang="en-US" sz="1100" b="1" spc="200" kern="0" dirty="0">
                 <a:solidFill>
-                  <a:srgbClr val="4FA47C"/>
-                </a:solidFill>
-                <a:latin typeface="Calibri" pitchFamily="34" charset="0"/>
+                  <a:srgbClr val="12345F"/>
+                </a:solidFill>
+                <a:latin typeface="Aptos" pitchFamily="34" charset="0"/>
                 <a:ea typeface="Calibri" pitchFamily="34" charset="-122"/>
                 <a:cs typeface="Calibri" pitchFamily="34" charset="-120"/>
               </a:rPr>
@@ -5999,9 +6075,9 @@
             <a:r>
               <a:rPr lang="en-US" sz="3000" b="1" dirty="0">
                 <a:solidFill>
-                  <a:srgbClr val="0B0B0B"/>
-                </a:solidFill>
-                <a:latin typeface="Cambria" pitchFamily="34" charset="0"/>
+                  <a:srgbClr val="12345F"/>
+                </a:solidFill>
+                <a:latin typeface="Aptos" pitchFamily="34" charset="0"/>
                 <a:ea typeface="Cambria" pitchFamily="34" charset="-122"/>
                 <a:cs typeface="Cambria" pitchFamily="34" charset="-120"/>
               </a:rPr>
@@ -6052,15 +6128,19 @@
             </a:avLst>
           </a:prstGeom>
           <a:solidFill>
-            <a:srgbClr val="EAF3EE"/>
+            <a:srgbClr val="EAF1FB"/>
           </a:solidFill>
           <a:ln w="12700">
             <a:solidFill>
-              <a:srgbClr val="EAF3EE"/>
+              <a:srgbClr val="EAF1FB"/>
             </a:solidFill>
             <a:prstDash val="solid"/>
           </a:ln>
         </p:spPr>
+        <p:txBody>
+          <a:bodyPr/>
+          <a:p/>
+        </p:txBody>
       </p:sp>
       <p:sp>
         <p:nvSpPr>
@@ -6089,9 +6169,9 @@
             <a:r>
               <a:rPr lang="en-US" sz="3400" b="1" dirty="0">
                 <a:solidFill>
-                  <a:srgbClr val="0E5236"/>
-                </a:solidFill>
-                <a:latin typeface="Cambria" pitchFamily="34" charset="0"/>
+                  <a:srgbClr val="12345F"/>
+                </a:solidFill>
+                <a:latin typeface="Aptos" pitchFamily="34" charset="0"/>
                 <a:ea typeface="Cambria" pitchFamily="34" charset="-122"/>
                 <a:cs typeface="Cambria" pitchFamily="34" charset="-120"/>
               </a:rPr>
@@ -6128,9 +6208,9 @@
             <a:r>
               <a:rPr lang="en-US" sz="1200" b="1" dirty="0">
                 <a:solidFill>
-                  <a:srgbClr val="0B0B0B"/>
-                </a:solidFill>
-                <a:latin typeface="Calibri" pitchFamily="34" charset="0"/>
+                  <a:srgbClr val="12345F"/>
+                </a:solidFill>
+                <a:latin typeface="Aptos" pitchFamily="34" charset="0"/>
                 <a:ea typeface="Calibri" pitchFamily="34" charset="-122"/>
                 <a:cs typeface="Calibri" pitchFamily="34" charset="-120"/>
               </a:rPr>
@@ -6167,9 +6247,9 @@
             <a:r>
               <a:rPr lang="en-US" sz="1000" dirty="0">
                 <a:solidFill>
-                  <a:srgbClr val="5A6B62"/>
-                </a:solidFill>
-                <a:latin typeface="Calibri" pitchFamily="34" charset="0"/>
+                  <a:srgbClr val="12345F"/>
+                </a:solidFill>
+                <a:latin typeface="Aptos" pitchFamily="34" charset="0"/>
                 <a:ea typeface="Calibri" pitchFamily="34" charset="-122"/>
                 <a:cs typeface="Calibri" pitchFamily="34" charset="-120"/>
               </a:rPr>
@@ -6196,15 +6276,19 @@
             </a:avLst>
           </a:prstGeom>
           <a:solidFill>
-            <a:srgbClr val="EAF3EE"/>
+            <a:srgbClr val="EAF1FB"/>
           </a:solidFill>
           <a:ln w="12700">
             <a:solidFill>
-              <a:srgbClr val="EAF3EE"/>
+              <a:srgbClr val="EAF1FB"/>
             </a:solidFill>
             <a:prstDash val="solid"/>
           </a:ln>
         </p:spPr>
+        <p:txBody>
+          <a:bodyPr/>
+          <a:p/>
+        </p:txBody>
       </p:sp>
       <p:sp>
         <p:nvSpPr>
@@ -6233,9 +6317,9 @@
             <a:r>
               <a:rPr lang="en-US" sz="3400" b="1" dirty="0">
                 <a:solidFill>
-                  <a:srgbClr val="EB6834"/>
-                </a:solidFill>
-                <a:latin typeface="Cambria" pitchFamily="34" charset="0"/>
+                  <a:srgbClr val="12345F"/>
+                </a:solidFill>
+                <a:latin typeface="Aptos" pitchFamily="34" charset="0"/>
                 <a:ea typeface="Cambria" pitchFamily="34" charset="-122"/>
                 <a:cs typeface="Cambria" pitchFamily="34" charset="-120"/>
               </a:rPr>
@@ -6272,9 +6356,9 @@
             <a:r>
               <a:rPr lang="en-US" sz="1200" b="1" dirty="0">
                 <a:solidFill>
-                  <a:srgbClr val="0B0B0B"/>
-                </a:solidFill>
-                <a:latin typeface="Calibri" pitchFamily="34" charset="0"/>
+                  <a:srgbClr val="12345F"/>
+                </a:solidFill>
+                <a:latin typeface="Aptos" pitchFamily="34" charset="0"/>
                 <a:ea typeface="Calibri" pitchFamily="34" charset="-122"/>
                 <a:cs typeface="Calibri" pitchFamily="34" charset="-120"/>
               </a:rPr>
@@ -6311,9 +6395,9 @@
             <a:r>
               <a:rPr lang="en-US" sz="1000" dirty="0">
                 <a:solidFill>
-                  <a:srgbClr val="5A6B62"/>
-                </a:solidFill>
-                <a:latin typeface="Calibri" pitchFamily="34" charset="0"/>
+                  <a:srgbClr val="12345F"/>
+                </a:solidFill>
+                <a:latin typeface="Aptos" pitchFamily="34" charset="0"/>
                 <a:ea typeface="Calibri" pitchFamily="34" charset="-122"/>
                 <a:cs typeface="Calibri" pitchFamily="34" charset="-120"/>
               </a:rPr>
@@ -6340,15 +6424,19 @@
             </a:avLst>
           </a:prstGeom>
           <a:solidFill>
-            <a:srgbClr val="07341F"/>
+            <a:srgbClr val="0B2540"/>
           </a:solidFill>
           <a:ln w="12700">
             <a:solidFill>
-              <a:srgbClr val="07341F"/>
+              <a:srgbClr val="0B2540"/>
             </a:solidFill>
             <a:prstDash val="solid"/>
           </a:ln>
         </p:spPr>
+        <p:txBody>
+          <a:bodyPr/>
+          <a:p/>
+        </p:txBody>
       </p:sp>
       <p:sp>
         <p:nvSpPr>
@@ -6377,9 +6465,9 @@
             <a:r>
               <a:rPr lang="en-US" sz="1450" i="1" dirty="0">
                 <a:solidFill>
-                  <a:srgbClr val="F2C230"/>
-                </a:solidFill>
-                <a:latin typeface="Cambria" pitchFamily="34" charset="0"/>
+                  <a:srgbClr val="FFFFFF"/>
+                </a:solidFill>
+                <a:latin typeface="Aptos" pitchFamily="34" charset="0"/>
                 <a:ea typeface="Cambria" pitchFamily="34" charset="-122"/>
                 <a:cs typeface="Cambria" pitchFamily="34" charset="-120"/>
               </a:rPr>
@@ -6421,7 +6509,7 @@
                 <a:solidFill>
                   <a:srgbClr val="0B0B0B"/>
                 </a:solidFill>
-                <a:latin typeface="Calibri" pitchFamily="34" charset="0"/>
+                <a:latin typeface="Aptos" pitchFamily="34" charset="0"/>
                 <a:ea typeface="Calibri" pitchFamily="34" charset="-122"/>
                 <a:cs typeface="Calibri" pitchFamily="34" charset="-120"/>
               </a:rPr>
@@ -6438,7 +6526,7 @@
                 <a:solidFill>
                   <a:srgbClr val="0B0B0B"/>
                 </a:solidFill>
-                <a:latin typeface="Calibri" pitchFamily="34" charset="0"/>
+                <a:latin typeface="Aptos" pitchFamily="34" charset="0"/>
                 <a:ea typeface="Calibri" pitchFamily="34" charset="-122"/>
                 <a:cs typeface="Calibri" pitchFamily="34" charset="-120"/>
               </a:rPr>
@@ -6467,7 +6555,7 @@
                 <a:solidFill>
                   <a:srgbClr val="0B0B0B"/>
                 </a:solidFill>
-                <a:latin typeface="Calibri" pitchFamily="34" charset="0"/>
+                <a:latin typeface="Aptos" pitchFamily="34" charset="0"/>
                 <a:ea typeface="Calibri" pitchFamily="34" charset="-122"/>
                 <a:cs typeface="Calibri" pitchFamily="34" charset="-120"/>
               </a:rPr>
@@ -6504,9 +6592,9 @@
             <a:r>
               <a:rPr lang="en-US" sz="1000" dirty="0">
                 <a:solidFill>
-                  <a:srgbClr val="5A6B62"/>
-                </a:solidFill>
-                <a:latin typeface="Calibri" pitchFamily="34" charset="0"/>
+                  <a:srgbClr val="0B0B0B"/>
+                </a:solidFill>
+                <a:latin typeface="Aptos" pitchFamily="34" charset="0"/>
                 <a:ea typeface="Calibri" pitchFamily="34" charset="-122"/>
                 <a:cs typeface="Calibri" pitchFamily="34" charset="-120"/>
               </a:rPr>
@@ -6527,6 +6615,14 @@
 <file path=ppt/slides/slide6.xml><?xml version="1.0" encoding="utf-8"?>
 <p:sld xmlns:a="http://schemas.openxmlformats.org/drawingml/2006/main" xmlns:r="http://schemas.openxmlformats.org/officeDocument/2006/relationships" xmlns:p="http://schemas.openxmlformats.org/presentationml/2006/main">
   <p:cSld name="Slide 6">
+    <p:bg>
+      <p:bgPr>
+        <a:solidFill>
+          <a:srgbClr val="FCFCFB"/>
+        </a:solidFill>
+        <a:effectLst/>
+      </p:bgPr>
+    </p:bg>
     <p:spTree>
       <p:nvGrpSpPr>
         <p:cNvPr id="1" name=""/>
@@ -6568,9 +6664,9 @@
             <a:r>
               <a:rPr lang="en-US" sz="1100" b="1" spc="200" kern="0" dirty="0">
                 <a:solidFill>
-                  <a:srgbClr val="4FA47C"/>
-                </a:solidFill>
-                <a:latin typeface="Calibri" pitchFamily="34" charset="0"/>
+                  <a:srgbClr val="12345F"/>
+                </a:solidFill>
+                <a:latin typeface="Aptos" pitchFamily="34" charset="0"/>
                 <a:ea typeface="Calibri" pitchFamily="34" charset="-122"/>
                 <a:cs typeface="Calibri" pitchFamily="34" charset="-120"/>
               </a:rPr>
@@ -6607,9 +6703,9 @@
             <a:r>
               <a:rPr lang="en-US" sz="3000" b="1" dirty="0">
                 <a:solidFill>
-                  <a:srgbClr val="0B0B0B"/>
-                </a:solidFill>
-                <a:latin typeface="Cambria" pitchFamily="34" charset="0"/>
+                  <a:srgbClr val="12345F"/>
+                </a:solidFill>
+                <a:latin typeface="Aptos" pitchFamily="34" charset="0"/>
                 <a:ea typeface="Cambria" pitchFamily="34" charset="-122"/>
                 <a:cs typeface="Cambria" pitchFamily="34" charset="-120"/>
               </a:rPr>
@@ -6660,15 +6756,19 @@
             </a:avLst>
           </a:prstGeom>
           <a:solidFill>
-            <a:srgbClr val="EAF3EE"/>
+            <a:srgbClr val="EAF1FB"/>
           </a:solidFill>
           <a:ln w="12700">
             <a:solidFill>
-              <a:srgbClr val="EAF3EE"/>
+              <a:srgbClr val="EAF1FB"/>
             </a:solidFill>
             <a:prstDash val="solid"/>
           </a:ln>
         </p:spPr>
+        <p:txBody>
+          <a:bodyPr/>
+          <a:p/>
+        </p:txBody>
       </p:sp>
       <p:sp>
         <p:nvSpPr>
@@ -6697,9 +6797,9 @@
             <a:r>
               <a:rPr lang="en-US" sz="3400" b="1" dirty="0">
                 <a:solidFill>
-                  <a:srgbClr val="0E5236"/>
-                </a:solidFill>
-                <a:latin typeface="Cambria" pitchFamily="34" charset="0"/>
+                  <a:srgbClr val="12345F"/>
+                </a:solidFill>
+                <a:latin typeface="Aptos" pitchFamily="34" charset="0"/>
                 <a:ea typeface="Cambria" pitchFamily="34" charset="-122"/>
                 <a:cs typeface="Cambria" pitchFamily="34" charset="-120"/>
               </a:rPr>
@@ -6736,9 +6836,9 @@
             <a:r>
               <a:rPr lang="en-US" sz="1200" b="1" dirty="0">
                 <a:solidFill>
-                  <a:srgbClr val="0B0B0B"/>
-                </a:solidFill>
-                <a:latin typeface="Calibri" pitchFamily="34" charset="0"/>
+                  <a:srgbClr val="12345F"/>
+                </a:solidFill>
+                <a:latin typeface="Aptos" pitchFamily="34" charset="0"/>
                 <a:ea typeface="Calibri" pitchFamily="34" charset="-122"/>
                 <a:cs typeface="Calibri" pitchFamily="34" charset="-120"/>
               </a:rPr>
@@ -6775,9 +6875,9 @@
             <a:r>
               <a:rPr lang="en-US" sz="1000" dirty="0">
                 <a:solidFill>
-                  <a:srgbClr val="5A6B62"/>
-                </a:solidFill>
-                <a:latin typeface="Calibri" pitchFamily="34" charset="0"/>
+                  <a:srgbClr val="12345F"/>
+                </a:solidFill>
+                <a:latin typeface="Aptos" pitchFamily="34" charset="0"/>
                 <a:ea typeface="Calibri" pitchFamily="34" charset="-122"/>
                 <a:cs typeface="Calibri" pitchFamily="34" charset="-120"/>
               </a:rPr>
@@ -6804,15 +6904,19 @@
             </a:avLst>
           </a:prstGeom>
           <a:solidFill>
-            <a:srgbClr val="EAF3EE"/>
+            <a:srgbClr val="EAF1FB"/>
           </a:solidFill>
           <a:ln w="12700">
             <a:solidFill>
-              <a:srgbClr val="EAF3EE"/>
+              <a:srgbClr val="EAF1FB"/>
             </a:solidFill>
             <a:prstDash val="solid"/>
           </a:ln>
         </p:spPr>
+        <p:txBody>
+          <a:bodyPr/>
+          <a:p/>
+        </p:txBody>
       </p:sp>
       <p:sp>
         <p:nvSpPr>
@@ -6841,9 +6945,9 @@
             <a:r>
               <a:rPr lang="en-US" sz="3400" b="1" dirty="0">
                 <a:solidFill>
-                  <a:srgbClr val="EB6834"/>
-                </a:solidFill>
-                <a:latin typeface="Cambria" pitchFamily="34" charset="0"/>
+                  <a:srgbClr val="12345F"/>
+                </a:solidFill>
+                <a:latin typeface="Aptos" pitchFamily="34" charset="0"/>
                 <a:ea typeface="Cambria" pitchFamily="34" charset="-122"/>
                 <a:cs typeface="Cambria" pitchFamily="34" charset="-120"/>
               </a:rPr>
@@ -6880,9 +6984,9 @@
             <a:r>
               <a:rPr lang="en-US" sz="1200" b="1" dirty="0">
                 <a:solidFill>
-                  <a:srgbClr val="0B0B0B"/>
-                </a:solidFill>
-                <a:latin typeface="Calibri" pitchFamily="34" charset="0"/>
+                  <a:srgbClr val="12345F"/>
+                </a:solidFill>
+                <a:latin typeface="Aptos" pitchFamily="34" charset="0"/>
                 <a:ea typeface="Calibri" pitchFamily="34" charset="-122"/>
                 <a:cs typeface="Calibri" pitchFamily="34" charset="-120"/>
               </a:rPr>
@@ -6919,9 +7023,9 @@
             <a:r>
               <a:rPr lang="en-US" sz="1000" dirty="0">
                 <a:solidFill>
-                  <a:srgbClr val="5A6B62"/>
-                </a:solidFill>
-                <a:latin typeface="Calibri" pitchFamily="34" charset="0"/>
+                  <a:srgbClr val="12345F"/>
+                </a:solidFill>
+                <a:latin typeface="Aptos" pitchFamily="34" charset="0"/>
                 <a:ea typeface="Calibri" pitchFamily="34" charset="-122"/>
                 <a:cs typeface="Calibri" pitchFamily="34" charset="-120"/>
               </a:rPr>
@@ -6963,7 +7067,7 @@
                 <a:solidFill>
                   <a:srgbClr val="0B0B0B"/>
                 </a:solidFill>
-                <a:latin typeface="Calibri" pitchFamily="34" charset="0"/>
+                <a:latin typeface="Aptos" pitchFamily="34" charset="0"/>
                 <a:ea typeface="Calibri" pitchFamily="34" charset="-122"/>
                 <a:cs typeface="Calibri" pitchFamily="34" charset="-120"/>
               </a:rPr>
@@ -6983,7 +7087,7 @@
                 <a:solidFill>
                   <a:srgbClr val="0B0B0B"/>
                 </a:solidFill>
-                <a:latin typeface="Calibri" pitchFamily="34" charset="0"/>
+                <a:latin typeface="Aptos" pitchFamily="34" charset="0"/>
                 <a:ea typeface="Calibri" pitchFamily="34" charset="-122"/>
                 <a:cs typeface="Calibri" pitchFamily="34" charset="-120"/>
               </a:rPr>
@@ -7012,7 +7116,7 @@
                 <a:solidFill>
                   <a:srgbClr val="0B0B0B"/>
                 </a:solidFill>
-                <a:latin typeface="Calibri" pitchFamily="34" charset="0"/>
+                <a:latin typeface="Aptos" pitchFamily="34" charset="0"/>
                 <a:ea typeface="Calibri" pitchFamily="34" charset="-122"/>
                 <a:cs typeface="Calibri" pitchFamily="34" charset="-120"/>
               </a:rPr>
@@ -7049,9 +7153,9 @@
             <a:r>
               <a:rPr lang="en-US" sz="1000" dirty="0">
                 <a:solidFill>
-                  <a:srgbClr val="5A6B62"/>
-                </a:solidFill>
-                <a:latin typeface="Calibri" pitchFamily="34" charset="0"/>
+                  <a:srgbClr val="12345F"/>
+                </a:solidFill>
+                <a:latin typeface="Aptos" pitchFamily="34" charset="0"/>
                 <a:ea typeface="Calibri" pitchFamily="34" charset="-122"/>
                 <a:cs typeface="Calibri" pitchFamily="34" charset="-120"/>
               </a:rPr>
@@ -7072,6 +7176,14 @@
 <file path=ppt/slides/slide7.xml><?xml version="1.0" encoding="utf-8"?>
 <p:sld xmlns:a="http://schemas.openxmlformats.org/drawingml/2006/main" xmlns:r="http://schemas.openxmlformats.org/officeDocument/2006/relationships" xmlns:p="http://schemas.openxmlformats.org/presentationml/2006/main">
   <p:cSld name="Slide 7">
+    <p:bg>
+      <p:bgPr>
+        <a:solidFill>
+          <a:srgbClr val="FCFCFB"/>
+        </a:solidFill>
+        <a:effectLst/>
+      </p:bgPr>
+    </p:bg>
     <p:spTree>
       <p:nvGrpSpPr>
         <p:cNvPr id="1" name=""/>
@@ -7113,9 +7225,9 @@
             <a:r>
               <a:rPr lang="en-US" sz="1100" b="1" spc="200" kern="0" dirty="0">
                 <a:solidFill>
-                  <a:srgbClr val="4FA47C"/>
-                </a:solidFill>
-                <a:latin typeface="Calibri" pitchFamily="34" charset="0"/>
+                  <a:srgbClr val="12345F"/>
+                </a:solidFill>
+                <a:latin typeface="Aptos" pitchFamily="34" charset="0"/>
                 <a:ea typeface="Calibri" pitchFamily="34" charset="-122"/>
                 <a:cs typeface="Calibri" pitchFamily="34" charset="-120"/>
               </a:rPr>
@@ -7152,9 +7264,9 @@
             <a:r>
               <a:rPr lang="en-US" sz="3000" b="1" dirty="0">
                 <a:solidFill>
-                  <a:srgbClr val="0B0B0B"/>
-                </a:solidFill>
-                <a:latin typeface="Cambria" pitchFamily="34" charset="0"/>
+                  <a:srgbClr val="12345F"/>
+                </a:solidFill>
+                <a:latin typeface="Aptos" pitchFamily="34" charset="0"/>
                 <a:ea typeface="Cambria" pitchFamily="34" charset="-122"/>
                 <a:cs typeface="Cambria" pitchFamily="34" charset="-120"/>
               </a:rPr>
@@ -7181,15 +7293,19 @@
             </a:avLst>
           </a:prstGeom>
           <a:solidFill>
-            <a:srgbClr val="0E5236"/>
+            <a:srgbClr val="12345F"/>
           </a:solidFill>
           <a:ln w="12700">
             <a:solidFill>
-              <a:srgbClr val="0E5236"/>
+              <a:srgbClr val="12345F"/>
             </a:solidFill>
             <a:prstDash val="solid"/>
           </a:ln>
         </p:spPr>
+        <p:txBody>
+          <a:bodyPr/>
+          <a:p/>
+        </p:txBody>
       </p:sp>
       <p:sp>
         <p:nvSpPr>
@@ -7220,7 +7336,7 @@
                 <a:solidFill>
                   <a:srgbClr val="FFFFFF"/>
                 </a:solidFill>
-                <a:latin typeface="Cambria" pitchFamily="34" charset="0"/>
+                <a:latin typeface="Aptos" pitchFamily="34" charset="0"/>
                 <a:ea typeface="Cambria" pitchFamily="34" charset="-122"/>
                 <a:cs typeface="Cambria" pitchFamily="34" charset="-120"/>
               </a:rPr>
@@ -7257,13 +7373,13 @@
             <a:r>
               <a:rPr lang="en-US" sz="4600" b="1" dirty="0">
                 <a:solidFill>
-                  <a:srgbClr val="F2C230"/>
-                </a:solidFill>
-                <a:latin typeface="Cambria" pitchFamily="34" charset="0"/>
+                  <a:srgbClr val="FFFFFF"/>
+                </a:solidFill>
+                <a:latin typeface="Aptos" pitchFamily="34" charset="0"/>
                 <a:ea typeface="Cambria" pitchFamily="34" charset="-122"/>
                 <a:cs typeface="Cambria" pitchFamily="34" charset="-120"/>
               </a:rPr>
-              <a:t>761</a:t>
+              <a:t>760</a:t>
             </a:r>
             <a:endParaRPr lang="en-US" sz="4600" dirty="0"/>
           </a:p>
@@ -7296,9 +7412,9 @@
             <a:r>
               <a:rPr lang="en-US" sz="1200" dirty="0">
                 <a:solidFill>
-                  <a:srgbClr val="BFDDCB"/>
-                </a:solidFill>
-                <a:latin typeface="Calibri" pitchFamily="34" charset="0"/>
+                  <a:srgbClr val="FFFFFF"/>
+                </a:solidFill>
+                <a:latin typeface="Aptos" pitchFamily="34" charset="0"/>
                 <a:ea typeface="Calibri" pitchFamily="34" charset="-122"/>
                 <a:cs typeface="Calibri" pitchFamily="34" charset="-120"/>
               </a:rPr>
@@ -7313,9 +7429,9 @@
             <a:r>
               <a:rPr lang="en-US" sz="1200" dirty="0">
                 <a:solidFill>
-                  <a:srgbClr val="BFDDCB"/>
-                </a:solidFill>
-                <a:latin typeface="Calibri" pitchFamily="34" charset="0"/>
+                  <a:srgbClr val="FFFFFF"/>
+                </a:solidFill>
+                <a:latin typeface="Aptos" pitchFamily="34" charset="0"/>
                 <a:ea typeface="Calibri" pitchFamily="34" charset="-122"/>
                 <a:cs typeface="Calibri" pitchFamily="34" charset="-120"/>
               </a:rPr>
@@ -7357,7 +7473,7 @@
                 <a:solidFill>
                   <a:srgbClr val="0B0B0B"/>
                 </a:solidFill>
-                <a:latin typeface="Calibri" pitchFamily="34" charset="0"/>
+                <a:latin typeface="Aptos" pitchFamily="34" charset="0"/>
                 <a:ea typeface="Calibri" pitchFamily="34" charset="-122"/>
                 <a:cs typeface="Calibri" pitchFamily="34" charset="-120"/>
               </a:rPr>
@@ -7377,11 +7493,11 @@
                 <a:solidFill>
                   <a:srgbClr val="0B0B0B"/>
                 </a:solidFill>
-                <a:latin typeface="Calibri" pitchFamily="34" charset="0"/>
+                <a:latin typeface="Aptos" pitchFamily="34" charset="0"/>
                 <a:ea typeface="Calibri" pitchFamily="34" charset="-122"/>
                 <a:cs typeface="Calibri" pitchFamily="34" charset="-120"/>
               </a:rPr>
-              <a:t>La préfecture la plus dynamique démographiquement du pays affiche 0,65 fois l’accès attendu au regard de sa population. La croissance urbaine a devancé l’implantation des services.</a:t>
+              <a:t>Une préfecture périurbaine fortement peuplée affiche 0,65 fois l’accès attendu au regard de sa population. La croissance urbaine a devancé l’implantation des services.</a:t>
             </a:r>
             <a:endParaRPr lang="en-US" sz="1200" dirty="0"/>
           </a:p>
@@ -7406,7 +7522,7 @@
                 <a:solidFill>
                   <a:srgbClr val="0B0B0B"/>
                 </a:solidFill>
-                <a:latin typeface="Calibri" pitchFamily="34" charset="0"/>
+                <a:latin typeface="Aptos" pitchFamily="34" charset="0"/>
                 <a:ea typeface="Calibri" pitchFamily="34" charset="-122"/>
                 <a:cs typeface="Calibri" pitchFamily="34" charset="-120"/>
               </a:rPr>
@@ -7435,7 +7551,7 @@
                 <a:solidFill>
                   <a:srgbClr val="0B0B0B"/>
                 </a:solidFill>
-                <a:latin typeface="Calibri" pitchFamily="34" charset="0"/>
+                <a:latin typeface="Aptos" pitchFamily="34" charset="0"/>
                 <a:ea typeface="Calibri" pitchFamily="34" charset="-122"/>
                 <a:cs typeface="Calibri" pitchFamily="34" charset="-120"/>
               </a:rPr>
@@ -7488,9 +7604,9 @@
             <a:r>
               <a:rPr lang="en-US" sz="1000" dirty="0">
                 <a:solidFill>
-                  <a:srgbClr val="5A6B62"/>
-                </a:solidFill>
-                <a:latin typeface="Calibri" pitchFamily="34" charset="0"/>
+                  <a:srgbClr val="0B0B0B"/>
+                </a:solidFill>
+                <a:latin typeface="Aptos" pitchFamily="34" charset="0"/>
                 <a:ea typeface="Calibri" pitchFamily="34" charset="-122"/>
                 <a:cs typeface="Calibri" pitchFamily="34" charset="-120"/>
               </a:rPr>
@@ -7511,6 +7627,14 @@
 <file path=ppt/slides/slide8.xml><?xml version="1.0" encoding="utf-8"?>
 <p:sld xmlns:a="http://schemas.openxmlformats.org/drawingml/2006/main" xmlns:r="http://schemas.openxmlformats.org/officeDocument/2006/relationships" xmlns:p="http://schemas.openxmlformats.org/presentationml/2006/main">
   <p:cSld name="Slide 8">
+    <p:bg>
+      <p:bgPr>
+        <a:solidFill>
+          <a:srgbClr val="FCFCFB"/>
+        </a:solidFill>
+        <a:effectLst/>
+      </p:bgPr>
+    </p:bg>
     <p:spTree>
       <p:nvGrpSpPr>
         <p:cNvPr id="1" name=""/>
@@ -7552,9 +7676,9 @@
             <a:r>
               <a:rPr lang="en-US" sz="1100" b="1" spc="200" kern="0" dirty="0">
                 <a:solidFill>
-                  <a:srgbClr val="4FA47C"/>
-                </a:solidFill>
-                <a:latin typeface="Calibri" pitchFamily="34" charset="0"/>
+                  <a:srgbClr val="12345F"/>
+                </a:solidFill>
+                <a:latin typeface="Aptos" pitchFamily="34" charset="0"/>
                 <a:ea typeface="Calibri" pitchFamily="34" charset="-122"/>
                 <a:cs typeface="Calibri" pitchFamily="34" charset="-120"/>
               </a:rPr>
@@ -7591,9 +7715,9 @@
             <a:r>
               <a:rPr lang="en-US" sz="3000" b="1" dirty="0">
                 <a:solidFill>
-                  <a:srgbClr val="0B0B0B"/>
-                </a:solidFill>
-                <a:latin typeface="Cambria" pitchFamily="34" charset="0"/>
+                  <a:srgbClr val="12345F"/>
+                </a:solidFill>
+                <a:latin typeface="Aptos" pitchFamily="34" charset="0"/>
                 <a:ea typeface="Cambria" pitchFamily="34" charset="-122"/>
                 <a:cs typeface="Cambria" pitchFamily="34" charset="-120"/>
               </a:rPr>
@@ -7620,15 +7744,19 @@
             </a:avLst>
           </a:prstGeom>
           <a:solidFill>
-            <a:srgbClr val="EAF3EE"/>
+            <a:srgbClr val="EAF1FB"/>
           </a:solidFill>
           <a:ln w="12700">
             <a:solidFill>
-              <a:srgbClr val="EAF3EE"/>
+              <a:srgbClr val="EAF1FB"/>
             </a:solidFill>
             <a:prstDash val="solid"/>
           </a:ln>
         </p:spPr>
+        <p:txBody>
+          <a:bodyPr/>
+          <a:p/>
+        </p:txBody>
       </p:sp>
       <p:sp>
         <p:nvSpPr>
@@ -7657,9 +7785,9 @@
             <a:r>
               <a:rPr lang="en-US" sz="1200" b="1" dirty="0">
                 <a:solidFill>
-                  <a:srgbClr val="0E5236"/>
-                </a:solidFill>
-                <a:latin typeface="Courier New" pitchFamily="34" charset="0"/>
+                  <a:srgbClr val="12345F"/>
+                </a:solidFill>
+                <a:latin typeface="Aptos" pitchFamily="34" charset="0"/>
                 <a:ea typeface="Courier New" pitchFamily="34" charset="-122"/>
                 <a:cs typeface="Courier New" pitchFamily="34" charset="-120"/>
               </a:rPr>
@@ -7701,7 +7829,7 @@
                 <a:solidFill>
                   <a:srgbClr val="0B0B0B"/>
                 </a:solidFill>
-                <a:latin typeface="Calibri" pitchFamily="34" charset="0"/>
+                <a:latin typeface="Aptos" pitchFamily="34" charset="0"/>
                 <a:ea typeface="Calibri" pitchFamily="34" charset="-122"/>
                 <a:cs typeface="Calibri" pitchFamily="34" charset="-120"/>
               </a:rPr>
@@ -7721,7 +7849,7 @@
                 <a:solidFill>
                   <a:srgbClr val="0B0B0B"/>
                 </a:solidFill>
-                <a:latin typeface="Calibri" pitchFamily="34" charset="0"/>
+                <a:latin typeface="Aptos" pitchFamily="34" charset="0"/>
                 <a:ea typeface="Calibri" pitchFamily="34" charset="-122"/>
                 <a:cs typeface="Calibri" pitchFamily="34" charset="-120"/>
               </a:rPr>
@@ -7750,7 +7878,7 @@
                 <a:solidFill>
                   <a:srgbClr val="0B0B0B"/>
                 </a:solidFill>
-                <a:latin typeface="Calibri" pitchFamily="34" charset="0"/>
+                <a:latin typeface="Aptos" pitchFamily="34" charset="0"/>
                 <a:ea typeface="Calibri" pitchFamily="34" charset="-122"/>
                 <a:cs typeface="Calibri" pitchFamily="34" charset="-120"/>
               </a:rPr>
@@ -7779,7 +7907,7 @@
                 <a:solidFill>
                   <a:srgbClr val="0B0B0B"/>
                 </a:solidFill>
-                <a:latin typeface="Calibri" pitchFamily="34" charset="0"/>
+                <a:latin typeface="Aptos" pitchFamily="34" charset="0"/>
                 <a:ea typeface="Calibri" pitchFamily="34" charset="-122"/>
                 <a:cs typeface="Calibri" pitchFamily="34" charset="-120"/>
               </a:rPr>
@@ -7832,9 +7960,9 @@
             <a:r>
               <a:rPr lang="en-US" sz="1000" dirty="0">
                 <a:solidFill>
-                  <a:srgbClr val="5A6B62"/>
-                </a:solidFill>
-                <a:latin typeface="Calibri" pitchFamily="34" charset="0"/>
+                  <a:srgbClr val="0B0B0B"/>
+                </a:solidFill>
+                <a:latin typeface="Aptos" pitchFamily="34" charset="0"/>
                 <a:ea typeface="Calibri" pitchFamily="34" charset="-122"/>
                 <a:cs typeface="Calibri" pitchFamily="34" charset="-120"/>
               </a:rPr>
@@ -7855,6 +7983,14 @@
 <file path=ppt/slides/slide9.xml><?xml version="1.0" encoding="utf-8"?>
 <p:sld xmlns:a="http://schemas.openxmlformats.org/drawingml/2006/main" xmlns:r="http://schemas.openxmlformats.org/officeDocument/2006/relationships" xmlns:p="http://schemas.openxmlformats.org/presentationml/2006/main">
   <p:cSld name="Slide 9">
+    <p:bg>
+      <p:bgPr>
+        <a:solidFill>
+          <a:srgbClr val="FCFCFB"/>
+        </a:solidFill>
+        <a:effectLst/>
+      </p:bgPr>
+    </p:bg>
     <p:spTree>
       <p:nvGrpSpPr>
         <p:cNvPr id="1" name=""/>
@@ -7896,9 +8032,9 @@
             <a:r>
               <a:rPr lang="en-US" sz="1100" b="1" spc="200" kern="0" dirty="0">
                 <a:solidFill>
-                  <a:srgbClr val="4FA47C"/>
-                </a:solidFill>
-                <a:latin typeface="Calibri" pitchFamily="34" charset="0"/>
+                  <a:srgbClr val="12345F"/>
+                </a:solidFill>
+                <a:latin typeface="Aptos" pitchFamily="34" charset="0"/>
                 <a:ea typeface="Calibri" pitchFamily="34" charset="-122"/>
                 <a:cs typeface="Calibri" pitchFamily="34" charset="-120"/>
               </a:rPr>
@@ -7935,9 +8071,9 @@
             <a:r>
               <a:rPr lang="en-US" sz="3000" b="1" dirty="0">
                 <a:solidFill>
-                  <a:srgbClr val="0B0B0B"/>
-                </a:solidFill>
-                <a:latin typeface="Cambria" pitchFamily="34" charset="0"/>
+                  <a:srgbClr val="12345F"/>
+                </a:solidFill>
+                <a:latin typeface="Aptos" pitchFamily="34" charset="0"/>
                 <a:ea typeface="Cambria" pitchFamily="34" charset="-122"/>
                 <a:cs typeface="Cambria" pitchFamily="34" charset="-120"/>
               </a:rPr>
@@ -7962,15 +8098,19 @@
             <a:avLst/>
           </a:prstGeom>
           <a:solidFill>
-            <a:srgbClr val="0E5236"/>
+            <a:srgbClr val="12345F"/>
           </a:solidFill>
           <a:ln w="12700">
             <a:solidFill>
-              <a:srgbClr val="0E5236"/>
+              <a:srgbClr val="12345F"/>
             </a:solidFill>
             <a:prstDash val="solid"/>
           </a:ln>
         </p:spPr>
+        <p:txBody>
+          <a:bodyPr/>
+          <a:p/>
+        </p:txBody>
       </p:sp>
       <p:sp>
         <p:nvSpPr>
@@ -8001,7 +8141,7 @@
                 <a:solidFill>
                   <a:srgbClr val="FFFFFF"/>
                 </a:solidFill>
-                <a:latin typeface="Cambria" pitchFamily="34" charset="0"/>
+                <a:latin typeface="Aptos" pitchFamily="34" charset="0"/>
                 <a:ea typeface="Cambria" pitchFamily="34" charset="-122"/>
                 <a:cs typeface="Cambria" pitchFamily="34" charset="-120"/>
               </a:rPr>
@@ -8038,9 +8178,9 @@
             <a:r>
               <a:rPr lang="en-US" sz="1400" b="1" dirty="0">
                 <a:solidFill>
-                  <a:srgbClr val="0E5236"/>
-                </a:solidFill>
-                <a:latin typeface="Cambria" pitchFamily="34" charset="0"/>
+                  <a:srgbClr val="12345F"/>
+                </a:solidFill>
+                <a:latin typeface="Aptos" pitchFamily="34" charset="0"/>
                 <a:ea typeface="Cambria" pitchFamily="34" charset="-122"/>
                 <a:cs typeface="Cambria" pitchFamily="34" charset="-120"/>
               </a:rPr>
@@ -8079,7 +8219,7 @@
                 <a:solidFill>
                   <a:srgbClr val="0B0B0B"/>
                 </a:solidFill>
-                <a:latin typeface="Calibri" pitchFamily="34" charset="0"/>
+                <a:latin typeface="Aptos" pitchFamily="34" charset="0"/>
                 <a:ea typeface="Calibri" pitchFamily="34" charset="-122"/>
                 <a:cs typeface="Calibri" pitchFamily="34" charset="-120"/>
               </a:rPr>
@@ -8104,15 +8244,19 @@
             <a:avLst/>
           </a:prstGeom>
           <a:solidFill>
-            <a:srgbClr val="0E5236"/>
+            <a:srgbClr val="12345F"/>
           </a:solidFill>
           <a:ln w="12700">
             <a:solidFill>
-              <a:srgbClr val="0E5236"/>
+              <a:srgbClr val="12345F"/>
             </a:solidFill>
             <a:prstDash val="solid"/>
           </a:ln>
         </p:spPr>
+        <p:txBody>
+          <a:bodyPr/>
+          <a:p/>
+        </p:txBody>
       </p:sp>
       <p:sp>
         <p:nvSpPr>
@@ -8143,7 +8287,7 @@
                 <a:solidFill>
                   <a:srgbClr val="FFFFFF"/>
                 </a:solidFill>
-                <a:latin typeface="Cambria" pitchFamily="34" charset="0"/>
+                <a:latin typeface="Aptos" pitchFamily="34" charset="0"/>
                 <a:ea typeface="Cambria" pitchFamily="34" charset="-122"/>
                 <a:cs typeface="Cambria" pitchFamily="34" charset="-120"/>
               </a:rPr>
@@ -8180,9 +8324,9 @@
             <a:r>
               <a:rPr lang="en-US" sz="1400" b="1" dirty="0">
                 <a:solidFill>
-                  <a:srgbClr val="0E5236"/>
-                </a:solidFill>
-                <a:latin typeface="Cambria" pitchFamily="34" charset="0"/>
+                  <a:srgbClr val="12345F"/>
+                </a:solidFill>
+                <a:latin typeface="Aptos" pitchFamily="34" charset="0"/>
                 <a:ea typeface="Cambria" pitchFamily="34" charset="-122"/>
                 <a:cs typeface="Cambria" pitchFamily="34" charset="-120"/>
               </a:rPr>
@@ -8221,7 +8365,7 @@
                 <a:solidFill>
                   <a:srgbClr val="0B0B0B"/>
                 </a:solidFill>
-                <a:latin typeface="Calibri" pitchFamily="34" charset="0"/>
+                <a:latin typeface="Aptos" pitchFamily="34" charset="0"/>
                 <a:ea typeface="Calibri" pitchFamily="34" charset="-122"/>
                 <a:cs typeface="Calibri" pitchFamily="34" charset="-120"/>
               </a:rPr>
@@ -8246,15 +8390,19 @@
             <a:avLst/>
           </a:prstGeom>
           <a:solidFill>
-            <a:srgbClr val="0E5236"/>
+            <a:srgbClr val="12345F"/>
           </a:solidFill>
           <a:ln w="12700">
             <a:solidFill>
-              <a:srgbClr val="0E5236"/>
+              <a:srgbClr val="12345F"/>
             </a:solidFill>
             <a:prstDash val="solid"/>
           </a:ln>
         </p:spPr>
+        <p:txBody>
+          <a:bodyPr/>
+          <a:p/>
+        </p:txBody>
       </p:sp>
       <p:sp>
         <p:nvSpPr>
@@ -8285,7 +8433,7 @@
                 <a:solidFill>
                   <a:srgbClr val="FFFFFF"/>
                 </a:solidFill>
-                <a:latin typeface="Cambria" pitchFamily="34" charset="0"/>
+                <a:latin typeface="Aptos" pitchFamily="34" charset="0"/>
                 <a:ea typeface="Cambria" pitchFamily="34" charset="-122"/>
                 <a:cs typeface="Cambria" pitchFamily="34" charset="-120"/>
               </a:rPr>
@@ -8322,9 +8470,9 @@
             <a:r>
               <a:rPr lang="en-US" sz="1400" b="1" dirty="0">
                 <a:solidFill>
-                  <a:srgbClr val="0E5236"/>
-                </a:solidFill>
-                <a:latin typeface="Cambria" pitchFamily="34" charset="0"/>
+                  <a:srgbClr val="12345F"/>
+                </a:solidFill>
+                <a:latin typeface="Aptos" pitchFamily="34" charset="0"/>
                 <a:ea typeface="Cambria" pitchFamily="34" charset="-122"/>
                 <a:cs typeface="Cambria" pitchFamily="34" charset="-120"/>
               </a:rPr>
@@ -8363,11 +8511,11 @@
                 <a:solidFill>
                   <a:srgbClr val="0B0B0B"/>
                 </a:solidFill>
-                <a:latin typeface="Calibri" pitchFamily="34" charset="0"/>
+                <a:latin typeface="Aptos" pitchFamily="34" charset="0"/>
                 <a:ea typeface="Calibri" pitchFamily="34" charset="-122"/>
                 <a:cs typeface="Calibri" pitchFamily="34" charset="-120"/>
               </a:rPr>
-              <a:t>Est-Mono, Vo et Lacs cumulent absence de guichet et déficit de points. Ce qui manque n’est pas le volume mais la souscription, le SAV et la réclamation.</a:t>
+              <a:t>Est-Mono, Vo et Lacs cumulent l’absence de guichet opérateur ; leurs besoins ne sont toutefois pas identiques en matière de mobile money.</a:t>
             </a:r>
             <a:endParaRPr lang="en-US" sz="1150" dirty="0"/>
           </a:p>
@@ -8388,15 +8536,19 @@
             <a:avLst/>
           </a:prstGeom>
           <a:solidFill>
-            <a:srgbClr val="4FA47C"/>
+            <a:srgbClr val="1BAF7A"/>
           </a:solidFill>
           <a:ln w="12700">
             <a:solidFill>
-              <a:srgbClr val="4FA47C"/>
+              <a:srgbClr val="1BAF7A"/>
             </a:solidFill>
             <a:prstDash val="solid"/>
           </a:ln>
         </p:spPr>
+        <p:txBody>
+          <a:bodyPr/>
+          <a:p/>
+        </p:txBody>
       </p:sp>
       <p:sp>
         <p:nvSpPr>
@@ -8425,9 +8577,9 @@
             <a:r>
               <a:rPr lang="en-US" sz="1500" b="1" dirty="0">
                 <a:solidFill>
-                  <a:srgbClr val="FFFFFF"/>
-                </a:solidFill>
-                <a:latin typeface="Cambria" pitchFamily="34" charset="0"/>
+                  <a:srgbClr val="12345F"/>
+                </a:solidFill>
+                <a:latin typeface="Aptos" pitchFamily="34" charset="0"/>
                 <a:ea typeface="Cambria" pitchFamily="34" charset="-122"/>
                 <a:cs typeface="Cambria" pitchFamily="34" charset="-120"/>
               </a:rPr>
@@ -8464,9 +8616,9 @@
             <a:r>
               <a:rPr lang="en-US" sz="1400" b="1" dirty="0">
                 <a:solidFill>
-                  <a:srgbClr val="0E5236"/>
-                </a:solidFill>
-                <a:latin typeface="Cambria" pitchFamily="34" charset="0"/>
+                  <a:srgbClr val="12345F"/>
+                </a:solidFill>
+                <a:latin typeface="Aptos" pitchFamily="34" charset="0"/>
                 <a:ea typeface="Cambria" pitchFamily="34" charset="-122"/>
                 <a:cs typeface="Cambria" pitchFamily="34" charset="-120"/>
               </a:rPr>
@@ -8505,7 +8657,7 @@
                 <a:solidFill>
                   <a:srgbClr val="0B0B0B"/>
                 </a:solidFill>
-                <a:latin typeface="Calibri" pitchFamily="34" charset="0"/>
+                <a:latin typeface="Aptos" pitchFamily="34" charset="0"/>
                 <a:ea typeface="Calibri" pitchFamily="34" charset="-122"/>
                 <a:cs typeface="Calibri" pitchFamily="34" charset="-120"/>
               </a:rPr>
@@ -8530,15 +8682,19 @@
             <a:avLst/>
           </a:prstGeom>
           <a:solidFill>
-            <a:srgbClr val="4FA47C"/>
+            <a:srgbClr val="1BAF7A"/>
           </a:solidFill>
           <a:ln w="12700">
             <a:solidFill>
-              <a:srgbClr val="4FA47C"/>
+              <a:srgbClr val="1BAF7A"/>
             </a:solidFill>
             <a:prstDash val="solid"/>
           </a:ln>
         </p:spPr>
+        <p:txBody>
+          <a:bodyPr/>
+          <a:p/>
+        </p:txBody>
       </p:sp>
       <p:sp>
         <p:nvSpPr>
@@ -8567,9 +8723,9 @@
             <a:r>
               <a:rPr lang="en-US" sz="1500" b="1" dirty="0">
                 <a:solidFill>
-                  <a:srgbClr val="FFFFFF"/>
-                </a:solidFill>
-                <a:latin typeface="Cambria" pitchFamily="34" charset="0"/>
+                  <a:srgbClr val="12345F"/>
+                </a:solidFill>
+                <a:latin typeface="Aptos" pitchFamily="34" charset="0"/>
                 <a:ea typeface="Cambria" pitchFamily="34" charset="-122"/>
                 <a:cs typeface="Cambria" pitchFamily="34" charset="-120"/>
               </a:rPr>
@@ -8606,9 +8762,9 @@
             <a:r>
               <a:rPr lang="en-US" sz="1400" b="1" dirty="0">
                 <a:solidFill>
-                  <a:srgbClr val="0E5236"/>
-                </a:solidFill>
-                <a:latin typeface="Cambria" pitchFamily="34" charset="0"/>
+                  <a:srgbClr val="12345F"/>
+                </a:solidFill>
+                <a:latin typeface="Aptos" pitchFamily="34" charset="0"/>
                 <a:ea typeface="Cambria" pitchFamily="34" charset="-122"/>
                 <a:cs typeface="Cambria" pitchFamily="34" charset="-120"/>
               </a:rPr>
@@ -8647,7 +8803,7 @@
                 <a:solidFill>
                   <a:srgbClr val="0B0B0B"/>
                 </a:solidFill>
-                <a:latin typeface="Calibri" pitchFamily="34" charset="0"/>
+                <a:latin typeface="Aptos" pitchFamily="34" charset="0"/>
                 <a:ea typeface="Calibri" pitchFamily="34" charset="-122"/>
                 <a:cs typeface="Calibri" pitchFamily="34" charset="-120"/>
               </a:rPr>
@@ -8684,9 +8840,9 @@
             <a:r>
               <a:rPr lang="en-US" sz="1000" dirty="0">
                 <a:solidFill>
-                  <a:srgbClr val="5A6B62"/>
-                </a:solidFill>
-                <a:latin typeface="Calibri" pitchFamily="34" charset="0"/>
+                  <a:srgbClr val="0B0B0B"/>
+                </a:solidFill>
+                <a:latin typeface="Aptos" pitchFamily="34" charset="0"/>
                 <a:ea typeface="Calibri" pitchFamily="34" charset="-122"/>
                 <a:cs typeface="Calibri" pitchFamily="34" charset="-120"/>
               </a:rPr>

</xml_diff>

<commit_message>
Refine jury report method and recommendations
</commit_message>
<xml_diff>
--- a/rapport/Rapport_Defi1_Acces_numerique_Togo.pptx
+++ b/rapport/Rapport_Defi1_Acces_numerique_Togo.pptx
@@ -3203,11 +3203,38 @@
           <a:bodyPr wrap="square" lIns="0" tIns="0" rIns="0" bIns="0" rtlCol="0" anchor="ctr"/>
           <a:lstStyle/>
           <a:p>
+            <a:r>
+              <a:t>Les six hypothèses à garder en tête</a:t>
+            </a:r>
+          </a:p>
+        </p:txBody>
+      </p:sp>
+      <p:sp>
+        <p:nvSpPr>
+          <p:cNvPr id="4" name="Text 2"/>
+          <p:cNvSpPr txBox="1"/>
+          <p:nvPr/>
+        </p:nvSpPr>
+        <p:spPr>
+          <a:xfrm>
+            <a:off x="822960" y="2011680"/>
+            <a:ext cx="3337560" cy="274320"/>
+          </a:xfrm>
+          <a:prstGeom prst="rect">
+            <a:avLst/>
+          </a:prstGeom>
+          <a:noFill/>
+          <a:ln/>
+        </p:spPr>
+        <p:txBody>
+          <a:bodyPr wrap="square" lIns="0" tIns="0" rIns="0" bIns="0" rtlCol="0" anchor="ctr"/>
+          <a:lstStyle/>
+          <a:p>
             <a:pPr indent="0" marL="0">
               <a:buNone/>
             </a:pPr>
             <a:r>
-              <a:rPr lang="en-US" sz="3000" b="1" dirty="0">
+              <a:rPr lang="en-US" sz="1300" b="1" dirty="0">
                 <a:solidFill>
                   <a:srgbClr val="12345F"/>
                 </a:solidFill>
@@ -3215,21 +3242,48 @@
                 <a:ea typeface="Cambria" pitchFamily="34" charset="-122"/>
                 <a:cs typeface="Cambria" pitchFamily="34" charset="-120"/>
               </a:rPr>
-              <a:t>Les six hypothèses, écrites noir sur blanc</a:t>
-            </a:r>
-            <a:endParaRPr lang="en-US" sz="3000" dirty="0"/>
-          </a:p>
-        </p:txBody>
-      </p:sp>
-      <p:sp>
-        <p:nvSpPr>
-          <p:cNvPr id="4" name="Text 2"/>
-          <p:cNvSpPr txBox="1"/>
-          <p:nvPr/>
-        </p:nvSpPr>
-        <p:spPr>
-          <a:xfrm>
-            <a:off x="822960" y="2011680"/>
+              <a:t>H1 · Norme d’équité</a:t>
+            </a:r>
+            <a:endParaRPr lang="en-US" sz="1300" dirty="0"/>
+          </a:p>
+        </p:txBody>
+      </p:sp>
+      <p:sp>
+        <p:nvSpPr>
+          <p:cNvPr id="5" name="Text 3"/>
+          <p:cNvSpPr txBox="1"/>
+          <p:nvPr/>
+        </p:nvSpPr>
+        <p:spPr>
+          <a:xfrm>
+            <a:off x="822960" y="2322576"/>
+            <a:ext cx="3337560" cy="1143000"/>
+          </a:xfrm>
+          <a:prstGeom prst="rect">
+            <a:avLst/>
+          </a:prstGeom>
+          <a:noFill/>
+          <a:ln/>
+        </p:spPr>
+        <p:txBody>
+          <a:bodyPr wrap="square" lIns="0" tIns="0" rIns="0" bIns="0" rtlCol="0" anchor="ctr"/>
+          <a:lstStyle/>
+          <a:p>
+            <a:r>
+              <a:t>H1 : « Attendu » signifie une répartition proportionnelle à la population. C’est une norme d’équité, pas une loi économique.</a:t>
+            </a:r>
+          </a:p>
+        </p:txBody>
+      </p:sp>
+      <p:sp>
+        <p:nvSpPr>
+          <p:cNvPr id="6" name="Text 4"/>
+          <p:cNvSpPr txBox="1"/>
+          <p:nvPr/>
+        </p:nvSpPr>
+        <p:spPr>
+          <a:xfrm>
+            <a:off x="4526280" y="2011680"/>
             <a:ext cx="3337560" cy="274320"/>
           </a:xfrm>
           <a:prstGeom prst="rect">
@@ -3254,7 +3308,7 @@
                 <a:ea typeface="Cambria" pitchFamily="34" charset="-122"/>
                 <a:cs typeface="Cambria" pitchFamily="34" charset="-120"/>
               </a:rPr>
-              <a:t>H1 · Norme d’équité</a:t>
+              <a:t>H2 · Poids de la population</a:t>
             </a:r>
             <a:endParaRPr lang="en-US" sz="1300" dirty="0"/>
           </a:p>
@@ -3262,13 +3316,13 @@
       </p:sp>
       <p:sp>
         <p:nvSpPr>
-          <p:cNvPr id="5" name="Text 3"/>
-          <p:cNvSpPr txBox="1"/>
-          <p:nvPr/>
-        </p:nvSpPr>
-        <p:spPr>
-          <a:xfrm>
-            <a:off x="822960" y="2322576"/>
+          <p:cNvPr id="7" name="Text 5"/>
+          <p:cNvSpPr txBox="1"/>
+          <p:nvPr/>
+        </p:nvSpPr>
+        <p:spPr>
+          <a:xfrm>
+            <a:off x="4526280" y="2322576"/>
             <a:ext cx="3337560" cy="1143000"/>
           </a:xfrm>
           <a:prstGeom prst="rect">
@@ -3281,33 +3335,21 @@
           <a:bodyPr wrap="square" lIns="0" tIns="0" rIns="0" bIns="0" rtlCol="0" anchor="ctr"/>
           <a:lstStyle/>
           <a:p>
-            <a:pPr indent="0" marL="0">
-              <a:buNone/>
-            </a:pPr>
-            <a:r>
-              <a:rPr lang="en-US" sz="1050" dirty="0">
-                <a:solidFill>
-                  <a:srgbClr val="0B0B0B"/>
-                </a:solidFill>
-                <a:latin typeface="Aptos" pitchFamily="34" charset="0"/>
-                <a:ea typeface="Calibri" pitchFamily="34" charset="-122"/>
-                <a:cs typeface="Calibri" pitchFamily="34" charset="-120"/>
-              </a:rPr>
-              <a:t>« Attendu » = répartition proportionnelle à la population. Norme choisie, pas loi économique : une autre norme donnerait un autre classement.</a:t>
-            </a:r>
-            <a:endParaRPr lang="en-US" sz="1050" dirty="0"/>
-          </a:p>
-        </p:txBody>
-      </p:sp>
-      <p:sp>
-        <p:nvSpPr>
-          <p:cNvPr id="6" name="Text 4"/>
-          <p:cNvSpPr txBox="1"/>
-          <p:nvPr/>
-        </p:nvSpPr>
-        <p:spPr>
-          <a:xfrm>
-            <a:off x="4526280" y="2011680"/>
+            <a:r>
+              <a:t>H2 : α = 0,5 est un arbitrage politique réglable dans le tableau de bord.</a:t>
+            </a:r>
+          </a:p>
+        </p:txBody>
+      </p:sp>
+      <p:sp>
+        <p:nvSpPr>
+          <p:cNvPr id="8" name="Text 6"/>
+          <p:cNvSpPr txBox="1"/>
+          <p:nvPr/>
+        </p:nvSpPr>
+        <p:spPr>
+          <a:xfrm>
+            <a:off x="8229600" y="2011680"/>
             <a:ext cx="3337560" cy="274320"/>
           </a:xfrm>
           <a:prstGeom prst="rect">
@@ -3332,7 +3374,7 @@
                 <a:ea typeface="Cambria" pitchFamily="34" charset="-122"/>
                 <a:cs typeface="Cambria" pitchFamily="34" charset="-120"/>
               </a:rPr>
-              <a:t>H2 · Poids de la population</a:t>
+              <a:t>H3 · Couverture radio</a:t>
             </a:r>
             <a:endParaRPr lang="en-US" sz="1300" dirty="0"/>
           </a:p>
@@ -3340,13 +3382,13 @@
       </p:sp>
       <p:sp>
         <p:nvSpPr>
-          <p:cNvPr id="7" name="Text 5"/>
-          <p:cNvSpPr txBox="1"/>
-          <p:nvPr/>
-        </p:nvSpPr>
-        <p:spPr>
-          <a:xfrm>
-            <a:off x="4526280" y="2322576"/>
+          <p:cNvPr id="9" name="Text 7"/>
+          <p:cNvSpPr txBox="1"/>
+          <p:nvPr/>
+        </p:nvSpPr>
+        <p:spPr>
+          <a:xfrm>
+            <a:off x="8229600" y="2322576"/>
             <a:ext cx="3337560" cy="1143000"/>
           </a:xfrm>
           <a:prstGeom prst="rect">
@@ -3359,33 +3401,21 @@
           <a:bodyPr wrap="square" lIns="0" tIns="0" rIns="0" bIns="0" rtlCol="0" anchor="ctr"/>
           <a:lstStyle/>
           <a:p>
-            <a:pPr indent="0" marL="0">
-              <a:buNone/>
-            </a:pPr>
-            <a:r>
-              <a:rPr lang="en-US" sz="1050" dirty="0">
-                <a:solidFill>
-                  <a:srgbClr val="0B0B0B"/>
-                </a:solidFill>
-                <a:latin typeface="Aptos" pitchFamily="34" charset="0"/>
-                <a:ea typeface="Calibri" pitchFamily="34" charset="-122"/>
-                <a:cs typeface="Calibri" pitchFamily="34" charset="-120"/>
-              </a:rPr>
-              <a:t>L’exposant α = 0,5 du score de priorité est un arbitrage politique. Il est réglable en direct dans le tableau de bord.</a:t>
-            </a:r>
-            <a:endParaRPr lang="en-US" sz="1050" dirty="0"/>
-          </a:p>
-        </p:txBody>
-      </p:sp>
-      <p:sp>
-        <p:nvSpPr>
-          <p:cNvPr id="8" name="Text 6"/>
-          <p:cNvSpPr txBox="1"/>
-          <p:nvPr/>
-        </p:nvSpPr>
-        <p:spPr>
-          <a:xfrm>
-            <a:off x="8229600" y="2011680"/>
+            <a:r>
+              <a:t>H3 : faute de données radio accessibles, une zone blanche signifie ici absence de service physique, pas absence de signal.</a:t>
+            </a:r>
+          </a:p>
+        </p:txBody>
+      </p:sp>
+      <p:sp>
+        <p:nvSpPr>
+          <p:cNvPr id="10" name="Text 8"/>
+          <p:cNvSpPr txBox="1"/>
+          <p:nvPr/>
+        </p:nvSpPr>
+        <p:spPr>
+          <a:xfrm>
+            <a:off x="822960" y="3611880"/>
             <a:ext cx="3337560" cy="274320"/>
           </a:xfrm>
           <a:prstGeom prst="rect">
@@ -3410,7 +3440,7 @@
                 <a:ea typeface="Cambria" pitchFamily="34" charset="-122"/>
                 <a:cs typeface="Cambria" pitchFamily="34" charset="-120"/>
               </a:rPr>
-              <a:t>H3 · Couverture radio</a:t>
+              <a:t>H4 · Centroïde du canton</a:t>
             </a:r>
             <a:endParaRPr lang="en-US" sz="1300" dirty="0"/>
           </a:p>
@@ -3418,13 +3448,13 @@
       </p:sp>
       <p:sp>
         <p:nvSpPr>
-          <p:cNvPr id="9" name="Text 7"/>
-          <p:cNvSpPr txBox="1"/>
-          <p:nvPr/>
-        </p:nvSpPr>
-        <p:spPr>
-          <a:xfrm>
-            <a:off x="8229600" y="2322576"/>
+          <p:cNvPr id="11" name="Text 9"/>
+          <p:cNvSpPr txBox="1"/>
+          <p:nvPr/>
+        </p:nvSpPr>
+        <p:spPr>
+          <a:xfrm>
+            <a:off x="822960" y="3922776"/>
             <a:ext cx="3337560" cy="1143000"/>
           </a:xfrm>
           <a:prstGeom prst="rect">
@@ -3437,33 +3467,21 @@
           <a:bodyPr wrap="square" lIns="0" tIns="0" rIns="0" bIns="0" rtlCol="0" anchor="ctr"/>
           <a:lstStyle/>
           <a:p>
-            <a:pPr indent="0" marL="0">
-              <a:buNone/>
-            </a:pPr>
-            <a:r>
-              <a:rPr lang="en-US" sz="1050" dirty="0">
-                <a:solidFill>
-                  <a:srgbClr val="0B0B0B"/>
-                </a:solidFill>
-                <a:latin typeface="Aptos" pitchFamily="34" charset="0"/>
-                <a:ea typeface="Calibri" pitchFamily="34" charset="-122"/>
-                <a:cs typeface="Calibri" pitchFamily="34" charset="-120"/>
-              </a:rPr>
-              <a:t>Couches « Tours télécoms » en accès restreint (HTTP 403) ; OpenStreetMap écarté (115 mâts pour tout le pays). Zone blanche = sans service, pas sans signal.</a:t>
-            </a:r>
-            <a:endParaRPr lang="en-US" sz="1050" dirty="0"/>
-          </a:p>
-        </p:txBody>
-      </p:sp>
-      <p:sp>
-        <p:nvSpPr>
-          <p:cNvPr id="10" name="Text 8"/>
-          <p:cNvSpPr txBox="1"/>
-          <p:nvPr/>
-        </p:nvSpPr>
-        <p:spPr>
-          <a:xfrm>
-            <a:off x="822960" y="3611880"/>
+            <a:r>
+              <a:t>H4 : les distances partent du centroïde du canton, faute de population infra-préfectorale.</a:t>
+            </a:r>
+          </a:p>
+        </p:txBody>
+      </p:sp>
+      <p:sp>
+        <p:nvSpPr>
+          <p:cNvPr id="12" name="Text 10"/>
+          <p:cNvSpPr txBox="1"/>
+          <p:nvPr/>
+        </p:nvSpPr>
+        <p:spPr>
+          <a:xfrm>
+            <a:off x="4526280" y="3611880"/>
             <a:ext cx="3337560" cy="274320"/>
           </a:xfrm>
           <a:prstGeom prst="rect">
@@ -3488,7 +3506,7 @@
                 <a:ea typeface="Cambria" pitchFamily="34" charset="-122"/>
                 <a:cs typeface="Cambria" pitchFamily="34" charset="-120"/>
               </a:rPr>
-              <a:t>H4 · Centroïde du canton</a:t>
+              <a:t>H5 · Noms reconstruits</a:t>
             </a:r>
             <a:endParaRPr lang="en-US" sz="1300" dirty="0"/>
           </a:p>
@@ -3496,13 +3514,13 @@
       </p:sp>
       <p:sp>
         <p:nvSpPr>
-          <p:cNvPr id="11" name="Text 9"/>
-          <p:cNvSpPr txBox="1"/>
-          <p:nvPr/>
-        </p:nvSpPr>
-        <p:spPr>
-          <a:xfrm>
-            <a:off x="822960" y="3922776"/>
+          <p:cNvPr id="13" name="Text 11"/>
+          <p:cNvSpPr txBox="1"/>
+          <p:nvPr/>
+        </p:nvSpPr>
+        <p:spPr>
+          <a:xfrm>
+            <a:off x="4526280" y="3922776"/>
             <a:ext cx="3337560" cy="1143000"/>
           </a:xfrm>
           <a:prstGeom prst="rect">
@@ -3515,33 +3533,21 @@
           <a:bodyPr wrap="square" lIns="0" tIns="0" rIns="0" bIns="0" rtlCol="0" anchor="ctr"/>
           <a:lstStyle/>
           <a:p>
-            <a:pPr indent="0" marL="0">
-              <a:buNone/>
-            </a:pPr>
-            <a:r>
-              <a:rPr lang="en-US" sz="1050" dirty="0">
-                <a:solidFill>
-                  <a:srgbClr val="0B0B0B"/>
-                </a:solidFill>
-                <a:latin typeface="Aptos" pitchFamily="34" charset="0"/>
-                <a:ea typeface="Calibri" pitchFamily="34" charset="-122"/>
-                <a:cs typeface="Calibri" pitchFamily="34" charset="-120"/>
-              </a:rPr>
-              <a:t>Les distances partent du centre géométrique : aucune population infra-préfectorale n’est publiée.</a:t>
-            </a:r>
-            <a:endParaRPr lang="en-US" sz="1050" dirty="0"/>
-          </a:p>
-        </p:txBody>
-      </p:sp>
-      <p:sp>
-        <p:nvSpPr>
-          <p:cNvPr id="12" name="Text 10"/>
-          <p:cNvSpPr txBox="1"/>
-          <p:nvPr/>
-        </p:nvSpPr>
-        <p:spPr>
-          <a:xfrm>
-            <a:off x="4526280" y="3611880"/>
+            <a:r>
+              <a:t>H5 : les noms des territoires ont été reconstruits par jointure spatiale ; 39/39 préfectures concordent.</a:t>
+            </a:r>
+          </a:p>
+        </p:txBody>
+      </p:sp>
+      <p:sp>
+        <p:nvSpPr>
+          <p:cNvPr id="14" name="Text 12"/>
+          <p:cNvSpPr txBox="1"/>
+          <p:nvPr/>
+        </p:nvSpPr>
+        <p:spPr>
+          <a:xfrm>
+            <a:off x="8229600" y="3611880"/>
             <a:ext cx="3337560" cy="274320"/>
           </a:xfrm>
           <a:prstGeom prst="rect">
@@ -3566,84 +3572,6 @@
                 <a:ea typeface="Cambria" pitchFamily="34" charset="-122"/>
                 <a:cs typeface="Cambria" pitchFamily="34" charset="-120"/>
               </a:rPr>
-              <a:t>H5 · Noms reconstruits</a:t>
-            </a:r>
-            <a:endParaRPr lang="en-US" sz="1300" dirty="0"/>
-          </a:p>
-        </p:txBody>
-      </p:sp>
-      <p:sp>
-        <p:nvSpPr>
-          <p:cNvPr id="13" name="Text 11"/>
-          <p:cNvSpPr txBox="1"/>
-          <p:nvPr/>
-        </p:nvSpPr>
-        <p:spPr>
-          <a:xfrm>
-            <a:off x="4526280" y="3922776"/>
-            <a:ext cx="3337560" cy="1143000"/>
-          </a:xfrm>
-          <a:prstGeom prst="rect">
-            <a:avLst/>
-          </a:prstGeom>
-          <a:noFill/>
-          <a:ln/>
-        </p:spPr>
-        <p:txBody>
-          <a:bodyPr wrap="square" lIns="0" tIns="0" rIns="0" bIns="0" rtlCol="0" anchor="ctr"/>
-          <a:lstStyle/>
-          <a:p>
-            <a:pPr indent="0" marL="0">
-              <a:buNone/>
-            </a:pPr>
-            <a:r>
-              <a:rPr lang="en-US" sz="1050" dirty="0">
-                <a:solidFill>
-                  <a:srgbClr val="0B0B0B"/>
-                </a:solidFill>
-                <a:latin typeface="Aptos" pitchFamily="34" charset="0"/>
-                <a:ea typeface="Calibri" pitchFamily="34" charset="-122"/>
-                <a:cs typeface="Calibri" pitchFamily="34" charset="-120"/>
-              </a:rPr>
-              <a:t>Les polygones officiels n’ont aucun attribut. Noms rétablis par jointure spatiale : 39/39, et superficies à 0,18 % du chiffre officiel.</a:t>
-            </a:r>
-            <a:endParaRPr lang="en-US" sz="1050" dirty="0"/>
-          </a:p>
-        </p:txBody>
-      </p:sp>
-      <p:sp>
-        <p:nvSpPr>
-          <p:cNvPr id="14" name="Text 12"/>
-          <p:cNvSpPr txBox="1"/>
-          <p:nvPr/>
-        </p:nvSpPr>
-        <p:spPr>
-          <a:xfrm>
-            <a:off x="8229600" y="3611880"/>
-            <a:ext cx="3337560" cy="274320"/>
-          </a:xfrm>
-          <a:prstGeom prst="rect">
-            <a:avLst/>
-          </a:prstGeom>
-          <a:noFill/>
-          <a:ln/>
-        </p:spPr>
-        <p:txBody>
-          <a:bodyPr wrap="square" lIns="0" tIns="0" rIns="0" bIns="0" rtlCol="0" anchor="ctr"/>
-          <a:lstStyle/>
-          <a:p>
-            <a:pPr indent="0" marL="0">
-              <a:buNone/>
-            </a:pPr>
-            <a:r>
-              <a:rPr lang="en-US" sz="1300" b="1" dirty="0">
-                <a:solidFill>
-                  <a:srgbClr val="12345F"/>
-                </a:solidFill>
-                <a:latin typeface="Aptos" pitchFamily="34" charset="0"/>
-                <a:ea typeface="Cambria" pitchFamily="34" charset="-122"/>
-                <a:cs typeface="Cambria" pitchFamily="34" charset="-120"/>
-              </a:rPr>
               <a:t>H6 · Données et millésimes</a:t>
             </a:r>
             <a:endParaRPr lang="en-US" sz="1300" dirty="0"/>
@@ -3671,21 +3599,9 @@
           <a:bodyPr wrap="square" lIns="0" tIns="0" rIns="0" bIns="0" rtlCol="0" anchor="ctr"/>
           <a:lstStyle/>
           <a:p>
-            <a:pPr indent="0" marL="0">
-              <a:buNone/>
-            </a:pPr>
-            <a:r>
-              <a:rPr lang="en-US" sz="1050" dirty="0">
-                <a:solidFill>
-                  <a:srgbClr val="0B0B0B"/>
-                </a:solidFill>
-                <a:latin typeface="Aptos" pitchFamily="34" charset="0"/>
-                <a:ea typeface="Calibri" pitchFamily="34" charset="-122"/>
-                <a:cs typeface="Calibri" pitchFamily="34" charset="-120"/>
-              </a:rPr>
-              <a:t>Inventaire et non échantillon, donc aucune inférence. Population 2022, implantations de date inconnue. 6,8 % d’opérateurs non renseignés, conservés. Telecom = Moov + Togocom : jamais additionnés.</a:t>
-            </a:r>
-            <a:endParaRPr lang="en-US" sz="1050" dirty="0"/>
+            <a:r>
+              <a:t>H6 : les données forment un inventaire. Population 2022, implantations de date inconnue, 6,8 % d’opérateurs non renseignés.</a:t>
+            </a:r>
           </a:p>
         </p:txBody>
       </p:sp>
@@ -3776,21 +3692,9 @@
           <a:bodyPr wrap="square" lIns="0" tIns="0" rIns="0" bIns="0" rtlCol="0" anchor="ctr"/>
           <a:lstStyle/>
           <a:p>
-            <a:pPr indent="0" marL="0">
-              <a:buNone/>
-            </a:pPr>
-            <a:r>
-              <a:rPr lang="en-US" sz="1100" dirty="0">
-                <a:solidFill>
-                  <a:srgbClr val="0B0B0B"/>
-                </a:solidFill>
-                <a:latin typeface="Aptos" pitchFamily="34" charset="0"/>
-                <a:ea typeface="Calibri" pitchFamily="34" charset="-122"/>
-                <a:cs typeface="Calibri" pitchFamily="34" charset="-120"/>
-              </a:rPr>
-              <a:t>8 vues, filtrables par région, avec une analyse cantonale dédiée dans Accès local · lecture automatique recalculée à chaque filtre · export CSV de toutes les tables · 3 scripts Python des sources brutes au rendu</a:t>
-            </a:r>
-            <a:endParaRPr lang="en-US" sz="1100" dirty="0"/>
+            <a:r>
+              <a:t>8 vues filtrables par région ; analyse cantonale dans Accès local ; lecture recalculée ; export CSV ; 3 scripts Python reproductibles.</a:t>
+            </a:r>
           </a:p>
         </p:txBody>
       </p:sp>
@@ -4697,21 +4601,9 @@
           <a:bodyPr wrap="square" lIns="0" tIns="0" rIns="0" bIns="0" rtlCol="0" anchor="ctr"/>
           <a:lstStyle/>
           <a:p>
-            <a:pPr indent="0" marL="0">
-              <a:buNone/>
-            </a:pPr>
-            <a:r>
-              <a:rPr lang="en-US" sz="1600" b="1" dirty="0">
-                <a:solidFill>
-                  <a:srgbClr val="12345F"/>
-                </a:solidFill>
-                <a:latin typeface="Aptos" pitchFamily="34" charset="0"/>
-                <a:ea typeface="Cambria" pitchFamily="34" charset="-122"/>
-                <a:cs typeface="Cambria" pitchFamily="34" charset="-120"/>
-              </a:rPr>
-              <a:t>Trois partis pris</a:t>
-            </a:r>
-            <a:endParaRPr lang="en-US" sz="1600" dirty="0"/>
+            <a:r>
+              <a:t>Méthode en quatre points</a:t>
+            </a:r>
           </a:p>
         </p:txBody>
       </p:sp>
@@ -4736,139 +4628,27 @@
           <a:bodyPr wrap="square" lIns="0" tIns="0" rIns="0" bIns="0" rtlCol="0" anchor="ctr"/>
           <a:lstStyle/>
           <a:p>
-            <a:pPr indent="0" marL="0">
-              <a:lnSpc>
-                <a:spcPts val="1600"/>
-              </a:lnSpc>
-              <a:buNone/>
-            </a:pPr>
-            <a:r>
-              <a:rPr lang="en-US" sz="1150" b="1" dirty="0">
-                <a:solidFill>
-                  <a:srgbClr val="0B0B0B"/>
-                </a:solidFill>
-                <a:latin typeface="Aptos" pitchFamily="34" charset="0"/>
-                <a:ea typeface="Calibri" pitchFamily="34" charset="-122"/>
-                <a:cs typeface="Calibri" pitchFamily="34" charset="-120"/>
-              </a:rPr>
-              <a:t>Un inventaire, pas un échantillon. </a:t>
-            </a:r>
-            <a:pPr indent="0" marL="0">
-              <a:lnSpc>
-                <a:spcPts val="1600"/>
-              </a:lnSpc>
-              <a:buNone/>
-            </a:pPr>
-            <a:r>
-              <a:rPr lang="en-US" sz="1150" dirty="0">
-                <a:solidFill>
-                  <a:srgbClr val="0B0B0B"/>
-                </a:solidFill>
-                <a:latin typeface="Aptos" pitchFamily="34" charset="0"/>
-                <a:ea typeface="Calibri" pitchFamily="34" charset="-122"/>
-                <a:cs typeface="Calibri" pitchFamily="34" charset="-120"/>
-              </a:rPr>
-              <a:t>Aucune p-value ni intervalle de confiance : ils n’auraient aucun sens sur un recensement d’établissements.</a:t>
-            </a:r>
-            <a:endParaRPr lang="en-US" sz="1150" dirty="0"/>
-          </a:p>
-          <a:p>
-            <a:pPr indent="0" marL="0">
-              <a:lnSpc>
-                <a:spcPts val="1600"/>
-              </a:lnSpc>
-              <a:buNone/>
-            </a:pPr>
-            <a:endParaRPr lang="en-US" sz="1150" dirty="0"/>
-          </a:p>
-          <a:p>
-            <a:pPr indent="0" marL="0">
-              <a:lnSpc>
-                <a:spcPts val="1600"/>
-              </a:lnSpc>
-              <a:buNone/>
-            </a:pPr>
-            <a:r>
-              <a:rPr lang="en-US" sz="1150" b="1" dirty="0">
-                <a:solidFill>
-                  <a:srgbClr val="0B0B0B"/>
-                </a:solidFill>
-                <a:latin typeface="Aptos" pitchFamily="34" charset="0"/>
-                <a:ea typeface="Calibri" pitchFamily="34" charset="-122"/>
-                <a:cs typeface="Calibri" pitchFamily="34" charset="-120"/>
-              </a:rPr>
-              <a:t>Deux échelles, toujours. </a:t>
-            </a:r>
-            <a:endParaRPr lang="en-US" sz="1150" dirty="0"/>
-          </a:p>
-          <a:p>
-            <a:pPr indent="0" marL="0">
-              <a:lnSpc>
-                <a:spcPts val="1600"/>
-              </a:lnSpc>
-              <a:buNone/>
-            </a:pPr>
-            <a:r>
-              <a:rPr lang="en-US" sz="1150" dirty="0">
-                <a:solidFill>
-                  <a:srgbClr val="0B0B0B"/>
-                </a:solidFill>
-                <a:latin typeface="Aptos" pitchFamily="34" charset="0"/>
-                <a:ea typeface="Calibri" pitchFamily="34" charset="-122"/>
-                <a:cs typeface="Calibri" pitchFamily="34" charset="-120"/>
-              </a:rPr>
-              <a:t>Préfecture et canton, pour que la conclusion ne dépende pas du découpage retenu.</a:t>
-            </a:r>
-            <a:endParaRPr lang="en-US" sz="1150" dirty="0"/>
-          </a:p>
-          <a:p>
-            <a:pPr indent="0" marL="0">
-              <a:lnSpc>
-                <a:spcPts val="1600"/>
-              </a:lnSpc>
-              <a:buNone/>
-            </a:pPr>
-            <a:endParaRPr lang="en-US" sz="1150" dirty="0"/>
-          </a:p>
-          <a:p>
-            <a:pPr indent="0" marL="0">
-              <a:lnSpc>
-                <a:spcPts val="1600"/>
-              </a:lnSpc>
-              <a:buNone/>
-            </a:pPr>
-            <a:r>
-              <a:rPr lang="en-US" sz="1150" b="1" dirty="0">
-                <a:solidFill>
-                  <a:srgbClr val="0B0B0B"/>
-                </a:solidFill>
-                <a:latin typeface="Aptos" pitchFamily="34" charset="0"/>
-                <a:ea typeface="Calibri" pitchFamily="34" charset="-122"/>
-                <a:cs typeface="Calibri" pitchFamily="34" charset="-120"/>
-              </a:rPr>
-              <a:t>Les limites sont écrites. </a:t>
-            </a:r>
-            <a:endParaRPr lang="en-US" sz="1150" dirty="0"/>
-          </a:p>
-          <a:p>
-            <a:pPr indent="0" marL="0">
-              <a:lnSpc>
-                <a:spcPts val="1600"/>
-              </a:lnSpc>
-              <a:buNone/>
-            </a:pPr>
-            <a:r>
-              <a:rPr lang="en-US" sz="1150" dirty="0">
-                <a:solidFill>
-                  <a:srgbClr val="0B0B0B"/>
-                </a:solidFill>
-                <a:latin typeface="Aptos" pitchFamily="34" charset="0"/>
-                <a:ea typeface="Calibri" pitchFamily="34" charset="-122"/>
-                <a:cs typeface="Calibri" pitchFamily="34" charset="-120"/>
-              </a:rPr>
-              <a:t>Millésimes hétérogènes, jeu CANAL+ vide, couverture radio inaccessible, 6,8 % d’opérateurs non renseignés.</a:t>
-            </a:r>
-            <a:endParaRPr lang="en-US" sz="1150" dirty="0"/>
+            <a:r>
+              <a:t>Un inventaire, pas un échantillon. Les résultats sont descriptifs : ils mesurent la situation observée dans les données disponibles.</a:t>
+            </a:r>
+          </a:p>
+          <a:p/>
+          <a:p>
+            <a:r>
+              <a:t>Deux échelles. La préfecture sert au diagnostic ; le canton révèle les écarts de proximité entre les territoires.</a:t>
+            </a:r>
+          </a:p>
+          <a:p/>
+          <a:p>
+            <a:r>
+              <a:t>Des ratios comparables. Les volumes sont rapportés à la population pour éviter de confondre taille et niveau d’accès.</a:t>
+            </a:r>
+          </a:p>
+          <a:p/>
+          <a:p>
+            <a:r>
+              <a:t>Des limites explicites. La couverture radio n’est pas mesurée, le jeu CANAL+ est vide et 6,8 % des opérateurs mobile money ne sont pas renseignés.</a:t>
+            </a:r>
           </a:p>
         </p:txBody>
       </p:sp>
@@ -4893,21 +4673,9 @@
           <a:bodyPr wrap="square" lIns="0" tIns="0" rIns="0" bIns="0" rtlCol="0" anchor="ctr"/>
           <a:lstStyle/>
           <a:p>
-            <a:pPr indent="0" marL="0">
-              <a:buNone/>
-            </a:pPr>
-            <a:r>
-              <a:rPr lang="en-US" sz="1000" dirty="0">
-                <a:solidFill>
-                  <a:srgbClr val="0B0B0B"/>
-                </a:solidFill>
-                <a:latin typeface="Aptos" pitchFamily="34" charset="0"/>
-                <a:ea typeface="Calibri" pitchFamily="34" charset="-122"/>
-                <a:cs typeface="Calibri" pitchFamily="34" charset="-120"/>
-              </a:rPr>
-              <a:t>Chaîne complète : 3 scripts Python, des sources brutes au tableau de bord. Tout est rejouable.</a:t>
-            </a:r>
-            <a:endParaRPr lang="en-US" sz="1000" dirty="0"/>
+            <a:r>
+              <a:t>Chaîne reproductible : données brutes, 3 scripts Python, tables d’analyse et tableau de bord.</a:t>
+            </a:r>
           </a:p>
         </p:txBody>
       </p:sp>
@@ -6459,21 +6227,9 @@
           <a:bodyPr wrap="square" lIns="0" tIns="0" rIns="0" bIns="0" rtlCol="0" anchor="ctr"/>
           <a:lstStyle/>
           <a:p>
-            <a:pPr indent="0" marL="0">
-              <a:buNone/>
-            </a:pPr>
-            <a:r>
-              <a:rPr lang="en-US" sz="1450" i="1" dirty="0">
-                <a:solidFill>
-                  <a:srgbClr val="FFFFFF"/>
-                </a:solidFill>
-                <a:latin typeface="Aptos" pitchFamily="34" charset="0"/>
-                <a:ea typeface="Cambria" pitchFamily="34" charset="-122"/>
-                <a:cs typeface="Cambria" pitchFamily="34" charset="-120"/>
-              </a:rPr>
-              <a:t>L’écart entre ces deux chiffres est un résultat, pas un détail : il mesure exactement ce que le réseau d’agents privés compense là où les opérateurs ne vont pas.</a:t>
-            </a:r>
-            <a:endParaRPr lang="en-US" sz="1450" dirty="0"/>
+            <a:r>
+              <a:t>L’écart entre ces deux chiffres montre le rôle complémentaire du réseau d’agents : il rapproche les services des habitants quand une agence est plus éloignée.</a:t>
+            </a:r>
           </a:p>
         </p:txBody>
       </p:sp>
@@ -6498,70 +6254,9 @@
           <a:bodyPr wrap="square" lIns="0" tIns="0" rIns="0" bIns="0" rtlCol="0" anchor="ctr"/>
           <a:lstStyle/>
           <a:p>
-            <a:pPr indent="0" marL="0">
-              <a:lnSpc>
-                <a:spcPts val="1700"/>
-              </a:lnSpc>
-              <a:buNone/>
-            </a:pPr>
-            <a:r>
-              <a:rPr lang="en-US" sz="1250" b="1" dirty="0">
-                <a:solidFill>
-                  <a:srgbClr val="0B0B0B"/>
-                </a:solidFill>
-                <a:latin typeface="Aptos" pitchFamily="34" charset="0"/>
-                <a:ea typeface="Calibri" pitchFamily="34" charset="-122"/>
-                <a:cs typeface="Calibri" pitchFamily="34" charset="-120"/>
-              </a:rPr>
-              <a:t>23 cantons sur 396</a:t>
-            </a:r>
-            <a:pPr indent="0" marL="0">
-              <a:lnSpc>
-                <a:spcPts val="1700"/>
-              </a:lnSpc>
-              <a:buNone/>
-            </a:pPr>
-            <a:r>
-              <a:rPr lang="en-US" sz="1250" dirty="0">
-                <a:solidFill>
-                  <a:srgbClr val="0B0B0B"/>
-                </a:solidFill>
-                <a:latin typeface="Aptos" pitchFamily="34" charset="0"/>
-                <a:ea typeface="Calibri" pitchFamily="34" charset="-122"/>
-                <a:cs typeface="Calibri" pitchFamily="34" charset="-120"/>
-              </a:rPr>
-              <a:t> ne comptent aucun point de service. Le plus isolé, dans Blitta, est à 21 km du premier service quel qu’il soit.</a:t>
-            </a:r>
-            <a:endParaRPr lang="en-US" sz="1250" dirty="0"/>
-          </a:p>
-          <a:p>
-            <a:pPr indent="0" marL="0">
-              <a:lnSpc>
-                <a:spcPts val="1700"/>
-              </a:lnSpc>
-              <a:buNone/>
-            </a:pPr>
-            <a:endParaRPr lang="en-US" sz="1250" dirty="0"/>
-          </a:p>
-          <a:p>
-            <a:pPr indent="0" marL="0">
-              <a:lnSpc>
-                <a:spcPts val="1700"/>
-              </a:lnSpc>
-              <a:buNone/>
-            </a:pPr>
-            <a:r>
-              <a:rPr lang="en-US" sz="1250" dirty="0">
-                <a:solidFill>
-                  <a:srgbClr val="0B0B0B"/>
-                </a:solidFill>
-                <a:latin typeface="Aptos" pitchFamily="34" charset="0"/>
-                <a:ea typeface="Calibri" pitchFamily="34" charset="-122"/>
-                <a:cs typeface="Calibri" pitchFamily="34" charset="-120"/>
-              </a:rPr>
-              <a:t>Ces écarts sont invisibles à l’échelle de la préfecture, qui les moyenne. Changer d’échelle change la carte des priorités — c’est pourquoi les deux sont présentées.</a:t>
-            </a:r>
-            <a:endParaRPr lang="en-US" sz="1250" dirty="0"/>
+            <a:r>
+              <a:t>23 cantons sur 396 ne comptent aucun point de service. Dans le canton le plus éloigné, situé à Blitta, le premier service est à 21 km. Ces écarts apparaissent seulement à l’échelle cantonale.</a:t>
+            </a:r>
           </a:p>
         </p:txBody>
       </p:sp>
@@ -6586,21 +6281,9 @@
           <a:bodyPr wrap="square" lIns="0" tIns="0" rIns="0" bIns="0" rtlCol="0" anchor="ctr"/>
           <a:lstStyle/>
           <a:p>
-            <a:pPr indent="0" marL="0">
-              <a:buNone/>
-            </a:pPr>
-            <a:r>
-              <a:rPr lang="en-US" sz="1000" dirty="0">
-                <a:solidFill>
-                  <a:srgbClr val="0B0B0B"/>
-                </a:solidFill>
-                <a:latin typeface="Aptos" pitchFamily="34" charset="0"/>
-                <a:ea typeface="Calibri" pitchFamily="34" charset="-122"/>
-                <a:cs typeface="Calibri" pitchFamily="34" charset="-120"/>
-              </a:rPr>
-              <a:t>Couverture radio indisponible (couches Géoportail en accès restreint) : la zone blanche est définie par la distance au service, depuis le centroïde du canton.</a:t>
-            </a:r>
-            <a:endParaRPr lang="en-US" sz="1000" dirty="0"/>
+            <a:r>
+              <a:t>La couverture radio n’est pas mesurée : les zones blanches désignent ici l’absence de service physique, depuis le centroïde du canton.</a:t>
+            </a:r>
           </a:p>
         </p:txBody>
       </p:sp>
@@ -7056,73 +6739,20 @@
           <a:bodyPr wrap="square" lIns="0" tIns="0" rIns="0" bIns="0" rtlCol="0" anchor="ctr"/>
           <a:lstStyle/>
           <a:p>
-            <a:pPr indent="0" marL="0">
-              <a:lnSpc>
-                <a:spcPts val="1700"/>
-              </a:lnSpc>
-              <a:buNone/>
-            </a:pPr>
-            <a:r>
-              <a:rPr lang="en-US" sz="1250" b="1" dirty="0">
-                <a:solidFill>
-                  <a:srgbClr val="0B0B0B"/>
-                </a:solidFill>
-                <a:latin typeface="Aptos" pitchFamily="34" charset="0"/>
-                <a:ea typeface="Calibri" pitchFamily="34" charset="-122"/>
-                <a:cs typeface="Calibri" pitchFamily="34" charset="-120"/>
-              </a:rPr>
+            <a:r>
               <a:t>Ce que cela signifie.</a:t>
             </a:r>
-            <a:endParaRPr lang="en-US" sz="1250" dirty="0"/>
-          </a:p>
-          <a:p>
-            <a:pPr indent="0" marL="0">
-              <a:lnSpc>
-                <a:spcPts val="1700"/>
-              </a:lnSpc>
-              <a:buNone/>
-            </a:pPr>
-            <a:r>
-              <a:rPr lang="en-US" sz="1250" dirty="0">
-                <a:solidFill>
-                  <a:srgbClr val="0B0B0B"/>
-                </a:solidFill>
-                <a:latin typeface="Aptos" pitchFamily="34" charset="0"/>
-                <a:ea typeface="Calibri" pitchFamily="34" charset="-122"/>
-                <a:cs typeface="Calibri" pitchFamily="34" charset="-120"/>
-              </a:rPr>
-              <a:t>Plus l’indice est bas, plus l’accès est également réparti entre les habitants. Le réseau d’agents agréés, porté par le marché, atteint une population que le réseau d’agences des opérateurs n’atteint pas.</a:t>
-            </a:r>
-            <a:endParaRPr lang="en-US" sz="1250" dirty="0"/>
-          </a:p>
-          <a:p>
-            <a:pPr indent="0" marL="0">
-              <a:lnSpc>
-                <a:spcPts val="1700"/>
-              </a:lnSpc>
-              <a:buNone/>
-            </a:pPr>
-            <a:endParaRPr lang="en-US" sz="1250" dirty="0"/>
-          </a:p>
-          <a:p>
-            <a:pPr indent="0" marL="0">
-              <a:lnSpc>
-                <a:spcPts val="1700"/>
-              </a:lnSpc>
-              <a:buNone/>
-            </a:pPr>
-            <a:r>
-              <a:rPr lang="en-US" sz="1250" dirty="0">
-                <a:solidFill>
-                  <a:srgbClr val="0B0B0B"/>
-                </a:solidFill>
-                <a:latin typeface="Aptos" pitchFamily="34" charset="0"/>
-                <a:ea typeface="Calibri" pitchFamily="34" charset="-122"/>
-                <a:cs typeface="Calibri" pitchFamily="34" charset="-120"/>
-              </a:rPr>
-              <a:t>La conséquence est directe : densifier le réseau d’agents corrige l’inégalité territoriale plus vite, et à moindre coût, que l’ouverture de nouvelles agences.</a:t>
-            </a:r>
-            <a:endParaRPr lang="en-US" sz="1250" dirty="0"/>
+          </a:p>
+          <a:p>
+            <a:r>
+              <a:t>Plus l’indice est bas, plus l’accès est également réparti. Le réseau d’agents apparaît mieux réparti que le réseau d’agences dans les données observées.</a:t>
+            </a:r>
+          </a:p>
+          <a:p/>
+          <a:p>
+            <a:r>
+              <a:t>Les données plaident donc en faveur d’une densification des agents, sans mesurer directement le coût ni la vitesse de déploiement.</a:t>
+            </a:r>
           </a:p>
         </p:txBody>
       </p:sp>
@@ -7462,102 +7092,21 @@
           <a:bodyPr wrap="square" lIns="0" tIns="0" rIns="0" bIns="0" rtlCol="0" anchor="ctr"/>
           <a:lstStyle/>
           <a:p>
-            <a:pPr indent="0" marL="0">
-              <a:lnSpc>
-                <a:spcPts val="1600"/>
-              </a:lnSpc>
-              <a:buNone/>
-            </a:pPr>
-            <a:r>
-              <a:rPr lang="en-US" sz="1200" b="1" dirty="0">
-                <a:solidFill>
-                  <a:srgbClr val="0B0B0B"/>
-                </a:solidFill>
-                <a:latin typeface="Aptos" pitchFamily="34" charset="0"/>
-                <a:ea typeface="Calibri" pitchFamily="34" charset="-122"/>
-                <a:cs typeface="Calibri" pitchFamily="34" charset="-120"/>
-              </a:rPr>
-              <a:t>La banlieue de Lomé, pas une zone reculée.</a:t>
-            </a:r>
-            <a:endParaRPr lang="en-US" sz="1200" dirty="0"/>
-          </a:p>
-          <a:p>
-            <a:pPr indent="0" marL="0">
-              <a:lnSpc>
-                <a:spcPts val="1600"/>
-              </a:lnSpc>
-              <a:buNone/>
-            </a:pPr>
-            <a:r>
-              <a:rPr lang="en-US" sz="1200" dirty="0">
-                <a:solidFill>
-                  <a:srgbClr val="0B0B0B"/>
-                </a:solidFill>
-                <a:latin typeface="Aptos" pitchFamily="34" charset="0"/>
-                <a:ea typeface="Calibri" pitchFamily="34" charset="-122"/>
-                <a:cs typeface="Calibri" pitchFamily="34" charset="-120"/>
-              </a:rPr>
-              <a:t>Une préfecture périurbaine fortement peuplée affiche 0,65 fois l’accès attendu au regard de sa population. La croissance urbaine a devancé l’implantation des services.</a:t>
-            </a:r>
-            <a:endParaRPr lang="en-US" sz="1200" dirty="0"/>
-          </a:p>
-          <a:p>
-            <a:pPr indent="0" marL="0">
-              <a:lnSpc>
-                <a:spcPts val="1600"/>
-              </a:lnSpc>
-              <a:buNone/>
-            </a:pPr>
-            <a:endParaRPr lang="en-US" sz="1200" dirty="0"/>
-          </a:p>
-          <a:p>
-            <a:pPr indent="0" marL="0">
-              <a:lnSpc>
-                <a:spcPts val="1600"/>
-              </a:lnSpc>
-              <a:buNone/>
-            </a:pPr>
-            <a:r>
-              <a:rPr lang="en-US" sz="1200" dirty="0">
-                <a:solidFill>
-                  <a:srgbClr val="0B0B0B"/>
-                </a:solidFill>
-                <a:latin typeface="Aptos" pitchFamily="34" charset="0"/>
-                <a:ea typeface="Calibri" pitchFamily="34" charset="-122"/>
-                <a:cs typeface="Calibri" pitchFamily="34" charset="-120"/>
-              </a:rPr>
-              <a:t>À l’inverse, les préfectures les mieux dotées sont les chefs-lieux régionaux : Sokodé (2,4×), Kara (2,3×), Cinkassé (1,7×) — devant Lomé.</a:t>
-            </a:r>
-            <a:endParaRPr lang="en-US" sz="1200" dirty="0"/>
-          </a:p>
-          <a:p>
-            <a:pPr indent="0" marL="0">
-              <a:lnSpc>
-                <a:spcPts val="1600"/>
-              </a:lnSpc>
-              <a:buNone/>
-            </a:pPr>
-            <a:endParaRPr lang="en-US" sz="1200" dirty="0"/>
-          </a:p>
-          <a:p>
-            <a:pPr indent="0" marL="0">
-              <a:lnSpc>
-                <a:spcPts val="1600"/>
-              </a:lnSpc>
-              <a:buNone/>
-            </a:pPr>
-            <a:r>
-              <a:rPr lang="en-US" sz="1200" b="1" dirty="0">
-                <a:solidFill>
-                  <a:srgbClr val="0B0B0B"/>
-                </a:solidFill>
-                <a:latin typeface="Aptos" pitchFamily="34" charset="0"/>
-                <a:ea typeface="Calibri" pitchFamily="34" charset="-122"/>
-                <a:cs typeface="Calibri" pitchFamily="34" charset="-120"/>
-              </a:rPr>
-              <a:t>L’implantation suit la carte administrative, pas la carte démographique.</a:t>
-            </a:r>
-            <a:endParaRPr lang="en-US" sz="1200" dirty="0"/>
+            <a:r>
+              <a:t>Agoè-Nyivé est une préfecture périurbaine fortement peuplée, mais son niveau de service reste inférieur à ce qu’impliquerait une répartition proportionnelle à la population.</a:t>
+            </a:r>
+          </a:p>
+          <a:p/>
+          <a:p>
+            <a:r>
+              <a:t>À l’inverse, les préfectures les mieux dotées sont les chefs-lieux régionaux : Sokodé (2,4×), Kara (2,3×) et Cinkassé (1,7×).</a:t>
+            </a:r>
+          </a:p>
+          <a:p/>
+          <a:p>
+            <a:r>
+              <a:t>L’implantation observée suit davantage la carte administrative que la carte démographique.</a:t>
+            </a:r>
           </a:p>
         </p:txBody>
       </p:sp>
@@ -7818,102 +7367,9 @@
           <a:bodyPr wrap="square" lIns="0" tIns="0" rIns="0" bIns="0" rtlCol="0" anchor="ctr"/>
           <a:lstStyle/>
           <a:p>
-            <a:pPr indent="0" marL="0">
-              <a:lnSpc>
-                <a:spcPts val="1600"/>
-              </a:lnSpc>
-              <a:buNone/>
-            </a:pPr>
-            <a:r>
-              <a:rPr lang="en-US" sz="1200" b="1" dirty="0">
-                <a:solidFill>
-                  <a:srgbClr val="0B0B0B"/>
-                </a:solidFill>
-                <a:latin typeface="Aptos" pitchFamily="34" charset="0"/>
-                <a:ea typeface="Calibri" pitchFamily="34" charset="-122"/>
-                <a:cs typeface="Calibri" pitchFamily="34" charset="-120"/>
-              </a:rPr>
-              <a:t>Pourquoi un exposant α.</a:t>
-            </a:r>
-            <a:endParaRPr lang="en-US" sz="1200" dirty="0"/>
-          </a:p>
-          <a:p>
-            <a:pPr indent="0" marL="0">
-              <a:lnSpc>
-                <a:spcPts val="1600"/>
-              </a:lnSpc>
-              <a:buNone/>
-            </a:pPr>
-            <a:r>
-              <a:rPr lang="en-US" sz="1200" dirty="0">
-                <a:solidFill>
-                  <a:srgbClr val="0B0B0B"/>
-                </a:solidFill>
-                <a:latin typeface="Aptos" pitchFamily="34" charset="0"/>
-                <a:ea typeface="Calibri" pitchFamily="34" charset="-122"/>
-                <a:cs typeface="Calibri" pitchFamily="34" charset="-120"/>
-              </a:rPr>
-              <a:t>Le déficit est déjà proportionnel à la population. Le repondérer une seconde fois par la population reviendrait à l’élever au carré et écraserait tout au profit des préfectures les plus peuplées.</a:t>
-            </a:r>
-            <a:endParaRPr lang="en-US" sz="1200" dirty="0"/>
-          </a:p>
-          <a:p>
-            <a:pPr indent="0" marL="0">
-              <a:lnSpc>
-                <a:spcPts val="1600"/>
-              </a:lnSpc>
-              <a:buNone/>
-            </a:pPr>
-            <a:endParaRPr lang="en-US" sz="1200" dirty="0"/>
-          </a:p>
-          <a:p>
-            <a:pPr indent="0" marL="0">
-              <a:lnSpc>
-                <a:spcPts val="1600"/>
-              </a:lnSpc>
-              <a:buNone/>
-            </a:pPr>
-            <a:r>
-              <a:rPr lang="en-US" sz="1200" dirty="0">
-                <a:solidFill>
-                  <a:srgbClr val="0B0B0B"/>
-                </a:solidFill>
-                <a:latin typeface="Aptos" pitchFamily="34" charset="0"/>
-                <a:ea typeface="Calibri" pitchFamily="34" charset="-122"/>
-                <a:cs typeface="Calibri" pitchFamily="34" charset="-120"/>
-              </a:rPr>
-              <a:t>α = 0 classe au déficit brut ; α = 1 privilégie le nombre d’habitants touchés. La valeur retenue, 0,5, est un compromis — et il est réglable en direct dans le tableau de bord.</a:t>
-            </a:r>
-            <a:endParaRPr lang="en-US" sz="1200" dirty="0"/>
-          </a:p>
-          <a:p>
-            <a:pPr indent="0" marL="0">
-              <a:lnSpc>
-                <a:spcPts val="1600"/>
-              </a:lnSpc>
-              <a:buNone/>
-            </a:pPr>
-            <a:endParaRPr lang="en-US" sz="1200" dirty="0"/>
-          </a:p>
-          <a:p>
-            <a:pPr indent="0" marL="0">
-              <a:lnSpc>
-                <a:spcPts val="1600"/>
-              </a:lnSpc>
-              <a:buNone/>
-            </a:pPr>
-            <a:r>
-              <a:rPr lang="en-US" sz="1200" b="1" dirty="0">
-                <a:solidFill>
-                  <a:srgbClr val="0B0B0B"/>
-                </a:solidFill>
-                <a:latin typeface="Aptos" pitchFamily="34" charset="0"/>
-                <a:ea typeface="Calibri" pitchFamily="34" charset="-122"/>
-                <a:cs typeface="Calibri" pitchFamily="34" charset="-120"/>
-              </a:rPr>
-              <a:t>Ce choix est un arbitrage politique, pas un résultat statistique. Il est exposé, pas dissimulé.</a:t>
-            </a:r>
-            <a:endParaRPr lang="en-US" sz="1200" dirty="0"/>
+            <a:r>
+              <a:t>Le curseur α équilibre deux priorités : corriger le déficit brut ou privilégier les territoires où davantage d’habitants sont concernés. α = 0 classe au déficit brut ; α = 1 donne davantage de poids à la population. La valeur retenue, 0,5, est réglable dans le tableau de bord.</a:t>
+            </a:r>
           </a:p>
         </p:txBody>
       </p:sp>
@@ -7954,21 +7410,9 @@
           <a:bodyPr wrap="square" lIns="0" tIns="0" rIns="0" bIns="0" rtlCol="0" anchor="ctr"/>
           <a:lstStyle/>
           <a:p>
-            <a:pPr indent="0" marL="0">
-              <a:buNone/>
-            </a:pPr>
-            <a:r>
-              <a:rPr lang="en-US" sz="1000" dirty="0">
-                <a:solidFill>
-                  <a:srgbClr val="0B0B0B"/>
-                </a:solidFill>
-                <a:latin typeface="Aptos" pitchFamily="34" charset="0"/>
-                <a:ea typeface="Calibri" pitchFamily="34" charset="-122"/>
-                <a:cs typeface="Calibri" pitchFamily="34" charset="-120"/>
-              </a:rPr>
-              <a:t>Aucun modèle boîte noire, aucun paramètre caché : le score se recalcule à la main à partir de la table publiée.</a:t>
-            </a:r>
-            <a:endParaRPr lang="en-US" sz="1000" dirty="0"/>
+            <a:r>
+              <a:t>Le score est transparent : aucun modèle boîte noire ni paramètre caché. Il peut être recalculé à partir de la table publiée.</a:t>
+            </a:r>
           </a:p>
         </p:txBody>
       </p:sp>
@@ -8211,21 +7655,9 @@
           <a:bodyPr wrap="square" lIns="0" tIns="0" rIns="0" bIns="0" rtlCol="0" anchor="ctr"/>
           <a:lstStyle/>
           <a:p>
-            <a:pPr indent="0" marL="0">
-              <a:buNone/>
-            </a:pPr>
-            <a:r>
-              <a:rPr lang="en-US" sz="1150" dirty="0">
-                <a:solidFill>
-                  <a:srgbClr val="0B0B0B"/>
-                </a:solidFill>
-                <a:latin typeface="Aptos" pitchFamily="34" charset="0"/>
-                <a:ea typeface="Calibri" pitchFamily="34" charset="-122"/>
-                <a:cs typeface="Calibri" pitchFamily="34" charset="-120"/>
-              </a:rPr>
-              <a:t>Agoè-Nyivé, Zio et Haho cumulent les scores les plus élevés : un déficit important rapporté à une population nombreuse. Chaque point installé y touche le plus grand nombre d’habitants.</a:t>
-            </a:r>
-            <a:endParaRPr lang="en-US" sz="1150" dirty="0"/>
+            <a:r>
+              <a:t>Agoè-Nyivé, Zio et Haho obtiennent les scores les plus élevés : elles combinent déficit important et population nombreuse.</a:t>
+            </a:r>
           </a:p>
         </p:txBody>
       </p:sp>
@@ -8357,21 +7789,9 @@
           <a:bodyPr wrap="square" lIns="0" tIns="0" rIns="0" bIns="0" rtlCol="0" anchor="ctr"/>
           <a:lstStyle/>
           <a:p>
-            <a:pPr indent="0" marL="0">
-              <a:buNone/>
-            </a:pPr>
-            <a:r>
-              <a:rPr lang="en-US" sz="1150" dirty="0">
-                <a:solidFill>
-                  <a:srgbClr val="0B0B0B"/>
-                </a:solidFill>
-                <a:latin typeface="Aptos" pitchFamily="34" charset="0"/>
-                <a:ea typeface="Calibri" pitchFamily="34" charset="-122"/>
-                <a:cs typeface="Calibri" pitchFamily="34" charset="-120"/>
-              </a:rPr>
-              <a:t>Gini 0,31 contre 0,38 : densifier le réseau d’agents agréés corrige l’inégalité territoriale plus vite et à moindre coût que l’ouverture de guichets.</a:t>
-            </a:r>
-            <a:endParaRPr lang="en-US" sz="1150" dirty="0"/>
+            <a:r>
+              <a:t>Gini 0,31 contre 0,38. Les données plaident pour densifier les agents, mieux répartis territorialement que les agences.</a:t>
+            </a:r>
           </a:p>
         </p:txBody>
       </p:sp>
@@ -8503,21 +7923,9 @@
           <a:bodyPr wrap="square" lIns="0" tIns="0" rIns="0" bIns="0" rtlCol="0" anchor="ctr"/>
           <a:lstStyle/>
           <a:p>
-            <a:pPr indent="0" marL="0">
-              <a:buNone/>
-            </a:pPr>
-            <a:r>
-              <a:rPr lang="en-US" sz="1150" dirty="0">
-                <a:solidFill>
-                  <a:srgbClr val="0B0B0B"/>
-                </a:solidFill>
-                <a:latin typeface="Aptos" pitchFamily="34" charset="0"/>
-                <a:ea typeface="Calibri" pitchFamily="34" charset="-122"/>
-                <a:cs typeface="Calibri" pitchFamily="34" charset="-120"/>
-              </a:rPr>
-              <a:t>Est-Mono, Vo et Lacs cumulent l’absence de guichet opérateur ; leurs besoins ne sont toutefois pas identiques en matière de mobile money.</a:t>
-            </a:r>
-            <a:endParaRPr lang="en-US" sz="1150" dirty="0"/>
+            <a:r>
+              <a:t>Est-Mono, Vo et Lacs n’ont aucun guichet opérateur. Leurs besoins en mobile money restent différents et doivent être traités séparément.</a:t>
+            </a:r>
           </a:p>
         </p:txBody>
       </p:sp>
@@ -8649,21 +8057,9 @@
           <a:bodyPr wrap="square" lIns="0" tIns="0" rIns="0" bIns="0" rtlCol="0" anchor="ctr"/>
           <a:lstStyle/>
           <a:p>
-            <a:pPr indent="0" marL="0">
-              <a:buNone/>
-            </a:pPr>
-            <a:r>
-              <a:rPr lang="en-US" sz="1150" dirty="0">
-                <a:solidFill>
-                  <a:srgbClr val="0B0B0B"/>
-                </a:solidFill>
-                <a:latin typeface="Aptos" pitchFamily="34" charset="0"/>
-                <a:ea typeface="Calibri" pitchFamily="34" charset="-122"/>
-                <a:cs typeface="Calibri" pitchFamily="34" charset="-120"/>
-              </a:rPr>
-              <a:t>Le déficit le plus lourd est périurbain. Un plan calé sur la seule ruralité manquerait la plus grosse poche de population sous-servie du pays.</a:t>
-            </a:r>
-            <a:endParaRPr lang="en-US" sz="1150" dirty="0"/>
+            <a:r>
+              <a:t>Le déficit le plus lourd est périurbain. Un plan fondé uniquement sur la ruralité manquerait une importante population sous-servie.</a:t>
+            </a:r>
           </a:p>
         </p:txBody>
       </p:sp>
@@ -8795,21 +8191,9 @@
           <a:bodyPr wrap="square" lIns="0" tIns="0" rIns="0" bIns="0" rtlCol="0" anchor="ctr"/>
           <a:lstStyle/>
           <a:p>
-            <a:pPr indent="0" marL="0">
-              <a:buNone/>
-            </a:pPr>
-            <a:r>
-              <a:rPr lang="en-US" sz="1150" dirty="0">
-                <a:solidFill>
-                  <a:srgbClr val="0B0B0B"/>
-                </a:solidFill>
-                <a:latin typeface="Aptos" pitchFamily="34" charset="0"/>
-                <a:ea typeface="Calibri" pitchFamily="34" charset="-122"/>
-                <a:cs typeface="Calibri" pitchFamily="34" charset="-120"/>
-              </a:rPr>
-              <a:t>Jeu CANAL+ vide, couverture radio en accès restreint, 6,8 % d’opérateurs non renseignés : ces trois points conditionnent tout ciblage sous la maille préfectorale.</a:t>
-            </a:r>
-            <a:endParaRPr lang="en-US" sz="1150" dirty="0"/>
+            <a:r>
+              <a:t>Avant un ciblage plus fin, compléter les données : boutiques CANAL+, couverture radio et opérateur des points mobile money.</a:t>
+            </a:r>
           </a:p>
         </p:txBody>
       </p:sp>
@@ -8834,21 +8218,9 @@
           <a:bodyPr wrap="square" lIns="0" tIns="0" rIns="0" bIns="0" rtlCol="0" anchor="ctr"/>
           <a:lstStyle/>
           <a:p>
-            <a:pPr indent="0" marL="0">
-              <a:buNone/>
-            </a:pPr>
-            <a:r>
-              <a:rPr lang="en-US" sz="1000" dirty="0">
-                <a:solidFill>
-                  <a:srgbClr val="0B0B0B"/>
-                </a:solidFill>
-                <a:latin typeface="Aptos" pitchFamily="34" charset="0"/>
-                <a:ea typeface="Calibri" pitchFamily="34" charset="-122"/>
-                <a:cs typeface="Calibri" pitchFamily="34" charset="-120"/>
-              </a:rPr>
-              <a:t>Les trois premières recommandations découlent directement du score de priorité ; les deux dernières, des limites de la donnée.</a:t>
-            </a:r>
-            <a:endParaRPr lang="en-US" sz="1000" dirty="0"/>
+            <a:r>
+              <a:t>Les trois premières recommandations viennent du score ; les deux dernières répondent aux limites des données.</a:t>
+            </a:r>
           </a:p>
         </p:txBody>
       </p:sp>

</xml_diff>

<commit_message>
Preserve report layout and prevent text overflow
</commit_message>
<xml_diff>
--- a/rapport/Rapport_Defi1_Acces_numerique_Togo.pptx
+++ b/rapport/Rapport_Defi1_Acces_numerique_Togo.pptx
@@ -3203,9 +3203,21 @@
           <a:bodyPr wrap="square" lIns="0" tIns="0" rIns="0" bIns="0" rtlCol="0" anchor="ctr"/>
           <a:lstStyle/>
           <a:p>
-            <a:r>
+            <a:pPr indent="0" marL="0">
+              <a:buNone/>
+            </a:pPr>
+            <a:r>
+              <a:rPr lang="en-US" sz="3000" b="1" dirty="0">
+                <a:solidFill>
+                  <a:srgbClr val="12345F"/>
+                </a:solidFill>
+                <a:latin typeface="Aptos" pitchFamily="34" charset="0"/>
+                <a:ea typeface="Cambria" pitchFamily="34" charset="-122"/>
+                <a:cs typeface="Cambria" pitchFamily="34" charset="-120"/>
+              </a:rPr>
               <a:t>Les six hypothèses à garder en tête</a:t>
             </a:r>
+            <a:endParaRPr lang="en-US" sz="3000" dirty="0"/>
           </a:p>
         </p:txBody>
       </p:sp>
@@ -3269,9 +3281,21 @@
           <a:bodyPr wrap="square" lIns="0" tIns="0" rIns="0" bIns="0" rtlCol="0" anchor="ctr"/>
           <a:lstStyle/>
           <a:p>
-            <a:r>
-              <a:t>H1 : « Attendu » signifie une répartition proportionnelle à la population. C’est une norme d’équité, pas une loi économique.</a:t>
-            </a:r>
+            <a:pPr indent="0" marL="0">
+              <a:buNone/>
+            </a:pPr>
+            <a:r>
+              <a:rPr lang="en-US" sz="1050" dirty="0">
+                <a:solidFill>
+                  <a:srgbClr val="0B0B0B"/>
+                </a:solidFill>
+                <a:latin typeface="Aptos" pitchFamily="34" charset="0"/>
+                <a:ea typeface="Calibri" pitchFamily="34" charset="-122"/>
+                <a:cs typeface="Calibri" pitchFamily="34" charset="-120"/>
+              </a:rPr>
+              <a:t>« Attendu » = répartition proportionnelle à la population. C’est une norme d’équité, pas une loi économique.</a:t>
+            </a:r>
+            <a:endParaRPr lang="en-US" sz="1050" dirty="0"/>
           </a:p>
         </p:txBody>
       </p:sp>
@@ -3335,9 +3359,21 @@
           <a:bodyPr wrap="square" lIns="0" tIns="0" rIns="0" bIns="0" rtlCol="0" anchor="ctr"/>
           <a:lstStyle/>
           <a:p>
-            <a:r>
-              <a:t>H2 : α = 0,5 est un arbitrage politique réglable dans le tableau de bord.</a:t>
-            </a:r>
+            <a:pPr indent="0" marL="0">
+              <a:buNone/>
+            </a:pPr>
+            <a:r>
+              <a:rPr lang="en-US" sz="1050" dirty="0">
+                <a:solidFill>
+                  <a:srgbClr val="0B0B0B"/>
+                </a:solidFill>
+                <a:latin typeface="Aptos" pitchFamily="34" charset="0"/>
+                <a:ea typeface="Calibri" pitchFamily="34" charset="-122"/>
+                <a:cs typeface="Calibri" pitchFamily="34" charset="-120"/>
+              </a:rPr>
+              <a:t>α = 0,5 est un arbitrage politique réglable dans le tableau de bord.</a:t>
+            </a:r>
+            <a:endParaRPr lang="en-US" sz="1050" dirty="0"/>
           </a:p>
         </p:txBody>
       </p:sp>
@@ -3401,9 +3437,21 @@
           <a:bodyPr wrap="square" lIns="0" tIns="0" rIns="0" bIns="0" rtlCol="0" anchor="ctr"/>
           <a:lstStyle/>
           <a:p>
-            <a:r>
-              <a:t>H3 : faute de données radio accessibles, une zone blanche signifie ici absence de service physique, pas absence de signal.</a:t>
-            </a:r>
+            <a:pPr indent="0" marL="0">
+              <a:buNone/>
+            </a:pPr>
+            <a:r>
+              <a:rPr lang="en-US" sz="1050" dirty="0">
+                <a:solidFill>
+                  <a:srgbClr val="0B0B0B"/>
+                </a:solidFill>
+                <a:latin typeface="Aptos" pitchFamily="34" charset="0"/>
+                <a:ea typeface="Calibri" pitchFamily="34" charset="-122"/>
+                <a:cs typeface="Calibri" pitchFamily="34" charset="-120"/>
+              </a:rPr>
+              <a:t>Faute de données radio accessibles, une zone blanche signifie ici absence de service physique, pas absence de signal.</a:t>
+            </a:r>
+            <a:endParaRPr lang="en-US" sz="1050" dirty="0"/>
           </a:p>
         </p:txBody>
       </p:sp>
@@ -3467,9 +3515,21 @@
           <a:bodyPr wrap="square" lIns="0" tIns="0" rIns="0" bIns="0" rtlCol="0" anchor="ctr"/>
           <a:lstStyle/>
           <a:p>
-            <a:r>
-              <a:t>H4 : les distances partent du centroïde du canton, faute de population infra-préfectorale.</a:t>
-            </a:r>
+            <a:pPr indent="0" marL="0">
+              <a:buNone/>
+            </a:pPr>
+            <a:r>
+              <a:rPr lang="en-US" sz="1050" dirty="0">
+                <a:solidFill>
+                  <a:srgbClr val="0B0B0B"/>
+                </a:solidFill>
+                <a:latin typeface="Aptos" pitchFamily="34" charset="0"/>
+                <a:ea typeface="Calibri" pitchFamily="34" charset="-122"/>
+                <a:cs typeface="Calibri" pitchFamily="34" charset="-120"/>
+              </a:rPr>
+              <a:t>Les distances partent du centroïde du canton, faute de population infra-préfectorale.</a:t>
+            </a:r>
+            <a:endParaRPr lang="en-US" sz="1050" dirty="0"/>
           </a:p>
         </p:txBody>
       </p:sp>
@@ -3533,9 +3593,21 @@
           <a:bodyPr wrap="square" lIns="0" tIns="0" rIns="0" bIns="0" rtlCol="0" anchor="ctr"/>
           <a:lstStyle/>
           <a:p>
-            <a:r>
-              <a:t>H5 : les noms des territoires ont été reconstruits par jointure spatiale ; 39/39 préfectures concordent.</a:t>
-            </a:r>
+            <a:pPr indent="0" marL="0">
+              <a:buNone/>
+            </a:pPr>
+            <a:r>
+              <a:rPr lang="en-US" sz="1050" dirty="0">
+                <a:solidFill>
+                  <a:srgbClr val="0B0B0B"/>
+                </a:solidFill>
+                <a:latin typeface="Aptos" pitchFamily="34" charset="0"/>
+                <a:ea typeface="Calibri" pitchFamily="34" charset="-122"/>
+                <a:cs typeface="Calibri" pitchFamily="34" charset="-120"/>
+              </a:rPr>
+              <a:t>Les noms ont été reconstruits par jointure spatiale ; 39/39 préfectures concordent.</a:t>
+            </a:r>
+            <a:endParaRPr lang="en-US" sz="1050" dirty="0"/>
           </a:p>
         </p:txBody>
       </p:sp>
@@ -3599,9 +3671,21 @@
           <a:bodyPr wrap="square" lIns="0" tIns="0" rIns="0" bIns="0" rtlCol="0" anchor="ctr"/>
           <a:lstStyle/>
           <a:p>
-            <a:r>
-              <a:t>H6 : les données forment un inventaire. Population 2022, implantations de date inconnue, 6,8 % d’opérateurs non renseignés.</a:t>
-            </a:r>
+            <a:pPr indent="0" marL="0">
+              <a:buNone/>
+            </a:pPr>
+            <a:r>
+              <a:rPr lang="en-US" sz="1050" dirty="0">
+                <a:solidFill>
+                  <a:srgbClr val="0B0B0B"/>
+                </a:solidFill>
+                <a:latin typeface="Aptos" pitchFamily="34" charset="0"/>
+                <a:ea typeface="Calibri" pitchFamily="34" charset="-122"/>
+                <a:cs typeface="Calibri" pitchFamily="34" charset="-120"/>
+              </a:rPr>
+              <a:t>Les données forment un inventaire. Population 2022, implantations de date inconnue, 6,8 % d’opérateurs non renseignés.</a:t>
+            </a:r>
+            <a:endParaRPr lang="en-US" sz="1050" dirty="0"/>
           </a:p>
         </p:txBody>
       </p:sp>
@@ -3692,9 +3776,21 @@
           <a:bodyPr wrap="square" lIns="0" tIns="0" rIns="0" bIns="0" rtlCol="0" anchor="ctr"/>
           <a:lstStyle/>
           <a:p>
-            <a:r>
+            <a:pPr indent="0" marL="0">
+              <a:buNone/>
+            </a:pPr>
+            <a:r>
+              <a:rPr lang="en-US" sz="1100" dirty="0">
+                <a:solidFill>
+                  <a:srgbClr val="0B0B0B"/>
+                </a:solidFill>
+                <a:latin typeface="Aptos" pitchFamily="34" charset="0"/>
+                <a:ea typeface="Calibri" pitchFamily="34" charset="-122"/>
+                <a:cs typeface="Calibri" pitchFamily="34" charset="-120"/>
+              </a:rPr>
               <a:t>8 vues filtrables par région ; analyse cantonale dans Accès local ; lecture recalculée ; export CSV ; 3 scripts Python reproductibles.</a:t>
             </a:r>
+            <a:endParaRPr lang="en-US" sz="1100" dirty="0"/>
           </a:p>
         </p:txBody>
       </p:sp>
@@ -4601,9 +4697,21 @@
           <a:bodyPr wrap="square" lIns="0" tIns="0" rIns="0" bIns="0" rtlCol="0" anchor="ctr"/>
           <a:lstStyle/>
           <a:p>
-            <a:r>
-              <a:t>Méthode en quatre points</a:t>
-            </a:r>
+            <a:pPr indent="0" marL="0">
+              <a:buNone/>
+            </a:pPr>
+            <a:r>
+              <a:rPr lang="en-US" sz="1600" b="1" dirty="0">
+                <a:solidFill>
+                  <a:srgbClr val="12345F"/>
+                </a:solidFill>
+                <a:latin typeface="Aptos" pitchFamily="34" charset="0"/>
+                <a:ea typeface="Cambria" pitchFamily="34" charset="-122"/>
+                <a:cs typeface="Cambria" pitchFamily="34" charset="-120"/>
+              </a:rPr>
+              <a:t>Trois partis pris</a:t>
+            </a:r>
+            <a:endParaRPr lang="en-US" sz="1600" dirty="0"/>
           </a:p>
         </p:txBody>
       </p:sp>
@@ -4628,27 +4736,139 @@
           <a:bodyPr wrap="square" lIns="0" tIns="0" rIns="0" bIns="0" rtlCol="0" anchor="ctr"/>
           <a:lstStyle/>
           <a:p>
-            <a:r>
-              <a:t>Un inventaire, pas un échantillon. Les résultats sont descriptifs : ils mesurent la situation observée dans les données disponibles.</a:t>
-            </a:r>
-          </a:p>
-          <a:p/>
-          <a:p>
-            <a:r>
-              <a:t>Deux échelles. La préfecture sert au diagnostic ; le canton révèle les écarts de proximité entre les territoires.</a:t>
-            </a:r>
-          </a:p>
-          <a:p/>
-          <a:p>
-            <a:r>
-              <a:t>Des ratios comparables. Les volumes sont rapportés à la population pour éviter de confondre taille et niveau d’accès.</a:t>
-            </a:r>
-          </a:p>
-          <a:p/>
-          <a:p>
-            <a:r>
-              <a:t>Des limites explicites. La couverture radio n’est pas mesurée, le jeu CANAL+ est vide et 6,8 % des opérateurs mobile money ne sont pas renseignés.</a:t>
-            </a:r>
+            <a:pPr indent="0" marL="0">
+              <a:lnSpc>
+                <a:spcPts val="1600"/>
+              </a:lnSpc>
+              <a:buNone/>
+            </a:pPr>
+            <a:r>
+              <a:rPr lang="en-US" sz="1150" b="1" dirty="0">
+                <a:solidFill>
+                  <a:srgbClr val="0B0B0B"/>
+                </a:solidFill>
+                <a:latin typeface="Aptos" pitchFamily="34" charset="0"/>
+                <a:ea typeface="Calibri" pitchFamily="34" charset="-122"/>
+                <a:cs typeface="Calibri" pitchFamily="34" charset="-120"/>
+              </a:rPr>
+              <a:t>Un inventaire, pas un échantillon. Les résultats sont descriptifs.</a:t>
+            </a:r>
+            <a:pPr indent="0" marL="0">
+              <a:lnSpc>
+                <a:spcPts val="1600"/>
+              </a:lnSpc>
+              <a:buNone/>
+            </a:pPr>
+            <a:r>
+              <a:rPr lang="en-US" sz="1150" dirty="0">
+                <a:solidFill>
+                  <a:srgbClr val="0B0B0B"/>
+                </a:solidFill>
+                <a:latin typeface="Aptos" pitchFamily="34" charset="0"/>
+                <a:ea typeface="Calibri" pitchFamily="34" charset="-122"/>
+                <a:cs typeface="Calibri" pitchFamily="34" charset="-120"/>
+              </a:rPr>
+              <a:t/>
+            </a:r>
+            <a:endParaRPr lang="en-US" sz="1150" dirty="0"/>
+          </a:p>
+          <a:p>
+            <a:pPr indent="0" marL="0">
+              <a:lnSpc>
+                <a:spcPts val="1600"/>
+              </a:lnSpc>
+              <a:buNone/>
+            </a:pPr>
+            <a:endParaRPr lang="en-US" sz="1150" dirty="0"/>
+          </a:p>
+          <a:p>
+            <a:pPr indent="0" marL="0">
+              <a:lnSpc>
+                <a:spcPts val="1600"/>
+              </a:lnSpc>
+              <a:buNone/>
+            </a:pPr>
+            <a:r>
+              <a:rPr lang="en-US" sz="1150" b="1" dirty="0">
+                <a:solidFill>
+                  <a:srgbClr val="0B0B0B"/>
+                </a:solidFill>
+                <a:latin typeface="Aptos" pitchFamily="34" charset="0"/>
+                <a:ea typeface="Calibri" pitchFamily="34" charset="-122"/>
+                <a:cs typeface="Calibri" pitchFamily="34" charset="-120"/>
+              </a:rPr>
+              <a:t>Deux échelles. La préfecture sert au diagnostic ; le canton révèle les écarts de proximité.</a:t>
+            </a:r>
+            <a:endParaRPr lang="en-US" sz="1150" dirty="0"/>
+          </a:p>
+          <a:p>
+            <a:pPr indent="0" marL="0">
+              <a:lnSpc>
+                <a:spcPts val="1600"/>
+              </a:lnSpc>
+              <a:buNone/>
+            </a:pPr>
+            <a:r>
+              <a:rPr lang="en-US" sz="1150" dirty="0">
+                <a:solidFill>
+                  <a:srgbClr val="0B0B0B"/>
+                </a:solidFill>
+                <a:latin typeface="Aptos" pitchFamily="34" charset="0"/>
+                <a:ea typeface="Calibri" pitchFamily="34" charset="-122"/>
+                <a:cs typeface="Calibri" pitchFamily="34" charset="-120"/>
+              </a:rPr>
+              <a:t/>
+            </a:r>
+            <a:endParaRPr lang="en-US" sz="1150" dirty="0"/>
+          </a:p>
+          <a:p>
+            <a:pPr indent="0" marL="0">
+              <a:lnSpc>
+                <a:spcPts val="1600"/>
+              </a:lnSpc>
+              <a:buNone/>
+            </a:pPr>
+            <a:endParaRPr lang="en-US" sz="1150" dirty="0"/>
+          </a:p>
+          <a:p>
+            <a:pPr indent="0" marL="0">
+              <a:lnSpc>
+                <a:spcPts val="1600"/>
+              </a:lnSpc>
+              <a:buNone/>
+            </a:pPr>
+            <a:r>
+              <a:rPr lang="en-US" sz="1150" b="1" dirty="0">
+                <a:solidFill>
+                  <a:srgbClr val="0B0B0B"/>
+                </a:solidFill>
+                <a:latin typeface="Aptos" pitchFamily="34" charset="0"/>
+                <a:ea typeface="Calibri" pitchFamily="34" charset="-122"/>
+                <a:cs typeface="Calibri" pitchFamily="34" charset="-120"/>
+              </a:rPr>
+              <a:t>Limites explicites.</a:t>
+            </a:r>
+            <a:endParaRPr lang="en-US" sz="1150" dirty="0"/>
+          </a:p>
+          <a:p>
+            <a:pPr indent="0" marL="0">
+              <a:lnSpc>
+                <a:spcPts val="1600"/>
+              </a:lnSpc>
+              <a:buNone/>
+            </a:pPr>
+            <a:r>
+              <a:rPr lang="en-US" sz="1150" dirty="0">
+                <a:solidFill>
+                  <a:srgbClr val="0B0B0B"/>
+                </a:solidFill>
+                <a:latin typeface="Aptos" pitchFamily="34" charset="0"/>
+                <a:ea typeface="Calibri" pitchFamily="34" charset="-122"/>
+                <a:cs typeface="Calibri" pitchFamily="34" charset="-120"/>
+              </a:rPr>
+              <a:t>Couverture radio non mesurée, jeu CANAL+ vide, 6,8 % d’opérateurs non renseignés.</a:t>
+            </a:r>
+            <a:endParaRPr lang="en-US" sz="1150" dirty="0"/>
           </a:p>
         </p:txBody>
       </p:sp>
@@ -4673,9 +4893,21 @@
           <a:bodyPr wrap="square" lIns="0" tIns="0" rIns="0" bIns="0" rtlCol="0" anchor="ctr"/>
           <a:lstStyle/>
           <a:p>
-            <a:r>
-              <a:t>Chaîne reproductible : données brutes, 3 scripts Python, tables d’analyse et tableau de bord.</a:t>
-            </a:r>
+            <a:pPr indent="0" marL="0">
+              <a:buNone/>
+            </a:pPr>
+            <a:r>
+              <a:rPr lang="en-US" sz="1000" dirty="0">
+                <a:solidFill>
+                  <a:srgbClr val="0B0B0B"/>
+                </a:solidFill>
+                <a:latin typeface="Aptos" pitchFamily="34" charset="0"/>
+                <a:ea typeface="Calibri" pitchFamily="34" charset="-122"/>
+                <a:cs typeface="Calibri" pitchFamily="34" charset="-120"/>
+              </a:rPr>
+              <a:t>Chaîne complète : 3 scripts Python, des sources brutes au tableau de bord. Tout est rejouable.</a:t>
+            </a:r>
+            <a:endParaRPr lang="en-US" sz="1000" dirty="0"/>
           </a:p>
         </p:txBody>
       </p:sp>
@@ -6227,9 +6459,21 @@
           <a:bodyPr wrap="square" lIns="0" tIns="0" rIns="0" bIns="0" rtlCol="0" anchor="ctr"/>
           <a:lstStyle/>
           <a:p>
-            <a:r>
-              <a:t>L’écart entre ces deux chiffres montre le rôle complémentaire du réseau d’agents : il rapproche les services des habitants quand une agence est plus éloignée.</a:t>
-            </a:r>
+            <a:pPr indent="0" marL="0">
+              <a:buNone/>
+            </a:pPr>
+            <a:r>
+              <a:rPr lang="en-US" sz="1450" i="1" dirty="0">
+                <a:solidFill>
+                  <a:srgbClr val="FFFFFF"/>
+                </a:solidFill>
+                <a:latin typeface="Aptos" pitchFamily="34" charset="0"/>
+                <a:ea typeface="Cambria" pitchFamily="34" charset="-122"/>
+                <a:cs typeface="Cambria" pitchFamily="34" charset="-120"/>
+              </a:rPr>
+              <a:t>L’écart entre ces deux chiffres est un résultat, pas un détail : il mesure exactement ce que le réseau d’agents privés compense là où les opérateurs ne vont pas.</a:t>
+            </a:r>
+            <a:endParaRPr lang="en-US" sz="1450" dirty="0"/>
           </a:p>
         </p:txBody>
       </p:sp>
@@ -6254,9 +6498,70 @@
           <a:bodyPr wrap="square" lIns="0" tIns="0" rIns="0" bIns="0" rtlCol="0" anchor="ctr"/>
           <a:lstStyle/>
           <a:p>
-            <a:r>
-              <a:t>23 cantons sur 396 ne comptent aucun point de service. Dans le canton le plus éloigné, situé à Blitta, le premier service est à 21 km. Ces écarts apparaissent seulement à l’échelle cantonale.</a:t>
-            </a:r>
+            <a:pPr indent="0" marL="0">
+              <a:lnSpc>
+                <a:spcPts val="1700"/>
+              </a:lnSpc>
+              <a:buNone/>
+            </a:pPr>
+            <a:r>
+              <a:rPr lang="en-US" sz="1250" b="1" dirty="0">
+                <a:solidFill>
+                  <a:srgbClr val="0B0B0B"/>
+                </a:solidFill>
+                <a:latin typeface="Aptos" pitchFamily="34" charset="0"/>
+                <a:ea typeface="Calibri" pitchFamily="34" charset="-122"/>
+                <a:cs typeface="Calibri" pitchFamily="34" charset="-120"/>
+              </a:rPr>
+              <a:t>23 cantons sur 396</a:t>
+            </a:r>
+            <a:pPr indent="0" marL="0">
+              <a:lnSpc>
+                <a:spcPts val="1700"/>
+              </a:lnSpc>
+              <a:buNone/>
+            </a:pPr>
+            <a:r>
+              <a:rPr lang="en-US" sz="1250" dirty="0">
+                <a:solidFill>
+                  <a:srgbClr val="0B0B0B"/>
+                </a:solidFill>
+                <a:latin typeface="Aptos" pitchFamily="34" charset="0"/>
+                <a:ea typeface="Calibri" pitchFamily="34" charset="-122"/>
+                <a:cs typeface="Calibri" pitchFamily="34" charset="-120"/>
+              </a:rPr>
+              <a:t> ne comptent aucun point de service. Le plus isolé, dans Blitta, est à 21 km du premier service quel qu’il soit.</a:t>
+            </a:r>
+            <a:endParaRPr lang="en-US" sz="1250" dirty="0"/>
+          </a:p>
+          <a:p>
+            <a:pPr indent="0" marL="0">
+              <a:lnSpc>
+                <a:spcPts val="1700"/>
+              </a:lnSpc>
+              <a:buNone/>
+            </a:pPr>
+            <a:endParaRPr lang="en-US" sz="1250" dirty="0"/>
+          </a:p>
+          <a:p>
+            <a:pPr indent="0" marL="0">
+              <a:lnSpc>
+                <a:spcPts val="1700"/>
+              </a:lnSpc>
+              <a:buNone/>
+            </a:pPr>
+            <a:r>
+              <a:rPr lang="en-US" sz="1250" dirty="0">
+                <a:solidFill>
+                  <a:srgbClr val="0B0B0B"/>
+                </a:solidFill>
+                <a:latin typeface="Aptos" pitchFamily="34" charset="0"/>
+                <a:ea typeface="Calibri" pitchFamily="34" charset="-122"/>
+                <a:cs typeface="Calibri" pitchFamily="34" charset="-120"/>
+              </a:rPr>
+              <a:t>Ces écarts sont invisibles à l’échelle de la préfecture, qui les moyenne. Changer d’échelle change la carte des priorités — c’est pourquoi les deux sont présentées.</a:t>
+            </a:r>
+            <a:endParaRPr lang="en-US" sz="1250" dirty="0"/>
           </a:p>
         </p:txBody>
       </p:sp>
@@ -6281,9 +6586,21 @@
           <a:bodyPr wrap="square" lIns="0" tIns="0" rIns="0" bIns="0" rtlCol="0" anchor="ctr"/>
           <a:lstStyle/>
           <a:p>
-            <a:r>
-              <a:t>La couverture radio n’est pas mesurée : les zones blanches désignent ici l’absence de service physique, depuis le centroïde du canton.</a:t>
-            </a:r>
+            <a:pPr indent="0" marL="0">
+              <a:buNone/>
+            </a:pPr>
+            <a:r>
+              <a:rPr lang="en-US" sz="1000" dirty="0">
+                <a:solidFill>
+                  <a:srgbClr val="0B0B0B"/>
+                </a:solidFill>
+                <a:latin typeface="Aptos" pitchFamily="34" charset="0"/>
+                <a:ea typeface="Calibri" pitchFamily="34" charset="-122"/>
+                <a:cs typeface="Calibri" pitchFamily="34" charset="-120"/>
+              </a:rPr>
+              <a:t>Couverture radio indisponible (couches Géoportail en accès restreint) : la zone blanche est définie par la distance au service, depuis le centroïde du canton.</a:t>
+            </a:r>
+            <a:endParaRPr lang="en-US" sz="1000" dirty="0"/>
           </a:p>
         </p:txBody>
       </p:sp>
@@ -6739,20 +7056,73 @@
           <a:bodyPr wrap="square" lIns="0" tIns="0" rIns="0" bIns="0" rtlCol="0" anchor="ctr"/>
           <a:lstStyle/>
           <a:p>
-            <a:r>
+            <a:pPr indent="0" marL="0">
+              <a:lnSpc>
+                <a:spcPts val="1700"/>
+              </a:lnSpc>
+              <a:buNone/>
+            </a:pPr>
+            <a:r>
+              <a:rPr lang="en-US" sz="1250" b="1" dirty="0">
+                <a:solidFill>
+                  <a:srgbClr val="0B0B0B"/>
+                </a:solidFill>
+                <a:latin typeface="Aptos" pitchFamily="34" charset="0"/>
+                <a:ea typeface="Calibri" pitchFamily="34" charset="-122"/>
+                <a:cs typeface="Calibri" pitchFamily="34" charset="-120"/>
+              </a:rPr>
               <a:t>Ce que cela signifie.</a:t>
             </a:r>
-          </a:p>
-          <a:p>
-            <a:r>
-              <a:t>Plus l’indice est bas, plus l’accès est également réparti. Le réseau d’agents apparaît mieux réparti que le réseau d’agences dans les données observées.</a:t>
-            </a:r>
-          </a:p>
-          <a:p/>
-          <a:p>
-            <a:r>
-              <a:t>Les données plaident donc en faveur d’une densification des agents, sans mesurer directement le coût ni la vitesse de déploiement.</a:t>
-            </a:r>
+            <a:endParaRPr lang="en-US" sz="1250" dirty="0"/>
+          </a:p>
+          <a:p>
+            <a:pPr indent="0" marL="0">
+              <a:lnSpc>
+                <a:spcPts val="1700"/>
+              </a:lnSpc>
+              <a:buNone/>
+            </a:pPr>
+            <a:r>
+              <a:rPr lang="en-US" sz="1250" dirty="0">
+                <a:solidFill>
+                  <a:srgbClr val="0B0B0B"/>
+                </a:solidFill>
+                <a:latin typeface="Aptos" pitchFamily="34" charset="0"/>
+                <a:ea typeface="Calibri" pitchFamily="34" charset="-122"/>
+                <a:cs typeface="Calibri" pitchFamily="34" charset="-120"/>
+              </a:rPr>
+              <a:t>Plus l’indice est bas, plus l’accès est également réparti entre les habitants. Le réseau d’agents agréés, porté par le marché, atteint une population que le réseau d’agences des opérateurs n’atteint pas.</a:t>
+            </a:r>
+            <a:endParaRPr lang="en-US" sz="1250" dirty="0"/>
+          </a:p>
+          <a:p>
+            <a:pPr indent="0" marL="0">
+              <a:lnSpc>
+                <a:spcPts val="1700"/>
+              </a:lnSpc>
+              <a:buNone/>
+            </a:pPr>
+            <a:endParaRPr lang="en-US" sz="1250" dirty="0"/>
+          </a:p>
+          <a:p>
+            <a:pPr indent="0" marL="0">
+              <a:lnSpc>
+                <a:spcPts val="1700"/>
+              </a:lnSpc>
+              <a:buNone/>
+            </a:pPr>
+            <a:r>
+              <a:rPr lang="en-US" sz="1250" dirty="0">
+                <a:solidFill>
+                  <a:srgbClr val="0B0B0B"/>
+                </a:solidFill>
+                <a:latin typeface="Aptos" pitchFamily="34" charset="0"/>
+                <a:ea typeface="Calibri" pitchFamily="34" charset="-122"/>
+                <a:cs typeface="Calibri" pitchFamily="34" charset="-120"/>
+              </a:rPr>
+              <a:t>Les données plaident pour densifier les agents, mieux répartis territorialement que les agences.</a:t>
+            </a:r>
+            <a:endParaRPr lang="en-US" sz="1250" dirty="0"/>
           </a:p>
         </p:txBody>
       </p:sp>
@@ -7092,21 +7462,102 @@
           <a:bodyPr wrap="square" lIns="0" tIns="0" rIns="0" bIns="0" rtlCol="0" anchor="ctr"/>
           <a:lstStyle/>
           <a:p>
-            <a:r>
-              <a:t>Agoè-Nyivé est une préfecture périurbaine fortement peuplée, mais son niveau de service reste inférieur à ce qu’impliquerait une répartition proportionnelle à la population.</a:t>
-            </a:r>
-          </a:p>
-          <a:p/>
-          <a:p>
-            <a:r>
-              <a:t>À l’inverse, les préfectures les mieux dotées sont les chefs-lieux régionaux : Sokodé (2,4×), Kara (2,3×) et Cinkassé (1,7×).</a:t>
-            </a:r>
-          </a:p>
-          <a:p/>
-          <a:p>
-            <a:r>
-              <a:t>L’implantation observée suit davantage la carte administrative que la carte démographique.</a:t>
-            </a:r>
+            <a:pPr indent="0" marL="0">
+              <a:lnSpc>
+                <a:spcPts val="1600"/>
+              </a:lnSpc>
+              <a:buNone/>
+            </a:pPr>
+            <a:r>
+              <a:rPr lang="en-US" sz="1200" b="1" dirty="0">
+                <a:solidFill>
+                  <a:srgbClr val="0B0B0B"/>
+                </a:solidFill>
+                <a:latin typeface="Aptos" pitchFamily="34" charset="0"/>
+                <a:ea typeface="Calibri" pitchFamily="34" charset="-122"/>
+                <a:cs typeface="Calibri" pitchFamily="34" charset="-120"/>
+              </a:rPr>
+              <a:t>La banlieue de Lomé, pas une zone reculée.</a:t>
+            </a:r>
+            <a:endParaRPr lang="en-US" sz="1200" dirty="0"/>
+          </a:p>
+          <a:p>
+            <a:pPr indent="0" marL="0">
+              <a:lnSpc>
+                <a:spcPts val="1600"/>
+              </a:lnSpc>
+              <a:buNone/>
+            </a:pPr>
+            <a:r>
+              <a:rPr lang="en-US" sz="1200" dirty="0">
+                <a:solidFill>
+                  <a:srgbClr val="0B0B0B"/>
+                </a:solidFill>
+                <a:latin typeface="Aptos" pitchFamily="34" charset="0"/>
+                <a:ea typeface="Calibri" pitchFamily="34" charset="-122"/>
+                <a:cs typeface="Calibri" pitchFamily="34" charset="-120"/>
+              </a:rPr>
+              <a:t>Une préfecture périurbaine fortement peuplée affiche 0,65 fois l’accès attendu au regard de sa population. Son niveau de service reste inférieur à ce qu’impliquerait une répartition proportionnelle à la population.</a:t>
+            </a:r>
+            <a:endParaRPr lang="en-US" sz="1200" dirty="0"/>
+          </a:p>
+          <a:p>
+            <a:pPr indent="0" marL="0">
+              <a:lnSpc>
+                <a:spcPts val="1600"/>
+              </a:lnSpc>
+              <a:buNone/>
+            </a:pPr>
+            <a:endParaRPr lang="en-US" sz="1200" dirty="0"/>
+          </a:p>
+          <a:p>
+            <a:pPr indent="0" marL="0">
+              <a:lnSpc>
+                <a:spcPts val="1600"/>
+              </a:lnSpc>
+              <a:buNone/>
+            </a:pPr>
+            <a:r>
+              <a:rPr lang="en-US" sz="1200" dirty="0">
+                <a:solidFill>
+                  <a:srgbClr val="0B0B0B"/>
+                </a:solidFill>
+                <a:latin typeface="Aptos" pitchFamily="34" charset="0"/>
+                <a:ea typeface="Calibri" pitchFamily="34" charset="-122"/>
+                <a:cs typeface="Calibri" pitchFamily="34" charset="-120"/>
+              </a:rPr>
+              <a:t>À l’inverse, les préfectures les mieux dotées sont les chefs-lieux régionaux : Sokodé (2,4×), Kara (2,3×), Cinkassé (1,7×) — devant Lomé.</a:t>
+            </a:r>
+            <a:endParaRPr lang="en-US" sz="1200" dirty="0"/>
+          </a:p>
+          <a:p>
+            <a:pPr indent="0" marL="0">
+              <a:lnSpc>
+                <a:spcPts val="1600"/>
+              </a:lnSpc>
+              <a:buNone/>
+            </a:pPr>
+            <a:endParaRPr lang="en-US" sz="1200" dirty="0"/>
+          </a:p>
+          <a:p>
+            <a:pPr indent="0" marL="0">
+              <a:lnSpc>
+                <a:spcPts val="1600"/>
+              </a:lnSpc>
+              <a:buNone/>
+            </a:pPr>
+            <a:r>
+              <a:rPr lang="en-US" sz="1200" b="1" dirty="0">
+                <a:solidFill>
+                  <a:srgbClr val="0B0B0B"/>
+                </a:solidFill>
+                <a:latin typeface="Aptos" pitchFamily="34" charset="0"/>
+                <a:ea typeface="Calibri" pitchFamily="34" charset="-122"/>
+                <a:cs typeface="Calibri" pitchFamily="34" charset="-120"/>
+              </a:rPr>
+              <a:t>L’implantation suit la carte administrative, pas la carte démographique.</a:t>
+            </a:r>
+            <a:endParaRPr lang="en-US" sz="1200" dirty="0"/>
           </a:p>
         </p:txBody>
       </p:sp>
@@ -7367,9 +7818,102 @@
           <a:bodyPr wrap="square" lIns="0" tIns="0" rIns="0" bIns="0" rtlCol="0" anchor="ctr"/>
           <a:lstStyle/>
           <a:p>
-            <a:r>
-              <a:t>Le curseur α équilibre deux priorités : corriger le déficit brut ou privilégier les territoires où davantage d’habitants sont concernés. α = 0 classe au déficit brut ; α = 1 donne davantage de poids à la population. La valeur retenue, 0,5, est réglable dans le tableau de bord.</a:t>
-            </a:r>
+            <a:pPr indent="0" marL="0">
+              <a:lnSpc>
+                <a:spcPts val="1600"/>
+              </a:lnSpc>
+              <a:buNone/>
+            </a:pPr>
+            <a:r>
+              <a:rPr lang="en-US" sz="1200" b="1" dirty="0">
+                <a:solidFill>
+                  <a:srgbClr val="0B0B0B"/>
+                </a:solidFill>
+                <a:latin typeface="Aptos" pitchFamily="34" charset="0"/>
+                <a:ea typeface="Calibri" pitchFamily="34" charset="-122"/>
+                <a:cs typeface="Calibri" pitchFamily="34" charset="-120"/>
+              </a:rPr>
+              <a:t>Le rôle de α.</a:t>
+            </a:r>
+            <a:endParaRPr lang="en-US" sz="1200" dirty="0"/>
+          </a:p>
+          <a:p>
+            <a:pPr indent="0" marL="0">
+              <a:lnSpc>
+                <a:spcPts val="1600"/>
+              </a:lnSpc>
+              <a:buNone/>
+            </a:pPr>
+            <a:r>
+              <a:rPr lang="en-US" sz="1200" dirty="0">
+                <a:solidFill>
+                  <a:srgbClr val="0B0B0B"/>
+                </a:solidFill>
+                <a:latin typeface="Aptos" pitchFamily="34" charset="0"/>
+                <a:ea typeface="Calibri" pitchFamily="34" charset="-122"/>
+                <a:cs typeface="Calibri" pitchFamily="34" charset="-120"/>
+              </a:rPr>
+              <a:t>Le curseur α équilibre deux priorités : corriger le déficit brut ou privilégier les territoires où davantage d’habitants sont concernés.</a:t>
+            </a:r>
+            <a:endParaRPr lang="en-US" sz="1200" dirty="0"/>
+          </a:p>
+          <a:p>
+            <a:pPr indent="0" marL="0">
+              <a:lnSpc>
+                <a:spcPts val="1600"/>
+              </a:lnSpc>
+              <a:buNone/>
+            </a:pPr>
+            <a:endParaRPr lang="en-US" sz="1200" dirty="0"/>
+          </a:p>
+          <a:p>
+            <a:pPr indent="0" marL="0">
+              <a:lnSpc>
+                <a:spcPts val="1600"/>
+              </a:lnSpc>
+              <a:buNone/>
+            </a:pPr>
+            <a:r>
+              <a:rPr lang="en-US" sz="1200" dirty="0">
+                <a:solidFill>
+                  <a:srgbClr val="0B0B0B"/>
+                </a:solidFill>
+                <a:latin typeface="Aptos" pitchFamily="34" charset="0"/>
+                <a:ea typeface="Calibri" pitchFamily="34" charset="-122"/>
+                <a:cs typeface="Calibri" pitchFamily="34" charset="-120"/>
+              </a:rPr>
+              <a:t>α = 0 classe au déficit brut ; α = 1 privilégie le nombre d’habitants touchés. La valeur retenue, 0,5, est un compromis — et il est réglable en direct dans le tableau de bord.</a:t>
+            </a:r>
+            <a:endParaRPr lang="en-US" sz="1200" dirty="0"/>
+          </a:p>
+          <a:p>
+            <a:pPr indent="0" marL="0">
+              <a:lnSpc>
+                <a:spcPts val="1600"/>
+              </a:lnSpc>
+              <a:buNone/>
+            </a:pPr>
+            <a:endParaRPr lang="en-US" sz="1200" dirty="0"/>
+          </a:p>
+          <a:p>
+            <a:pPr indent="0" marL="0">
+              <a:lnSpc>
+                <a:spcPts val="1600"/>
+              </a:lnSpc>
+              <a:buNone/>
+            </a:pPr>
+            <a:r>
+              <a:rPr lang="en-US" sz="1200" b="1" dirty="0">
+                <a:solidFill>
+                  <a:srgbClr val="0B0B0B"/>
+                </a:solidFill>
+                <a:latin typeface="Aptos" pitchFamily="34" charset="0"/>
+                <a:ea typeface="Calibri" pitchFamily="34" charset="-122"/>
+                <a:cs typeface="Calibri" pitchFamily="34" charset="-120"/>
+              </a:rPr>
+              <a:t>Ce choix est un arbitrage politique, pas un résultat statistique. Il est exposé, pas dissimulé.</a:t>
+            </a:r>
+            <a:endParaRPr lang="en-US" sz="1200" dirty="0"/>
           </a:p>
         </p:txBody>
       </p:sp>
@@ -7410,9 +7954,21 @@
           <a:bodyPr wrap="square" lIns="0" tIns="0" rIns="0" bIns="0" rtlCol="0" anchor="ctr"/>
           <a:lstStyle/>
           <a:p>
-            <a:r>
-              <a:t>Le score est transparent : aucun modèle boîte noire ni paramètre caché. Il peut être recalculé à partir de la table publiée.</a:t>
-            </a:r>
+            <a:pPr indent="0" marL="0">
+              <a:buNone/>
+            </a:pPr>
+            <a:r>
+              <a:rPr lang="en-US" sz="1000" dirty="0">
+                <a:solidFill>
+                  <a:srgbClr val="0B0B0B"/>
+                </a:solidFill>
+                <a:latin typeface="Aptos" pitchFamily="34" charset="0"/>
+                <a:ea typeface="Calibri" pitchFamily="34" charset="-122"/>
+                <a:cs typeface="Calibri" pitchFamily="34" charset="-120"/>
+              </a:rPr>
+              <a:t>Aucun modèle boîte noire, aucun paramètre caché : le score se recalcule à la main à partir de la table publiée.</a:t>
+            </a:r>
+            <a:endParaRPr lang="en-US" sz="1000" dirty="0"/>
           </a:p>
         </p:txBody>
       </p:sp>
@@ -7655,9 +8211,21 @@
           <a:bodyPr wrap="square" lIns="0" tIns="0" rIns="0" bIns="0" rtlCol="0" anchor="ctr"/>
           <a:lstStyle/>
           <a:p>
-            <a:r>
+            <a:pPr indent="0" marL="0">
+              <a:buNone/>
+            </a:pPr>
+            <a:r>
+              <a:rPr lang="en-US" sz="1150" dirty="0">
+                <a:solidFill>
+                  <a:srgbClr val="0B0B0B"/>
+                </a:solidFill>
+                <a:latin typeface="Aptos" pitchFamily="34" charset="0"/>
+                <a:ea typeface="Calibri" pitchFamily="34" charset="-122"/>
+                <a:cs typeface="Calibri" pitchFamily="34" charset="-120"/>
+              </a:rPr>
               <a:t>Agoè-Nyivé, Zio et Haho obtiennent les scores les plus élevés : elles combinent déficit important et population nombreuse.</a:t>
             </a:r>
+            <a:endParaRPr lang="en-US" sz="1150" dirty="0"/>
           </a:p>
         </p:txBody>
       </p:sp>
@@ -7789,9 +8357,21 @@
           <a:bodyPr wrap="square" lIns="0" tIns="0" rIns="0" bIns="0" rtlCol="0" anchor="ctr"/>
           <a:lstStyle/>
           <a:p>
-            <a:r>
+            <a:pPr indent="0" marL="0">
+              <a:buNone/>
+            </a:pPr>
+            <a:r>
+              <a:rPr lang="en-US" sz="1150" dirty="0">
+                <a:solidFill>
+                  <a:srgbClr val="0B0B0B"/>
+                </a:solidFill>
+                <a:latin typeface="Aptos" pitchFamily="34" charset="0"/>
+                <a:ea typeface="Calibri" pitchFamily="34" charset="-122"/>
+                <a:cs typeface="Calibri" pitchFamily="34" charset="-120"/>
+              </a:rPr>
               <a:t>Gini 0,31 contre 0,38. Les données plaident pour densifier les agents, mieux répartis territorialement que les agences.</a:t>
             </a:r>
+            <a:endParaRPr lang="en-US" sz="1150" dirty="0"/>
           </a:p>
         </p:txBody>
       </p:sp>
@@ -7923,9 +8503,21 @@
           <a:bodyPr wrap="square" lIns="0" tIns="0" rIns="0" bIns="0" rtlCol="0" anchor="ctr"/>
           <a:lstStyle/>
           <a:p>
-            <a:r>
-              <a:t>Est-Mono, Vo et Lacs n’ont aucun guichet opérateur. Leurs besoins en mobile money restent différents et doivent être traités séparément.</a:t>
-            </a:r>
+            <a:pPr indent="0" marL="0">
+              <a:buNone/>
+            </a:pPr>
+            <a:r>
+              <a:rPr lang="en-US" sz="1150" dirty="0">
+                <a:solidFill>
+                  <a:srgbClr val="0B0B0B"/>
+                </a:solidFill>
+                <a:latin typeface="Aptos" pitchFamily="34" charset="0"/>
+                <a:ea typeface="Calibri" pitchFamily="34" charset="-122"/>
+                <a:cs typeface="Calibri" pitchFamily="34" charset="-120"/>
+              </a:rPr>
+              <a:t>Est-Mono, Vo et Lacs n’ont aucun guichet opérateur. Leurs besoins en mobile money restent différents.</a:t>
+            </a:r>
+            <a:endParaRPr lang="en-US" sz="1150" dirty="0"/>
           </a:p>
         </p:txBody>
       </p:sp>
@@ -8057,9 +8649,21 @@
           <a:bodyPr wrap="square" lIns="0" tIns="0" rIns="0" bIns="0" rtlCol="0" anchor="ctr"/>
           <a:lstStyle/>
           <a:p>
-            <a:r>
+            <a:pPr indent="0" marL="0">
+              <a:buNone/>
+            </a:pPr>
+            <a:r>
+              <a:rPr lang="en-US" sz="1150" dirty="0">
+                <a:solidFill>
+                  <a:srgbClr val="0B0B0B"/>
+                </a:solidFill>
+                <a:latin typeface="Aptos" pitchFamily="34" charset="0"/>
+                <a:ea typeface="Calibri" pitchFamily="34" charset="-122"/>
+                <a:cs typeface="Calibri" pitchFamily="34" charset="-120"/>
+              </a:rPr>
               <a:t>Le déficit le plus lourd est périurbain. Un plan fondé uniquement sur la ruralité manquerait une importante population sous-servie.</a:t>
             </a:r>
+            <a:endParaRPr lang="en-US" sz="1150" dirty="0"/>
           </a:p>
         </p:txBody>
       </p:sp>
@@ -8191,9 +8795,21 @@
           <a:bodyPr wrap="square" lIns="0" tIns="0" rIns="0" bIns="0" rtlCol="0" anchor="ctr"/>
           <a:lstStyle/>
           <a:p>
-            <a:r>
+            <a:pPr indent="0" marL="0">
+              <a:buNone/>
+            </a:pPr>
+            <a:r>
+              <a:rPr lang="en-US" sz="1150" dirty="0">
+                <a:solidFill>
+                  <a:srgbClr val="0B0B0B"/>
+                </a:solidFill>
+                <a:latin typeface="Aptos" pitchFamily="34" charset="0"/>
+                <a:ea typeface="Calibri" pitchFamily="34" charset="-122"/>
+                <a:cs typeface="Calibri" pitchFamily="34" charset="-120"/>
+              </a:rPr>
               <a:t>Avant un ciblage plus fin, compléter les données : boutiques CANAL+, couverture radio et opérateur des points mobile money.</a:t>
             </a:r>
+            <a:endParaRPr lang="en-US" sz="1150" dirty="0"/>
           </a:p>
         </p:txBody>
       </p:sp>
@@ -8218,9 +8834,21 @@
           <a:bodyPr wrap="square" lIns="0" tIns="0" rIns="0" bIns="0" rtlCol="0" anchor="ctr"/>
           <a:lstStyle/>
           <a:p>
-            <a:r>
+            <a:pPr indent="0" marL="0">
+              <a:buNone/>
+            </a:pPr>
+            <a:r>
+              <a:rPr lang="en-US" sz="1000" dirty="0">
+                <a:solidFill>
+                  <a:srgbClr val="0B0B0B"/>
+                </a:solidFill>
+                <a:latin typeface="Aptos" pitchFamily="34" charset="0"/>
+                <a:ea typeface="Calibri" pitchFamily="34" charset="-122"/>
+                <a:cs typeface="Calibri" pitchFamily="34" charset="-120"/>
+              </a:rPr>
               <a:t>Les trois premières recommandations viennent du score ; les deux dernières répondent aux limites des données.</a:t>
             </a:r>
+            <a:endParaRPr lang="en-US" sz="1000" dirty="0"/>
           </a:p>
         </p:txBody>
       </p:sp>

</xml_diff>

<commit_message>
Turn method slide into workflow
</commit_message>
<xml_diff>
--- a/rapport/Rapport_Defi1_Acces_numerique_Togo.pptx
+++ b/rapport/Rapport_Defi1_Acces_numerique_Togo.pptx
@@ -4006,7 +4006,7 @@
                 <a:ea typeface="Cambria" pitchFamily="34" charset="-122"/>
                 <a:cs typeface="Cambria" pitchFamily="34" charset="-120"/>
               </a:rPr>
-              <a:t>19 788</a:t>
+              <a:t>1</a:t>
             </a:r>
             <a:endParaRPr lang="en-US" sz="2300" dirty="0"/>
           </a:p>
@@ -4045,7 +4045,7 @@
                 <a:ea typeface="Calibri" pitchFamily="34" charset="-122"/>
                 <a:cs typeface="Calibri" pitchFamily="34" charset="-120"/>
               </a:rPr>
-              <a:t>Agents mobile money</a:t>
+              <a:t>Sources</a:t>
             </a:r>
             <a:endParaRPr lang="en-US" sz="1400" dirty="0"/>
           </a:p>
@@ -4084,7 +4084,8 @@
                 <a:ea typeface="Calibri" pitchFamily="34" charset="-122"/>
                 <a:cs typeface="Calibri" pitchFamily="34" charset="-120"/>
               </a:rPr>
-              <a:t>Géoportail Géodata Togo</a:t>
+              <a:t>Géodata Togo et INSEED
+Données d’infrastructures, population et limites administratives.</a:t>
             </a:r>
             <a:endParaRPr lang="en-US" sz="1100" dirty="0"/>
           </a:p>
@@ -4191,7 +4192,7 @@
                 <a:ea typeface="Cambria" pitchFamily="34" charset="-122"/>
                 <a:cs typeface="Cambria" pitchFamily="34" charset="-120"/>
               </a:rPr>
-              <a:t>90</a:t>
+              <a:t>2</a:t>
             </a:r>
             <a:endParaRPr lang="en-US" sz="2300" dirty="0"/>
           </a:p>
@@ -4230,7 +4231,7 @@
                 <a:ea typeface="Calibri" pitchFamily="34" charset="-122"/>
                 <a:cs typeface="Calibri" pitchFamily="34" charset="-120"/>
               </a:rPr>
-              <a:t>Agences Moov et Togocom</a:t>
+              <a:t>Préparation</a:t>
             </a:r>
             <a:endParaRPr lang="en-US" sz="1400" dirty="0"/>
           </a:p>
@@ -4269,7 +4270,8 @@
                 <a:ea typeface="Calibri" pitchFamily="34" charset="-122"/>
                 <a:cs typeface="Calibri" pitchFamily="34" charset="-120"/>
               </a:rPr>
-              <a:t>7 boutiques CANAL+ retrouvées hors Géodata</a:t>
+              <a:t>Contrôle des données
+Jointures spatiales, noms des territoires et tables propres.</a:t>
             </a:r>
             <a:endParaRPr lang="en-US" sz="1100" dirty="0"/>
           </a:p>
@@ -4376,7 +4378,7 @@
                 <a:ea typeface="Cambria" pitchFamily="34" charset="-122"/>
                 <a:cs typeface="Cambria" pitchFamily="34" charset="-120"/>
               </a:rPr>
-              <a:t>39 + 396</a:t>
+              <a:t>3</a:t>
             </a:r>
             <a:endParaRPr lang="en-US" sz="2300" dirty="0"/>
           </a:p>
@@ -4415,7 +4417,7 @@
                 <a:ea typeface="Calibri" pitchFamily="34" charset="-122"/>
                 <a:cs typeface="Calibri" pitchFamily="34" charset="-120"/>
               </a:rPr>
-              <a:t>Préfectures et cantons</a:t>
+              <a:t>Analyse</a:t>
             </a:r>
             <a:endParaRPr lang="en-US" sz="1400" dirty="0"/>
           </a:p>
@@ -4454,7 +4456,8 @@
                 <a:ea typeface="Calibri" pitchFamily="34" charset="-122"/>
                 <a:cs typeface="Calibri" pitchFamily="34" charset="-120"/>
               </a:rPr>
-              <a:t>limites administratives, noms reconstruits par jointure spatiale</a:t>
+              <a:t>Deux échelles
+Ratios par habitant, distances et comparaison observé / attendu.</a:t>
             </a:r>
             <a:endParaRPr lang="en-US" sz="1100" dirty="0"/>
           </a:p>
@@ -4561,7 +4564,7 @@
                 <a:ea typeface="Cambria" pitchFamily="34" charset="-122"/>
                 <a:cs typeface="Cambria" pitchFamily="34" charset="-120"/>
               </a:rPr>
-              <a:t>8 095 498</a:t>
+              <a:t>4</a:t>
             </a:r>
             <a:endParaRPr lang="en-US" sz="2300" dirty="0"/>
           </a:p>
@@ -4600,7 +4603,7 @@
                 <a:ea typeface="Calibri" pitchFamily="34" charset="-122"/>
                 <a:cs typeface="Calibri" pitchFamily="34" charset="-120"/>
               </a:rPr>
-              <a:t>Habitants (RGPH-5, 2022)</a:t>
+              <a:t>Restitution</a:t>
             </a:r>
             <a:endParaRPr lang="en-US" sz="1400" dirty="0"/>
           </a:p>
@@ -4639,7 +4642,8 @@
                 <a:ea typeface="Calibri" pitchFamily="34" charset="-122"/>
                 <a:cs typeface="Calibri" pitchFamily="34" charset="-120"/>
               </a:rPr>
-              <a:t>somme des 39 préfectures vérifiée au chiffre près</a:t>
+              <a:t>Dashboard et rapport
+Résultats, limites et priorités d’action.</a:t>
             </a:r>
             <a:endParaRPr lang="en-US" sz="1100" dirty="0"/>
           </a:p>
@@ -4709,7 +4713,7 @@
                 <a:ea typeface="Cambria" pitchFamily="34" charset="-122"/>
                 <a:cs typeface="Cambria" pitchFamily="34" charset="-120"/>
               </a:rPr>
-              <a:t>Trois partis pris</a:t>
+              <a:t>Principes de lecture</a:t>
             </a:r>
             <a:endParaRPr lang="en-US" sz="1600" dirty="0"/>
           </a:p>
@@ -4751,7 +4755,9 @@
                 <a:ea typeface="Calibri" pitchFamily="34" charset="-122"/>
                 <a:cs typeface="Calibri" pitchFamily="34" charset="-120"/>
               </a:rPr>
-              <a:t>Un inventaire, pas un échantillon. Les résultats sont descriptifs.</a:t>
+              <a:t>Un inventaire, pas un échantillon : les résultats sont descriptifs.
+Deux échelles : la préfecture pour le diagnostic, le canton pour la proximité.
+Des limites explicites : couverture radio non mesurée, jeu CANAL+ vide et 6,8 % d’opérateurs mobile money non renseignés.</a:t>
             </a:r>
             <a:pPr indent="0" marL="0">
               <a:lnSpc>
@@ -4797,7 +4803,7 @@
                 <a:ea typeface="Calibri" pitchFamily="34" charset="-122"/>
                 <a:cs typeface="Calibri" pitchFamily="34" charset="-120"/>
               </a:rPr>
-              <a:t>Deux échelles. La préfecture sert au diagnostic ; le canton révèle les écarts de proximité.</a:t>
+              <a:t/>
             </a:r>
             <a:endParaRPr lang="en-US" sz="1150" dirty="0"/>
           </a:p>
@@ -4846,7 +4852,7 @@
                 <a:ea typeface="Calibri" pitchFamily="34" charset="-122"/>
                 <a:cs typeface="Calibri" pitchFamily="34" charset="-120"/>
               </a:rPr>
-              <a:t>Limites explicites.</a:t>
+              <a:t/>
             </a:r>
             <a:endParaRPr lang="en-US" sz="1150" dirty="0"/>
           </a:p>
@@ -4866,7 +4872,7 @@
                 <a:ea typeface="Calibri" pitchFamily="34" charset="-122"/>
                 <a:cs typeface="Calibri" pitchFamily="34" charset="-120"/>
               </a:rPr>
-              <a:t>Couverture radio non mesurée, jeu CANAL+ vide, 6,8 % d’opérateurs non renseignés.</a:t>
+              <a:t/>
             </a:r>
             <a:endParaRPr lang="en-US" sz="1150" dirty="0"/>
           </a:p>
@@ -4905,7 +4911,7 @@
                 <a:ea typeface="Calibri" pitchFamily="34" charset="-122"/>
                 <a:cs typeface="Calibri" pitchFamily="34" charset="-120"/>
               </a:rPr>
-              <a:t>Chaîne complète : 3 scripts Python, des sources brutes au tableau de bord. Tout est rejouable.</a:t>
+              <a:t>Chaîne reproductible : sources → scripts Python → tables d’analyse → dashboard et rapport.</a:t>
             </a:r>
             <a:endParaRPr lang="en-US" sz="1000" dirty="0"/>
           </a:p>

</xml_diff>

<commit_message>
Explain actual analysis method on report slide
</commit_message>
<xml_diff>
--- a/rapport/Rapport_Defi1_Acces_numerique_Togo.pptx
+++ b/rapport/Rapport_Defi1_Acces_numerique_Togo.pptx
@@ -3899,7 +3899,7 @@
                 <a:ea typeface="Cambria" pitchFamily="34" charset="-122"/>
                 <a:cs typeface="Cambria" pitchFamily="34" charset="-120"/>
               </a:rPr>
-              <a:t>Des données publiques, une chaîne reproductible</a:t>
+              <a:t>De la donnée brute à la recommandation</a:t>
             </a:r>
             <a:endParaRPr lang="en-US" sz="3000" dirty="0"/>
           </a:p>
@@ -4006,7 +4006,7 @@
                 <a:ea typeface="Cambria" pitchFamily="34" charset="-122"/>
                 <a:cs typeface="Cambria" pitchFamily="34" charset="-120"/>
               </a:rPr>
-              <a:t>1</a:t>
+              <a:t/>
             </a:r>
             <a:endParaRPr lang="en-US" sz="2300" dirty="0"/>
           </a:p>
@@ -4045,7 +4045,7 @@
                 <a:ea typeface="Calibri" pitchFamily="34" charset="-122"/>
                 <a:cs typeface="Calibri" pitchFamily="34" charset="-120"/>
               </a:rPr>
-              <a:t>Sources</a:t>
+              <a:t>Harmoniser les données</a:t>
             </a:r>
             <a:endParaRPr lang="en-US" sz="1400" dirty="0"/>
           </a:p>
@@ -4085,7 +4085,7 @@
                 <a:cs typeface="Calibri" pitchFamily="34" charset="-120"/>
               </a:rPr>
               <a:t>Géodata Togo et INSEED
-Données d’infrastructures, population et limites administratives.</a:t>
+Jointure spatiale, contrôle des noms et des superficies.</a:t>
             </a:r>
             <a:endParaRPr lang="en-US" sz="1100" dirty="0"/>
           </a:p>
@@ -4192,7 +4192,7 @@
                 <a:ea typeface="Cambria" pitchFamily="34" charset="-122"/>
                 <a:cs typeface="Cambria" pitchFamily="34" charset="-120"/>
               </a:rPr>
-              <a:t>2</a:t>
+              <a:t/>
             </a:r>
             <a:endParaRPr lang="en-US" sz="2300" dirty="0"/>
           </a:p>
@@ -4231,7 +4231,7 @@
                 <a:ea typeface="Calibri" pitchFamily="34" charset="-122"/>
                 <a:cs typeface="Calibri" pitchFamily="34" charset="-120"/>
               </a:rPr>
-              <a:t>Préparation</a:t>
+              <a:t>Construire les indicateurs</a:t>
             </a:r>
             <a:endParaRPr lang="en-US" sz="1400" dirty="0"/>
           </a:p>
@@ -4270,8 +4270,8 @@
                 <a:ea typeface="Calibri" pitchFamily="34" charset="-122"/>
                 <a:cs typeface="Calibri" pitchFamily="34" charset="-120"/>
               </a:rPr>
-              <a:t>Contrôle des données
-Jointures spatiales, noms des territoires et tables propres.</a:t>
+              <a:t>Comptages et taux par habitant
+Observé / attendu, distances et indice de Gini.</a:t>
             </a:r>
             <a:endParaRPr lang="en-US" sz="1100" dirty="0"/>
           </a:p>
@@ -4378,7 +4378,7 @@
                 <a:ea typeface="Cambria" pitchFamily="34" charset="-122"/>
                 <a:cs typeface="Cambria" pitchFamily="34" charset="-120"/>
               </a:rPr>
-              <a:t>3</a:t>
+              <a:t/>
             </a:r>
             <a:endParaRPr lang="en-US" sz="2300" dirty="0"/>
           </a:p>
@@ -4417,7 +4417,7 @@
                 <a:ea typeface="Calibri" pitchFamily="34" charset="-122"/>
                 <a:cs typeface="Calibri" pitchFamily="34" charset="-120"/>
               </a:rPr>
-              <a:t>Analyse</a:t>
+              <a:t>Comparer les échelles</a:t>
             </a:r>
             <a:endParaRPr lang="en-US" sz="1400" dirty="0"/>
           </a:p>
@@ -4456,8 +4456,8 @@
                 <a:ea typeface="Calibri" pitchFamily="34" charset="-122"/>
                 <a:cs typeface="Calibri" pitchFamily="34" charset="-120"/>
               </a:rPr>
-              <a:t>Deux échelles
-Ratios par habitant, distances et comparaison observé / attendu.</a:t>
+              <a:t>Préfecture pour le diagnostic
+Canton pour mesurer la proximité et les zones sans service.</a:t>
             </a:r>
             <a:endParaRPr lang="en-US" sz="1100" dirty="0"/>
           </a:p>
@@ -4564,7 +4564,7 @@
                 <a:ea typeface="Cambria" pitchFamily="34" charset="-122"/>
                 <a:cs typeface="Cambria" pitchFamily="34" charset="-120"/>
               </a:rPr>
-              <a:t>4</a:t>
+              <a:t/>
             </a:r>
             <a:endParaRPr lang="en-US" sz="2300" dirty="0"/>
           </a:p>
@@ -4603,7 +4603,7 @@
                 <a:ea typeface="Calibri" pitchFamily="34" charset="-122"/>
                 <a:cs typeface="Calibri" pitchFamily="34" charset="-120"/>
               </a:rPr>
-              <a:t>Restitution</a:t>
+              <a:t>Prioriser l’action</a:t>
             </a:r>
             <a:endParaRPr lang="en-US" sz="1400" dirty="0"/>
           </a:p>
@@ -4642,8 +4642,8 @@
                 <a:ea typeface="Calibri" pitchFamily="34" charset="-122"/>
                 <a:cs typeface="Calibri" pitchFamily="34" charset="-120"/>
               </a:rPr>
-              <a:t>Dashboard et rapport
-Résultats, limites et priorités d’action.</a:t>
+              <a:t>Déficit × poids de population × bonus zone blanche
+Classement transparent et recommandations ciblées.</a:t>
             </a:r>
             <a:endParaRPr lang="en-US" sz="1100" dirty="0"/>
           </a:p>
@@ -4713,7 +4713,7 @@
                 <a:ea typeface="Cambria" pitchFamily="34" charset="-122"/>
                 <a:cs typeface="Cambria" pitchFamily="34" charset="-120"/>
               </a:rPr>
-              <a:t>Principes de lecture</a:t>
+              <a:t>Ce que mesure l’étude</a:t>
             </a:r>
             <a:endParaRPr lang="en-US" sz="1600" dirty="0"/>
           </a:p>
@@ -4755,9 +4755,9 @@
                 <a:ea typeface="Calibri" pitchFamily="34" charset="-122"/>
                 <a:cs typeface="Calibri" pitchFamily="34" charset="-120"/>
               </a:rPr>
-              <a:t>Un inventaire, pas un échantillon : les résultats sont descriptifs.
-Deux échelles : la préfecture pour le diagnostic, le canton pour la proximité.
-Des limites explicites : couverture radio non mesurée, jeu CANAL+ vide et 6,8 % d’opérateurs mobile money non renseignés.</a:t>
+              <a:t>Accès aux points de service : la couverture radio n’est pas mesurée.
+Résultats descriptifs : les données sont un inventaire, pas un échantillon.
+Norme explicite : « attendu » signifie une répartition proportionnelle à la population.</a:t>
             </a:r>
             <a:pPr indent="0" marL="0">
               <a:lnSpc>
@@ -4911,7 +4911,7 @@
                 <a:ea typeface="Calibri" pitchFamily="34" charset="-122"/>
                 <a:cs typeface="Calibri" pitchFamily="34" charset="-120"/>
               </a:rPr>
-              <a:t>Chaîne reproductible : sources → scripts Python → tables d’analyse → dashboard et rapport.</a:t>
+              <a:t>Chaîne reproductible : sources → scripts Python → indicateurs → dashboard et rapport.</a:t>
             </a:r>
             <a:endParaRPr lang="en-US" sz="1000" dirty="0"/>
           </a:p>

</xml_diff>

<commit_message>
Update report files and deployment instructions
Publish the user's latest PPTX and PDF changes, and document virtual environment setup plus the public Streamlit dashboard URL.
</commit_message>
<xml_diff>
--- a/rapport/Rapport_Defi1_Acces_numerique_Togo.pptx
+++ b/rapport/Rapport_Defi1_Acces_numerique_Togo.pptx
@@ -4,6 +4,9 @@
   <p:sldMasterIdLst>
     <p:sldMasterId id="2147483648" r:id="rId1"/>
   </p:sldMasterIdLst>
+  <p:notesMasterIdLst>
+    <p:notesMasterId r:id="rId12"/>
+  </p:notesMasterIdLst>
   <p:sldIdLst>
     <p:sldId id="256" r:id="rId2"/>
     <p:sldId id="257" r:id="rId3"/>
@@ -16,9 +19,6 @@
     <p:sldId id="264" r:id="rId10"/>
     <p:sldId id="265" r:id="rId11"/>
   </p:sldIdLst>
-  <p:notesMasterIdLst>
-    <p:notesMasterId r:id="rId12"/>
-  </p:notesMasterIdLst>
   <p:sldSz cx="12192000" cy="6858000"/>
   <p:notesSz cx="6858000" cy="12192000"/>
   <p:defaultTextStyle>
@@ -113,13 +113,20 @@
       </a:defRPr>
     </a:lvl9pPr>
   </p:defaultTextStyle>
+  <p:extLst>
+    <p:ext uri="{EFAFB233-063F-42B5-8137-9DF3F51BA10A}">
+      <p15:sldGuideLst xmlns:p15="http://schemas.microsoft.com/office/powerpoint/2012/main"/>
+    </p:ext>
+  </p:extLst>
 </p:presentation>
 </file>
 
 <file path=ppt/charts/chart1.xml><?xml version="1.0" encoding="utf-8"?>
-<c:chartSpace xmlns:c="http://schemas.openxmlformats.org/drawingml/2006/chart" xmlns:a="http://schemas.openxmlformats.org/drawingml/2006/main" xmlns:r="http://schemas.openxmlformats.org/officeDocument/2006/relationships">
+<c:chartSpace xmlns:c="http://schemas.openxmlformats.org/drawingml/2006/chart" xmlns:a="http://schemas.openxmlformats.org/drawingml/2006/main" xmlns:r="http://schemas.openxmlformats.org/officeDocument/2006/relationships" xmlns:c16r2="http://schemas.microsoft.com/office/drawing/2015/06/chart">
   <c:date1904 val="0"/>
+  <c:lang val="en-US"/>
   <c:roundedCorners val="1"/>
+  <c:style val="2"/>
   <c:chart>
     <c:title>
       <c:tx>
@@ -136,7 +143,7 @@
               </a:defRPr>
             </a:pPr>
             <a:r>
-              <a:rPr sz="1200" b="0" i="0" u="none" strike="noStrike">
+              <a:rPr lang="fr-FR" sz="1200" b="0" i="0" u="none" strike="noStrike">
                 <a:solidFill>
                   <a:srgbClr val="5A6B62"/>
                 </a:solidFill>
@@ -147,7 +154,6 @@
           </a:p>
         </c:rich>
       </c:tx>
-      <c:layout/>
       <c:overlay val="0"/>
     </c:title>
     <c:autoTitleDeleted val="0"/>
@@ -180,18 +186,26 @@
           <c:invertIfNegative val="0"/>
           <c:dLbls>
             <c:numFmt formatCode="0.0" sourceLinked="0"/>
+            <c:spPr>
+              <a:noFill/>
+              <a:ln>
+                <a:noFill/>
+              </a:ln>
+              <a:effectLst/>
+            </c:spPr>
             <c:txPr>
               <a:bodyPr/>
               <a:lstStyle/>
               <a:p>
                 <a:pPr>
-                  <a:defRPr b="0" i="0" strike="noStrike" sz="1100" u="none">
+                  <a:defRPr sz="1100" b="0" i="0" u="none" strike="noStrike">
                     <a:solidFill>
                       <a:srgbClr val="0B0B0B"/>
                     </a:solidFill>
                     <a:latin typeface="Calibri"/>
                   </a:defRPr>
                 </a:pPr>
+                <a:endParaRPr lang="en-US"/>
               </a:p>
             </c:txPr>
             <c:showLegendKey val="0"/>
@@ -201,31 +215,34 @@
             <c:showPercent val="0"/>
             <c:showBubbleSize val="0"/>
             <c:showLeaderLines val="0"/>
+            <c:extLst>
+              <c:ext xmlns:c15="http://schemas.microsoft.com/office/drawing/2012/chart" uri="{CE6537A1-D6FC-4f65-9D91-7224C49458BB}">
+                <c15:showLeaderLines val="0"/>
+              </c:ext>
+            </c:extLst>
           </c:dLbls>
           <c:cat>
-            <c:multiLvlStrRef>
+            <c:strRef>
               <c:f>Sheet1!$A$2:$A$6</c:f>
-              <c:multiLvlStrCache>
+              <c:strCache>
                 <c:ptCount val="5"/>
-                <c:lvl>
-                  <c:pt idx="0">
-                    <c:v>Plateaux</c:v>
-                  </c:pt>
-                  <c:pt idx="1">
-                    <c:v>Savanes</c:v>
-                  </c:pt>
-                  <c:pt idx="2">
-                    <c:v>Maritime</c:v>
-                  </c:pt>
-                  <c:pt idx="3">
-                    <c:v>Centrale</c:v>
-                  </c:pt>
-                  <c:pt idx="4">
-                    <c:v>Kara</c:v>
-                  </c:pt>
-                </c:lvl>
-              </c:multiLvlStrCache>
-            </c:multiLvlStrRef>
+                <c:pt idx="0">
+                  <c:v>Plateaux</c:v>
+                </c:pt>
+                <c:pt idx="1">
+                  <c:v>Savanes</c:v>
+                </c:pt>
+                <c:pt idx="2">
+                  <c:v>Maritime</c:v>
+                </c:pt>
+                <c:pt idx="3">
+                  <c:v>Centrale</c:v>
+                </c:pt>
+                <c:pt idx="4">
+                  <c:v>Kara</c:v>
+                </c:pt>
+              </c:strCache>
+            </c:strRef>
           </c:cat>
           <c:val>
             <c:numRef>
@@ -251,36 +268,23 @@
               </c:numCache>
             </c:numRef>
           </c:val>
+          <c:extLst>
+            <c:ext xmlns:c16="http://schemas.microsoft.com/office/drawing/2014/chart" uri="{C3380CC4-5D6E-409C-BE32-E72D297353CC}">
+              <c16:uniqueId val="{00000000-163B-4135-B3A1-6725CDB91BCE}"/>
+            </c:ext>
+          </c:extLst>
         </c:ser>
         <c:dLbls>
-          <c:numFmt formatCode="0.0" sourceLinked="0"/>
-          <c:txPr>
-            <a:bodyPr/>
-            <a:lstStyle/>
-            <a:p>
-              <a:pPr>
-                <a:defRPr b="0" i="0" strike="noStrike" sz="1100" u="none">
-                  <a:solidFill>
-                    <a:srgbClr val="0B0B0B"/>
-                  </a:solidFill>
-                  <a:latin typeface="Calibri"/>
-                </a:defRPr>
-              </a:pPr>
-            </a:p>
-          </c:txPr>
           <c:showLegendKey val="0"/>
           <c:showVal val="1"/>
           <c:showCatName val="0"/>
           <c:showSerName val="0"/>
           <c:showPercent val="0"/>
           <c:showBubbleSize val="0"/>
-          <c:showLeaderLines val="0"/>
         </c:dLbls>
         <c:gapWidth val="55"/>
-        <c:overlap val="0"/>
         <c:axId val="2094734554"/>
         <c:axId val="2094734552"/>
-        <c:axId val="2094734556"/>
       </c:barChart>
       <c:catAx>
         <c:axId val="2094734554"/>
@@ -321,6 +325,7 @@
         <c:crosses val="autoZero"/>
         <c:auto val="1"/>
         <c:lblAlgn val="ctr"/>
+        <c:lblOffset val="100"/>
         <c:noMultiLvlLbl val="1"/>
       </c:catAx>
       <c:valAx>
@@ -345,30 +350,6 @@
         <c:majorTickMark val="out"/>
         <c:minorTickMark val="none"/>
         <c:tickLblPos val="low"/>
-        <c:spPr>
-          <a:ln w="12700" cap="flat">
-            <a:solidFill>
-              <a:srgbClr val="888888"/>
-            </a:solidFill>
-            <a:prstDash val="solid"/>
-            <a:round/>
-          </a:ln>
-        </c:spPr>
-        <c:txPr>
-          <a:bodyPr/>
-          <a:lstStyle/>
-          <a:p>
-            <a:pPr>
-              <a:defRPr sz="1000" b="0" i="0" u="none" strike="noStrike">
-                <a:solidFill>
-                  <a:srgbClr val="5A6B62"/>
-                </a:solidFill>
-                <a:latin typeface="Calibri"/>
-              </a:defRPr>
-            </a:pPr>
-            <a:endParaRPr lang="en-US"/>
-          </a:p>
-        </c:txPr>
         <c:crossAx val="2094734554"/>
         <c:crosses val="autoZero"/>
         <c:crossBetween val="between"/>
@@ -383,6 +364,7 @@
     </c:plotArea>
     <c:plotVisOnly val="1"/>
     <c:dispBlanksAs val="span"/>
+    <c:showDLblsOverMax val="1"/>
   </c:chart>
   <c:spPr>
     <a:noFill/>
@@ -398,9 +380,11 @@
 </file>
 
 <file path=ppt/charts/chart2.xml><?xml version="1.0" encoding="utf-8"?>
-<c:chartSpace xmlns:c="http://schemas.openxmlformats.org/drawingml/2006/chart" xmlns:a="http://schemas.openxmlformats.org/drawingml/2006/main" xmlns:r="http://schemas.openxmlformats.org/officeDocument/2006/relationships">
+<c:chartSpace xmlns:c="http://schemas.openxmlformats.org/drawingml/2006/chart" xmlns:a="http://schemas.openxmlformats.org/drawingml/2006/main" xmlns:r="http://schemas.openxmlformats.org/officeDocument/2006/relationships" xmlns:c16r2="http://schemas.microsoft.com/office/drawing/2015/06/chart">
   <c:date1904 val="0"/>
+  <c:lang val="en-US"/>
   <c:roundedCorners val="1"/>
+  <c:style val="2"/>
   <c:chart>
     <c:title>
       <c:tx>
@@ -417,7 +401,7 @@
               </a:defRPr>
             </a:pPr>
             <a:r>
-              <a:rPr sz="1200" b="0" i="0" u="none" strike="noStrike">
+              <a:rPr lang="fr-FR" sz="1200" b="0" i="0" u="none" strike="noStrike">
                 <a:solidFill>
                   <a:srgbClr val="5A6B62"/>
                 </a:solidFill>
@@ -428,7 +412,6 @@
           </a:p>
         </c:rich>
       </c:tx>
-      <c:layout/>
       <c:overlay val="0"/>
     </c:title>
     <c:autoTitleDeleted val="0"/>
@@ -460,19 +443,27 @@
           </c:spPr>
           <c:invertIfNegative val="0"/>
           <c:dLbls>
-            <c:numFmt formatCode="# ##0" sourceLinked="0"/>
+            <c:numFmt formatCode="#\ ##0" sourceLinked="0"/>
+            <c:spPr>
+              <a:noFill/>
+              <a:ln>
+                <a:noFill/>
+              </a:ln>
+              <a:effectLst/>
+            </c:spPr>
             <c:txPr>
               <a:bodyPr/>
               <a:lstStyle/>
               <a:p>
                 <a:pPr>
-                  <a:defRPr b="0" i="0" strike="noStrike" sz="1100" u="none">
+                  <a:defRPr sz="1100" b="0" i="0" u="none" strike="noStrike">
                     <a:solidFill>
                       <a:srgbClr val="0B0B0B"/>
                     </a:solidFill>
                     <a:latin typeface="Calibri"/>
                   </a:defRPr>
                 </a:pPr>
+                <a:endParaRPr lang="en-US"/>
               </a:p>
             </c:txPr>
             <c:showLegendKey val="0"/>
@@ -482,52 +473,55 @@
             <c:showPercent val="0"/>
             <c:showBubbleSize val="0"/>
             <c:showLeaderLines val="0"/>
+            <c:extLst>
+              <c:ext xmlns:c15="http://schemas.microsoft.com/office/drawing/2012/chart" uri="{CE6537A1-D6FC-4f65-9D91-7224C49458BB}">
+                <c15:showLeaderLines val="0"/>
+              </c:ext>
+            </c:extLst>
           </c:dLbls>
           <c:cat>
-            <c:multiLvlStrRef>
+            <c:strRef>
               <c:f>Sheet1!$A$2:$A$13</c:f>
-              <c:multiLvlStrCache>
+              <c:strCache>
                 <c:ptCount val="12"/>
-                <c:lvl>
-                  <c:pt idx="0">
-                    <c:v>Danyi</c:v>
-                  </c:pt>
-                  <c:pt idx="1">
-                    <c:v>Mô</c:v>
-                  </c:pt>
-                  <c:pt idx="2">
-                    <c:v>Akébou</c:v>
-                  </c:pt>
-                  <c:pt idx="3">
-                    <c:v>Binah</c:v>
-                  </c:pt>
-                  <c:pt idx="4">
-                    <c:v>Kpendjal</c:v>
-                  </c:pt>
-                  <c:pt idx="5">
-                    <c:v>Wawa</c:v>
-                  </c:pt>
-                  <c:pt idx="6">
-                    <c:v>Amou</c:v>
-                  </c:pt>
-                  <c:pt idx="7">
-                    <c:v>Kpendjal-Ouest</c:v>
-                  </c:pt>
-                  <c:pt idx="8">
-                    <c:v>Tandjoaré</c:v>
-                  </c:pt>
-                  <c:pt idx="9">
-                    <c:v>Est-Mono</c:v>
-                  </c:pt>
-                  <c:pt idx="10">
-                    <c:v>Vo</c:v>
-                  </c:pt>
-                  <c:pt idx="11">
-                    <c:v>Lacs</c:v>
-                  </c:pt>
-                </c:lvl>
-              </c:multiLvlStrCache>
-            </c:multiLvlStrRef>
+                <c:pt idx="0">
+                  <c:v>Danyi</c:v>
+                </c:pt>
+                <c:pt idx="1">
+                  <c:v>Mô</c:v>
+                </c:pt>
+                <c:pt idx="2">
+                  <c:v>Akébou</c:v>
+                </c:pt>
+                <c:pt idx="3">
+                  <c:v>Binah</c:v>
+                </c:pt>
+                <c:pt idx="4">
+                  <c:v>Kpendjal</c:v>
+                </c:pt>
+                <c:pt idx="5">
+                  <c:v>Wawa</c:v>
+                </c:pt>
+                <c:pt idx="6">
+                  <c:v>Amou</c:v>
+                </c:pt>
+                <c:pt idx="7">
+                  <c:v>Kpendjal-Ouest</c:v>
+                </c:pt>
+                <c:pt idx="8">
+                  <c:v>Tandjoaré</c:v>
+                </c:pt>
+                <c:pt idx="9">
+                  <c:v>Est-Mono</c:v>
+                </c:pt>
+                <c:pt idx="10">
+                  <c:v>Vo</c:v>
+                </c:pt>
+                <c:pt idx="11">
+                  <c:v>Lacs</c:v>
+                </c:pt>
+              </c:strCache>
+            </c:strRef>
           </c:cat>
           <c:val>
             <c:numRef>
@@ -574,36 +568,23 @@
               </c:numCache>
             </c:numRef>
           </c:val>
+          <c:extLst>
+            <c:ext xmlns:c16="http://schemas.microsoft.com/office/drawing/2014/chart" uri="{C3380CC4-5D6E-409C-BE32-E72D297353CC}">
+              <c16:uniqueId val="{00000000-E0A8-437F-91B2-CD1C299230A9}"/>
+            </c:ext>
+          </c:extLst>
         </c:ser>
         <c:dLbls>
-          <c:numFmt formatCode="# ##0" sourceLinked="0"/>
-          <c:txPr>
-            <a:bodyPr/>
-            <a:lstStyle/>
-            <a:p>
-              <a:pPr>
-                <a:defRPr b="0" i="0" strike="noStrike" sz="1100" u="none">
-                  <a:solidFill>
-                    <a:srgbClr val="0B0B0B"/>
-                  </a:solidFill>
-                  <a:latin typeface="Calibri"/>
-                </a:defRPr>
-              </a:pPr>
-            </a:p>
-          </c:txPr>
           <c:showLegendKey val="0"/>
           <c:showVal val="1"/>
           <c:showCatName val="0"/>
           <c:showSerName val="0"/>
           <c:showPercent val="0"/>
           <c:showBubbleSize val="0"/>
-          <c:showLeaderLines val="0"/>
         </c:dLbls>
         <c:gapWidth val="40"/>
-        <c:overlap val="0"/>
         <c:axId val="2094734554"/>
         <c:axId val="2094734552"/>
-        <c:axId val="2094734556"/>
       </c:barChart>
       <c:catAx>
         <c:axId val="2094734554"/>
@@ -644,6 +625,7 @@
         <c:crosses val="autoZero"/>
         <c:auto val="1"/>
         <c:lblAlgn val="ctr"/>
+        <c:lblOffset val="100"/>
         <c:noMultiLvlLbl val="1"/>
       </c:catAx>
       <c:valAx>
@@ -668,30 +650,6 @@
         <c:majorTickMark val="out"/>
         <c:minorTickMark val="none"/>
         <c:tickLblPos val="low"/>
-        <c:spPr>
-          <a:ln w="12700" cap="flat">
-            <a:solidFill>
-              <a:srgbClr val="888888"/>
-            </a:solidFill>
-            <a:prstDash val="solid"/>
-            <a:round/>
-          </a:ln>
-        </c:spPr>
-        <c:txPr>
-          <a:bodyPr/>
-          <a:lstStyle/>
-          <a:p>
-            <a:pPr>
-              <a:defRPr sz="1000" b="0" i="0" u="none" strike="noStrike">
-                <a:solidFill>
-                  <a:srgbClr val="5A6B62"/>
-                </a:solidFill>
-                <a:latin typeface="Calibri"/>
-              </a:defRPr>
-            </a:pPr>
-            <a:endParaRPr lang="en-US"/>
-          </a:p>
-        </c:txPr>
         <c:crossAx val="2094734554"/>
         <c:crosses val="autoZero"/>
         <c:crossBetween val="between"/>
@@ -706,6 +664,7 @@
     </c:plotArea>
     <c:plotVisOnly val="1"/>
     <c:dispBlanksAs val="span"/>
+    <c:showDLblsOverMax val="1"/>
   </c:chart>
   <c:spPr>
     <a:noFill/>
@@ -721,9 +680,11 @@
 </file>
 
 <file path=ppt/charts/chart3.xml><?xml version="1.0" encoding="utf-8"?>
-<c:chartSpace xmlns:c="http://schemas.openxmlformats.org/drawingml/2006/chart" xmlns:a="http://schemas.openxmlformats.org/drawingml/2006/main" xmlns:r="http://schemas.openxmlformats.org/officeDocument/2006/relationships">
+<c:chartSpace xmlns:c="http://schemas.openxmlformats.org/drawingml/2006/chart" xmlns:a="http://schemas.openxmlformats.org/drawingml/2006/main" xmlns:r="http://schemas.openxmlformats.org/officeDocument/2006/relationships" xmlns:c16r2="http://schemas.microsoft.com/office/drawing/2015/06/chart">
   <c:date1904 val="0"/>
+  <c:lang val="en-US"/>
   <c:roundedCorners val="1"/>
+  <c:style val="2"/>
   <c:chart>
     <c:title>
       <c:tx>
@@ -740,7 +701,7 @@
               </a:defRPr>
             </a:pPr>
             <a:r>
-              <a:rPr sz="1200" b="0" i="0" u="none" strike="noStrike">
+              <a:rPr lang="fr-FR" sz="1200" b="0" i="0" u="none" strike="noStrike">
                 <a:solidFill>
                   <a:srgbClr val="5A6B62"/>
                 </a:solidFill>
@@ -751,7 +712,6 @@
           </a:p>
         </c:rich>
       </c:tx>
-      <c:layout/>
       <c:overlay val="0"/>
     </c:title>
     <c:autoTitleDeleted val="0"/>
@@ -784,18 +744,26 @@
           <c:invertIfNegative val="0"/>
           <c:dLbls>
             <c:numFmt formatCode="0.00" sourceLinked="0"/>
+            <c:spPr>
+              <a:noFill/>
+              <a:ln>
+                <a:noFill/>
+              </a:ln>
+              <a:effectLst/>
+            </c:spPr>
             <c:txPr>
               <a:bodyPr/>
               <a:lstStyle/>
               <a:p>
                 <a:pPr>
-                  <a:defRPr b="0" i="0" strike="noStrike" sz="1100" u="none">
+                  <a:defRPr sz="1100" b="0" i="0" u="none" strike="noStrike">
                     <a:solidFill>
                       <a:srgbClr val="0B0B0B"/>
                     </a:solidFill>
                     <a:latin typeface="Calibri"/>
                   </a:defRPr>
                 </a:pPr>
+                <a:endParaRPr lang="en-US"/>
               </a:p>
             </c:txPr>
             <c:showLegendKey val="0"/>
@@ -805,37 +773,40 @@
             <c:showPercent val="0"/>
             <c:showBubbleSize val="0"/>
             <c:showLeaderLines val="0"/>
+            <c:extLst>
+              <c:ext xmlns:c15="http://schemas.microsoft.com/office/drawing/2012/chart" uri="{CE6537A1-D6FC-4f65-9D91-7224C49458BB}">
+                <c15:showLeaderLines val="0"/>
+              </c:ext>
+            </c:extLst>
           </c:dLbls>
           <c:cat>
-            <c:multiLvlStrRef>
+            <c:strRef>
               <c:f>Sheet1!$A$2:$A$8</c:f>
-              <c:multiLvlStrCache>
+              <c:strCache>
                 <c:ptCount val="7"/>
-                <c:lvl>
-                  <c:pt idx="0">
-                    <c:v>Kpendjal</c:v>
-                  </c:pt>
-                  <c:pt idx="1">
-                    <c:v>Blitta</c:v>
-                  </c:pt>
-                  <c:pt idx="2">
-                    <c:v>Mô</c:v>
-                  </c:pt>
-                  <c:pt idx="3">
-                    <c:v>Moyen-Mono</c:v>
-                  </c:pt>
-                  <c:pt idx="4">
-                    <c:v>Yoto</c:v>
-                  </c:pt>
-                  <c:pt idx="5">
-                    <c:v>Tchamba</c:v>
-                  </c:pt>
-                  <c:pt idx="6">
-                    <c:v>Agoè-Nyivé</c:v>
-                  </c:pt>
-                </c:lvl>
-              </c:multiLvlStrCache>
-            </c:multiLvlStrRef>
+                <c:pt idx="0">
+                  <c:v>Kpendjal</c:v>
+                </c:pt>
+                <c:pt idx="1">
+                  <c:v>Blitta</c:v>
+                </c:pt>
+                <c:pt idx="2">
+                  <c:v>Mô</c:v>
+                </c:pt>
+                <c:pt idx="3">
+                  <c:v>Moyen-Mono</c:v>
+                </c:pt>
+                <c:pt idx="4">
+                  <c:v>Yoto</c:v>
+                </c:pt>
+                <c:pt idx="5">
+                  <c:v>Tchamba</c:v>
+                </c:pt>
+                <c:pt idx="6">
+                  <c:v>Agoè-Nyivé</c:v>
+                </c:pt>
+              </c:strCache>
+            </c:strRef>
           </c:cat>
           <c:val>
             <c:numRef>
@@ -867,36 +838,23 @@
               </c:numCache>
             </c:numRef>
           </c:val>
+          <c:extLst>
+            <c:ext xmlns:c16="http://schemas.microsoft.com/office/drawing/2014/chart" uri="{C3380CC4-5D6E-409C-BE32-E72D297353CC}">
+              <c16:uniqueId val="{00000000-747E-45A6-B115-D8E2DC5F7BCF}"/>
+            </c:ext>
+          </c:extLst>
         </c:ser>
         <c:dLbls>
-          <c:numFmt formatCode="0.00" sourceLinked="0"/>
-          <c:txPr>
-            <a:bodyPr/>
-            <a:lstStyle/>
-            <a:p>
-              <a:pPr>
-                <a:defRPr b="0" i="0" strike="noStrike" sz="1100" u="none">
-                  <a:solidFill>
-                    <a:srgbClr val="0B0B0B"/>
-                  </a:solidFill>
-                  <a:latin typeface="Calibri"/>
-                </a:defRPr>
-              </a:pPr>
-            </a:p>
-          </c:txPr>
           <c:showLegendKey val="0"/>
           <c:showVal val="1"/>
           <c:showCatName val="0"/>
           <c:showSerName val="0"/>
           <c:showPercent val="0"/>
           <c:showBubbleSize val="0"/>
-          <c:showLeaderLines val="0"/>
         </c:dLbls>
         <c:gapWidth val="45"/>
-        <c:overlap val="0"/>
         <c:axId val="2094734554"/>
         <c:axId val="2094734552"/>
-        <c:axId val="2094734556"/>
       </c:barChart>
       <c:catAx>
         <c:axId val="2094734554"/>
@@ -937,6 +895,7 @@
         <c:crosses val="autoZero"/>
         <c:auto val="1"/>
         <c:lblAlgn val="ctr"/>
+        <c:lblOffset val="100"/>
         <c:noMultiLvlLbl val="1"/>
       </c:catAx>
       <c:valAx>
@@ -961,30 +920,6 @@
         <c:majorTickMark val="out"/>
         <c:minorTickMark val="none"/>
         <c:tickLblPos val="low"/>
-        <c:spPr>
-          <a:ln w="12700" cap="flat">
-            <a:solidFill>
-              <a:srgbClr val="888888"/>
-            </a:solidFill>
-            <a:prstDash val="solid"/>
-            <a:round/>
-          </a:ln>
-        </c:spPr>
-        <c:txPr>
-          <a:bodyPr/>
-          <a:lstStyle/>
-          <a:p>
-            <a:pPr>
-              <a:defRPr sz="1000" b="0" i="0" u="none" strike="noStrike">
-                <a:solidFill>
-                  <a:srgbClr val="5A6B62"/>
-                </a:solidFill>
-                <a:latin typeface="Calibri"/>
-              </a:defRPr>
-            </a:pPr>
-            <a:endParaRPr lang="en-US"/>
-          </a:p>
-        </c:txPr>
         <c:crossAx val="2094734554"/>
         <c:crosses val="autoZero"/>
         <c:crossBetween val="between"/>
@@ -999,6 +934,7 @@
     </c:plotArea>
     <c:plotVisOnly val="1"/>
     <c:dispBlanksAs val="span"/>
+    <c:showDLblsOverMax val="1"/>
   </c:chart>
   <c:spPr>
     <a:noFill/>
@@ -1014,9 +950,11 @@
 </file>
 
 <file path=ppt/charts/chart4.xml><?xml version="1.0" encoding="utf-8"?>
-<c:chartSpace xmlns:c="http://schemas.openxmlformats.org/drawingml/2006/chart" xmlns:a="http://schemas.openxmlformats.org/drawingml/2006/main" xmlns:r="http://schemas.openxmlformats.org/officeDocument/2006/relationships">
+<c:chartSpace xmlns:c="http://schemas.openxmlformats.org/drawingml/2006/chart" xmlns:a="http://schemas.openxmlformats.org/drawingml/2006/main" xmlns:r="http://schemas.openxmlformats.org/officeDocument/2006/relationships" xmlns:c16r2="http://schemas.microsoft.com/office/drawing/2015/06/chart">
   <c:date1904 val="0"/>
+  <c:lang val="en-US"/>
   <c:roundedCorners val="1"/>
+  <c:style val="2"/>
   <c:chart>
     <c:title>
       <c:tx>
@@ -1033,7 +971,7 @@
               </a:defRPr>
             </a:pPr>
             <a:r>
-              <a:rPr sz="1200" b="0" i="0" u="none" strike="noStrike">
+              <a:rPr lang="fr-FR" sz="1200" b="0" i="0" u="none" strike="noStrike">
                 <a:solidFill>
                   <a:srgbClr val="5A6B62"/>
                 </a:solidFill>
@@ -1044,7 +982,6 @@
           </a:p>
         </c:rich>
       </c:tx>
-      <c:layout/>
       <c:overlay val="0"/>
     </c:title>
     <c:autoTitleDeleted val="0"/>
@@ -1077,18 +1014,26 @@
           <c:invertIfNegative val="0"/>
           <c:dLbls>
             <c:numFmt formatCode="0" sourceLinked="0"/>
+            <c:spPr>
+              <a:noFill/>
+              <a:ln>
+                <a:noFill/>
+              </a:ln>
+              <a:effectLst/>
+            </c:spPr>
             <c:txPr>
               <a:bodyPr/>
               <a:lstStyle/>
               <a:p>
                 <a:pPr>
-                  <a:defRPr b="0" i="0" strike="noStrike" sz="1100" u="none">
+                  <a:defRPr sz="1100" b="0" i="0" u="none" strike="noStrike">
                     <a:solidFill>
                       <a:srgbClr val="0B0B0B"/>
                     </a:solidFill>
                     <a:latin typeface="Calibri"/>
                   </a:defRPr>
                 </a:pPr>
+                <a:endParaRPr lang="en-US"/>
               </a:p>
             </c:txPr>
             <c:showLegendKey val="0"/>
@@ -1098,40 +1043,43 @@
             <c:showPercent val="0"/>
             <c:showBubbleSize val="0"/>
             <c:showLeaderLines val="0"/>
+            <c:extLst>
+              <c:ext xmlns:c15="http://schemas.microsoft.com/office/drawing/2012/chart" uri="{CE6537A1-D6FC-4f65-9D91-7224C49458BB}">
+                <c15:showLeaderLines val="0"/>
+              </c:ext>
+            </c:extLst>
           </c:dLbls>
           <c:cat>
-            <c:multiLvlStrRef>
+            <c:strRef>
               <c:f>Sheet1!$A$2:$A$9</c:f>
-              <c:multiLvlStrCache>
+              <c:strCache>
                 <c:ptCount val="8"/>
-                <c:lvl>
-                  <c:pt idx="0">
-                    <c:v>Dankpen</c:v>
-                  </c:pt>
-                  <c:pt idx="1">
-                    <c:v>Est-Mono</c:v>
-                  </c:pt>
-                  <c:pt idx="2">
-                    <c:v>Yoto</c:v>
-                  </c:pt>
-                  <c:pt idx="3">
-                    <c:v>Tchamba</c:v>
-                  </c:pt>
-                  <c:pt idx="4">
-                    <c:v>Blitta</c:v>
-                  </c:pt>
-                  <c:pt idx="5">
-                    <c:v>Haho</c:v>
-                  </c:pt>
-                  <c:pt idx="6">
-                    <c:v>Zio</c:v>
-                  </c:pt>
-                  <c:pt idx="7">
-                    <c:v>Agoè-Nyivé</c:v>
-                  </c:pt>
-                </c:lvl>
-              </c:multiLvlStrCache>
-            </c:multiLvlStrRef>
+                <c:pt idx="0">
+                  <c:v>Dankpen</c:v>
+                </c:pt>
+                <c:pt idx="1">
+                  <c:v>Est-Mono</c:v>
+                </c:pt>
+                <c:pt idx="2">
+                  <c:v>Yoto</c:v>
+                </c:pt>
+                <c:pt idx="3">
+                  <c:v>Tchamba</c:v>
+                </c:pt>
+                <c:pt idx="4">
+                  <c:v>Blitta</c:v>
+                </c:pt>
+                <c:pt idx="5">
+                  <c:v>Haho</c:v>
+                </c:pt>
+                <c:pt idx="6">
+                  <c:v>Zio</c:v>
+                </c:pt>
+                <c:pt idx="7">
+                  <c:v>Agoè-Nyivé</c:v>
+                </c:pt>
+              </c:strCache>
+            </c:strRef>
           </c:cat>
           <c:val>
             <c:numRef>
@@ -1166,36 +1114,23 @@
               </c:numCache>
             </c:numRef>
           </c:val>
+          <c:extLst>
+            <c:ext xmlns:c16="http://schemas.microsoft.com/office/drawing/2014/chart" uri="{C3380CC4-5D6E-409C-BE32-E72D297353CC}">
+              <c16:uniqueId val="{00000000-8534-41F9-897E-EEDA8691CC17}"/>
+            </c:ext>
+          </c:extLst>
         </c:ser>
         <c:dLbls>
-          <c:numFmt formatCode="0" sourceLinked="0"/>
-          <c:txPr>
-            <a:bodyPr/>
-            <a:lstStyle/>
-            <a:p>
-              <a:pPr>
-                <a:defRPr b="0" i="0" strike="noStrike" sz="1100" u="none">
-                  <a:solidFill>
-                    <a:srgbClr val="0B0B0B"/>
-                  </a:solidFill>
-                  <a:latin typeface="Calibri"/>
-                </a:defRPr>
-              </a:pPr>
-            </a:p>
-          </c:txPr>
           <c:showLegendKey val="0"/>
           <c:showVal val="1"/>
           <c:showCatName val="0"/>
           <c:showSerName val="0"/>
           <c:showPercent val="0"/>
           <c:showBubbleSize val="0"/>
-          <c:showLeaderLines val="0"/>
         </c:dLbls>
         <c:gapWidth val="45"/>
-        <c:overlap val="0"/>
         <c:axId val="2094734554"/>
         <c:axId val="2094734552"/>
-        <c:axId val="2094734556"/>
       </c:barChart>
       <c:catAx>
         <c:axId val="2094734554"/>
@@ -1236,6 +1171,7 @@
         <c:crosses val="autoZero"/>
         <c:auto val="1"/>
         <c:lblAlgn val="ctr"/>
+        <c:lblOffset val="100"/>
         <c:noMultiLvlLbl val="1"/>
       </c:catAx>
       <c:valAx>
@@ -1260,30 +1196,6 @@
         <c:majorTickMark val="out"/>
         <c:minorTickMark val="none"/>
         <c:tickLblPos val="low"/>
-        <c:spPr>
-          <a:ln w="12700" cap="flat">
-            <a:solidFill>
-              <a:srgbClr val="888888"/>
-            </a:solidFill>
-            <a:prstDash val="solid"/>
-            <a:round/>
-          </a:ln>
-        </c:spPr>
-        <c:txPr>
-          <a:bodyPr/>
-          <a:lstStyle/>
-          <a:p>
-            <a:pPr>
-              <a:defRPr sz="1000" b="0" i="0" u="none" strike="noStrike">
-                <a:solidFill>
-                  <a:srgbClr val="5A6B62"/>
-                </a:solidFill>
-                <a:latin typeface="Calibri"/>
-              </a:defRPr>
-            </a:pPr>
-            <a:endParaRPr lang="en-US"/>
-          </a:p>
-        </c:txPr>
         <c:crossAx val="2094734554"/>
         <c:crosses val="autoZero"/>
         <c:crossBetween val="between"/>
@@ -1298,6 +1210,7 @@
     </c:plotArea>
     <c:plotVisOnly val="1"/>
     <c:dispBlanksAs val="span"/>
+    <c:showDLblsOverMax val="1"/>
   </c:chart>
   <c:spPr>
     <a:noFill/>
@@ -1334,234 +1247,10 @@
           <a:chExt cx="0" cy="0"/>
         </a:xfrm>
       </p:grpSpPr>
-      <p:sp>
-        <p:nvSpPr>
-          <p:cNvPr id="2" name="Header Placeholder 1"/>
-          <p:cNvSpPr>
-            <a:spLocks noGrp="1"/>
-          </p:cNvSpPr>
-          <p:nvPr>
-            <p:ph type="hdr" sz="quarter"/>
-          </p:nvPr>
-        </p:nvSpPr>
-        <p:spPr>
-          <a:xfrm>
-            <a:off x="0" y="0"/>
-            <a:ext cx="2971800" cy="458788"/>
-          </a:xfrm>
-          <a:prstGeom prst="rect">
-            <a:avLst/>
-          </a:prstGeom>
-        </p:spPr>
-        <p:txBody>
-          <a:bodyPr vert="horz" lIns="91440" tIns="45720" rIns="91440" bIns="45720" rtlCol="0"/>
-          <a:lstStyle>
-            <a:lvl1pPr algn="l">
-              <a:defRPr sz="1200"/>
-            </a:lvl1pPr>
-          </a:lstStyle>
-          <a:p>
-            <a:endParaRPr lang="en-US"/>
-          </a:p>
-        </p:txBody>
-      </p:sp>
-      <p:sp>
-        <p:nvSpPr>
-          <p:cNvPr id="3" name="Date Placeholder 2"/>
-          <p:cNvSpPr>
-            <a:spLocks noGrp="1"/>
-          </p:cNvSpPr>
-          <p:nvPr>
-            <p:ph type="dt" idx="1"/>
-          </p:nvPr>
-        </p:nvSpPr>
-        <p:spPr>
-          <a:xfrm>
-            <a:off x="3884613" y="0"/>
-            <a:ext cx="2971800" cy="458788"/>
-          </a:xfrm>
-          <a:prstGeom prst="rect">
-            <a:avLst/>
-          </a:prstGeom>
-        </p:spPr>
-        <p:txBody>
-          <a:bodyPr vert="horz" lIns="91440" tIns="45720" rIns="91440" bIns="45720" rtlCol="0"/>
-          <a:lstStyle>
-            <a:lvl1pPr algn="r">
-              <a:defRPr sz="1200"/>
-            </a:lvl1pPr>
-          </a:lstStyle>
-          <a:p>
-            <a:fld id="{5282F153-3F37-0F45-9E97-73ACFA13230C}" type="datetimeFigureOut">
-              <a:rPr lang="en-US"/>
-              <a:t>7/23/19</a:t>
-            </a:fld>
-            <a:endParaRPr lang="en-US"/>
-          </a:p>
-        </p:txBody>
-      </p:sp>
-      <p:sp>
-        <p:nvSpPr>
-          <p:cNvPr id="4" name="Slide Image Placeholder 3"/>
-          <p:cNvSpPr>
-            <a:spLocks noGrp="1" noRot="1" noChangeAspect="1"/>
-          </p:cNvSpPr>
-          <p:nvPr>
-            <p:ph type="sldImg" idx="2"/>
-          </p:nvPr>
-        </p:nvSpPr>
-        <p:spPr>
-          <a:xfrm>
-            <a:off x="685800" y="1143000"/>
-            <a:ext cx="5486400" cy="3086100"/>
-          </a:xfrm>
-          <a:prstGeom prst="rect">
-            <a:avLst/>
-          </a:prstGeom>
-          <a:noFill/>
-          <a:ln w="12700">
-            <a:solidFill>
-              <a:prstClr val="black"/>
-            </a:solidFill>
-          </a:ln>
-        </p:spPr>
-        <p:txBody>
-          <a:bodyPr vert="horz" lIns="91440" tIns="45720" rIns="91440" bIns="45720" rtlCol="0" anchor="ctr"/>
-          <a:lstStyle/>
-          <a:p>
-            <a:endParaRPr lang="en-US"/>
-          </a:p>
-        </p:txBody>
-      </p:sp>
-      <p:sp>
-        <p:nvSpPr>
-          <p:cNvPr id="5" name="Notes Placeholder 4"/>
-          <p:cNvSpPr>
-            <a:spLocks noGrp="1"/>
-          </p:cNvSpPr>
-          <p:nvPr>
-            <p:ph type="body" sz="quarter" idx="3"/>
-          </p:nvPr>
-        </p:nvSpPr>
-        <p:spPr>
-          <a:xfrm>
-            <a:off x="685800" y="4400550"/>
-            <a:ext cx="5486400" cy="3600450"/>
-          </a:xfrm>
-          <a:prstGeom prst="rect">
-            <a:avLst/>
-          </a:prstGeom>
-        </p:spPr>
-        <p:txBody>
-          <a:bodyPr vert="horz" lIns="91440" tIns="45720" rIns="91440" bIns="45720" rtlCol="0"/>
-          <a:lstStyle/>
-          <a:p>
-            <a:pPr lvl="0"/>
-            <a:r>
-              <a:rPr lang="en-US"/>
-              <a:t>Click to edit Master text styles</a:t>
-            </a:r>
-          </a:p>
-          <a:p>
-            <a:pPr lvl="1"/>
-            <a:r>
-              <a:rPr lang="en-US"/>
-              <a:t>Second level</a:t>
-            </a:r>
-          </a:p>
-          <a:p>
-            <a:pPr lvl="2"/>
-            <a:r>
-              <a:rPr lang="en-US"/>
-              <a:t>Third level</a:t>
-            </a:r>
-          </a:p>
-          <a:p>
-            <a:pPr lvl="3"/>
-            <a:r>
-              <a:rPr lang="en-US"/>
-              <a:t>Fourth level</a:t>
-            </a:r>
-          </a:p>
-          <a:p>
-            <a:pPr lvl="4"/>
-            <a:r>
-              <a:rPr lang="en-US"/>
-              <a:t>Fifth level</a:t>
-            </a:r>
-          </a:p>
-        </p:txBody>
-      </p:sp>
-      <p:sp>
-        <p:nvSpPr>
-          <p:cNvPr id="6" name="Footer Placeholder 5"/>
-          <p:cNvSpPr>
-            <a:spLocks noGrp="1"/>
-          </p:cNvSpPr>
-          <p:nvPr>
-            <p:ph type="ftr" sz="quarter" idx="4"/>
-          </p:nvPr>
-        </p:nvSpPr>
-        <p:spPr>
-          <a:xfrm>
-            <a:off x="0" y="8685213"/>
-            <a:ext cx="2971800" cy="458787"/>
-          </a:xfrm>
-          <a:prstGeom prst="rect">
-            <a:avLst/>
-          </a:prstGeom>
-        </p:spPr>
-        <p:txBody>
-          <a:bodyPr vert="horz" lIns="91440" tIns="45720" rIns="91440" bIns="45720" rtlCol="0" anchor="b"/>
-          <a:lstStyle>
-            <a:lvl1pPr algn="l">
-              <a:defRPr sz="1200"/>
-            </a:lvl1pPr>
-          </a:lstStyle>
-          <a:p>
-            <a:endParaRPr lang="en-US"/>
-          </a:p>
-        </p:txBody>
-      </p:sp>
-      <p:sp>
-        <p:nvSpPr>
-          <p:cNvPr id="7" name="Slide Number Placeholder 6"/>
-          <p:cNvSpPr>
-            <a:spLocks noGrp="1"/>
-          </p:cNvSpPr>
-          <p:nvPr>
-            <p:ph type="sldNum" sz="quarter" idx="5"/>
-          </p:nvPr>
-        </p:nvSpPr>
-        <p:spPr>
-          <a:xfrm>
-            <a:off x="3884613" y="8685213"/>
-            <a:ext cx="2971800" cy="458787"/>
-          </a:xfrm>
-          <a:prstGeom prst="rect">
-            <a:avLst/>
-          </a:prstGeom>
-        </p:spPr>
-        <p:txBody>
-          <a:bodyPr vert="horz" lIns="91440" tIns="45720" rIns="91440" bIns="45720" rtlCol="0" anchor="b"/>
-          <a:lstStyle>
-            <a:lvl1pPr algn="r">
-              <a:defRPr sz="1200"/>
-            </a:lvl1pPr>
-          </a:lstStyle>
-          <a:p>
-            <a:fld id="{CE5E9CC1-C706-0F49-92D6-E571CC5EEA8F}" type="slidenum">
-              <a:rPr lang="en-US"/>
-              <a:t>‹#›</a:t>
-            </a:fld>
-            <a:endParaRPr lang="en-US"/>
-          </a:p>
-        </p:txBody>
-      </p:sp>
     </p:spTree>
     <p:extLst>
       <p:ext uri="{BB962C8B-B14F-4D97-AF65-F5344CB8AC3E}">
-        <p14:creationId xmlns:p14="http://schemas.microsoft.com/office/powerpoint/2010/main" val="1024086991"/>
+        <p14:creationId xmlns:p14="http://schemas.microsoft.com/office/powerpoint/2010/main" val="813037803"/>
       </p:ext>
     </p:extLst>
   </p:cSld>
@@ -1709,7 +1398,6 @@
               <a:rPr lang="en-US" dirty="0"/>
               <a:t>Le message d'ouverture : le diagnostic ne porte pas sur le signal mais sur l'accès effectif au service.</a:t>
             </a:r>
-            <a:endParaRPr lang="en-US" dirty="0"/>
           </a:p>
         </p:txBody>
       </p:sp>
@@ -1793,10 +1481,6 @@
           <a:bodyPr/>
           <a:lstStyle/>
           <a:p>
-            <a:r>
-              <a:rPr lang="en-US" dirty="0"/>
-              <a:t/>
-            </a:r>
             <a:endParaRPr lang="en-US" dirty="0"/>
           </a:p>
         </p:txBody>
@@ -1885,7 +1569,6 @@
               <a:rPr lang="en-US" dirty="0"/>
               <a:t>Insister : la valeur ajoutée est la reconstruction des noms de préfectures et de cantons, absents des polygones officiels.</a:t>
             </a:r>
-            <a:endParaRPr lang="en-US" dirty="0"/>
           </a:p>
         </p:txBody>
       </p:sp>
@@ -1973,7 +1656,6 @@
               <a:rPr lang="en-US" dirty="0"/>
               <a:t>Point de bascule de la présentation : montrer que le récit intuitif est faux.</a:t>
             </a:r>
-            <a:endParaRPr lang="en-US" dirty="0"/>
           </a:p>
         </p:txBody>
       </p:sp>
@@ -2057,10 +1739,6 @@
           <a:bodyPr/>
           <a:lstStyle/>
           <a:p>
-            <a:r>
-              <a:rPr lang="en-US" dirty="0"/>
-              <a:t/>
-            </a:r>
             <a:endParaRPr lang="en-US" dirty="0"/>
           </a:p>
         </p:txBody>
@@ -2149,7 +1827,6 @@
               <a:rPr lang="en-US" dirty="0"/>
               <a:t>Préciser la limite : le centroïde n’est pas le barycentre de population.</a:t>
             </a:r>
-            <a:endParaRPr lang="en-US" dirty="0"/>
           </a:p>
         </p:txBody>
       </p:sp>
@@ -2233,10 +1910,6 @@
           <a:bodyPr/>
           <a:lstStyle/>
           <a:p>
-            <a:r>
-              <a:rPr lang="en-US" dirty="0"/>
-              <a:t/>
-            </a:r>
             <a:endParaRPr lang="en-US" dirty="0"/>
           </a:p>
         </p:txBody>
@@ -2321,10 +1994,6 @@
           <a:bodyPr/>
           <a:lstStyle/>
           <a:p>
-            <a:r>
-              <a:rPr lang="en-US" dirty="0"/>
-              <a:t/>
-            </a:r>
             <a:endParaRPr lang="en-US" dirty="0"/>
           </a:p>
         </p:txBody>
@@ -2409,10 +2078,6 @@
           <a:bodyPr/>
           <a:lstStyle/>
           <a:p>
-            <a:r>
-              <a:rPr lang="en-US" dirty="0"/>
-              <a:t/>
-            </a:r>
             <a:endParaRPr lang="en-US" dirty="0"/>
           </a:p>
         </p:txBody>
@@ -2497,10 +2162,6 @@
           <a:bodyPr/>
           <a:lstStyle/>
           <a:p>
-            <a:r>
-              <a:rPr lang="en-US" dirty="0"/>
-              <a:t/>
-            </a:r>
             <a:endParaRPr lang="en-US" dirty="0"/>
           </a:p>
         </p:txBody>
@@ -2574,6 +2235,11 @@
 <file path=ppt/slideMasters/slideMaster1.xml><?xml version="1.0" encoding="utf-8"?>
 <p:sldMaster xmlns:a="http://schemas.openxmlformats.org/drawingml/2006/main" xmlns:r="http://schemas.openxmlformats.org/officeDocument/2006/relationships" xmlns:p="http://schemas.openxmlformats.org/presentationml/2006/main">
   <p:cSld>
+    <p:bg>
+      <p:bgRef idx="1001">
+        <a:schemeClr val="bg1"/>
+      </p:bgRef>
+    </p:bg>
     <p:spTree>
       <p:nvGrpSpPr>
         <p:cNvPr id="1" name=""/>
@@ -2856,6 +2522,7 @@
         <a:solidFill>
           <a:srgbClr val="FCFCFB"/>
         </a:solidFill>
+        <a:effectLst/>
       </p:bgPr>
     </p:bg>
     <p:spTree>
@@ -2893,11 +2560,11 @@
           <a:bodyPr wrap="square" lIns="0" tIns="0" rIns="0" bIns="0" rtlCol="0" anchor="ctr"/>
           <a:lstStyle/>
           <a:p>
-            <a:pPr indent="0" marL="0">
-              <a:buNone/>
-            </a:pPr>
-            <a:r>
-              <a:rPr lang="en-US" sz="1200" b="1" spc="200" kern="0" dirty="0">
+            <a:pPr marL="0" indent="0">
+              <a:buNone/>
+            </a:pPr>
+            <a:r>
+              <a:rPr lang="en-US" sz="1200" b="1" kern="0" spc="200" dirty="0">
                 <a:solidFill>
                   <a:srgbClr val="12345F"/>
                 </a:solidFill>
@@ -2932,7 +2599,7 @@
           <a:bodyPr wrap="square" lIns="0" tIns="0" rIns="0" bIns="0" rtlCol="0" anchor="ctr"/>
           <a:lstStyle/>
           <a:p>
-            <a:pPr indent="0" marL="0">
+            <a:pPr marL="0" indent="0">
               <a:buNone/>
             </a:pPr>
             <a:r>
@@ -2971,7 +2638,7 @@
           <a:bodyPr wrap="square" lIns="0" tIns="0" rIns="0" bIns="0" rtlCol="0" anchor="ctr"/>
           <a:lstStyle/>
           <a:p>
-            <a:pPr indent="0" marL="0">
+            <a:pPr marL="0" indent="0">
               <a:buNone/>
             </a:pPr>
             <a:r>
@@ -3013,7 +2680,10 @@
         </p:spPr>
         <p:txBody>
           <a:bodyPr/>
-          <a:p/>
+          <a:lstStyle/>
+          <a:p>
+            <a:endParaRPr/>
+          </a:p>
         </p:txBody>
       </p:sp>
       <p:sp>
@@ -3037,7 +2707,7 @@
           <a:bodyPr wrap="square" lIns="0" tIns="0" rIns="0" bIns="0" rtlCol="0" anchor="ctr"/>
           <a:lstStyle/>
           <a:p>
-            <a:pPr indent="0" marL="0">
+            <a:pPr marL="0" indent="0">
               <a:buNone/>
             </a:pPr>
             <a:r>
@@ -3049,24 +2719,84 @@
                 <a:ea typeface="Cambria" pitchFamily="34" charset="-122"/>
                 <a:cs typeface="Cambria" pitchFamily="34" charset="-120"/>
               </a:rPr>
-              <a:t>Un Togolais sur six vit dans une préfecture où aucun opérateur</a:t>
-            </a:r>
-            <a:endParaRPr lang="en-US" sz="1900" dirty="0"/>
-          </a:p>
-          <a:p>
-            <a:pPr indent="0" marL="0">
-              <a:buNone/>
-            </a:pPr>
-            <a:r>
-              <a:rPr lang="en-US" sz="1900" i="1" dirty="0">
-                <a:solidFill>
-                  <a:srgbClr val="0B0B0B"/>
+              <a:t>Un Togolais sur six vit dans une préfecture où </a:t>
+            </a:r>
+            <a:r>
+              <a:rPr lang="en-US" sz="1900" i="1" dirty="0" err="1">
+                <a:solidFill>
+                  <a:srgbClr val="12345F"/>
                 </a:solidFill>
                 <a:latin typeface="Aptos" pitchFamily="34" charset="0"/>
                 <a:ea typeface="Cambria" pitchFamily="34" charset="-122"/>
                 <a:cs typeface="Cambria" pitchFamily="34" charset="-120"/>
               </a:rPr>
-              <a:t>n’a de guichet physique.</a:t>
+              <a:t>aucun</a:t>
+            </a:r>
+            <a:r>
+              <a:rPr lang="en-US" sz="1900" i="1" dirty="0">
+                <a:solidFill>
+                  <a:srgbClr val="12345F"/>
+                </a:solidFill>
+                <a:latin typeface="Aptos" pitchFamily="34" charset="0"/>
+                <a:ea typeface="Cambria" pitchFamily="34" charset="-122"/>
+                <a:cs typeface="Cambria" pitchFamily="34" charset="-120"/>
+              </a:rPr>
+              <a:t> </a:t>
+            </a:r>
+            <a:r>
+              <a:rPr lang="en-US" sz="1900" i="1" dirty="0" err="1">
+                <a:solidFill>
+                  <a:srgbClr val="12345F"/>
+                </a:solidFill>
+                <a:latin typeface="Aptos" pitchFamily="34" charset="0"/>
+                <a:ea typeface="Cambria" pitchFamily="34" charset="-122"/>
+                <a:cs typeface="Cambria" pitchFamily="34" charset="-120"/>
+              </a:rPr>
+              <a:t>opérateur</a:t>
+            </a:r>
+            <a:r>
+              <a:rPr lang="en-US" sz="1900" i="1" dirty="0">
+                <a:solidFill>
+                  <a:srgbClr val="12345F"/>
+                </a:solidFill>
+                <a:latin typeface="Aptos" pitchFamily="34" charset="0"/>
+                <a:ea typeface="Cambria" pitchFamily="34" charset="-122"/>
+                <a:cs typeface="Cambria" pitchFamily="34" charset="-120"/>
+              </a:rPr>
+              <a:t> </a:t>
+            </a:r>
+            <a:r>
+              <a:rPr lang="en-US" sz="1900" i="1" dirty="0" err="1">
+                <a:solidFill>
+                  <a:srgbClr val="12345F"/>
+                </a:solidFill>
+                <a:latin typeface="Aptos" pitchFamily="34" charset="0"/>
+                <a:ea typeface="Cambria" pitchFamily="34" charset="-122"/>
+                <a:cs typeface="Cambria" pitchFamily="34" charset="-120"/>
+              </a:rPr>
+              <a:t>n’a</a:t>
+            </a:r>
+            <a:r>
+              <a:rPr lang="en-US" sz="1900" i="1" dirty="0">
+                <a:solidFill>
+                  <a:srgbClr val="12345F"/>
+                </a:solidFill>
+                <a:latin typeface="Aptos" pitchFamily="34" charset="0"/>
+                <a:ea typeface="Cambria" pitchFamily="34" charset="-122"/>
+                <a:cs typeface="Cambria" pitchFamily="34" charset="-120"/>
+              </a:rPr>
+              <a:t> de guichet physique</a:t>
+            </a:r>
+            <a:r>
+              <a:rPr lang="en-US" sz="1900" i="1" dirty="0">
+                <a:solidFill>
+                  <a:srgbClr val="0B0B0B"/>
+                </a:solidFill>
+                <a:latin typeface="Aptos" pitchFamily="34" charset="0"/>
+                <a:ea typeface="Cambria" pitchFamily="34" charset="-122"/>
+                <a:cs typeface="Cambria" pitchFamily="34" charset="-120"/>
+              </a:rPr>
+              <a:t>.</a:t>
             </a:r>
             <a:endParaRPr lang="en-US" sz="1900" dirty="0"/>
           </a:p>
@@ -3093,11 +2823,11 @@
           <a:bodyPr wrap="square" lIns="0" tIns="0" rIns="0" bIns="0" rtlCol="0" anchor="ctr"/>
           <a:lstStyle/>
           <a:p>
-            <a:pPr indent="0" marL="0">
-              <a:buNone/>
-            </a:pPr>
-            <a:r>
-              <a:rPr lang="en-US" sz="1100" dirty="0">
+            <a:pPr marL="0" indent="0">
+              <a:buNone/>
+            </a:pPr>
+            <a:r>
+              <a:rPr lang="en-US" dirty="0">
                 <a:solidFill>
                   <a:srgbClr val="12345F"/>
                 </a:solidFill>
@@ -3105,9 +2835,9 @@
                 <a:ea typeface="Calibri" pitchFamily="34" charset="-122"/>
                 <a:cs typeface="Calibri" pitchFamily="34" charset="-120"/>
               </a:rPr>
-              <a:t>Komi Selassi GAYI  ·  septembre 2026  ·  39 préfectures, 396 cantons, 8 095 498 habitants</a:t>
-            </a:r>
-            <a:endParaRPr lang="en-US" sz="1100" dirty="0"/>
+              <a:t>GAYI Komi Selassi  ·  septembre 2026  </a:t>
+            </a:r>
+            <a:endParaRPr lang="en-US" dirty="0"/>
           </a:p>
         </p:txBody>
       </p:sp>
@@ -3127,6 +2857,7 @@
         <a:solidFill>
           <a:srgbClr val="FCFCFB"/>
         </a:solidFill>
+        <a:effectLst/>
       </p:bgPr>
     </p:bg>
     <p:spTree>
@@ -3164,11 +2895,11 @@
           <a:bodyPr wrap="square" lIns="0" tIns="0" rIns="0" bIns="0" rtlCol="0" anchor="ctr"/>
           <a:lstStyle/>
           <a:p>
-            <a:pPr indent="0" marL="0">
-              <a:buNone/>
-            </a:pPr>
-            <a:r>
-              <a:rPr lang="en-US" sz="1200" b="1" spc="200" kern="0" dirty="0">
+            <a:pPr marL="0" indent="0">
+              <a:buNone/>
+            </a:pPr>
+            <a:r>
+              <a:rPr lang="en-US" sz="1200" b="1" kern="0" spc="200" dirty="0">
                 <a:solidFill>
                   <a:srgbClr val="12345F"/>
                 </a:solidFill>
@@ -3176,7 +2907,7 @@
                 <a:ea typeface="Calibri" pitchFamily="34" charset="-122"/>
                 <a:cs typeface="Calibri" pitchFamily="34" charset="-120"/>
               </a:rPr>
-              <a:t>CE SUR QUOI REPOSE CE DIAGNOSTIC · ET CE QU’IL NE DIT PAS</a:t>
+              <a:t>CE SUR QUOI REPOSE CE DIAGNOSTIC </a:t>
             </a:r>
             <a:endParaRPr lang="en-US" sz="1200" dirty="0"/>
           </a:p>
@@ -3203,7 +2934,7 @@
           <a:bodyPr wrap="square" lIns="0" tIns="0" rIns="0" bIns="0" rtlCol="0" anchor="ctr"/>
           <a:lstStyle/>
           <a:p>
-            <a:pPr indent="0" marL="0">
+            <a:pPr marL="0" indent="0">
               <a:buNone/>
             </a:pPr>
             <a:r>
@@ -3215,7 +2946,18 @@
                 <a:ea typeface="Cambria" pitchFamily="34" charset="-122"/>
                 <a:cs typeface="Cambria" pitchFamily="34" charset="-120"/>
               </a:rPr>
-              <a:t>Les six hypothèses à garder en tête</a:t>
+              <a:t>Six </a:t>
+            </a:r>
+            <a:r>
+              <a:rPr lang="en-US" sz="3000" b="1" dirty="0" err="1">
+                <a:solidFill>
+                  <a:srgbClr val="12345F"/>
+                </a:solidFill>
+                <a:latin typeface="Aptos" pitchFamily="34" charset="0"/>
+                <a:ea typeface="Cambria" pitchFamily="34" charset="-122"/>
+                <a:cs typeface="Cambria" pitchFamily="34" charset="-120"/>
+              </a:rPr>
+              <a:t>hypothèses</a:t>
             </a:r>
             <a:endParaRPr lang="en-US" sz="3000" dirty="0"/>
           </a:p>
@@ -3242,11 +2984,11 @@
           <a:bodyPr wrap="square" lIns="0" tIns="0" rIns="0" bIns="0" rtlCol="0" anchor="ctr"/>
           <a:lstStyle/>
           <a:p>
-            <a:pPr indent="0" marL="0">
-              <a:buNone/>
-            </a:pPr>
-            <a:r>
-              <a:rPr lang="en-US" sz="1300" b="1" dirty="0">
+            <a:pPr marL="0" indent="0">
+              <a:buNone/>
+            </a:pPr>
+            <a:r>
+              <a:rPr lang="en-US" sz="1600" b="1" dirty="0">
                 <a:solidFill>
                   <a:srgbClr val="12345F"/>
                 </a:solidFill>
@@ -3256,7 +2998,7 @@
               </a:rPr>
               <a:t>H1 · Norme d’équité</a:t>
             </a:r>
-            <a:endParaRPr lang="en-US" sz="1300" dirty="0"/>
+            <a:endParaRPr lang="en-US" sz="1600" dirty="0"/>
           </a:p>
         </p:txBody>
       </p:sp>
@@ -3281,11 +3023,11 @@
           <a:bodyPr wrap="square" lIns="0" tIns="0" rIns="0" bIns="0" rtlCol="0" anchor="ctr"/>
           <a:lstStyle/>
           <a:p>
-            <a:pPr indent="0" marL="0">
-              <a:buNone/>
-            </a:pPr>
-            <a:r>
-              <a:rPr lang="en-US" sz="1050" dirty="0">
+            <a:pPr marL="0" indent="0">
+              <a:buNone/>
+            </a:pPr>
+            <a:r>
+              <a:rPr lang="en-US" sz="1600" dirty="0">
                 <a:solidFill>
                   <a:srgbClr val="0B0B0B"/>
                 </a:solidFill>
@@ -3295,7 +3037,7 @@
               </a:rPr>
               <a:t>« Attendu » = répartition proportionnelle à la population. C’est une norme d’équité, pas une loi économique.</a:t>
             </a:r>
-            <a:endParaRPr lang="en-US" sz="1050" dirty="0"/>
+            <a:endParaRPr lang="en-US" sz="1600" dirty="0"/>
           </a:p>
         </p:txBody>
       </p:sp>
@@ -3307,7 +3049,7 @@
         </p:nvSpPr>
         <p:spPr>
           <a:xfrm>
-            <a:off x="4526280" y="2011680"/>
+            <a:off x="4602480" y="2011680"/>
             <a:ext cx="3337560" cy="274320"/>
           </a:xfrm>
           <a:prstGeom prst="rect">
@@ -3320,11 +3062,11 @@
           <a:bodyPr wrap="square" lIns="0" tIns="0" rIns="0" bIns="0" rtlCol="0" anchor="ctr"/>
           <a:lstStyle/>
           <a:p>
-            <a:pPr indent="0" marL="0">
-              <a:buNone/>
-            </a:pPr>
-            <a:r>
-              <a:rPr lang="en-US" sz="1300" b="1" dirty="0">
+            <a:pPr marL="0" indent="0">
+              <a:buNone/>
+            </a:pPr>
+            <a:r>
+              <a:rPr lang="en-US" sz="1600" b="1" dirty="0">
                 <a:solidFill>
                   <a:srgbClr val="12345F"/>
                 </a:solidFill>
@@ -3334,7 +3076,7 @@
               </a:rPr>
               <a:t>H2 · Poids de la population</a:t>
             </a:r>
-            <a:endParaRPr lang="en-US" sz="1300" dirty="0"/>
+            <a:endParaRPr lang="en-US" sz="1600" dirty="0"/>
           </a:p>
         </p:txBody>
       </p:sp>
@@ -3346,24 +3088,24 @@
         </p:nvSpPr>
         <p:spPr>
           <a:xfrm>
-            <a:off x="4526280" y="2322576"/>
-            <a:ext cx="3337560" cy="1143000"/>
-          </a:xfrm>
-          <a:prstGeom prst="rect">
-            <a:avLst/>
-          </a:prstGeom>
-          <a:noFill/>
-          <a:ln/>
-        </p:spPr>
-        <p:txBody>
-          <a:bodyPr wrap="square" lIns="0" tIns="0" rIns="0" bIns="0" rtlCol="0" anchor="ctr"/>
-          <a:lstStyle/>
-          <a:p>
-            <a:pPr indent="0" marL="0">
-              <a:buNone/>
-            </a:pPr>
-            <a:r>
-              <a:rPr lang="en-US" sz="1050" dirty="0">
+            <a:off x="4488180" y="2157984"/>
+            <a:ext cx="3337560" cy="905256"/>
+          </a:xfrm>
+          <a:prstGeom prst="rect">
+            <a:avLst/>
+          </a:prstGeom>
+          <a:noFill/>
+          <a:ln/>
+        </p:spPr>
+        <p:txBody>
+          <a:bodyPr wrap="square" lIns="0" tIns="0" rIns="0" bIns="0" rtlCol="0" anchor="ctr"/>
+          <a:lstStyle/>
+          <a:p>
+            <a:pPr marL="0" indent="0">
+              <a:buNone/>
+            </a:pPr>
+            <a:r>
+              <a:rPr lang="en-US" sz="1600" dirty="0">
                 <a:solidFill>
                   <a:srgbClr val="0B0B0B"/>
                 </a:solidFill>
@@ -3373,7 +3115,7 @@
               </a:rPr>
               <a:t>α = 0,5 est un arbitrage politique réglable dans le tableau de bord.</a:t>
             </a:r>
-            <a:endParaRPr lang="en-US" sz="1050" dirty="0"/>
+            <a:endParaRPr lang="en-US" sz="1600" dirty="0"/>
           </a:p>
         </p:txBody>
       </p:sp>
@@ -3398,11 +3140,11 @@
           <a:bodyPr wrap="square" lIns="0" tIns="0" rIns="0" bIns="0" rtlCol="0" anchor="ctr"/>
           <a:lstStyle/>
           <a:p>
-            <a:pPr indent="0" marL="0">
-              <a:buNone/>
-            </a:pPr>
-            <a:r>
-              <a:rPr lang="en-US" sz="1300" b="1" dirty="0">
+            <a:pPr marL="0" indent="0">
+              <a:buNone/>
+            </a:pPr>
+            <a:r>
+              <a:rPr lang="en-US" sz="1600" b="1" dirty="0">
                 <a:solidFill>
                   <a:srgbClr val="12345F"/>
                 </a:solidFill>
@@ -3412,7 +3154,7 @@
               </a:rPr>
               <a:t>H3 · Couverture radio</a:t>
             </a:r>
-            <a:endParaRPr lang="en-US" sz="1300" dirty="0"/>
+            <a:endParaRPr lang="en-US" sz="1600" dirty="0"/>
           </a:p>
         </p:txBody>
       </p:sp>
@@ -3424,7 +3166,7 @@
         </p:nvSpPr>
         <p:spPr>
           <a:xfrm>
-            <a:off x="8229600" y="2322576"/>
+            <a:off x="8201025" y="2227326"/>
             <a:ext cx="3337560" cy="1143000"/>
           </a:xfrm>
           <a:prstGeom prst="rect">
@@ -3437,11 +3179,11 @@
           <a:bodyPr wrap="square" lIns="0" tIns="0" rIns="0" bIns="0" rtlCol="0" anchor="ctr"/>
           <a:lstStyle/>
           <a:p>
-            <a:pPr indent="0" marL="0">
-              <a:buNone/>
-            </a:pPr>
-            <a:r>
-              <a:rPr lang="en-US" sz="1050" dirty="0">
+            <a:pPr marL="0" indent="0">
+              <a:buNone/>
+            </a:pPr>
+            <a:r>
+              <a:rPr lang="en-US" sz="1600" dirty="0">
                 <a:solidFill>
                   <a:srgbClr val="0B0B0B"/>
                 </a:solidFill>
@@ -3451,7 +3193,7 @@
               </a:rPr>
               <a:t>Faute de données radio accessibles, une zone blanche signifie ici absence de service physique, pas absence de signal.</a:t>
             </a:r>
-            <a:endParaRPr lang="en-US" sz="1050" dirty="0"/>
+            <a:endParaRPr lang="en-US" sz="1600" dirty="0"/>
           </a:p>
         </p:txBody>
       </p:sp>
@@ -3476,11 +3218,11 @@
           <a:bodyPr wrap="square" lIns="0" tIns="0" rIns="0" bIns="0" rtlCol="0" anchor="ctr"/>
           <a:lstStyle/>
           <a:p>
-            <a:pPr indent="0" marL="0">
-              <a:buNone/>
-            </a:pPr>
-            <a:r>
-              <a:rPr lang="en-US" sz="1300" b="1" dirty="0">
+            <a:pPr marL="0" indent="0">
+              <a:buNone/>
+            </a:pPr>
+            <a:r>
+              <a:rPr lang="en-US" sz="1600" b="1" dirty="0">
                 <a:solidFill>
                   <a:srgbClr val="12345F"/>
                 </a:solidFill>
@@ -3490,7 +3232,7 @@
               </a:rPr>
               <a:t>H4 · Centroïde du canton</a:t>
             </a:r>
-            <a:endParaRPr lang="en-US" sz="1300" dirty="0"/>
+            <a:endParaRPr lang="en-US" sz="1600" dirty="0"/>
           </a:p>
         </p:txBody>
       </p:sp>
@@ -3502,24 +3244,24 @@
         </p:nvSpPr>
         <p:spPr>
           <a:xfrm>
-            <a:off x="822960" y="3922776"/>
-            <a:ext cx="3337560" cy="1143000"/>
-          </a:xfrm>
-          <a:prstGeom prst="rect">
-            <a:avLst/>
-          </a:prstGeom>
-          <a:noFill/>
-          <a:ln/>
-        </p:spPr>
-        <p:txBody>
-          <a:bodyPr wrap="square" lIns="0" tIns="0" rIns="0" bIns="0" rtlCol="0" anchor="ctr"/>
-          <a:lstStyle/>
-          <a:p>
-            <a:pPr indent="0" marL="0">
-              <a:buNone/>
-            </a:pPr>
-            <a:r>
-              <a:rPr lang="en-US" sz="1050" dirty="0">
+            <a:off x="822960" y="3842004"/>
+            <a:ext cx="3337560" cy="1033272"/>
+          </a:xfrm>
+          <a:prstGeom prst="rect">
+            <a:avLst/>
+          </a:prstGeom>
+          <a:noFill/>
+          <a:ln/>
+        </p:spPr>
+        <p:txBody>
+          <a:bodyPr wrap="square" lIns="0" tIns="0" rIns="0" bIns="0" rtlCol="0" anchor="ctr"/>
+          <a:lstStyle/>
+          <a:p>
+            <a:pPr marL="0" indent="0">
+              <a:buNone/>
+            </a:pPr>
+            <a:r>
+              <a:rPr lang="en-US" sz="1600" dirty="0">
                 <a:solidFill>
                   <a:srgbClr val="0B0B0B"/>
                 </a:solidFill>
@@ -3529,7 +3271,7 @@
               </a:rPr>
               <a:t>Les distances partent du centroïde du canton, faute de population infra-préfectorale.</a:t>
             </a:r>
-            <a:endParaRPr lang="en-US" sz="1050" dirty="0"/>
+            <a:endParaRPr lang="en-US" sz="1600" dirty="0"/>
           </a:p>
         </p:txBody>
       </p:sp>
@@ -3554,11 +3296,11 @@
           <a:bodyPr wrap="square" lIns="0" tIns="0" rIns="0" bIns="0" rtlCol="0" anchor="ctr"/>
           <a:lstStyle/>
           <a:p>
-            <a:pPr indent="0" marL="0">
-              <a:buNone/>
-            </a:pPr>
-            <a:r>
-              <a:rPr lang="en-US" sz="1300" b="1" dirty="0">
+            <a:pPr marL="0" indent="0">
+              <a:buNone/>
+            </a:pPr>
+            <a:r>
+              <a:rPr lang="en-US" sz="1600" b="1" dirty="0">
                 <a:solidFill>
                   <a:srgbClr val="12345F"/>
                 </a:solidFill>
@@ -3568,7 +3310,7 @@
               </a:rPr>
               <a:t>H5 · Noms reconstruits</a:t>
             </a:r>
-            <a:endParaRPr lang="en-US" sz="1300" dirty="0"/>
+            <a:endParaRPr lang="en-US" sz="1600" dirty="0"/>
           </a:p>
         </p:txBody>
       </p:sp>
@@ -3580,7 +3322,7 @@
         </p:nvSpPr>
         <p:spPr>
           <a:xfrm>
-            <a:off x="4526280" y="3922776"/>
+            <a:off x="4526280" y="3742563"/>
             <a:ext cx="3337560" cy="1143000"/>
           </a:xfrm>
           <a:prstGeom prst="rect">
@@ -3593,11 +3335,11 @@
           <a:bodyPr wrap="square" lIns="0" tIns="0" rIns="0" bIns="0" rtlCol="0" anchor="ctr"/>
           <a:lstStyle/>
           <a:p>
-            <a:pPr indent="0" marL="0">
-              <a:buNone/>
-            </a:pPr>
-            <a:r>
-              <a:rPr lang="en-US" sz="1050" dirty="0">
+            <a:pPr marL="0" indent="0">
+              <a:buNone/>
+            </a:pPr>
+            <a:r>
+              <a:rPr lang="en-US" sz="1600" dirty="0">
                 <a:solidFill>
                   <a:srgbClr val="0B0B0B"/>
                 </a:solidFill>
@@ -3607,7 +3349,7 @@
               </a:rPr>
               <a:t>Les noms ont été reconstruits par jointure spatiale ; 39/39 préfectures concordent.</a:t>
             </a:r>
-            <a:endParaRPr lang="en-US" sz="1050" dirty="0"/>
+            <a:endParaRPr lang="en-US" sz="1600" dirty="0"/>
           </a:p>
         </p:txBody>
       </p:sp>
@@ -3632,11 +3374,11 @@
           <a:bodyPr wrap="square" lIns="0" tIns="0" rIns="0" bIns="0" rtlCol="0" anchor="ctr"/>
           <a:lstStyle/>
           <a:p>
-            <a:pPr indent="0" marL="0">
-              <a:buNone/>
-            </a:pPr>
-            <a:r>
-              <a:rPr lang="en-US" sz="1300" b="1" dirty="0">
+            <a:pPr marL="0" indent="0">
+              <a:buNone/>
+            </a:pPr>
+            <a:r>
+              <a:rPr lang="en-US" sz="1600" b="1" dirty="0">
                 <a:solidFill>
                   <a:srgbClr val="12345F"/>
                 </a:solidFill>
@@ -3646,7 +3388,7 @@
               </a:rPr>
               <a:t>H6 · Données et millésimes</a:t>
             </a:r>
-            <a:endParaRPr lang="en-US" sz="1300" dirty="0"/>
+            <a:endParaRPr lang="en-US" sz="1600" dirty="0"/>
           </a:p>
         </p:txBody>
       </p:sp>
@@ -3658,7 +3400,7 @@
         </p:nvSpPr>
         <p:spPr>
           <a:xfrm>
-            <a:off x="8229600" y="3922776"/>
+            <a:off x="8201025" y="3813049"/>
             <a:ext cx="3337560" cy="1143000"/>
           </a:xfrm>
           <a:prstGeom prst="rect">
@@ -3671,11 +3413,11 @@
           <a:bodyPr wrap="square" lIns="0" tIns="0" rIns="0" bIns="0" rtlCol="0" anchor="ctr"/>
           <a:lstStyle/>
           <a:p>
-            <a:pPr indent="0" marL="0">
-              <a:buNone/>
-            </a:pPr>
-            <a:r>
-              <a:rPr lang="en-US" sz="1050" dirty="0">
+            <a:pPr marL="0" indent="0">
+              <a:buNone/>
+            </a:pPr>
+            <a:r>
+              <a:rPr lang="en-US" sz="1600" dirty="0">
                 <a:solidFill>
                   <a:srgbClr val="0B0B0B"/>
                 </a:solidFill>
@@ -3685,7 +3427,7 @@
               </a:rPr>
               <a:t>Les données forment un inventaire. Population 2022, implantations de date inconnue, 6,8 % d’opérateurs non renseignés.</a:t>
             </a:r>
-            <a:endParaRPr lang="en-US" sz="1050" dirty="0"/>
+            <a:endParaRPr lang="en-US" sz="1600" dirty="0"/>
           </a:p>
         </p:txBody>
       </p:sp>
@@ -3713,7 +3455,10 @@
         </p:spPr>
         <p:txBody>
           <a:bodyPr/>
-          <a:p/>
+          <a:lstStyle/>
+          <a:p>
+            <a:endParaRPr/>
+          </a:p>
         </p:txBody>
       </p:sp>
       <p:sp>
@@ -3737,11 +3482,11 @@
           <a:bodyPr wrap="square" lIns="0" tIns="0" rIns="0" bIns="0" rtlCol="0" anchor="ctr"/>
           <a:lstStyle/>
           <a:p>
-            <a:pPr indent="0" marL="0">
-              <a:buNone/>
-            </a:pPr>
-            <a:r>
-              <a:rPr lang="en-US" sz="1400" b="1" dirty="0">
+            <a:pPr marL="0" indent="0">
+              <a:buNone/>
+            </a:pPr>
+            <a:r>
+              <a:rPr lang="en-US" sz="1600" b="1" dirty="0">
                 <a:solidFill>
                   <a:srgbClr val="12345F"/>
                 </a:solidFill>
@@ -3751,7 +3496,7 @@
               </a:rPr>
               <a:t>Tableau de bord interactif, données et code reproductible</a:t>
             </a:r>
-            <a:endParaRPr lang="en-US" sz="1400" dirty="0"/>
+            <a:endParaRPr lang="en-US" sz="1600" dirty="0"/>
           </a:p>
         </p:txBody>
       </p:sp>
@@ -3776,11 +3521,11 @@
           <a:bodyPr wrap="square" lIns="0" tIns="0" rIns="0" bIns="0" rtlCol="0" anchor="ctr"/>
           <a:lstStyle/>
           <a:p>
-            <a:pPr indent="0" marL="0">
-              <a:buNone/>
-            </a:pPr>
-            <a:r>
-              <a:rPr lang="en-US" sz="1100" dirty="0">
+            <a:pPr marL="0" indent="0">
+              <a:buNone/>
+            </a:pPr>
+            <a:r>
+              <a:rPr lang="en-US" sz="1600" dirty="0">
                 <a:solidFill>
                   <a:srgbClr val="0B0B0B"/>
                 </a:solidFill>
@@ -3790,7 +3535,7 @@
               </a:rPr>
               <a:t>8 vues filtrables par région ; analyse cantonale dans Accès local ; lecture recalculée ; export CSV ; 3 scripts Python reproductibles.</a:t>
             </a:r>
-            <a:endParaRPr lang="en-US" sz="1100" dirty="0"/>
+            <a:endParaRPr lang="en-US" sz="1600" dirty="0"/>
           </a:p>
         </p:txBody>
       </p:sp>
@@ -3848,11 +3593,11 @@
           <a:bodyPr wrap="square" lIns="0" tIns="0" rIns="0" bIns="0" rtlCol="0" anchor="ctr"/>
           <a:lstStyle/>
           <a:p>
-            <a:pPr indent="0" marL="0">
-              <a:buNone/>
-            </a:pPr>
-            <a:r>
-              <a:rPr lang="en-US" sz="1100" b="1" spc="200" kern="0" dirty="0">
+            <a:pPr marL="0" indent="0">
+              <a:buNone/>
+            </a:pPr>
+            <a:r>
+              <a:rPr lang="en-US" sz="1100" b="1" kern="0" spc="200" dirty="0">
                 <a:solidFill>
                   <a:srgbClr val="12345F"/>
                 </a:solidFill>
@@ -3887,7 +3632,7 @@
           <a:bodyPr wrap="square" lIns="0" tIns="0" rIns="0" bIns="0" rtlCol="0" anchor="ctr"/>
           <a:lstStyle/>
           <a:p>
-            <a:pPr indent="0" marL="0">
+            <a:pPr marL="0" indent="0">
               <a:buNone/>
             </a:pPr>
             <a:r>
@@ -3931,7 +3676,10 @@
         </p:spPr>
         <p:txBody>
           <a:bodyPr/>
-          <a:p/>
+          <a:lstStyle/>
+          <a:p>
+            <a:endParaRPr/>
+          </a:p>
         </p:txBody>
       </p:sp>
       <p:sp>
@@ -3955,7 +3703,7 @@
           <a:bodyPr wrap="square" lIns="0" tIns="0" rIns="0" bIns="0" rtlCol="0" anchor="ctr"/>
           <a:lstStyle/>
           <a:p>
-            <a:pPr algn="ctr" indent="0" marL="0">
+            <a:pPr marL="0" indent="0" algn="ctr">
               <a:buNone/>
             </a:pPr>
             <a:r>
@@ -3994,20 +3742,9 @@
           <a:bodyPr wrap="square" lIns="0" tIns="0" rIns="0" bIns="0" rtlCol="0" anchor="ctr"/>
           <a:lstStyle/>
           <a:p>
-            <a:pPr indent="0" marL="0">
-              <a:buNone/>
-            </a:pPr>
-            <a:r>
-              <a:rPr lang="en-US" sz="2300" b="1" dirty="0">
-                <a:solidFill>
-                  <a:srgbClr val="12345F"/>
-                </a:solidFill>
-                <a:latin typeface="Aptos" pitchFamily="34" charset="0"/>
-                <a:ea typeface="Cambria" pitchFamily="34" charset="-122"/>
-                <a:cs typeface="Cambria" pitchFamily="34" charset="-120"/>
-              </a:rPr>
-              <a:t/>
-            </a:r>
+            <a:pPr marL="0" indent="0">
+              <a:buNone/>
+            </a:pPr>
             <a:endParaRPr lang="en-US" sz="2300" dirty="0"/>
           </a:p>
         </p:txBody>
@@ -4033,7 +3770,7 @@
           <a:bodyPr wrap="square" lIns="0" tIns="0" rIns="0" bIns="0" rtlCol="0" anchor="ctr"/>
           <a:lstStyle/>
           <a:p>
-            <a:pPr indent="0" marL="0">
+            <a:pPr marL="0" indent="0">
               <a:buNone/>
             </a:pPr>
             <a:r>
@@ -4072,7 +3809,7 @@
           <a:bodyPr wrap="square" lIns="0" tIns="0" rIns="0" bIns="0" rtlCol="0" anchor="ctr"/>
           <a:lstStyle/>
           <a:p>
-            <a:pPr indent="0" marL="0">
+            <a:pPr marL="0" indent="0">
               <a:buNone/>
             </a:pPr>
             <a:r>
@@ -4117,7 +3854,10 @@
         </p:spPr>
         <p:txBody>
           <a:bodyPr/>
-          <a:p/>
+          <a:lstStyle/>
+          <a:p>
+            <a:endParaRPr/>
+          </a:p>
         </p:txBody>
       </p:sp>
       <p:sp>
@@ -4141,7 +3881,7 @@
           <a:bodyPr wrap="square" lIns="0" tIns="0" rIns="0" bIns="0" rtlCol="0" anchor="ctr"/>
           <a:lstStyle/>
           <a:p>
-            <a:pPr algn="ctr" indent="0" marL="0">
+            <a:pPr marL="0" indent="0" algn="ctr">
               <a:buNone/>
             </a:pPr>
             <a:r>
@@ -4180,20 +3920,9 @@
           <a:bodyPr wrap="square" lIns="0" tIns="0" rIns="0" bIns="0" rtlCol="0" anchor="ctr"/>
           <a:lstStyle/>
           <a:p>
-            <a:pPr indent="0" marL="0">
-              <a:buNone/>
-            </a:pPr>
-            <a:r>
-              <a:rPr lang="en-US" sz="2300" b="1" dirty="0">
-                <a:solidFill>
-                  <a:srgbClr val="12345F"/>
-                </a:solidFill>
-                <a:latin typeface="Aptos" pitchFamily="34" charset="0"/>
-                <a:ea typeface="Cambria" pitchFamily="34" charset="-122"/>
-                <a:cs typeface="Cambria" pitchFamily="34" charset="-120"/>
-              </a:rPr>
-              <a:t/>
-            </a:r>
+            <a:pPr marL="0" indent="0">
+              <a:buNone/>
+            </a:pPr>
             <a:endParaRPr lang="en-US" sz="2300" dirty="0"/>
           </a:p>
         </p:txBody>
@@ -4219,7 +3948,7 @@
           <a:bodyPr wrap="square" lIns="0" tIns="0" rIns="0" bIns="0" rtlCol="0" anchor="ctr"/>
           <a:lstStyle/>
           <a:p>
-            <a:pPr indent="0" marL="0">
+            <a:pPr marL="0" indent="0">
               <a:buNone/>
             </a:pPr>
             <a:r>
@@ -4258,7 +3987,7 @@
           <a:bodyPr wrap="square" lIns="0" tIns="0" rIns="0" bIns="0" rtlCol="0" anchor="ctr"/>
           <a:lstStyle/>
           <a:p>
-            <a:pPr indent="0" marL="0">
+            <a:pPr marL="0" indent="0">
               <a:buNone/>
             </a:pPr>
             <a:r>
@@ -4303,7 +4032,10 @@
         </p:spPr>
         <p:txBody>
           <a:bodyPr/>
-          <a:p/>
+          <a:lstStyle/>
+          <a:p>
+            <a:endParaRPr/>
+          </a:p>
         </p:txBody>
       </p:sp>
       <p:sp>
@@ -4327,7 +4059,7 @@
           <a:bodyPr wrap="square" lIns="0" tIns="0" rIns="0" bIns="0" rtlCol="0" anchor="ctr"/>
           <a:lstStyle/>
           <a:p>
-            <a:pPr algn="ctr" indent="0" marL="0">
+            <a:pPr marL="0" indent="0" algn="ctr">
               <a:buNone/>
             </a:pPr>
             <a:r>
@@ -4366,20 +4098,9 @@
           <a:bodyPr wrap="square" lIns="0" tIns="0" rIns="0" bIns="0" rtlCol="0" anchor="ctr"/>
           <a:lstStyle/>
           <a:p>
-            <a:pPr indent="0" marL="0">
-              <a:buNone/>
-            </a:pPr>
-            <a:r>
-              <a:rPr lang="en-US" sz="2300" b="1" dirty="0">
-                <a:solidFill>
-                  <a:srgbClr val="12345F"/>
-                </a:solidFill>
-                <a:latin typeface="Aptos" pitchFamily="34" charset="0"/>
-                <a:ea typeface="Cambria" pitchFamily="34" charset="-122"/>
-                <a:cs typeface="Cambria" pitchFamily="34" charset="-120"/>
-              </a:rPr>
-              <a:t/>
-            </a:r>
+            <a:pPr marL="0" indent="0">
+              <a:buNone/>
+            </a:pPr>
             <a:endParaRPr lang="en-US" sz="2300" dirty="0"/>
           </a:p>
         </p:txBody>
@@ -4405,7 +4126,7 @@
           <a:bodyPr wrap="square" lIns="0" tIns="0" rIns="0" bIns="0" rtlCol="0" anchor="ctr"/>
           <a:lstStyle/>
           <a:p>
-            <a:pPr indent="0" marL="0">
+            <a:pPr marL="0" indent="0">
               <a:buNone/>
             </a:pPr>
             <a:r>
@@ -4444,7 +4165,7 @@
           <a:bodyPr wrap="square" lIns="0" tIns="0" rIns="0" bIns="0" rtlCol="0" anchor="ctr"/>
           <a:lstStyle/>
           <a:p>
-            <a:pPr indent="0" marL="0">
+            <a:pPr marL="0" indent="0">
               <a:buNone/>
             </a:pPr>
             <a:r>
@@ -4489,7 +4210,10 @@
         </p:spPr>
         <p:txBody>
           <a:bodyPr/>
-          <a:p/>
+          <a:lstStyle/>
+          <a:p>
+            <a:endParaRPr/>
+          </a:p>
         </p:txBody>
       </p:sp>
       <p:sp>
@@ -4513,7 +4237,7 @@
           <a:bodyPr wrap="square" lIns="0" tIns="0" rIns="0" bIns="0" rtlCol="0" anchor="ctr"/>
           <a:lstStyle/>
           <a:p>
-            <a:pPr algn="ctr" indent="0" marL="0">
+            <a:pPr marL="0" indent="0" algn="ctr">
               <a:buNone/>
             </a:pPr>
             <a:r>
@@ -4552,20 +4276,9 @@
           <a:bodyPr wrap="square" lIns="0" tIns="0" rIns="0" bIns="0" rtlCol="0" anchor="ctr"/>
           <a:lstStyle/>
           <a:p>
-            <a:pPr indent="0" marL="0">
-              <a:buNone/>
-            </a:pPr>
-            <a:r>
-              <a:rPr lang="en-US" sz="2300" b="1" dirty="0">
-                <a:solidFill>
-                  <a:srgbClr val="12345F"/>
-                </a:solidFill>
-                <a:latin typeface="Aptos" pitchFamily="34" charset="0"/>
-                <a:ea typeface="Cambria" pitchFamily="34" charset="-122"/>
-                <a:cs typeface="Cambria" pitchFamily="34" charset="-120"/>
-              </a:rPr>
-              <a:t/>
-            </a:r>
+            <a:pPr marL="0" indent="0">
+              <a:buNone/>
+            </a:pPr>
             <a:endParaRPr lang="en-US" sz="2300" dirty="0"/>
           </a:p>
         </p:txBody>
@@ -4591,7 +4304,7 @@
           <a:bodyPr wrap="square" lIns="0" tIns="0" rIns="0" bIns="0" rtlCol="0" anchor="ctr"/>
           <a:lstStyle/>
           <a:p>
-            <a:pPr indent="0" marL="0">
+            <a:pPr marL="0" indent="0">
               <a:buNone/>
             </a:pPr>
             <a:r>
@@ -4630,7 +4343,7 @@
           <a:bodyPr wrap="square" lIns="0" tIns="0" rIns="0" bIns="0" rtlCol="0" anchor="ctr"/>
           <a:lstStyle/>
           <a:p>
-            <a:pPr indent="0" marL="0">
+            <a:pPr marL="0" indent="0">
               <a:buNone/>
             </a:pPr>
             <a:r>
@@ -4677,7 +4390,10 @@
         </p:spPr>
         <p:txBody>
           <a:bodyPr/>
-          <a:p/>
+          <a:lstStyle/>
+          <a:p>
+            <a:endParaRPr/>
+          </a:p>
         </p:txBody>
       </p:sp>
       <p:sp>
@@ -4701,7 +4417,7 @@
           <a:bodyPr wrap="square" lIns="0" tIns="0" rIns="0" bIns="0" rtlCol="0" anchor="ctr"/>
           <a:lstStyle/>
           <a:p>
-            <a:pPr indent="0" marL="0">
+            <a:pPr marL="0" indent="0">
               <a:buNone/>
             </a:pPr>
             <a:r>
@@ -4740,7 +4456,7 @@
           <a:bodyPr wrap="square" lIns="0" tIns="0" rIns="0" bIns="0" rtlCol="0" anchor="ctr"/>
           <a:lstStyle/>
           <a:p>
-            <a:pPr indent="0" marL="0">
+            <a:pPr marL="0" indent="0">
               <a:lnSpc>
                 <a:spcPts val="1600"/>
               </a:lnSpc>
@@ -4759,27 +4475,19 @@
 Résultats descriptifs : les données sont un inventaire, pas un échantillon.
 Norme explicite : « attendu » signifie une répartition proportionnelle à la population.</a:t>
             </a:r>
-            <a:pPr indent="0" marL="0">
+            <a:endParaRPr lang="en-US" sz="1150" dirty="0"/>
+          </a:p>
+          <a:p>
+            <a:pPr marL="0" indent="0">
               <a:lnSpc>
                 <a:spcPts val="1600"/>
               </a:lnSpc>
               <a:buNone/>
             </a:pPr>
-            <a:r>
-              <a:rPr lang="en-US" sz="1150" dirty="0">
-                <a:solidFill>
-                  <a:srgbClr val="0B0B0B"/>
-                </a:solidFill>
-                <a:latin typeface="Aptos" pitchFamily="34" charset="0"/>
-                <a:ea typeface="Calibri" pitchFamily="34" charset="-122"/>
-                <a:cs typeface="Calibri" pitchFamily="34" charset="-120"/>
-              </a:rPr>
-              <a:t/>
-            </a:r>
             <a:endParaRPr lang="en-US" sz="1150" dirty="0"/>
           </a:p>
           <a:p>
-            <a:pPr indent="0" marL="0">
+            <a:pPr marL="0" indent="0">
               <a:lnSpc>
                 <a:spcPts val="1600"/>
               </a:lnSpc>
@@ -4788,47 +4496,25 @@
             <a:endParaRPr lang="en-US" sz="1150" dirty="0"/>
           </a:p>
           <a:p>
-            <a:pPr indent="0" marL="0">
+            <a:pPr marL="0" indent="0">
               <a:lnSpc>
                 <a:spcPts val="1600"/>
               </a:lnSpc>
               <a:buNone/>
             </a:pPr>
-            <a:r>
-              <a:rPr lang="en-US" sz="1150" b="1" dirty="0">
-                <a:solidFill>
-                  <a:srgbClr val="0B0B0B"/>
-                </a:solidFill>
-                <a:latin typeface="Aptos" pitchFamily="34" charset="0"/>
-                <a:ea typeface="Calibri" pitchFamily="34" charset="-122"/>
-                <a:cs typeface="Calibri" pitchFamily="34" charset="-120"/>
-              </a:rPr>
-              <a:t/>
-            </a:r>
             <a:endParaRPr lang="en-US" sz="1150" dirty="0"/>
           </a:p>
           <a:p>
-            <a:pPr indent="0" marL="0">
+            <a:pPr marL="0" indent="0">
               <a:lnSpc>
                 <a:spcPts val="1600"/>
               </a:lnSpc>
               <a:buNone/>
             </a:pPr>
-            <a:r>
-              <a:rPr lang="en-US" sz="1150" dirty="0">
-                <a:solidFill>
-                  <a:srgbClr val="0B0B0B"/>
-                </a:solidFill>
-                <a:latin typeface="Aptos" pitchFamily="34" charset="0"/>
-                <a:ea typeface="Calibri" pitchFamily="34" charset="-122"/>
-                <a:cs typeface="Calibri" pitchFamily="34" charset="-120"/>
-              </a:rPr>
-              <a:t/>
-            </a:r>
             <a:endParaRPr lang="en-US" sz="1150" dirty="0"/>
           </a:p>
           <a:p>
-            <a:pPr indent="0" marL="0">
+            <a:pPr marL="0" indent="0">
               <a:lnSpc>
                 <a:spcPts val="1600"/>
               </a:lnSpc>
@@ -4837,14 +4523,42 @@
             <a:endParaRPr lang="en-US" sz="1150" dirty="0"/>
           </a:p>
           <a:p>
-            <a:pPr indent="0" marL="0">
+            <a:pPr marL="0" indent="0">
               <a:lnSpc>
                 <a:spcPts val="1600"/>
               </a:lnSpc>
               <a:buNone/>
             </a:pPr>
-            <a:r>
-              <a:rPr lang="en-US" sz="1150" b="1" dirty="0">
+            <a:endParaRPr lang="en-US" sz="1150" dirty="0"/>
+          </a:p>
+        </p:txBody>
+      </p:sp>
+      <p:sp>
+        <p:nvSpPr>
+          <p:cNvPr id="27" name="Text 25"/>
+          <p:cNvSpPr txBox="1"/>
+          <p:nvPr/>
+        </p:nvSpPr>
+        <p:spPr>
+          <a:xfrm>
+            <a:off x="640080" y="6236208"/>
+            <a:ext cx="10881360" cy="365760"/>
+          </a:xfrm>
+          <a:prstGeom prst="rect">
+            <a:avLst/>
+          </a:prstGeom>
+          <a:noFill/>
+          <a:ln/>
+        </p:spPr>
+        <p:txBody>
+          <a:bodyPr wrap="square" lIns="0" tIns="0" rIns="0" bIns="0" rtlCol="0" anchor="ctr"/>
+          <a:lstStyle/>
+          <a:p>
+            <a:pPr marL="0" indent="0">
+              <a:buNone/>
+            </a:pPr>
+            <a:r>
+              <a:rPr lang="en-US" sz="1400" dirty="0">
                 <a:solidFill>
                   <a:srgbClr val="0B0B0B"/>
                 </a:solidFill>
@@ -4852,68 +4566,9 @@
                 <a:ea typeface="Calibri" pitchFamily="34" charset="-122"/>
                 <a:cs typeface="Calibri" pitchFamily="34" charset="-120"/>
               </a:rPr>
-              <a:t/>
-            </a:r>
-            <a:endParaRPr lang="en-US" sz="1150" dirty="0"/>
-          </a:p>
-          <a:p>
-            <a:pPr indent="0" marL="0">
-              <a:lnSpc>
-                <a:spcPts val="1600"/>
-              </a:lnSpc>
-              <a:buNone/>
-            </a:pPr>
-            <a:r>
-              <a:rPr lang="en-US" sz="1150" dirty="0">
-                <a:solidFill>
-                  <a:srgbClr val="0B0B0B"/>
-                </a:solidFill>
-                <a:latin typeface="Aptos" pitchFamily="34" charset="0"/>
-                <a:ea typeface="Calibri" pitchFamily="34" charset="-122"/>
-                <a:cs typeface="Calibri" pitchFamily="34" charset="-120"/>
-              </a:rPr>
-              <a:t/>
-            </a:r>
-            <a:endParaRPr lang="en-US" sz="1150" dirty="0"/>
-          </a:p>
-        </p:txBody>
-      </p:sp>
-      <p:sp>
-        <p:nvSpPr>
-          <p:cNvPr id="27" name="Text 25"/>
-          <p:cNvSpPr txBox="1"/>
-          <p:nvPr/>
-        </p:nvSpPr>
-        <p:spPr>
-          <a:xfrm>
-            <a:off x="640080" y="6236208"/>
-            <a:ext cx="10881360" cy="365760"/>
-          </a:xfrm>
-          <a:prstGeom prst="rect">
-            <a:avLst/>
-          </a:prstGeom>
-          <a:noFill/>
-          <a:ln/>
-        </p:spPr>
-        <p:txBody>
-          <a:bodyPr wrap="square" lIns="0" tIns="0" rIns="0" bIns="0" rtlCol="0" anchor="ctr"/>
-          <a:lstStyle/>
-          <a:p>
-            <a:pPr indent="0" marL="0">
-              <a:buNone/>
-            </a:pPr>
-            <a:r>
-              <a:rPr lang="en-US" sz="1000" dirty="0">
-                <a:solidFill>
-                  <a:srgbClr val="0B0B0B"/>
-                </a:solidFill>
-                <a:latin typeface="Aptos" pitchFamily="34" charset="0"/>
-                <a:ea typeface="Calibri" pitchFamily="34" charset="-122"/>
-                <a:cs typeface="Calibri" pitchFamily="34" charset="-120"/>
-              </a:rPr>
               <a:t>Chaîne reproductible : sources → scripts Python → indicateurs → dashboard et rapport.</a:t>
             </a:r>
-            <a:endParaRPr lang="en-US" sz="1000" dirty="0"/>
+            <a:endParaRPr lang="en-US" sz="1400" dirty="0"/>
           </a:p>
         </p:txBody>
       </p:sp>
@@ -4971,11 +4626,11 @@
           <a:bodyPr wrap="square" lIns="0" tIns="0" rIns="0" bIns="0" rtlCol="0" anchor="ctr"/>
           <a:lstStyle/>
           <a:p>
-            <a:pPr indent="0" marL="0">
-              <a:buNone/>
-            </a:pPr>
-            <a:r>
-              <a:rPr lang="en-US" sz="1100" b="1" spc="200" kern="0" dirty="0">
+            <a:pPr marL="0" indent="0">
+              <a:buNone/>
+            </a:pPr>
+            <a:r>
+              <a:rPr lang="en-US" sz="1100" b="1" kern="0" spc="200" dirty="0">
                 <a:solidFill>
                   <a:srgbClr val="12345F"/>
                 </a:solidFill>
@@ -5010,7 +4665,7 @@
           <a:bodyPr wrap="square" lIns="0" tIns="0" rIns="0" bIns="0" rtlCol="0" anchor="ctr"/>
           <a:lstStyle/>
           <a:p>
-            <a:pPr indent="0" marL="0">
+            <a:pPr marL="0" indent="0">
               <a:buNone/>
             </a:pPr>
             <a:r>
@@ -5030,14 +4685,14 @@
       </p:sp>
       <p:pic>
         <p:nvPicPr>
-          <p:cNvPr id="4" name="Image 0" descr="img/carte_acces.png">    </p:cNvPr>
+          <p:cNvPr id="4" name="Image 0" descr="img/carte_acces.png"/>
           <p:cNvPicPr>
             <a:picLocks noChangeAspect="1"/>
           </p:cNvPicPr>
           <p:nvPr/>
         </p:nvPicPr>
         <p:blipFill>
-          <a:blip r:embed="rId1"/>
+          <a:blip r:embed="rId3"/>
           <a:stretch>
             <a:fillRect/>
           </a:stretch>
@@ -5054,7 +4709,7 @@
       </p:pic>
       <p:graphicFrame>
         <p:nvGraphicFramePr>
-          <p:cNvPr id="5" name="Chart 0" descr=""/>
+          <p:cNvPr id="5" name="Chart 0"/>
           <p:cNvGraphicFramePr/>
           <p:nvPr/>
         </p:nvGraphicFramePr>
@@ -5062,9 +4717,9 @@
           <a:off x="4114800" y="1554480"/>
           <a:ext cx="4206240" cy="2834640"/>
         </p:xfrm>
-        <a:graphic xmlns:a="http://schemas.openxmlformats.org/drawingml/2006/main">
+        <a:graphic>
           <a:graphicData uri="http://schemas.openxmlformats.org/drawingml/2006/chart">
-            <c:chart xmlns:c="http://schemas.openxmlformats.org/drawingml/2006/chart" r:id="rId2"/>
+            <c:chart xmlns:c="http://schemas.openxmlformats.org/drawingml/2006/chart" xmlns:r="http://schemas.openxmlformats.org/officeDocument/2006/relationships" r:id="rId4"/>
           </a:graphicData>
         </a:graphic>
       </p:graphicFrame>
@@ -5076,24 +4731,29 @@
         </p:nvSpPr>
         <p:spPr>
           <a:xfrm>
-            <a:off x="4114800" y="4572000"/>
-            <a:ext cx="4206240" cy="1005840"/>
-          </a:xfrm>
-          <a:prstGeom prst="rect">
-            <a:avLst/>
-          </a:prstGeom>
-          <a:noFill/>
-          <a:ln/>
-        </p:spPr>
-        <p:txBody>
-          <a:bodyPr wrap="square" lIns="0" tIns="0" rIns="0" bIns="0" rtlCol="0" anchor="ctr"/>
-          <a:lstStyle/>
-          <a:p>
-            <a:pPr indent="0" marL="0">
-              <a:buNone/>
-            </a:pPr>
-            <a:r>
-              <a:rPr lang="en-US" sz="1200" dirty="0">
+            <a:off x="3657601" y="5500497"/>
+            <a:ext cx="8020050" cy="711327"/>
+          </a:xfrm>
+          <a:prstGeom prst="rect">
+            <a:avLst/>
+          </a:prstGeom>
+          <a:solidFill>
+            <a:schemeClr val="accent6">
+              <a:lumMod val="60000"/>
+              <a:lumOff val="40000"/>
+            </a:schemeClr>
+          </a:solidFill>
+          <a:ln/>
+        </p:spPr>
+        <p:txBody>
+          <a:bodyPr wrap="square" lIns="0" tIns="0" rIns="0" bIns="0" rtlCol="0" anchor="ctr"/>
+          <a:lstStyle/>
+          <a:p>
+            <a:pPr marL="0" indent="0">
+              <a:buNone/>
+            </a:pPr>
+            <a:r>
+              <a:rPr lang="en-US" sz="1400" b="1" dirty="0">
                 <a:solidFill>
                   <a:srgbClr val="0B0B0B"/>
                 </a:solidFill>
@@ -5101,9 +4761,113 @@
                 <a:ea typeface="Calibri" pitchFamily="34" charset="-122"/>
                 <a:cs typeface="Calibri" pitchFamily="34" charset="-120"/>
               </a:rPr>
-              <a:t>Le classement en valeur absolue dit l’inverse : Maritime concentre 45 % des points de service. C’est le dénominateur — la population — qui renverse la lecture.</a:t>
-            </a:r>
-            <a:endParaRPr lang="en-US" sz="1200" dirty="0"/>
+              <a:t>Le classement en valeur absolue dit </a:t>
+            </a:r>
+            <a:r>
+              <a:rPr lang="en-US" sz="1400" b="1" dirty="0" err="1">
+                <a:solidFill>
+                  <a:srgbClr val="0B0B0B"/>
+                </a:solidFill>
+                <a:latin typeface="Aptos" pitchFamily="34" charset="0"/>
+                <a:ea typeface="Calibri" pitchFamily="34" charset="-122"/>
+                <a:cs typeface="Calibri" pitchFamily="34" charset="-120"/>
+              </a:rPr>
+              <a:t>l’inverse</a:t>
+            </a:r>
+            <a:r>
+              <a:rPr lang="en-US" sz="1400" b="1" dirty="0">
+                <a:solidFill>
+                  <a:srgbClr val="0B0B0B"/>
+                </a:solidFill>
+                <a:latin typeface="Aptos" pitchFamily="34" charset="0"/>
+                <a:ea typeface="Calibri" pitchFamily="34" charset="-122"/>
+                <a:cs typeface="Calibri" pitchFamily="34" charset="-120"/>
+              </a:rPr>
+              <a:t> :</a:t>
+            </a:r>
+          </a:p>
+          <a:p>
+            <a:pPr marL="0" indent="0">
+              <a:buNone/>
+            </a:pPr>
+            <a:r>
+              <a:rPr lang="en-US" sz="1400" b="1" dirty="0">
+                <a:solidFill>
+                  <a:srgbClr val="0B0B0B"/>
+                </a:solidFill>
+                <a:latin typeface="Aptos" pitchFamily="34" charset="0"/>
+                <a:ea typeface="Calibri" pitchFamily="34" charset="-122"/>
+                <a:cs typeface="Calibri" pitchFamily="34" charset="-120"/>
+              </a:rPr>
+              <a:t> </a:t>
+            </a:r>
+            <a:r>
+              <a:rPr lang="en-US" sz="1400" dirty="0">
+                <a:solidFill>
+                  <a:srgbClr val="0B0B0B"/>
+                </a:solidFill>
+                <a:latin typeface="Aptos" pitchFamily="34" charset="0"/>
+                <a:ea typeface="Calibri" pitchFamily="34" charset="-122"/>
+                <a:cs typeface="Calibri" pitchFamily="34" charset="-120"/>
+              </a:rPr>
+              <a:t>Maritime concentre </a:t>
+            </a:r>
+            <a:r>
+              <a:rPr lang="en-US" sz="1400" b="1" dirty="0">
+                <a:solidFill>
+                  <a:srgbClr val="0B0B0B"/>
+                </a:solidFill>
+                <a:latin typeface="Aptos" pitchFamily="34" charset="0"/>
+                <a:ea typeface="Calibri" pitchFamily="34" charset="-122"/>
+                <a:cs typeface="Calibri" pitchFamily="34" charset="-120"/>
+              </a:rPr>
+              <a:t>45 % </a:t>
+            </a:r>
+            <a:r>
+              <a:rPr lang="en-US" sz="1400" dirty="0">
+                <a:solidFill>
+                  <a:srgbClr val="0B0B0B"/>
+                </a:solidFill>
+                <a:latin typeface="Aptos" pitchFamily="34" charset="0"/>
+                <a:ea typeface="Calibri" pitchFamily="34" charset="-122"/>
+                <a:cs typeface="Calibri" pitchFamily="34" charset="-120"/>
+              </a:rPr>
+              <a:t>des points de service. C’est le </a:t>
+            </a:r>
+            <a:r>
+              <a:rPr lang="en-US" sz="1400" dirty="0" err="1">
+                <a:solidFill>
+                  <a:srgbClr val="0B0B0B"/>
+                </a:solidFill>
+                <a:latin typeface="Aptos" pitchFamily="34" charset="0"/>
+                <a:ea typeface="Calibri" pitchFamily="34" charset="-122"/>
+                <a:cs typeface="Calibri" pitchFamily="34" charset="-120"/>
+              </a:rPr>
+              <a:t>dénominateur</a:t>
+            </a:r>
+            <a:r>
+              <a:rPr lang="en-US" sz="1400" b="1" dirty="0">
+                <a:solidFill>
+                  <a:srgbClr val="0B0B0B"/>
+                </a:solidFill>
+                <a:latin typeface="Aptos" pitchFamily="34" charset="0"/>
+                <a:ea typeface="Calibri" pitchFamily="34" charset="-122"/>
+                <a:cs typeface="Calibri" pitchFamily="34" charset="-120"/>
+              </a:rPr>
+              <a:t>, la population </a:t>
+            </a:r>
+            <a:r>
+              <a:rPr lang="en-US" sz="1400" dirty="0">
+                <a:solidFill>
+                  <a:srgbClr val="0B0B0B"/>
+                </a:solidFill>
+                <a:latin typeface="Aptos" pitchFamily="34" charset="0"/>
+                <a:ea typeface="Calibri" pitchFamily="34" charset="-122"/>
+                <a:cs typeface="Calibri" pitchFamily="34" charset="-120"/>
+              </a:rPr>
+              <a:t>qui renverse la lecture.</a:t>
+            </a:r>
+            <a:endParaRPr lang="en-US" sz="1400" dirty="0"/>
           </a:p>
         </p:txBody>
       </p:sp>
@@ -5135,7 +4899,10 @@
         </p:spPr>
         <p:txBody>
           <a:bodyPr/>
-          <a:p/>
+          <a:lstStyle/>
+          <a:p>
+            <a:endParaRPr/>
+          </a:p>
         </p:txBody>
       </p:sp>
       <p:sp>
@@ -5159,7 +4926,7 @@
           <a:bodyPr wrap="square" lIns="0" tIns="0" rIns="0" bIns="0" rtlCol="0" anchor="ctr"/>
           <a:lstStyle/>
           <a:p>
-            <a:pPr indent="0" marL="0">
+            <a:pPr marL="0" indent="0">
               <a:buNone/>
             </a:pPr>
             <a:r>
@@ -5198,7 +4965,7 @@
           <a:bodyPr wrap="square" lIns="0" tIns="0" rIns="0" bIns="0" rtlCol="0" anchor="ctr"/>
           <a:lstStyle/>
           <a:p>
-            <a:pPr indent="0" marL="0">
+            <a:pPr marL="0" indent="0">
               <a:buNone/>
             </a:pPr>
             <a:r>
@@ -5237,7 +5004,7 @@
           <a:bodyPr wrap="square" lIns="0" tIns="0" rIns="0" bIns="0" rtlCol="0" anchor="ctr"/>
           <a:lstStyle/>
           <a:p>
-            <a:pPr indent="0" marL="0">
+            <a:pPr marL="0" indent="0">
               <a:buNone/>
             </a:pPr>
             <a:r>
@@ -5283,7 +5050,10 @@
         </p:spPr>
         <p:txBody>
           <a:bodyPr/>
-          <a:p/>
+          <a:lstStyle/>
+          <a:p>
+            <a:endParaRPr/>
+          </a:p>
         </p:txBody>
       </p:sp>
       <p:sp>
@@ -5307,7 +5077,7 @@
           <a:bodyPr wrap="square" lIns="0" tIns="0" rIns="0" bIns="0" rtlCol="0" anchor="ctr"/>
           <a:lstStyle/>
           <a:p>
-            <a:pPr indent="0" marL="0">
+            <a:pPr marL="0" indent="0">
               <a:buNone/>
             </a:pPr>
             <a:r>
@@ -5346,7 +5116,7 @@
           <a:bodyPr wrap="square" lIns="0" tIns="0" rIns="0" bIns="0" rtlCol="0" anchor="ctr"/>
           <a:lstStyle/>
           <a:p>
-            <a:pPr indent="0" marL="0">
+            <a:pPr marL="0" indent="0">
               <a:buNone/>
             </a:pPr>
             <a:r>
@@ -5385,7 +5155,7 @@
           <a:bodyPr wrap="square" lIns="0" tIns="0" rIns="0" bIns="0" rtlCol="0" anchor="ctr"/>
           <a:lstStyle/>
           <a:p>
-            <a:pPr indent="0" marL="0">
+            <a:pPr marL="0" indent="0">
               <a:buNone/>
             </a:pPr>
             <a:r>
@@ -5405,52 +5175,13 @@
       </p:sp>
       <p:sp>
         <p:nvSpPr>
-          <p:cNvPr id="15" name="Text 11"/>
-          <p:cNvSpPr txBox="1"/>
-          <p:nvPr/>
-        </p:nvSpPr>
-        <p:spPr>
-          <a:xfrm>
-            <a:off x="8595360" y="4892040"/>
-            <a:ext cx="2926080" cy="914400"/>
-          </a:xfrm>
-          <a:prstGeom prst="rect">
-            <a:avLst/>
-          </a:prstGeom>
-          <a:noFill/>
-          <a:ln/>
-        </p:spPr>
-        <p:txBody>
-          <a:bodyPr wrap="square" lIns="0" tIns="0" rIns="0" bIns="0" rtlCol="0" anchor="ctr"/>
-          <a:lstStyle/>
-          <a:p>
-            <a:pPr indent="0" marL="0">
-              <a:buNone/>
-            </a:pPr>
-            <a:r>
-              <a:rPr lang="en-US" sz="1200" i="1" dirty="0">
-                <a:solidFill>
-                  <a:srgbClr val="12345F"/>
-                </a:solidFill>
-                <a:latin typeface="Aptos" pitchFamily="34" charset="0"/>
-                <a:ea typeface="Cambria" pitchFamily="34" charset="-122"/>
-                <a:cs typeface="Cambria" pitchFamily="34" charset="-120"/>
-              </a:rPr>
-              <a:t>La priorité géographique évidente — « le Nord d’abord » — ne résiste pas aux chiffres.</a:t>
-            </a:r>
-            <a:endParaRPr lang="en-US" sz="1200" dirty="0"/>
-          </a:p>
-        </p:txBody>
-      </p:sp>
-      <p:sp>
-        <p:nvSpPr>
           <p:cNvPr id="16" name="Text 12"/>
           <p:cNvSpPr txBox="1"/>
           <p:nvPr/>
         </p:nvSpPr>
         <p:spPr>
           <a:xfrm>
-            <a:off x="640080" y="6236208"/>
+            <a:off x="640080" y="6473952"/>
             <a:ext cx="10881360" cy="365760"/>
           </a:xfrm>
           <a:prstGeom prst="rect">
@@ -5463,11 +5194,11 @@
           <a:bodyPr wrap="square" lIns="0" tIns="0" rIns="0" bIns="0" rtlCol="0" anchor="ctr"/>
           <a:lstStyle/>
           <a:p>
-            <a:pPr indent="0" marL="0">
-              <a:buNone/>
-            </a:pPr>
-            <a:r>
-              <a:rPr lang="en-US" sz="1000" dirty="0">
+            <a:pPr marL="0" indent="0">
+              <a:buNone/>
+            </a:pPr>
+            <a:r>
+              <a:rPr lang="en-US" sz="1100" dirty="0">
                 <a:solidFill>
                   <a:srgbClr val="12345F"/>
                 </a:solidFill>
@@ -5477,7 +5208,7 @@
               </a:rPr>
               <a:t>Source : Géoportail Géodata Togo (extraction du 9 septembre 2026) et RGPH-5, INSEED 2022.</a:t>
             </a:r>
-            <a:endParaRPr lang="en-US" sz="1000" dirty="0"/>
+            <a:endParaRPr lang="en-US" sz="1100" dirty="0"/>
           </a:p>
         </p:txBody>
       </p:sp>
@@ -5535,11 +5266,11 @@
           <a:bodyPr wrap="square" lIns="0" tIns="0" rIns="0" bIns="0" rtlCol="0" anchor="ctr"/>
           <a:lstStyle/>
           <a:p>
-            <a:pPr indent="0" marL="0">
-              <a:buNone/>
-            </a:pPr>
-            <a:r>
-              <a:rPr lang="en-US" sz="1100" b="1" spc="200" kern="0" dirty="0">
+            <a:pPr marL="0" indent="0">
+              <a:buNone/>
+            </a:pPr>
+            <a:r>
+              <a:rPr lang="en-US" sz="1100" b="1" kern="0" spc="200" dirty="0">
                 <a:solidFill>
                   <a:srgbClr val="12345F"/>
                 </a:solidFill>
@@ -5574,7 +5305,7 @@
           <a:bodyPr wrap="square" lIns="0" tIns="0" rIns="0" bIns="0" rtlCol="0" anchor="ctr"/>
           <a:lstStyle/>
           <a:p>
-            <a:pPr indent="0" marL="0">
+            <a:pPr marL="0" indent="0">
               <a:buNone/>
             </a:pPr>
             <a:r>
@@ -5620,7 +5351,10 @@
         </p:spPr>
         <p:txBody>
           <a:bodyPr/>
-          <a:p/>
+          <a:lstStyle/>
+          <a:p>
+            <a:endParaRPr/>
+          </a:p>
         </p:txBody>
       </p:sp>
       <p:sp>
@@ -5644,7 +5378,7 @@
           <a:bodyPr wrap="square" lIns="0" tIns="0" rIns="0" bIns="0" rtlCol="0" anchor="ctr"/>
           <a:lstStyle/>
           <a:p>
-            <a:pPr indent="0" marL="0">
+            <a:pPr marL="0" indent="0">
               <a:buNone/>
             </a:pPr>
             <a:r>
@@ -5683,7 +5417,7 @@
           <a:bodyPr wrap="square" lIns="0" tIns="0" rIns="0" bIns="0" rtlCol="0" anchor="ctr"/>
           <a:lstStyle/>
           <a:p>
-            <a:pPr indent="0" marL="0">
+            <a:pPr marL="0" indent="0">
               <a:buNone/>
             </a:pPr>
             <a:r>
@@ -5722,7 +5456,7 @@
           <a:bodyPr wrap="square" lIns="0" tIns="0" rIns="0" bIns="0" rtlCol="0" anchor="ctr"/>
           <a:lstStyle/>
           <a:p>
-            <a:pPr indent="0" marL="0">
+            <a:pPr marL="0" indent="0">
               <a:buNone/>
             </a:pPr>
             <a:r>
@@ -5768,7 +5502,10 @@
         </p:spPr>
         <p:txBody>
           <a:bodyPr/>
-          <a:p/>
+          <a:lstStyle/>
+          <a:p>
+            <a:endParaRPr/>
+          </a:p>
         </p:txBody>
       </p:sp>
       <p:sp>
@@ -5792,7 +5529,7 @@
           <a:bodyPr wrap="square" lIns="0" tIns="0" rIns="0" bIns="0" rtlCol="0" anchor="ctr"/>
           <a:lstStyle/>
           <a:p>
-            <a:pPr indent="0" marL="0">
+            <a:pPr marL="0" indent="0">
               <a:buNone/>
             </a:pPr>
             <a:r>
@@ -5831,7 +5568,7 @@
           <a:bodyPr wrap="square" lIns="0" tIns="0" rIns="0" bIns="0" rtlCol="0" anchor="ctr"/>
           <a:lstStyle/>
           <a:p>
-            <a:pPr indent="0" marL="0">
+            <a:pPr marL="0" indent="0">
               <a:buNone/>
             </a:pPr>
             <a:r>
@@ -5870,7 +5607,7 @@
           <a:bodyPr wrap="square" lIns="0" tIns="0" rIns="0" bIns="0" rtlCol="0" anchor="ctr"/>
           <a:lstStyle/>
           <a:p>
-            <a:pPr indent="0" marL="0">
+            <a:pPr marL="0" indent="0">
               <a:buNone/>
             </a:pPr>
             <a:r>
@@ -5909,7 +5646,7 @@
           <a:bodyPr wrap="square" lIns="0" tIns="0" rIns="0" bIns="0" rtlCol="0" anchor="ctr"/>
           <a:lstStyle/>
           <a:p>
-            <a:pPr indent="0" marL="0">
+            <a:pPr marL="0" indent="0">
               <a:buNone/>
             </a:pPr>
             <a:r>
@@ -5929,7 +5666,7 @@
       </p:sp>
       <p:graphicFrame>
         <p:nvGraphicFramePr>
-          <p:cNvPr id="13" name="Chart 0" descr=""/>
+          <p:cNvPr id="13" name="Chart 0"/>
           <p:cNvGraphicFramePr/>
           <p:nvPr/>
         </p:nvGraphicFramePr>
@@ -5937,9 +5674,9 @@
           <a:off x="4343400" y="1463040"/>
           <a:ext cx="7178040" cy="4526280"/>
         </p:xfrm>
-        <a:graphic xmlns:a="http://schemas.openxmlformats.org/drawingml/2006/main">
+        <a:graphic>
           <a:graphicData uri="http://schemas.openxmlformats.org/drawingml/2006/chart">
-            <c:chart xmlns:c="http://schemas.openxmlformats.org/drawingml/2006/chart" r:id="rId1"/>
+            <c:chart xmlns:c="http://schemas.openxmlformats.org/drawingml/2006/chart" xmlns:r="http://schemas.openxmlformats.org/officeDocument/2006/relationships" r:id="rId3"/>
           </a:graphicData>
         </a:graphic>
       </p:graphicFrame>
@@ -5951,7 +5688,7 @@
         </p:nvSpPr>
         <p:spPr>
           <a:xfrm>
-            <a:off x="640080" y="6236208"/>
+            <a:off x="640080" y="6419088"/>
             <a:ext cx="10881360" cy="365760"/>
           </a:xfrm>
           <a:prstGeom prst="rect">
@@ -5964,11 +5701,11 @@
           <a:bodyPr wrap="square" lIns="0" tIns="0" rIns="0" bIns="0" rtlCol="0" anchor="ctr"/>
           <a:lstStyle/>
           <a:p>
-            <a:pPr indent="0" marL="0">
-              <a:buNone/>
-            </a:pPr>
-            <a:r>
-              <a:rPr lang="en-US" sz="1000" dirty="0">
+            <a:pPr marL="0" indent="0">
+              <a:buNone/>
+            </a:pPr>
+            <a:r>
+              <a:rPr lang="en-US" sz="1400" b="1" dirty="0">
                 <a:solidFill>
                   <a:srgbClr val="0B0B0B"/>
                 </a:solidFill>
@@ -5978,7 +5715,7 @@
               </a:rPr>
               <a:t>Une agence n’est pas qu’un point de vente : c’est le lieu de la souscription, du SAV et de la réclamation.</a:t>
             </a:r>
-            <a:endParaRPr lang="en-US" sz="1000" dirty="0"/>
+            <a:endParaRPr lang="en-US" sz="1400" b="1" dirty="0"/>
           </a:p>
         </p:txBody>
       </p:sp>
@@ -6036,11 +5773,11 @@
           <a:bodyPr wrap="square" lIns="0" tIns="0" rIns="0" bIns="0" rtlCol="0" anchor="ctr"/>
           <a:lstStyle/>
           <a:p>
-            <a:pPr indent="0" marL="0">
-              <a:buNone/>
-            </a:pPr>
-            <a:r>
-              <a:rPr lang="en-US" sz="1100" b="1" spc="200" kern="0" dirty="0">
+            <a:pPr marL="0" indent="0">
+              <a:buNone/>
+            </a:pPr>
+            <a:r>
+              <a:rPr lang="en-US" sz="1100" b="1" kern="0" spc="200" dirty="0">
                 <a:solidFill>
                   <a:srgbClr val="12345F"/>
                 </a:solidFill>
@@ -6075,7 +5812,7 @@
           <a:bodyPr wrap="square" lIns="0" tIns="0" rIns="0" bIns="0" rtlCol="0" anchor="ctr"/>
           <a:lstStyle/>
           <a:p>
-            <a:pPr indent="0" marL="0">
+            <a:pPr marL="0" indent="0">
               <a:buNone/>
             </a:pPr>
             <a:r>
@@ -6095,14 +5832,14 @@
       </p:sp>
       <p:pic>
         <p:nvPicPr>
-          <p:cNvPr id="4" name="Image 0" descr="img/carte_distance.png">    </p:cNvPr>
+          <p:cNvPr id="4" name="Image 0" descr="img/carte_distance.png"/>
           <p:cNvPicPr>
             <a:picLocks noChangeAspect="1"/>
           </p:cNvPicPr>
           <p:nvPr/>
         </p:nvPicPr>
         <p:blipFill>
-          <a:blip r:embed="rId1"/>
+          <a:blip r:embed="rId3"/>
           <a:stretch>
             <a:fillRect/>
           </a:stretch>
@@ -6145,7 +5882,10 @@
         </p:spPr>
         <p:txBody>
           <a:bodyPr/>
-          <a:p/>
+          <a:lstStyle/>
+          <a:p>
+            <a:endParaRPr/>
+          </a:p>
         </p:txBody>
       </p:sp>
       <p:sp>
@@ -6169,7 +5909,7 @@
           <a:bodyPr wrap="square" lIns="0" tIns="0" rIns="0" bIns="0" rtlCol="0" anchor="ctr"/>
           <a:lstStyle/>
           <a:p>
-            <a:pPr indent="0" marL="0">
+            <a:pPr marL="0" indent="0">
               <a:buNone/>
             </a:pPr>
             <a:r>
@@ -6208,7 +5948,7 @@
           <a:bodyPr wrap="square" lIns="0" tIns="0" rIns="0" bIns="0" rtlCol="0" anchor="ctr"/>
           <a:lstStyle/>
           <a:p>
-            <a:pPr indent="0" marL="0">
+            <a:pPr marL="0" indent="0">
               <a:buNone/>
             </a:pPr>
             <a:r>
@@ -6247,7 +5987,7 @@
           <a:bodyPr wrap="square" lIns="0" tIns="0" rIns="0" bIns="0" rtlCol="0" anchor="ctr"/>
           <a:lstStyle/>
           <a:p>
-            <a:pPr indent="0" marL="0">
+            <a:pPr marL="0" indent="0">
               <a:buNone/>
             </a:pPr>
             <a:r>
@@ -6293,7 +6033,10 @@
         </p:spPr>
         <p:txBody>
           <a:bodyPr/>
-          <a:p/>
+          <a:lstStyle/>
+          <a:p>
+            <a:endParaRPr/>
+          </a:p>
         </p:txBody>
       </p:sp>
       <p:sp>
@@ -6317,7 +6060,7 @@
           <a:bodyPr wrap="square" lIns="0" tIns="0" rIns="0" bIns="0" rtlCol="0" anchor="ctr"/>
           <a:lstStyle/>
           <a:p>
-            <a:pPr indent="0" marL="0">
+            <a:pPr marL="0" indent="0">
               <a:buNone/>
             </a:pPr>
             <a:r>
@@ -6356,7 +6099,7 @@
           <a:bodyPr wrap="square" lIns="0" tIns="0" rIns="0" bIns="0" rtlCol="0" anchor="ctr"/>
           <a:lstStyle/>
           <a:p>
-            <a:pPr indent="0" marL="0">
+            <a:pPr marL="0" indent="0">
               <a:buNone/>
             </a:pPr>
             <a:r>
@@ -6395,7 +6138,7 @@
           <a:bodyPr wrap="square" lIns="0" tIns="0" rIns="0" bIns="0" rtlCol="0" anchor="ctr"/>
           <a:lstStyle/>
           <a:p>
-            <a:pPr indent="0" marL="0">
+            <a:pPr marL="0" indent="0">
               <a:buNone/>
             </a:pPr>
             <a:r>
@@ -6441,7 +6184,10 @@
         </p:spPr>
         <p:txBody>
           <a:bodyPr/>
-          <a:p/>
+          <a:lstStyle/>
+          <a:p>
+            <a:endParaRPr/>
+          </a:p>
         </p:txBody>
       </p:sp>
       <p:sp>
@@ -6465,7 +6211,7 @@
           <a:bodyPr wrap="square" lIns="0" tIns="0" rIns="0" bIns="0" rtlCol="0" anchor="ctr"/>
           <a:lstStyle/>
           <a:p>
-            <a:pPr indent="0" marL="0">
+            <a:pPr marL="0" indent="0">
               <a:buNone/>
             </a:pPr>
             <a:r>
@@ -6477,7 +6223,29 @@
                 <a:ea typeface="Cambria" pitchFamily="34" charset="-122"/>
                 <a:cs typeface="Cambria" pitchFamily="34" charset="-120"/>
               </a:rPr>
-              <a:t>L’écart entre ces deux chiffres est un résultat, pas un détail : il mesure exactement ce que le réseau d’agents privés compense là où les opérateurs ne vont pas.</a:t>
+              <a:t>L’écart entre ces deux chiffres est un résultat, pas un </a:t>
+            </a:r>
+            <a:r>
+              <a:rPr lang="en-US" sz="1450" i="1" dirty="0" err="1">
+                <a:solidFill>
+                  <a:srgbClr val="FFFFFF"/>
+                </a:solidFill>
+                <a:latin typeface="Aptos" pitchFamily="34" charset="0"/>
+                <a:ea typeface="Cambria" pitchFamily="34" charset="-122"/>
+                <a:cs typeface="Cambria" pitchFamily="34" charset="-120"/>
+              </a:rPr>
+              <a:t>détail</a:t>
+            </a:r>
+            <a:r>
+              <a:rPr lang="en-US" sz="1450" i="1" dirty="0">
+                <a:solidFill>
+                  <a:srgbClr val="FFFFFF"/>
+                </a:solidFill>
+                <a:latin typeface="Aptos" pitchFamily="34" charset="0"/>
+                <a:ea typeface="Cambria" pitchFamily="34" charset="-122"/>
+                <a:cs typeface="Cambria" pitchFamily="34" charset="-120"/>
+              </a:rPr>
+              <a:t> : il mesure exactement ce que le réseau d’agents privés compense là où les opérateurs ne vont pas.</a:t>
             </a:r>
             <a:endParaRPr lang="en-US" sz="1450" dirty="0"/>
           </a:p>
@@ -6504,7 +6272,7 @@
           <a:bodyPr wrap="square" lIns="0" tIns="0" rIns="0" bIns="0" rtlCol="0" anchor="ctr"/>
           <a:lstStyle/>
           <a:p>
-            <a:pPr indent="0" marL="0">
+            <a:pPr marL="0" indent="0">
               <a:lnSpc>
                 <a:spcPts val="1700"/>
               </a:lnSpc>
@@ -6521,41 +6289,35 @@
               </a:rPr>
               <a:t>23 cantons sur 396</a:t>
             </a:r>
-            <a:pPr indent="0" marL="0">
+            <a:r>
+              <a:rPr lang="en-US" sz="1250" dirty="0">
+                <a:solidFill>
+                  <a:srgbClr val="0B0B0B"/>
+                </a:solidFill>
+                <a:latin typeface="Aptos" pitchFamily="34" charset="0"/>
+                <a:ea typeface="Calibri" pitchFamily="34" charset="-122"/>
+                <a:cs typeface="Calibri" pitchFamily="34" charset="-120"/>
+              </a:rPr>
+              <a:t> ne comptent aucun point de service. Le plus isolé, dans Blitta, est à 21 km du premier service quel qu’il soit.</a:t>
+            </a:r>
+            <a:endParaRPr lang="en-US" sz="1250" dirty="0"/>
+          </a:p>
+          <a:p>
+            <a:pPr marL="0" indent="0">
               <a:lnSpc>
                 <a:spcPts val="1700"/>
               </a:lnSpc>
               <a:buNone/>
             </a:pPr>
-            <a:r>
-              <a:rPr lang="en-US" sz="1250" dirty="0">
-                <a:solidFill>
-                  <a:srgbClr val="0B0B0B"/>
-                </a:solidFill>
-                <a:latin typeface="Aptos" pitchFamily="34" charset="0"/>
-                <a:ea typeface="Calibri" pitchFamily="34" charset="-122"/>
-                <a:cs typeface="Calibri" pitchFamily="34" charset="-120"/>
-              </a:rPr>
-              <a:t> ne comptent aucun point de service. Le plus isolé, dans Blitta, est à 21 km du premier service quel qu’il soit.</a:t>
-            </a:r>
             <a:endParaRPr lang="en-US" sz="1250" dirty="0"/>
           </a:p>
           <a:p>
-            <a:pPr indent="0" marL="0">
+            <a:pPr marL="0" indent="0">
               <a:lnSpc>
                 <a:spcPts val="1700"/>
               </a:lnSpc>
               <a:buNone/>
             </a:pPr>
-            <a:endParaRPr lang="en-US" sz="1250" dirty="0"/>
-          </a:p>
-          <a:p>
-            <a:pPr indent="0" marL="0">
-              <a:lnSpc>
-                <a:spcPts val="1700"/>
-              </a:lnSpc>
-              <a:buNone/>
-            </a:pPr>
             <a:r>
               <a:rPr lang="en-US" sz="1250" dirty="0">
                 <a:solidFill>
@@ -6565,7 +6327,29 @@
                 <a:ea typeface="Calibri" pitchFamily="34" charset="-122"/>
                 <a:cs typeface="Calibri" pitchFamily="34" charset="-120"/>
               </a:rPr>
-              <a:t>Ces écarts sont invisibles à l’échelle de la préfecture, qui les moyenne. Changer d’échelle change la carte des priorités — c’est pourquoi les deux sont présentées.</a:t>
+              <a:t>Ces écarts sont invisibles à l’échelle de la préfecture, qui les moyenne. Changer d’échelle change la carte des </a:t>
+            </a:r>
+            <a:r>
+              <a:rPr lang="en-US" sz="1250" dirty="0" err="1">
+                <a:solidFill>
+                  <a:srgbClr val="0B0B0B"/>
+                </a:solidFill>
+                <a:latin typeface="Aptos" pitchFamily="34" charset="0"/>
+                <a:ea typeface="Calibri" pitchFamily="34" charset="-122"/>
+                <a:cs typeface="Calibri" pitchFamily="34" charset="-120"/>
+              </a:rPr>
+              <a:t>priorités</a:t>
+            </a:r>
+            <a:r>
+              <a:rPr lang="en-US" sz="1250" dirty="0">
+                <a:solidFill>
+                  <a:srgbClr val="0B0B0B"/>
+                </a:solidFill>
+                <a:latin typeface="Aptos" pitchFamily="34" charset="0"/>
+                <a:ea typeface="Calibri" pitchFamily="34" charset="-122"/>
+                <a:cs typeface="Calibri" pitchFamily="34" charset="-120"/>
+              </a:rPr>
+              <a:t>.</a:t>
             </a:r>
             <a:endParaRPr lang="en-US" sz="1250" dirty="0"/>
           </a:p>
@@ -6592,11 +6376,11 @@
           <a:bodyPr wrap="square" lIns="0" tIns="0" rIns="0" bIns="0" rtlCol="0" anchor="ctr"/>
           <a:lstStyle/>
           <a:p>
-            <a:pPr indent="0" marL="0">
-              <a:buNone/>
-            </a:pPr>
-            <a:r>
-              <a:rPr lang="en-US" sz="1000" dirty="0">
+            <a:pPr marL="0" indent="0">
+              <a:buNone/>
+            </a:pPr>
+            <a:r>
+              <a:rPr lang="en-US" sz="1200" b="1" dirty="0">
                 <a:solidFill>
                   <a:srgbClr val="0B0B0B"/>
                 </a:solidFill>
@@ -6606,7 +6390,7 @@
               </a:rPr>
               <a:t>Couverture radio indisponible (couches Géoportail en accès restreint) : la zone blanche est définie par la distance au service, depuis le centroïde du canton.</a:t>
             </a:r>
-            <a:endParaRPr lang="en-US" sz="1000" dirty="0"/>
+            <a:endParaRPr lang="en-US" sz="1200" b="1" dirty="0"/>
           </a:p>
         </p:txBody>
       </p:sp>
@@ -6664,11 +6448,11 @@
           <a:bodyPr wrap="square" lIns="0" tIns="0" rIns="0" bIns="0" rtlCol="0" anchor="ctr"/>
           <a:lstStyle/>
           <a:p>
-            <a:pPr indent="0" marL="0">
-              <a:buNone/>
-            </a:pPr>
-            <a:r>
-              <a:rPr lang="en-US" sz="1100" b="1" spc="200" kern="0" dirty="0">
+            <a:pPr marL="0" indent="0">
+              <a:buNone/>
+            </a:pPr>
+            <a:r>
+              <a:rPr lang="en-US" sz="1100" b="1" kern="0" spc="200" dirty="0">
                 <a:solidFill>
                   <a:srgbClr val="12345F"/>
                 </a:solidFill>
@@ -6703,7 +6487,7 @@
           <a:bodyPr wrap="square" lIns="0" tIns="0" rIns="0" bIns="0" rtlCol="0" anchor="ctr"/>
           <a:lstStyle/>
           <a:p>
-            <a:pPr indent="0" marL="0">
+            <a:pPr marL="0" indent="0">
               <a:buNone/>
             </a:pPr>
             <a:r>
@@ -6723,14 +6507,14 @@
       </p:sp>
       <p:pic>
         <p:nvPicPr>
-          <p:cNvPr id="4" name="Image 0" descr="img/lorenz.png">    </p:cNvPr>
+          <p:cNvPr id="4" name="Image 0" descr="img/lorenz.png"/>
           <p:cNvPicPr>
             <a:picLocks noChangeAspect="1"/>
           </p:cNvPicPr>
           <p:nvPr/>
         </p:nvPicPr>
         <p:blipFill>
-          <a:blip r:embed="rId1"/>
+          <a:blip r:embed="rId3"/>
           <a:stretch>
             <a:fillRect/>
           </a:stretch>
@@ -6773,7 +6557,10 @@
         </p:spPr>
         <p:txBody>
           <a:bodyPr/>
-          <a:p/>
+          <a:lstStyle/>
+          <a:p>
+            <a:endParaRPr/>
+          </a:p>
         </p:txBody>
       </p:sp>
       <p:sp>
@@ -6797,7 +6584,7 @@
           <a:bodyPr wrap="square" lIns="0" tIns="0" rIns="0" bIns="0" rtlCol="0" anchor="ctr"/>
           <a:lstStyle/>
           <a:p>
-            <a:pPr indent="0" marL="0">
+            <a:pPr marL="0" indent="0">
               <a:buNone/>
             </a:pPr>
             <a:r>
@@ -6836,7 +6623,7 @@
           <a:bodyPr wrap="square" lIns="0" tIns="0" rIns="0" bIns="0" rtlCol="0" anchor="ctr"/>
           <a:lstStyle/>
           <a:p>
-            <a:pPr indent="0" marL="0">
+            <a:pPr marL="0" indent="0">
               <a:buNone/>
             </a:pPr>
             <a:r>
@@ -6875,7 +6662,7 @@
           <a:bodyPr wrap="square" lIns="0" tIns="0" rIns="0" bIns="0" rtlCol="0" anchor="ctr"/>
           <a:lstStyle/>
           <a:p>
-            <a:pPr indent="0" marL="0">
+            <a:pPr marL="0" indent="0">
               <a:buNone/>
             </a:pPr>
             <a:r>
@@ -6921,7 +6708,10 @@
         </p:spPr>
         <p:txBody>
           <a:bodyPr/>
-          <a:p/>
+          <a:lstStyle/>
+          <a:p>
+            <a:endParaRPr/>
+          </a:p>
         </p:txBody>
       </p:sp>
       <p:sp>
@@ -6945,7 +6735,7 @@
           <a:bodyPr wrap="square" lIns="0" tIns="0" rIns="0" bIns="0" rtlCol="0" anchor="ctr"/>
           <a:lstStyle/>
           <a:p>
-            <a:pPr indent="0" marL="0">
+            <a:pPr marL="0" indent="0">
               <a:buNone/>
             </a:pPr>
             <a:r>
@@ -6984,7 +6774,7 @@
           <a:bodyPr wrap="square" lIns="0" tIns="0" rIns="0" bIns="0" rtlCol="0" anchor="ctr"/>
           <a:lstStyle/>
           <a:p>
-            <a:pPr indent="0" marL="0">
+            <a:pPr marL="0" indent="0">
               <a:buNone/>
             </a:pPr>
             <a:r>
@@ -7023,7 +6813,7 @@
           <a:bodyPr wrap="square" lIns="0" tIns="0" rIns="0" bIns="0" rtlCol="0" anchor="ctr"/>
           <a:lstStyle/>
           <a:p>
-            <a:pPr indent="0" marL="0">
+            <a:pPr marL="0" indent="0">
               <a:buNone/>
             </a:pPr>
             <a:r>
@@ -7062,7 +6852,7 @@
           <a:bodyPr wrap="square" lIns="0" tIns="0" rIns="0" bIns="0" rtlCol="0" anchor="ctr"/>
           <a:lstStyle/>
           <a:p>
-            <a:pPr indent="0" marL="0">
+            <a:pPr marL="0" indent="0">
               <a:lnSpc>
                 <a:spcPts val="1700"/>
               </a:lnSpc>
@@ -7082,7 +6872,7 @@
             <a:endParaRPr lang="en-US" sz="1250" dirty="0"/>
           </a:p>
           <a:p>
-            <a:pPr indent="0" marL="0">
+            <a:pPr marL="0" indent="0">
               <a:lnSpc>
                 <a:spcPts val="1700"/>
               </a:lnSpc>
@@ -7102,7 +6892,7 @@
             <a:endParaRPr lang="en-US" sz="1250" dirty="0"/>
           </a:p>
           <a:p>
-            <a:pPr indent="0" marL="0">
+            <a:pPr marL="0" indent="0">
               <a:lnSpc>
                 <a:spcPts val="1700"/>
               </a:lnSpc>
@@ -7111,7 +6901,7 @@
             <a:endParaRPr lang="en-US" sz="1250" dirty="0"/>
           </a:p>
           <a:p>
-            <a:pPr indent="0" marL="0">
+            <a:pPr marL="0" indent="0">
               <a:lnSpc>
                 <a:spcPts val="1700"/>
               </a:lnSpc>
@@ -7153,7 +6943,7 @@
           <a:bodyPr wrap="square" lIns="0" tIns="0" rIns="0" bIns="0" rtlCol="0" anchor="ctr"/>
           <a:lstStyle/>
           <a:p>
-            <a:pPr indent="0" marL="0">
+            <a:pPr marL="0" indent="0">
               <a:buNone/>
             </a:pPr>
             <a:r>
@@ -7225,11 +7015,11 @@
           <a:bodyPr wrap="square" lIns="0" tIns="0" rIns="0" bIns="0" rtlCol="0" anchor="ctr"/>
           <a:lstStyle/>
           <a:p>
-            <a:pPr indent="0" marL="0">
-              <a:buNone/>
-            </a:pPr>
-            <a:r>
-              <a:rPr lang="en-US" sz="1100" b="1" spc="200" kern="0" dirty="0">
+            <a:pPr marL="0" indent="0">
+              <a:buNone/>
+            </a:pPr>
+            <a:r>
+              <a:rPr lang="en-US" sz="1100" b="1" kern="0" spc="200" dirty="0">
                 <a:solidFill>
                   <a:srgbClr val="12345F"/>
                 </a:solidFill>
@@ -7264,7 +7054,7 @@
           <a:bodyPr wrap="square" lIns="0" tIns="0" rIns="0" bIns="0" rtlCol="0" anchor="ctr"/>
           <a:lstStyle/>
           <a:p>
-            <a:pPr indent="0" marL="0">
+            <a:pPr marL="0" indent="0">
               <a:buNone/>
             </a:pPr>
             <a:r>
@@ -7310,7 +7100,10 @@
         </p:spPr>
         <p:txBody>
           <a:bodyPr/>
-          <a:p/>
+          <a:lstStyle/>
+          <a:p>
+            <a:endParaRPr/>
+          </a:p>
         </p:txBody>
       </p:sp>
       <p:sp>
@@ -7334,7 +7127,7 @@
           <a:bodyPr wrap="square" lIns="0" tIns="0" rIns="0" bIns="0" rtlCol="0" anchor="ctr"/>
           <a:lstStyle/>
           <a:p>
-            <a:pPr indent="0" marL="0">
+            <a:pPr marL="0" indent="0">
               <a:buNone/>
             </a:pPr>
             <a:r>
@@ -7373,7 +7166,7 @@
           <a:bodyPr wrap="square" lIns="0" tIns="0" rIns="0" bIns="0" rtlCol="0" anchor="ctr"/>
           <a:lstStyle/>
           <a:p>
-            <a:pPr indent="0" marL="0">
+            <a:pPr marL="0" indent="0">
               <a:buNone/>
             </a:pPr>
             <a:r>
@@ -7412,7 +7205,7 @@
           <a:bodyPr wrap="square" lIns="0" tIns="0" rIns="0" bIns="0" rtlCol="0" anchor="ctr"/>
           <a:lstStyle/>
           <a:p>
-            <a:pPr indent="0" marL="0">
+            <a:pPr marL="0" indent="0">
               <a:buNone/>
             </a:pPr>
             <a:r>
@@ -7429,7 +7222,7 @@
             <a:endParaRPr lang="en-US" sz="1200" dirty="0"/>
           </a:p>
           <a:p>
-            <a:pPr indent="0" marL="0">
+            <a:pPr marL="0" indent="0">
               <a:buNone/>
             </a:pPr>
             <a:r>
@@ -7468,7 +7261,7 @@
           <a:bodyPr wrap="square" lIns="0" tIns="0" rIns="0" bIns="0" rtlCol="0" anchor="ctr"/>
           <a:lstStyle/>
           <a:p>
-            <a:pPr indent="0" marL="0">
+            <a:pPr marL="0" indent="0">
               <a:lnSpc>
                 <a:spcPts val="1600"/>
               </a:lnSpc>
@@ -7488,7 +7281,7 @@
             <a:endParaRPr lang="en-US" sz="1200" dirty="0"/>
           </a:p>
           <a:p>
-            <a:pPr indent="0" marL="0">
+            <a:pPr marL="0" indent="0">
               <a:lnSpc>
                 <a:spcPts val="1600"/>
               </a:lnSpc>
@@ -7508,7 +7301,7 @@
             <a:endParaRPr lang="en-US" sz="1200" dirty="0"/>
           </a:p>
           <a:p>
-            <a:pPr indent="0" marL="0">
+            <a:pPr marL="0" indent="0">
               <a:lnSpc>
                 <a:spcPts val="1600"/>
               </a:lnSpc>
@@ -7517,7 +7310,7 @@
             <a:endParaRPr lang="en-US" sz="1200" dirty="0"/>
           </a:p>
           <a:p>
-            <a:pPr indent="0" marL="0">
+            <a:pPr marL="0" indent="0">
               <a:lnSpc>
                 <a:spcPts val="1600"/>
               </a:lnSpc>
@@ -7532,12 +7325,12 @@
                 <a:ea typeface="Calibri" pitchFamily="34" charset="-122"/>
                 <a:cs typeface="Calibri" pitchFamily="34" charset="-120"/>
               </a:rPr>
-              <a:t>À l’inverse, les préfectures les mieux dotées sont les chefs-lieux régionaux : Sokodé (2,4×), Kara (2,3×), Cinkassé (1,7×) — devant Lomé.</a:t>
+              <a:t>À l’inverse, les préfectures les mieux dotées sont les chefs-lieux régionaux : Sokodé (2,4×), Kara (2,3×), Cinkassé (1,7×), devant Lomé.</a:t>
             </a:r>
             <a:endParaRPr lang="en-US" sz="1200" dirty="0"/>
           </a:p>
           <a:p>
-            <a:pPr indent="0" marL="0">
+            <a:pPr marL="0" indent="0">
               <a:lnSpc>
                 <a:spcPts val="1600"/>
               </a:lnSpc>
@@ -7546,7 +7339,7 @@
             <a:endParaRPr lang="en-US" sz="1200" dirty="0"/>
           </a:p>
           <a:p>
-            <a:pPr indent="0" marL="0">
+            <a:pPr marL="0" indent="0">
               <a:lnSpc>
                 <a:spcPts val="1600"/>
               </a:lnSpc>
@@ -7569,7 +7362,7 @@
       </p:sp>
       <p:graphicFrame>
         <p:nvGraphicFramePr>
-          <p:cNvPr id="9" name="Chart 0" descr=""/>
+          <p:cNvPr id="9" name="Chart 0"/>
           <p:cNvGraphicFramePr/>
           <p:nvPr/>
         </p:nvGraphicFramePr>
@@ -7577,9 +7370,9 @@
           <a:off x="4846320" y="1554480"/>
           <a:ext cx="6675120" cy="4480560"/>
         </p:xfrm>
-        <a:graphic xmlns:a="http://schemas.openxmlformats.org/drawingml/2006/main">
+        <a:graphic>
           <a:graphicData uri="http://schemas.openxmlformats.org/drawingml/2006/chart">
-            <c:chart xmlns:c="http://schemas.openxmlformats.org/drawingml/2006/chart" r:id="rId1"/>
+            <c:chart xmlns:c="http://schemas.openxmlformats.org/drawingml/2006/chart" xmlns:r="http://schemas.openxmlformats.org/officeDocument/2006/relationships" r:id="rId3"/>
           </a:graphicData>
         </a:graphic>
       </p:graphicFrame>
@@ -7591,7 +7384,7 @@
         </p:nvSpPr>
         <p:spPr>
           <a:xfrm>
-            <a:off x="640080" y="6236208"/>
+            <a:off x="640080" y="6369558"/>
             <a:ext cx="10881360" cy="365760"/>
           </a:xfrm>
           <a:prstGeom prst="rect">
@@ -7604,11 +7397,11 @@
           <a:bodyPr wrap="square" lIns="0" tIns="0" rIns="0" bIns="0" rtlCol="0" anchor="ctr"/>
           <a:lstStyle/>
           <a:p>
-            <a:pPr indent="0" marL="0">
-              <a:buNone/>
-            </a:pPr>
-            <a:r>
-              <a:rPr lang="en-US" sz="1000" dirty="0">
+            <a:pPr marL="0" indent="0">
+              <a:buNone/>
+            </a:pPr>
+            <a:r>
+              <a:rPr lang="en-US" sz="1200" b="1" dirty="0">
                 <a:solidFill>
                   <a:srgbClr val="0B0B0B"/>
                 </a:solidFill>
@@ -7618,7 +7411,7 @@
               </a:rPr>
               <a:t>« Attendu » = répartition strictement proportionnelle à la population. Hypothèse normative explicite, pas une vérité économique.</a:t>
             </a:r>
-            <a:endParaRPr lang="en-US" sz="1000" dirty="0"/>
+            <a:endParaRPr lang="en-US" sz="1200" b="1" dirty="0"/>
           </a:p>
         </p:txBody>
       </p:sp>
@@ -7676,11 +7469,11 @@
           <a:bodyPr wrap="square" lIns="0" tIns="0" rIns="0" bIns="0" rtlCol="0" anchor="ctr"/>
           <a:lstStyle/>
           <a:p>
-            <a:pPr indent="0" marL="0">
-              <a:buNone/>
-            </a:pPr>
-            <a:r>
-              <a:rPr lang="en-US" sz="1100" b="1" spc="200" kern="0" dirty="0">
+            <a:pPr marL="0" indent="0">
+              <a:buNone/>
+            </a:pPr>
+            <a:r>
+              <a:rPr lang="en-US" sz="1100" b="1" kern="0" spc="200" dirty="0">
                 <a:solidFill>
                   <a:srgbClr val="12345F"/>
                 </a:solidFill>
@@ -7715,7 +7508,7 @@
           <a:bodyPr wrap="square" lIns="0" tIns="0" rIns="0" bIns="0" rtlCol="0" anchor="ctr"/>
           <a:lstStyle/>
           <a:p>
-            <a:pPr indent="0" marL="0">
+            <a:pPr marL="0" indent="0">
               <a:buNone/>
             </a:pPr>
             <a:r>
@@ -7761,7 +7554,10 @@
         </p:spPr>
         <p:txBody>
           <a:bodyPr/>
-          <a:p/>
+          <a:lstStyle/>
+          <a:p>
+            <a:endParaRPr/>
+          </a:p>
         </p:txBody>
       </p:sp>
       <p:sp>
@@ -7785,7 +7581,7 @@
           <a:bodyPr wrap="square" lIns="0" tIns="0" rIns="0" bIns="0" rtlCol="0" anchor="ctr"/>
           <a:lstStyle/>
           <a:p>
-            <a:pPr indent="0" marL="0">
+            <a:pPr marL="0" indent="0">
               <a:buNone/>
             </a:pPr>
             <a:r>
@@ -7824,7 +7620,7 @@
           <a:bodyPr wrap="square" lIns="0" tIns="0" rIns="0" bIns="0" rtlCol="0" anchor="ctr"/>
           <a:lstStyle/>
           <a:p>
-            <a:pPr indent="0" marL="0">
+            <a:pPr marL="0" indent="0">
               <a:lnSpc>
                 <a:spcPts val="1600"/>
               </a:lnSpc>
@@ -7844,7 +7640,7 @@
             <a:endParaRPr lang="en-US" sz="1200" dirty="0"/>
           </a:p>
           <a:p>
-            <a:pPr indent="0" marL="0">
+            <a:pPr marL="0" indent="0">
               <a:lnSpc>
                 <a:spcPts val="1600"/>
               </a:lnSpc>
@@ -7864,7 +7660,7 @@
             <a:endParaRPr lang="en-US" sz="1200" dirty="0"/>
           </a:p>
           <a:p>
-            <a:pPr indent="0" marL="0">
+            <a:pPr marL="0" indent="0">
               <a:lnSpc>
                 <a:spcPts val="1600"/>
               </a:lnSpc>
@@ -7873,7 +7669,7 @@
             <a:endParaRPr lang="en-US" sz="1200" dirty="0"/>
           </a:p>
           <a:p>
-            <a:pPr indent="0" marL="0">
+            <a:pPr marL="0" indent="0">
               <a:lnSpc>
                 <a:spcPts val="1600"/>
               </a:lnSpc>
@@ -7888,12 +7684,12 @@
                 <a:ea typeface="Calibri" pitchFamily="34" charset="-122"/>
                 <a:cs typeface="Calibri" pitchFamily="34" charset="-120"/>
               </a:rPr>
-              <a:t>α = 0 classe au déficit brut ; α = 1 privilégie le nombre d’habitants touchés. La valeur retenue, 0,5, est un compromis — et il est réglable en direct dans le tableau de bord.</a:t>
+              <a:t>α = 0 classe au déficit brut ; α = 1 privilégie le nombre d’habitants touchés. La valeur retenue, 0,5, est un compromise, et il est réglable en direct dans le tableau de bord.</a:t>
             </a:r>
             <a:endParaRPr lang="en-US" sz="1200" dirty="0"/>
           </a:p>
           <a:p>
-            <a:pPr indent="0" marL="0">
+            <a:pPr marL="0" indent="0">
               <a:lnSpc>
                 <a:spcPts val="1600"/>
               </a:lnSpc>
@@ -7902,7 +7698,7 @@
             <a:endParaRPr lang="en-US" sz="1200" dirty="0"/>
           </a:p>
           <a:p>
-            <a:pPr indent="0" marL="0">
+            <a:pPr marL="0" indent="0">
               <a:lnSpc>
                 <a:spcPts val="1600"/>
               </a:lnSpc>
@@ -7917,7 +7713,51 @@
                 <a:ea typeface="Calibri" pitchFamily="34" charset="-122"/>
                 <a:cs typeface="Calibri" pitchFamily="34" charset="-120"/>
               </a:rPr>
-              <a:t>Ce choix est un arbitrage politique, pas un résultat statistique. Il est exposé, pas dissimulé.</a:t>
+              <a:t>Ce choix est un arbitrage politique, pas un </a:t>
+            </a:r>
+            <a:r>
+              <a:rPr lang="en-US" sz="1200" b="1" dirty="0" err="1">
+                <a:solidFill>
+                  <a:srgbClr val="0B0B0B"/>
+                </a:solidFill>
+                <a:latin typeface="Aptos" pitchFamily="34" charset="0"/>
+                <a:ea typeface="Calibri" pitchFamily="34" charset="-122"/>
+                <a:cs typeface="Calibri" pitchFamily="34" charset="-120"/>
+              </a:rPr>
+              <a:t>résultat</a:t>
+            </a:r>
+            <a:r>
+              <a:rPr lang="en-US" sz="1200" b="1" dirty="0">
+                <a:solidFill>
+                  <a:srgbClr val="0B0B0B"/>
+                </a:solidFill>
+                <a:latin typeface="Aptos" pitchFamily="34" charset="0"/>
+                <a:ea typeface="Calibri" pitchFamily="34" charset="-122"/>
+                <a:cs typeface="Calibri" pitchFamily="34" charset="-120"/>
+              </a:rPr>
+              <a:t> </a:t>
+            </a:r>
+            <a:r>
+              <a:rPr lang="en-US" sz="1200" b="1" dirty="0" err="1">
+                <a:solidFill>
+                  <a:srgbClr val="0B0B0B"/>
+                </a:solidFill>
+                <a:latin typeface="Aptos" pitchFamily="34" charset="0"/>
+                <a:ea typeface="Calibri" pitchFamily="34" charset="-122"/>
+                <a:cs typeface="Calibri" pitchFamily="34" charset="-120"/>
+              </a:rPr>
+              <a:t>statistique</a:t>
+            </a:r>
+            <a:r>
+              <a:rPr lang="en-US" sz="1200" b="1" dirty="0">
+                <a:solidFill>
+                  <a:srgbClr val="0B0B0B"/>
+                </a:solidFill>
+                <a:latin typeface="Aptos" pitchFamily="34" charset="0"/>
+                <a:ea typeface="Calibri" pitchFamily="34" charset="-122"/>
+                <a:cs typeface="Calibri" pitchFamily="34" charset="-120"/>
+              </a:rPr>
+              <a:t>.</a:t>
             </a:r>
             <a:endParaRPr lang="en-US" sz="1200" dirty="0"/>
           </a:p>
@@ -7925,7 +7765,7 @@
       </p:sp>
       <p:graphicFrame>
         <p:nvGraphicFramePr>
-          <p:cNvPr id="7" name="Chart 0" descr=""/>
+          <p:cNvPr id="7" name="Chart 0"/>
           <p:cNvGraphicFramePr/>
           <p:nvPr/>
         </p:nvGraphicFramePr>
@@ -7933,9 +7773,9 @@
           <a:off x="4846320" y="1554480"/>
           <a:ext cx="6675120" cy="4480560"/>
         </p:xfrm>
-        <a:graphic xmlns:a="http://schemas.openxmlformats.org/drawingml/2006/main">
+        <a:graphic>
           <a:graphicData uri="http://schemas.openxmlformats.org/drawingml/2006/chart">
-            <c:chart xmlns:c="http://schemas.openxmlformats.org/drawingml/2006/chart" r:id="rId1"/>
+            <c:chart xmlns:c="http://schemas.openxmlformats.org/drawingml/2006/chart" xmlns:r="http://schemas.openxmlformats.org/officeDocument/2006/relationships" r:id="rId3"/>
           </a:graphicData>
         </a:graphic>
       </p:graphicFrame>
@@ -7960,11 +7800,11 @@
           <a:bodyPr wrap="square" lIns="0" tIns="0" rIns="0" bIns="0" rtlCol="0" anchor="ctr"/>
           <a:lstStyle/>
           <a:p>
-            <a:pPr indent="0" marL="0">
-              <a:buNone/>
-            </a:pPr>
-            <a:r>
-              <a:rPr lang="en-US" sz="1000" dirty="0">
+            <a:pPr marL="0" indent="0">
+              <a:buNone/>
+            </a:pPr>
+            <a:r>
+              <a:rPr lang="en-US" sz="1100" b="1" dirty="0">
                 <a:solidFill>
                   <a:srgbClr val="0B0B0B"/>
                 </a:solidFill>
@@ -7972,9 +7812,53 @@
                 <a:ea typeface="Calibri" pitchFamily="34" charset="-122"/>
                 <a:cs typeface="Calibri" pitchFamily="34" charset="-120"/>
               </a:rPr>
-              <a:t>Aucun modèle boîte noire, aucun paramètre caché : le score se recalcule à la main à partir de la table publiée.</a:t>
-            </a:r>
-            <a:endParaRPr lang="en-US" sz="1000" dirty="0"/>
+              <a:t>Aucun modèle </a:t>
+            </a:r>
+            <a:r>
+              <a:rPr lang="en-US" sz="1100" b="1" dirty="0" err="1">
+                <a:solidFill>
+                  <a:srgbClr val="0B0B0B"/>
+                </a:solidFill>
+                <a:latin typeface="Aptos" pitchFamily="34" charset="0"/>
+                <a:ea typeface="Calibri" pitchFamily="34" charset="-122"/>
+                <a:cs typeface="Calibri" pitchFamily="34" charset="-120"/>
+              </a:rPr>
+              <a:t>boîte</a:t>
+            </a:r>
+            <a:r>
+              <a:rPr lang="en-US" sz="1100" b="1" dirty="0">
+                <a:solidFill>
+                  <a:srgbClr val="0B0B0B"/>
+                </a:solidFill>
+                <a:latin typeface="Aptos" pitchFamily="34" charset="0"/>
+                <a:ea typeface="Calibri" pitchFamily="34" charset="-122"/>
+                <a:cs typeface="Calibri" pitchFamily="34" charset="-120"/>
+              </a:rPr>
+              <a:t> noire : le score se </a:t>
+            </a:r>
+            <a:r>
+              <a:rPr lang="en-US" sz="1100" b="1" dirty="0" err="1">
+                <a:solidFill>
+                  <a:srgbClr val="0B0B0B"/>
+                </a:solidFill>
+                <a:latin typeface="Aptos" pitchFamily="34" charset="0"/>
+                <a:ea typeface="Calibri" pitchFamily="34" charset="-122"/>
+                <a:cs typeface="Calibri" pitchFamily="34" charset="-120"/>
+              </a:rPr>
+              <a:t>recalcule</a:t>
+            </a:r>
+            <a:r>
+              <a:rPr lang="en-US" sz="1100" b="1" dirty="0">
+                <a:solidFill>
+                  <a:srgbClr val="0B0B0B"/>
+                </a:solidFill>
+                <a:latin typeface="Aptos" pitchFamily="34" charset="0"/>
+                <a:ea typeface="Calibri" pitchFamily="34" charset="-122"/>
+                <a:cs typeface="Calibri" pitchFamily="34" charset="-120"/>
+              </a:rPr>
+              <a:t> à partir de la table publiée.</a:t>
+            </a:r>
+            <a:endParaRPr lang="en-US" sz="1100" b="1" dirty="0"/>
           </a:p>
         </p:txBody>
       </p:sp>
@@ -8032,11 +7916,11 @@
           <a:bodyPr wrap="square" lIns="0" tIns="0" rIns="0" bIns="0" rtlCol="0" anchor="ctr"/>
           <a:lstStyle/>
           <a:p>
-            <a:pPr indent="0" marL="0">
-              <a:buNone/>
-            </a:pPr>
-            <a:r>
-              <a:rPr lang="en-US" sz="1100" b="1" spc="200" kern="0" dirty="0">
+            <a:pPr marL="0" indent="0">
+              <a:buNone/>
+            </a:pPr>
+            <a:r>
+              <a:rPr lang="en-US" sz="1100" b="1" kern="0" spc="200" dirty="0">
                 <a:solidFill>
                   <a:srgbClr val="12345F"/>
                 </a:solidFill>
@@ -8071,7 +7955,7 @@
           <a:bodyPr wrap="square" lIns="0" tIns="0" rIns="0" bIns="0" rtlCol="0" anchor="ctr"/>
           <a:lstStyle/>
           <a:p>
-            <a:pPr indent="0" marL="0">
+            <a:pPr marL="0" indent="0">
               <a:buNone/>
             </a:pPr>
             <a:r>
@@ -8115,7 +7999,10 @@
         </p:spPr>
         <p:txBody>
           <a:bodyPr/>
-          <a:p/>
+          <a:lstStyle/>
+          <a:p>
+            <a:endParaRPr/>
+          </a:p>
         </p:txBody>
       </p:sp>
       <p:sp>
@@ -8139,7 +8026,7 @@
           <a:bodyPr wrap="square" lIns="0" tIns="0" rIns="0" bIns="0" rtlCol="0" anchor="ctr"/>
           <a:lstStyle/>
           <a:p>
-            <a:pPr algn="ctr" indent="0" marL="0">
+            <a:pPr marL="0" indent="0" algn="ctr">
               <a:buNone/>
             </a:pPr>
             <a:r>
@@ -8178,7 +8065,7 @@
           <a:bodyPr wrap="square" lIns="0" tIns="0" rIns="0" bIns="0" rtlCol="0" anchor="ctr"/>
           <a:lstStyle/>
           <a:p>
-            <a:pPr indent="0" marL="0">
+            <a:pPr marL="0" indent="0">
               <a:buNone/>
             </a:pPr>
             <a:r>
@@ -8217,7 +8104,7 @@
           <a:bodyPr wrap="square" lIns="0" tIns="0" rIns="0" bIns="0" rtlCol="0" anchor="ctr"/>
           <a:lstStyle/>
           <a:p>
-            <a:pPr indent="0" marL="0">
+            <a:pPr marL="0" indent="0">
               <a:buNone/>
             </a:pPr>
             <a:r>
@@ -8261,7 +8148,10 @@
         </p:spPr>
         <p:txBody>
           <a:bodyPr/>
-          <a:p/>
+          <a:lstStyle/>
+          <a:p>
+            <a:endParaRPr/>
+          </a:p>
         </p:txBody>
       </p:sp>
       <p:sp>
@@ -8285,7 +8175,7 @@
           <a:bodyPr wrap="square" lIns="0" tIns="0" rIns="0" bIns="0" rtlCol="0" anchor="ctr"/>
           <a:lstStyle/>
           <a:p>
-            <a:pPr algn="ctr" indent="0" marL="0">
+            <a:pPr marL="0" indent="0" algn="ctr">
               <a:buNone/>
             </a:pPr>
             <a:r>
@@ -8324,7 +8214,7 @@
           <a:bodyPr wrap="square" lIns="0" tIns="0" rIns="0" bIns="0" rtlCol="0" anchor="ctr"/>
           <a:lstStyle/>
           <a:p>
-            <a:pPr indent="0" marL="0">
+            <a:pPr marL="0" indent="0">
               <a:buNone/>
             </a:pPr>
             <a:r>
@@ -8363,7 +8253,7 @@
           <a:bodyPr wrap="square" lIns="0" tIns="0" rIns="0" bIns="0" rtlCol="0" anchor="ctr"/>
           <a:lstStyle/>
           <a:p>
-            <a:pPr indent="0" marL="0">
+            <a:pPr marL="0" indent="0">
               <a:buNone/>
             </a:pPr>
             <a:r>
@@ -8407,7 +8297,10 @@
         </p:spPr>
         <p:txBody>
           <a:bodyPr/>
-          <a:p/>
+          <a:lstStyle/>
+          <a:p>
+            <a:endParaRPr/>
+          </a:p>
         </p:txBody>
       </p:sp>
       <p:sp>
@@ -8431,7 +8324,7 @@
           <a:bodyPr wrap="square" lIns="0" tIns="0" rIns="0" bIns="0" rtlCol="0" anchor="ctr"/>
           <a:lstStyle/>
           <a:p>
-            <a:pPr algn="ctr" indent="0" marL="0">
+            <a:pPr marL="0" indent="0" algn="ctr">
               <a:buNone/>
             </a:pPr>
             <a:r>
@@ -8470,7 +8363,7 @@
           <a:bodyPr wrap="square" lIns="0" tIns="0" rIns="0" bIns="0" rtlCol="0" anchor="ctr"/>
           <a:lstStyle/>
           <a:p>
-            <a:pPr indent="0" marL="0">
+            <a:pPr marL="0" indent="0">
               <a:buNone/>
             </a:pPr>
             <a:r>
@@ -8509,7 +8402,7 @@
           <a:bodyPr wrap="square" lIns="0" tIns="0" rIns="0" bIns="0" rtlCol="0" anchor="ctr"/>
           <a:lstStyle/>
           <a:p>
-            <a:pPr indent="0" marL="0">
+            <a:pPr marL="0" indent="0">
               <a:buNone/>
             </a:pPr>
             <a:r>
@@ -8553,7 +8446,10 @@
         </p:spPr>
         <p:txBody>
           <a:bodyPr/>
-          <a:p/>
+          <a:lstStyle/>
+          <a:p>
+            <a:endParaRPr/>
+          </a:p>
         </p:txBody>
       </p:sp>
       <p:sp>
@@ -8577,7 +8473,7 @@
           <a:bodyPr wrap="square" lIns="0" tIns="0" rIns="0" bIns="0" rtlCol="0" anchor="ctr"/>
           <a:lstStyle/>
           <a:p>
-            <a:pPr algn="ctr" indent="0" marL="0">
+            <a:pPr marL="0" indent="0" algn="ctr">
               <a:buNone/>
             </a:pPr>
             <a:r>
@@ -8616,7 +8512,7 @@
           <a:bodyPr wrap="square" lIns="0" tIns="0" rIns="0" bIns="0" rtlCol="0" anchor="ctr"/>
           <a:lstStyle/>
           <a:p>
-            <a:pPr indent="0" marL="0">
+            <a:pPr marL="0" indent="0">
               <a:buNone/>
             </a:pPr>
             <a:r>
@@ -8655,7 +8551,7 @@
           <a:bodyPr wrap="square" lIns="0" tIns="0" rIns="0" bIns="0" rtlCol="0" anchor="ctr"/>
           <a:lstStyle/>
           <a:p>
-            <a:pPr indent="0" marL="0">
+            <a:pPr marL="0" indent="0">
               <a:buNone/>
             </a:pPr>
             <a:r>
@@ -8699,7 +8595,10 @@
         </p:spPr>
         <p:txBody>
           <a:bodyPr/>
-          <a:p/>
+          <a:lstStyle/>
+          <a:p>
+            <a:endParaRPr/>
+          </a:p>
         </p:txBody>
       </p:sp>
       <p:sp>
@@ -8723,7 +8622,7 @@
           <a:bodyPr wrap="square" lIns="0" tIns="0" rIns="0" bIns="0" rtlCol="0" anchor="ctr"/>
           <a:lstStyle/>
           <a:p>
-            <a:pPr algn="ctr" indent="0" marL="0">
+            <a:pPr marL="0" indent="0" algn="ctr">
               <a:buNone/>
             </a:pPr>
             <a:r>
@@ -8762,7 +8661,7 @@
           <a:bodyPr wrap="square" lIns="0" tIns="0" rIns="0" bIns="0" rtlCol="0" anchor="ctr"/>
           <a:lstStyle/>
           <a:p>
-            <a:pPr indent="0" marL="0">
+            <a:pPr marL="0" indent="0">
               <a:buNone/>
             </a:pPr>
             <a:r>
@@ -8801,7 +8700,7 @@
           <a:bodyPr wrap="square" lIns="0" tIns="0" rIns="0" bIns="0" rtlCol="0" anchor="ctr"/>
           <a:lstStyle/>
           <a:p>
-            <a:pPr indent="0" marL="0">
+            <a:pPr marL="0" indent="0">
               <a:buNone/>
             </a:pPr>
             <a:r>
@@ -8827,7 +8726,7 @@
         </p:nvSpPr>
         <p:spPr>
           <a:xfrm>
-            <a:off x="640080" y="6236208"/>
+            <a:off x="640080" y="6350508"/>
             <a:ext cx="10881360" cy="365760"/>
           </a:xfrm>
           <a:prstGeom prst="rect">
@@ -8840,11 +8739,11 @@
           <a:bodyPr wrap="square" lIns="0" tIns="0" rIns="0" bIns="0" rtlCol="0" anchor="ctr"/>
           <a:lstStyle/>
           <a:p>
-            <a:pPr indent="0" marL="0">
-              <a:buNone/>
-            </a:pPr>
-            <a:r>
-              <a:rPr lang="en-US" sz="1000" dirty="0">
+            <a:pPr marL="0" indent="0">
+              <a:buNone/>
+            </a:pPr>
+            <a:r>
+              <a:rPr lang="en-US" sz="1600" b="1" dirty="0">
                 <a:solidFill>
                   <a:srgbClr val="0B0B0B"/>
                 </a:solidFill>
@@ -8854,7 +8753,7 @@
               </a:rPr>
               <a:t>Les trois premières recommandations viennent du score ; les deux dernières répondent aux limites des données.</a:t>
             </a:r>
-            <a:endParaRPr lang="en-US" sz="1000" dirty="0"/>
+            <a:endParaRPr lang="en-US" sz="1600" b="1" dirty="0"/>
           </a:p>
         </p:txBody>
       </p:sp>
@@ -9159,4 +9058,299 @@
     </a:ext>
   </a:extLst>
 </a:theme>
+</file>
+
+<file path=ppt/theme/theme2.xml><?xml version="1.0" encoding="utf-8"?>
+<a:theme xmlns:a="http://schemas.openxmlformats.org/drawingml/2006/main" name="Office Theme">
+  <a:themeElements>
+    <a:clrScheme name="Office">
+      <a:dk1>
+        <a:sysClr val="windowText" lastClr="000000"/>
+      </a:dk1>
+      <a:lt1>
+        <a:sysClr val="window" lastClr="FFFFFF"/>
+      </a:lt1>
+      <a:dk2>
+        <a:srgbClr val="44546A"/>
+      </a:dk2>
+      <a:lt2>
+        <a:srgbClr val="E7E6E6"/>
+      </a:lt2>
+      <a:accent1>
+        <a:srgbClr val="4472C4"/>
+      </a:accent1>
+      <a:accent2>
+        <a:srgbClr val="ED7D31"/>
+      </a:accent2>
+      <a:accent3>
+        <a:srgbClr val="A5A5A5"/>
+      </a:accent3>
+      <a:accent4>
+        <a:srgbClr val="FFC000"/>
+      </a:accent4>
+      <a:accent5>
+        <a:srgbClr val="5B9BD5"/>
+      </a:accent5>
+      <a:accent6>
+        <a:srgbClr val="70AD47"/>
+      </a:accent6>
+      <a:hlink>
+        <a:srgbClr val="0563C1"/>
+      </a:hlink>
+      <a:folHlink>
+        <a:srgbClr val="954F72"/>
+      </a:folHlink>
+    </a:clrScheme>
+    <a:fontScheme name="Office">
+      <a:majorFont>
+        <a:latin typeface="Calibri Light" panose="020F0302020204030204"/>
+        <a:ea typeface=""/>
+        <a:cs typeface=""/>
+        <a:font script="Jpan" typeface="游ゴシック Light"/>
+        <a:font script="Hang" typeface="맑은 고딕"/>
+        <a:font script="Hans" typeface="等线 Light"/>
+        <a:font script="Hant" typeface="新細明體"/>
+        <a:font script="Arab" typeface="Times New Roman"/>
+        <a:font script="Hebr" typeface="Times New Roman"/>
+        <a:font script="Thai" typeface="Angsana New"/>
+        <a:font script="Ethi" typeface="Nyala"/>
+        <a:font script="Beng" typeface="Vrinda"/>
+        <a:font script="Gujr" typeface="Shruti"/>
+        <a:font script="Khmr" typeface="MoolBoran"/>
+        <a:font script="Knda" typeface="Tunga"/>
+        <a:font script="Guru" typeface="Raavi"/>
+        <a:font script="Cans" typeface="Euphemia"/>
+        <a:font script="Cher" typeface="Plantagenet Cherokee"/>
+        <a:font script="Yiii" typeface="Microsoft Yi Baiti"/>
+        <a:font script="Tibt" typeface="Microsoft Himalaya"/>
+        <a:font script="Thaa" typeface="MV Boli"/>
+        <a:font script="Deva" typeface="Mangal"/>
+        <a:font script="Telu" typeface="Gautami"/>
+        <a:font script="Taml" typeface="Latha"/>
+        <a:font script="Syrc" typeface="Estrangelo Edessa"/>
+        <a:font script="Orya" typeface="Kalinga"/>
+        <a:font script="Mlym" typeface="Kartika"/>
+        <a:font script="Laoo" typeface="DokChampa"/>
+        <a:font script="Sinh" typeface="Iskoola Pota"/>
+        <a:font script="Mong" typeface="Mongolian Baiti"/>
+        <a:font script="Viet" typeface="Times New Roman"/>
+        <a:font script="Uigh" typeface="Microsoft Uighur"/>
+        <a:font script="Geor" typeface="Sylfaen"/>
+        <a:font script="Armn" typeface="Arial"/>
+        <a:font script="Bugi" typeface="Leelawadee UI"/>
+        <a:font script="Bopo" typeface="Microsoft JhengHei"/>
+        <a:font script="Java" typeface="Javanese Text"/>
+        <a:font script="Lisu" typeface="Segoe UI"/>
+        <a:font script="Mymr" typeface="Myanmar Text"/>
+        <a:font script="Nkoo" typeface="Ebrima"/>
+        <a:font script="Olck" typeface="Nirmala UI"/>
+        <a:font script="Osma" typeface="Ebrima"/>
+        <a:font script="Phag" typeface="Phagspa"/>
+        <a:font script="Syrn" typeface="Estrangelo Edessa"/>
+        <a:font script="Syrj" typeface="Estrangelo Edessa"/>
+        <a:font script="Syre" typeface="Estrangelo Edessa"/>
+        <a:font script="Sora" typeface="Nirmala UI"/>
+        <a:font script="Tale" typeface="Microsoft Tai Le"/>
+        <a:font script="Talu" typeface="Microsoft New Tai Lue"/>
+        <a:font script="Tfng" typeface="Ebrima"/>
+      </a:majorFont>
+      <a:minorFont>
+        <a:latin typeface="Calibri" panose="020F0502020204030204"/>
+        <a:ea typeface=""/>
+        <a:cs typeface=""/>
+        <a:font script="Jpan" typeface="游ゴシック"/>
+        <a:font script="Hang" typeface="맑은 고딕"/>
+        <a:font script="Hans" typeface="等线"/>
+        <a:font script="Hant" typeface="新細明體"/>
+        <a:font script="Arab" typeface="Arial"/>
+        <a:font script="Hebr" typeface="Arial"/>
+        <a:font script="Thai" typeface="Cordia New"/>
+        <a:font script="Ethi" typeface="Nyala"/>
+        <a:font script="Beng" typeface="Vrinda"/>
+        <a:font script="Gujr" typeface="Shruti"/>
+        <a:font script="Khmr" typeface="DaunPenh"/>
+        <a:font script="Knda" typeface="Tunga"/>
+        <a:font script="Guru" typeface="Raavi"/>
+        <a:font script="Cans" typeface="Euphemia"/>
+        <a:font script="Cher" typeface="Plantagenet Cherokee"/>
+        <a:font script="Yiii" typeface="Microsoft Yi Baiti"/>
+        <a:font script="Tibt" typeface="Microsoft Himalaya"/>
+        <a:font script="Thaa" typeface="MV Boli"/>
+        <a:font script="Deva" typeface="Mangal"/>
+        <a:font script="Telu" typeface="Gautami"/>
+        <a:font script="Taml" typeface="Latha"/>
+        <a:font script="Syrc" typeface="Estrangelo Edessa"/>
+        <a:font script="Orya" typeface="Kalinga"/>
+        <a:font script="Mlym" typeface="Kartika"/>
+        <a:font script="Laoo" typeface="DokChampa"/>
+        <a:font script="Sinh" typeface="Iskoola Pota"/>
+        <a:font script="Mong" typeface="Mongolian Baiti"/>
+        <a:font script="Viet" typeface="Arial"/>
+        <a:font script="Uigh" typeface="Microsoft Uighur"/>
+        <a:font script="Geor" typeface="Sylfaen"/>
+        <a:font script="Armn" typeface="Arial"/>
+        <a:font script="Bugi" typeface="Leelawadee UI"/>
+        <a:font script="Bopo" typeface="Microsoft JhengHei"/>
+        <a:font script="Java" typeface="Javanese Text"/>
+        <a:font script="Lisu" typeface="Segoe UI"/>
+        <a:font script="Mymr" typeface="Myanmar Text"/>
+        <a:font script="Nkoo" typeface="Ebrima"/>
+        <a:font script="Olck" typeface="Nirmala UI"/>
+        <a:font script="Osma" typeface="Ebrima"/>
+        <a:font script="Phag" typeface="Phagspa"/>
+        <a:font script="Syrn" typeface="Estrangelo Edessa"/>
+        <a:font script="Syrj" typeface="Estrangelo Edessa"/>
+        <a:font script="Syre" typeface="Estrangelo Edessa"/>
+        <a:font script="Sora" typeface="Nirmala UI"/>
+        <a:font script="Tale" typeface="Microsoft Tai Le"/>
+        <a:font script="Talu" typeface="Microsoft New Tai Lue"/>
+        <a:font script="Tfng" typeface="Ebrima"/>
+      </a:minorFont>
+    </a:fontScheme>
+    <a:fmtScheme name="Office">
+      <a:fillStyleLst>
+        <a:solidFill>
+          <a:schemeClr val="phClr"/>
+        </a:solidFill>
+        <a:gradFill rotWithShape="1">
+          <a:gsLst>
+            <a:gs pos="0">
+              <a:schemeClr val="phClr">
+                <a:lumMod val="110000"/>
+                <a:satMod val="105000"/>
+                <a:tint val="67000"/>
+              </a:schemeClr>
+            </a:gs>
+            <a:gs pos="50000">
+              <a:schemeClr val="phClr">
+                <a:lumMod val="105000"/>
+                <a:satMod val="103000"/>
+                <a:tint val="73000"/>
+              </a:schemeClr>
+            </a:gs>
+            <a:gs pos="100000">
+              <a:schemeClr val="phClr">
+                <a:lumMod val="105000"/>
+                <a:satMod val="109000"/>
+                <a:tint val="81000"/>
+              </a:schemeClr>
+            </a:gs>
+          </a:gsLst>
+          <a:lin ang="5400000" scaled="0"/>
+        </a:gradFill>
+        <a:gradFill rotWithShape="1">
+          <a:gsLst>
+            <a:gs pos="0">
+              <a:schemeClr val="phClr">
+                <a:satMod val="103000"/>
+                <a:lumMod val="102000"/>
+                <a:tint val="94000"/>
+              </a:schemeClr>
+            </a:gs>
+            <a:gs pos="50000">
+              <a:schemeClr val="phClr">
+                <a:satMod val="110000"/>
+                <a:lumMod val="100000"/>
+                <a:shade val="100000"/>
+              </a:schemeClr>
+            </a:gs>
+            <a:gs pos="100000">
+              <a:schemeClr val="phClr">
+                <a:lumMod val="99000"/>
+                <a:satMod val="120000"/>
+                <a:shade val="78000"/>
+              </a:schemeClr>
+            </a:gs>
+          </a:gsLst>
+          <a:lin ang="5400000" scaled="0"/>
+        </a:gradFill>
+      </a:fillStyleLst>
+      <a:lnStyleLst>
+        <a:ln w="6350" cap="flat" cmpd="sng" algn="ctr">
+          <a:solidFill>
+            <a:schemeClr val="phClr"/>
+          </a:solidFill>
+          <a:prstDash val="solid"/>
+          <a:miter lim="800000"/>
+        </a:ln>
+        <a:ln w="12700" cap="flat" cmpd="sng" algn="ctr">
+          <a:solidFill>
+            <a:schemeClr val="phClr"/>
+          </a:solidFill>
+          <a:prstDash val="solid"/>
+          <a:miter lim="800000"/>
+        </a:ln>
+        <a:ln w="19050" cap="flat" cmpd="sng" algn="ctr">
+          <a:solidFill>
+            <a:schemeClr val="phClr"/>
+          </a:solidFill>
+          <a:prstDash val="solid"/>
+          <a:miter lim="800000"/>
+        </a:ln>
+      </a:lnStyleLst>
+      <a:effectStyleLst>
+        <a:effectStyle>
+          <a:effectLst/>
+        </a:effectStyle>
+        <a:effectStyle>
+          <a:effectLst/>
+        </a:effectStyle>
+        <a:effectStyle>
+          <a:effectLst>
+            <a:outerShdw blurRad="57150" dist="19050" dir="5400000" algn="ctr" rotWithShape="0">
+              <a:srgbClr val="000000">
+                <a:alpha val="63000"/>
+              </a:srgbClr>
+            </a:outerShdw>
+          </a:effectLst>
+        </a:effectStyle>
+      </a:effectStyleLst>
+      <a:bgFillStyleLst>
+        <a:solidFill>
+          <a:schemeClr val="phClr"/>
+        </a:solidFill>
+        <a:solidFill>
+          <a:schemeClr val="phClr">
+            <a:tint val="95000"/>
+            <a:satMod val="170000"/>
+          </a:schemeClr>
+        </a:solidFill>
+        <a:gradFill rotWithShape="1">
+          <a:gsLst>
+            <a:gs pos="0">
+              <a:schemeClr val="phClr">
+                <a:tint val="93000"/>
+                <a:satMod val="150000"/>
+                <a:shade val="98000"/>
+                <a:lumMod val="102000"/>
+              </a:schemeClr>
+            </a:gs>
+            <a:gs pos="50000">
+              <a:schemeClr val="phClr">
+                <a:tint val="98000"/>
+                <a:satMod val="130000"/>
+                <a:shade val="90000"/>
+                <a:lumMod val="103000"/>
+              </a:schemeClr>
+            </a:gs>
+            <a:gs pos="100000">
+              <a:schemeClr val="phClr">
+                <a:shade val="63000"/>
+                <a:satMod val="120000"/>
+              </a:schemeClr>
+            </a:gs>
+          </a:gsLst>
+          <a:lin ang="5400000" scaled="0"/>
+        </a:gradFill>
+      </a:bgFillStyleLst>
+    </a:fmtScheme>
+  </a:themeElements>
+  <a:objectDefaults/>
+  <a:extraClrSchemeLst/>
+  <a:extLst>
+    <a:ext uri="{05A4C25C-085E-4340-85A3-A5531E510DB2}">
+      <thm15:themeFamily xmlns:thm15="http://schemas.microsoft.com/office/thememl/2012/main" name="Office Theme" id="{62F939B6-93AF-4DB8-9C6B-D6C7DFDC589F}" vid="{4A3C46E8-61CC-4603-A589-7422A47A8E4A}"/>
+    </a:ext>
+  </a:extLst>
+</a:theme>
 </file>
</xml_diff>